<commit_message>
feat(demo): refine film framing and publish verified pitch deck
</commit_message>
<xml_diff>
--- a/apps/web/public/demo/roadstar-pitch.pptx
+++ b/apps/web/public/demo/roadstar-pitch.pptx
@@ -2,25 +2,25 @@
 <file path=ppt/presentation.xml><?xml version="1.0" encoding="utf-8"?>
 <p:presentation xmlns:p="http://schemas.openxmlformats.org/presentationml/2006/main">
   <p:sldMasterIdLst>
-    <p:sldMasterId xmlns:r="http://schemas.openxmlformats.org/officeDocument/2006/relationships" id="2147483648" r:id="Re2227e90cf424db8"/>
+    <p:sldMasterId xmlns:r="http://schemas.openxmlformats.org/officeDocument/2006/relationships" id="2147483648" r:id="R90ecf1d36a1d4f46"/>
   </p:sldMasterIdLst>
   <p:notesMasterIdLst>
-    <p:notesMasterId xmlns:r="http://schemas.openxmlformats.org/officeDocument/2006/relationships" r:id="R58ec571a1b044c54"/>
+    <p:notesMasterId xmlns:r="http://schemas.openxmlformats.org/officeDocument/2006/relationships" r:id="R2f4376c42a6d4248"/>
   </p:notesMasterIdLst>
   <p:sldIdLst>
-    <p:sldId xmlns:r="http://schemas.openxmlformats.org/officeDocument/2006/relationships" id="256" r:id="R0ad800c5582c45be"/>
-    <p:sldId xmlns:r="http://schemas.openxmlformats.org/officeDocument/2006/relationships" id="257" r:id="R655401bcba4b4ddd"/>
-    <p:sldId xmlns:r="http://schemas.openxmlformats.org/officeDocument/2006/relationships" id="258" r:id="R547bb9e412794837"/>
-    <p:sldId xmlns:r="http://schemas.openxmlformats.org/officeDocument/2006/relationships" id="259" r:id="Rc38ef55b6a6542fe"/>
-    <p:sldId xmlns:r="http://schemas.openxmlformats.org/officeDocument/2006/relationships" id="260" r:id="Rd0b33d2fe67a47be"/>
-    <p:sldId xmlns:r="http://schemas.openxmlformats.org/officeDocument/2006/relationships" id="261" r:id="R1e84c372d33e4f17"/>
-    <p:sldId xmlns:r="http://schemas.openxmlformats.org/officeDocument/2006/relationships" id="262" r:id="Rc74331142c2a42b5"/>
-    <p:sldId xmlns:r="http://schemas.openxmlformats.org/officeDocument/2006/relationships" id="263" r:id="Rd54154d3f9004ccc"/>
-    <p:sldId xmlns:r="http://schemas.openxmlformats.org/officeDocument/2006/relationships" id="264" r:id="Rffdf2b45b7424790"/>
-    <p:sldId xmlns:r="http://schemas.openxmlformats.org/officeDocument/2006/relationships" id="265" r:id="R984c0bd8989246b2"/>
-    <p:sldId xmlns:r="http://schemas.openxmlformats.org/officeDocument/2006/relationships" id="266" r:id="R9830ef882b3b4196"/>
-    <p:sldId xmlns:r="http://schemas.openxmlformats.org/officeDocument/2006/relationships" id="267" r:id="Rc5e9cf50d08d4ec6"/>
-    <p:sldId xmlns:r="http://schemas.openxmlformats.org/officeDocument/2006/relationships" id="268" r:id="Rae0e632b1e514470"/>
+    <p:sldId xmlns:r="http://schemas.openxmlformats.org/officeDocument/2006/relationships" id="256" r:id="R1e766043f1d54a34"/>
+    <p:sldId xmlns:r="http://schemas.openxmlformats.org/officeDocument/2006/relationships" id="257" r:id="Rc97f4d94be834adb"/>
+    <p:sldId xmlns:r="http://schemas.openxmlformats.org/officeDocument/2006/relationships" id="258" r:id="R479f24bc35c742f2"/>
+    <p:sldId xmlns:r="http://schemas.openxmlformats.org/officeDocument/2006/relationships" id="259" r:id="R64c927bcc5b643ed"/>
+    <p:sldId xmlns:r="http://schemas.openxmlformats.org/officeDocument/2006/relationships" id="260" r:id="R6c2e617993574eca"/>
+    <p:sldId xmlns:r="http://schemas.openxmlformats.org/officeDocument/2006/relationships" id="261" r:id="Rb336c101aff746ce"/>
+    <p:sldId xmlns:r="http://schemas.openxmlformats.org/officeDocument/2006/relationships" id="262" r:id="R8788ab124aec474c"/>
+    <p:sldId xmlns:r="http://schemas.openxmlformats.org/officeDocument/2006/relationships" id="263" r:id="R7cfe72bdc54b474f"/>
+    <p:sldId xmlns:r="http://schemas.openxmlformats.org/officeDocument/2006/relationships" id="264" r:id="Re114ce9dc9d24bd1"/>
+    <p:sldId xmlns:r="http://schemas.openxmlformats.org/officeDocument/2006/relationships" id="265" r:id="R9973bf2d54e24d29"/>
+    <p:sldId xmlns:r="http://schemas.openxmlformats.org/officeDocument/2006/relationships" id="266" r:id="Rcd2f8719bca341a0"/>
+    <p:sldId xmlns:r="http://schemas.openxmlformats.org/officeDocument/2006/relationships" id="267" r:id="R10086aa5c4204556"/>
+    <p:sldId xmlns:r="http://schemas.openxmlformats.org/officeDocument/2006/relationships" id="268" r:id="Rbd327a9df0644536"/>
   </p:sldIdLst>
   <p:sldSz cx="12192000" cy="6858000"/>
   <p:notesSz cx="6858000" cy="9144000"/>
@@ -934,7 +934,7 @@
           <a:lstStyle xmlns:a="http://schemas.openxmlformats.org/drawingml/2006/main"/>
           <a:p xmlns:a="http://schemas.openxmlformats.org/drawingml/2006/main">
             <a:r>
-              <a:t>80 seconds. Switch to live cloud film-demo or downloaded recording. Record expected departure and inspect the affected next load. Sources: actual RoadStar cloud browser capture, docs/evidence/cloud-auth-smoke.json. Visual: September 10 design-film cloud recording, 01-dock-delay-end.png, exact disruption strip. 12:00 planned departure, 13:30 expected departure, 12:15 next pickup, ET. Final frozen web source: capture-final/delay-impact.png, expanded real delay record in design-final synthetic carrier, September 10 2026.</a:t>
+              <a:t>80 seconds. Switch to live cloud film-demo or downloaded recording. Record expected departure and inspect the affected next load. Sources: actual RoadStar cloud browser capture, docs/evidence/cloud-auth-smoke.json. Visual: September 10 design-film cloud recording, 01-dock-delay-end.png, exact disruption strip. 12:00 planned departure, 13:30 expected departure, 12:15 next pickup, ET. Final frozen web source: capture-final/delay-impact.png, expanded real delay record in design-final synthetic carrier, September 10 2026. Final v9 source: /tmp/roadstar-polish/final-capture/delay-impact.png, deployment 00017-bj6, design-polish-final carrier. Actual recorded delay; same 12:00 / 13:30 / 12:15 ET scenario.</a:t>
             </a:r>
           </a:p>
           <a:p xmlns:a="http://schemas.openxmlformats.org/drawingml/2006/main">
@@ -1014,7 +1014,7 @@
           <a:lstStyle xmlns:a="http://schemas.openxmlformats.org/drawingml/2006/main"/>
           <a:p xmlns:a="http://schemas.openxmlformats.org/drawingml/2006/main">
             <a:r>
-              <a:t>65 seconds. Show current assignment and proposed D02/T102/V102. Approval rechecks versions and availability, then commits reservations and driver offer atomically. Source: tests/postgres.test.ts and actual cloud recovery verification. Visual: exact modal frame at 16 seconds from the new design-film 02-recovery-approval recording. Actual proposal and approval API responses succeeded. Final frozen web source: capture-final/approval-review.png, exact displayed consequential approval dialog in design-final carrier. The capture precedes the explicit confirmation.</a:t>
+              <a:t>65 seconds. Show current assignment and proposed D02/T102/V102. Approval rechecks versions and availability, then commits reservations and driver offer atomically. Source: tests/postgres.test.ts and actual cloud recovery verification. Visual: exact modal frame at 16 seconds from the new design-film 02-recovery-approval recording. Actual proposal and approval API responses succeeded. Final frozen web source: capture-final/approval-review.png, exact displayed consequential approval dialog in design-final carrier. The capture precedes the explicit confirmation. Final v9 capture: /tmp/roadstar-polish/capture/approval-review.png. Current and proposed drivers and equipment are shown before confirmation. Driver acceptance is separate. Checks and assumptions remain available in the disclosure. Final v9 source supersedes previous frame: /tmp/roadstar-polish/final-capture/approval-review.png, deployment 00017-bj6. Same explicit current-to-proposed dialog before confirmation.</a:t>
             </a:r>
           </a:p>
           <a:p xmlns:a="http://schemas.openxmlformats.org/drawingml/2006/main">
@@ -1094,7 +1094,7 @@
           <a:lstStyle xmlns:a="http://schemas.openxmlformats.org/drawingml/2006/main"/>
           <a:p xmlns:a="http://schemas.openxmlformats.org/drawingml/2006/main">
             <a:r>
-              <a:t>65 seconds. Native API35 Android emulator testing: Firebase login, offline acceptance, force-stop, restored session/downloaded trip/note/pending key, reconnect to accepted version2. Physical device background location and native iOS remain unverified. Current visual: actual September 10 Android API35 emulator Today screen. RS1043 accepted, pickup already completed, delivery is next. The screenshot does not claim a newly completed delivery or a new offline acceptance test. Density refresh: final native screenshot mobile/34-today-frozen.png, consistent RoadStar case and compact header. State remains accepted with delivery next. Final source freeze uses mobile/41-today-final.png. Compact one-row identity header and explicit synthetic scenario label. Original facility values remain unchanged underneath their shortened display labels.</a:t>
+              <a:t>65 seconds. Native API35 Android emulator testing: Firebase login, offline acceptance, force-stop, restored session/downloaded trip/note/pending key, reconnect to accepted version2. Physical device background location and native iOS remain unverified. Current visual: actual September 10 Android API35 emulator Today screen. RS1043 accepted, pickup already completed, delivery is next. The screenshot does not claim a newly completed delivery or a new offline acceptance test. Density refresh: final native screenshot mobile/34-today-frozen.png, consistent RoadStar case and compact header. State remains accepted with delivery next. Final source freeze uses mobile/41-today-final.png. Compact one-row identity header and explicit synthetic scenario label. Original facility values remain unchanged underneath their shortened display labels. Final review-pass capture: mobile/56-today-frozen-review-pass.png. Same accepted trip state, pickup completed and delivery next; this capture is not new offline-acceptance verification. Final v9 capture supersedes the prior frame: mobile/60-today-density-final.png. Compact single-row header; accepted trip and delivery-next state unchanged.</a:t>
             </a:r>
           </a:p>
           <a:p xmlns:a="http://schemas.openxmlformats.org/drawingml/2006/main">
@@ -1492,7 +1492,7 @@
   </p:cSld>
   <p:clrMap bg1="lt1" tx1="dk1" bg2="lt2" tx2="dk2" accent1="accent1" accent2="accent2" accent3="accent3" accent4="accent4" accent5="accent5" accent6="accent6" hlink="hlink" folHlink="folHlink"/>
   <p:sldLayoutIdLst>
-    <p:sldLayoutId xmlns:r="http://schemas.openxmlformats.org/officeDocument/2006/relationships" id="2147483649" r:id="Rae490f2208064b7d"/>
+    <p:sldLayoutId xmlns:r="http://schemas.openxmlformats.org/officeDocument/2006/relationships" id="2147483649" r:id="R08382bcaccff487c"/>
   </p:sldLayoutIdLst>
   <p:txStyles>
     <p:titleStyle>
@@ -2043,7 +2043,7 @@
           <p:cNvPr id="8" name="">
             <a:extLst xmlns:a="http://schemas.openxmlformats.org/drawingml/2006/main">
               <a:ext uri="{FF2B5EF4-FFF2-40B4-BE49-F238E27FC236}">
-                <a16:creationId xmlns:a16="http://schemas.microsoft.com/office/drawing/2014/main" id="{53B6D10B-AE51-4F85-9EFE-FD499CF7D94C}"/>
+                <a16:creationId xmlns:a16="http://schemas.microsoft.com/office/drawing/2014/main" id="{C3ABF97B-8E14-4BE5-9431-DF00D506885C}"/>
               </a:ext>
             </a:extLst>
           </p:cNvPr>
@@ -2104,7 +2104,7 @@
           <p:nvPr/>
         </p:nvPicPr>
         <p:blipFill>
-          <a:blip xmlns:r="http://schemas.openxmlformats.org/officeDocument/2006/relationships" xmlns:a="http://schemas.openxmlformats.org/drawingml/2006/main" r:embed="Raa64d33c897d45aa"/>
+          <a:blip xmlns:r="http://schemas.openxmlformats.org/officeDocument/2006/relationships" xmlns:a="http://schemas.openxmlformats.org/drawingml/2006/main" r:embed="R4a1d33ccf4ae4313"/>
           <a:srcRect xmlns:a="http://schemas.openxmlformats.org/drawingml/2006/main" l="0" t="27" r="0" b="27"/>
           <a:stretch xmlns:a="http://schemas.openxmlformats.org/drawingml/2006/main">
             <a:fillRect l="0" t="0" r="0" b="0"/>
@@ -2129,10 +2129,10 @@
           <p:nvPr/>
         </p:nvPicPr>
         <p:blipFill>
-          <a:blip xmlns:r="http://schemas.openxmlformats.org/officeDocument/2006/relationships" xmlns:a="http://schemas.openxmlformats.org/drawingml/2006/main" r:embed="Rd98ec958c7ac49f1">
+          <a:blip xmlns:r="http://schemas.openxmlformats.org/officeDocument/2006/relationships" xmlns:a="http://schemas.openxmlformats.org/drawingml/2006/main" r:embed="Rd4eab1898fc84c72">
             <a:extLst>
               <a:ext uri="{96DAC541-7B7A-43D3-8B79-37D633B846F1}">
-                <asvg:svgBlip xmlns:asvg="http://schemas.microsoft.com/office/drawing/2016/SVG/main" r:embed="R12179e68c4ae466c"/>
+                <asvg:svgBlip xmlns:asvg="http://schemas.microsoft.com/office/drawing/2016/SVG/main" r:embed="R010120eeaad54d85"/>
               </a:ext>
             </a:extLst>
           </a:blip>
@@ -2153,7 +2153,7 @@
           <p:cNvPr id="4" name="">
             <a:extLst xmlns:a="http://schemas.openxmlformats.org/drawingml/2006/main">
               <a:ext uri="{FF2B5EF4-FFF2-40B4-BE49-F238E27FC236}">
-                <a16:creationId xmlns:a16="http://schemas.microsoft.com/office/drawing/2014/main" id="{9A50A282-A578-4176-B75C-842ECF098105}"/>
+                <a16:creationId xmlns:a16="http://schemas.microsoft.com/office/drawing/2014/main" id="{76AB2219-6D78-4F45-9FA9-B0C106F8779D}"/>
               </a:ext>
             </a:extLst>
           </p:cNvPr>
@@ -2210,7 +2210,7 @@
           <p:cNvPr id="5" name="">
             <a:extLst xmlns:a="http://schemas.openxmlformats.org/drawingml/2006/main">
               <a:ext uri="{FF2B5EF4-FFF2-40B4-BE49-F238E27FC236}">
-                <a16:creationId xmlns:a16="http://schemas.microsoft.com/office/drawing/2014/main" id="{ABD09ED7-8D7D-4FA6-BDE5-971E286EB555}"/>
+                <a16:creationId xmlns:a16="http://schemas.microsoft.com/office/drawing/2014/main" id="{65F9E3ED-5BFD-4EF6-9892-87303D57F00C}"/>
               </a:ext>
             </a:extLst>
           </p:cNvPr>
@@ -2267,7 +2267,7 @@
           <p:cNvPr id="6" name="">
             <a:extLst xmlns:a="http://schemas.openxmlformats.org/drawingml/2006/main">
               <a:ext uri="{FF2B5EF4-FFF2-40B4-BE49-F238E27FC236}">
-                <a16:creationId xmlns:a16="http://schemas.microsoft.com/office/drawing/2014/main" id="{E05BDE63-B342-485A-883A-C12F89F83372}"/>
+                <a16:creationId xmlns:a16="http://schemas.microsoft.com/office/drawing/2014/main" id="{D3C3A533-4D86-4D03-AA96-C907B8C2B051}"/>
               </a:ext>
             </a:extLst>
           </p:cNvPr>
@@ -2324,7 +2324,7 @@
           <p:cNvPr id="7" name="">
             <a:extLst xmlns:a="http://schemas.openxmlformats.org/drawingml/2006/main">
               <a:ext uri="{FF2B5EF4-FFF2-40B4-BE49-F238E27FC236}">
-                <a16:creationId xmlns:a16="http://schemas.microsoft.com/office/drawing/2014/main" id="{1CAB2522-831A-418F-8489-7AB941461DC7}"/>
+                <a16:creationId xmlns:a16="http://schemas.microsoft.com/office/drawing/2014/main" id="{63A06127-03DF-4C49-A829-B6E8176FDD2E}"/>
               </a:ext>
             </a:extLst>
           </p:cNvPr>
@@ -2379,7 +2379,7 @@
     </p:spTree>
     <p:extLst>
       <p:ext uri="{BB962C8B-B14F-4D97-AF65-F5344CB8AC3E}">
-        <p14:creationId xmlns:p14="http://schemas.microsoft.com/office/powerpoint/2010/main" val="1736035480"/>
+        <p14:creationId xmlns:p14="http://schemas.microsoft.com/office/powerpoint/2010/main" val="1391469382"/>
       </p:ext>
     </p:extLst>
   </p:cSld>
@@ -2410,7 +2410,7 @@
           <p:cNvPr id="9" name="">
             <a:extLst xmlns:a="http://schemas.openxmlformats.org/drawingml/2006/main">
               <a:ext uri="{FF2B5EF4-FFF2-40B4-BE49-F238E27FC236}">
-                <a16:creationId xmlns:a16="http://schemas.microsoft.com/office/drawing/2014/main" id="{0EF2E747-8CAE-4C7E-9BB1-E70A16158916}"/>
+                <a16:creationId xmlns:a16="http://schemas.microsoft.com/office/drawing/2014/main" id="{88F42D03-F424-4AF8-8408-12FDB74EE866}"/>
               </a:ext>
             </a:extLst>
           </p:cNvPr>
@@ -2467,7 +2467,7 @@
           <p:cNvPr id="2" name="">
             <a:extLst xmlns:a="http://schemas.openxmlformats.org/drawingml/2006/main">
               <a:ext uri="{FF2B5EF4-FFF2-40B4-BE49-F238E27FC236}">
-                <a16:creationId xmlns:a16="http://schemas.microsoft.com/office/drawing/2014/main" id="{D0C0E62F-8095-4C06-999F-6200F51AF0EA}"/>
+                <a16:creationId xmlns:a16="http://schemas.microsoft.com/office/drawing/2014/main" id="{2F96C6AC-0058-47EA-899D-C968C71FCA30}"/>
               </a:ext>
             </a:extLst>
           </p:cNvPr>
@@ -2524,7 +2524,7 @@
           <p:cNvPr id="3" name="">
             <a:extLst xmlns:a="http://schemas.openxmlformats.org/drawingml/2006/main">
               <a:ext uri="{FF2B5EF4-FFF2-40B4-BE49-F238E27FC236}">
-                <a16:creationId xmlns:a16="http://schemas.microsoft.com/office/drawing/2014/main" id="{800A0754-188A-4912-BB7C-93C30D4ACCD0}"/>
+                <a16:creationId xmlns:a16="http://schemas.microsoft.com/office/drawing/2014/main" id="{C9365952-645D-4651-9109-09BF7288B03D}"/>
               </a:ext>
             </a:extLst>
           </p:cNvPr>
@@ -2581,7 +2581,7 @@
           <p:cNvPr id="4" name="">
             <a:extLst xmlns:a="http://schemas.openxmlformats.org/drawingml/2006/main">
               <a:ext uri="{FF2B5EF4-FFF2-40B4-BE49-F238E27FC236}">
-                <a16:creationId xmlns:a16="http://schemas.microsoft.com/office/drawing/2014/main" id="{DCAB2B79-728C-4BA5-BA61-7A39C8AD816C}"/>
+                <a16:creationId xmlns:a16="http://schemas.microsoft.com/office/drawing/2014/main" id="{0C5FDD06-9E1C-4212-8270-B78E12CACCC4}"/>
               </a:ext>
             </a:extLst>
           </p:cNvPr>
@@ -2661,7 +2661,7 @@
           <p:cNvPr id="5" name="">
             <a:extLst xmlns:a="http://schemas.openxmlformats.org/drawingml/2006/main">
               <a:ext uri="{FF2B5EF4-FFF2-40B4-BE49-F238E27FC236}">
-                <a16:creationId xmlns:a16="http://schemas.microsoft.com/office/drawing/2014/main" id="{30E80D6B-5694-4CBF-A783-F99029A030A6}"/>
+                <a16:creationId xmlns:a16="http://schemas.microsoft.com/office/drawing/2014/main" id="{6CE0193B-C4D8-43C4-9DC3-85D8C027E288}"/>
               </a:ext>
             </a:extLst>
           </p:cNvPr>
@@ -2718,7 +2718,7 @@
           <p:cNvPr id="6" name="">
             <a:extLst xmlns:a="http://schemas.openxmlformats.org/drawingml/2006/main">
               <a:ext uri="{FF2B5EF4-FFF2-40B4-BE49-F238E27FC236}">
-                <a16:creationId xmlns:a16="http://schemas.microsoft.com/office/drawing/2014/main" id="{92746CEF-A0DF-47AA-BCA2-CACFCB3C426B}"/>
+                <a16:creationId xmlns:a16="http://schemas.microsoft.com/office/drawing/2014/main" id="{CD03C185-7849-47B6-BEFC-C284798D99F2}"/>
               </a:ext>
             </a:extLst>
           </p:cNvPr>
@@ -2798,7 +2798,7 @@
           <p:cNvPr id="7" name="">
             <a:extLst xmlns:a="http://schemas.openxmlformats.org/drawingml/2006/main">
               <a:ext uri="{FF2B5EF4-FFF2-40B4-BE49-F238E27FC236}">
-                <a16:creationId xmlns:a16="http://schemas.microsoft.com/office/drawing/2014/main" id="{19D6531B-C81F-4B08-A7B7-DC3326B223D1}"/>
+                <a16:creationId xmlns:a16="http://schemas.microsoft.com/office/drawing/2014/main" id="{E2C45FF2-B137-4862-BF84-B52D2409B801}"/>
               </a:ext>
             </a:extLst>
           </p:cNvPr>
@@ -2901,7 +2901,7 @@
           <p:cNvPr id="8" name="">
             <a:extLst xmlns:a="http://schemas.openxmlformats.org/drawingml/2006/main">
               <a:ext uri="{FF2B5EF4-FFF2-40B4-BE49-F238E27FC236}">
-                <a16:creationId xmlns:a16="http://schemas.microsoft.com/office/drawing/2014/main" id="{70C6F67D-D5BF-45FA-A6B6-84363035D31F}"/>
+                <a16:creationId xmlns:a16="http://schemas.microsoft.com/office/drawing/2014/main" id="{41CF3AE4-9A03-4794-98C4-C18D5089A70B}"/>
               </a:ext>
             </a:extLst>
           </p:cNvPr>
@@ -2979,7 +2979,7 @@
     </p:spTree>
     <p:extLst>
       <p:ext uri="{BB962C8B-B14F-4D97-AF65-F5344CB8AC3E}">
-        <p14:creationId xmlns:p14="http://schemas.microsoft.com/office/powerpoint/2010/main" val="1029510875"/>
+        <p14:creationId xmlns:p14="http://schemas.microsoft.com/office/powerpoint/2010/main" val="1898114888"/>
       </p:ext>
     </p:extLst>
   </p:cSld>
@@ -3010,7 +3010,7 @@
           <p:cNvPr id="6" name="">
             <a:extLst xmlns:a="http://schemas.openxmlformats.org/drawingml/2006/main">
               <a:ext uri="{FF2B5EF4-FFF2-40B4-BE49-F238E27FC236}">
-                <a16:creationId xmlns:a16="http://schemas.microsoft.com/office/drawing/2014/main" id="{90A1DD5C-30D5-4DBC-BA91-F0605E2FAD7F}"/>
+                <a16:creationId xmlns:a16="http://schemas.microsoft.com/office/drawing/2014/main" id="{63AE70DC-F184-4CD5-8C58-E16757A70732}"/>
               </a:ext>
             </a:extLst>
           </p:cNvPr>
@@ -3071,7 +3071,7 @@
           <p:nvPr/>
         </p:nvPicPr>
         <p:blipFill>
-          <a:blip xmlns:r="http://schemas.openxmlformats.org/officeDocument/2006/relationships" xmlns:a="http://schemas.openxmlformats.org/drawingml/2006/main" r:embed="R0ce3ca2b783d45c2"/>
+          <a:blip xmlns:r="http://schemas.openxmlformats.org/officeDocument/2006/relationships" xmlns:a="http://schemas.openxmlformats.org/drawingml/2006/main" r:embed="R2d06679150f247ac"/>
           <a:srcRect xmlns:a="http://schemas.openxmlformats.org/drawingml/2006/main" l="0" t="27" r="0" b="27"/>
           <a:stretch xmlns:a="http://schemas.openxmlformats.org/drawingml/2006/main">
             <a:fillRect l="0" t="0" r="0" b="0"/>
@@ -3092,7 +3092,7 @@
           <p:cNvPr id="3" name="">
             <a:extLst xmlns:a="http://schemas.openxmlformats.org/drawingml/2006/main">
               <a:ext uri="{FF2B5EF4-FFF2-40B4-BE49-F238E27FC236}">
-                <a16:creationId xmlns:a16="http://schemas.microsoft.com/office/drawing/2014/main" id="{1BF6CD90-E2FF-4CA3-AD35-C24FBDE2B9CB}"/>
+                <a16:creationId xmlns:a16="http://schemas.microsoft.com/office/drawing/2014/main" id="{58EDE611-F8D4-4FE5-9123-A1CEC2CAF57C}"/>
               </a:ext>
             </a:extLst>
           </p:cNvPr>
@@ -3172,7 +3172,7 @@
           <p:cNvPr id="4" name="">
             <a:extLst xmlns:a="http://schemas.openxmlformats.org/drawingml/2006/main">
               <a:ext uri="{FF2B5EF4-FFF2-40B4-BE49-F238E27FC236}">
-                <a16:creationId xmlns:a16="http://schemas.microsoft.com/office/drawing/2014/main" id="{C28738A8-F14B-4804-868A-4A3F01F86941}"/>
+                <a16:creationId xmlns:a16="http://schemas.microsoft.com/office/drawing/2014/main" id="{1582DF1C-E3B1-4257-9E58-3889E49C43D3}"/>
               </a:ext>
             </a:extLst>
           </p:cNvPr>
@@ -3275,7 +3275,7 @@
           <p:cNvPr id="5" name="">
             <a:extLst xmlns:a="http://schemas.openxmlformats.org/drawingml/2006/main">
               <a:ext uri="{FF2B5EF4-FFF2-40B4-BE49-F238E27FC236}">
-                <a16:creationId xmlns:a16="http://schemas.microsoft.com/office/drawing/2014/main" id="{68E77B39-8F1F-4205-AAB9-58CACDEBA7F8}"/>
+                <a16:creationId xmlns:a16="http://schemas.microsoft.com/office/drawing/2014/main" id="{8634058C-2FFB-4914-A23B-C94F6D3D7A5C}"/>
               </a:ext>
             </a:extLst>
           </p:cNvPr>
@@ -3330,7 +3330,7 @@
     </p:spTree>
     <p:extLst>
       <p:ext uri="{BB962C8B-B14F-4D97-AF65-F5344CB8AC3E}">
-        <p14:creationId xmlns:p14="http://schemas.microsoft.com/office/powerpoint/2010/main" val="1852658680"/>
+        <p14:creationId xmlns:p14="http://schemas.microsoft.com/office/powerpoint/2010/main" val="862955831"/>
       </p:ext>
     </p:extLst>
   </p:cSld>
@@ -3361,7 +3361,7 @@
           <p:cNvPr id="13" name="">
             <a:extLst xmlns:a="http://schemas.openxmlformats.org/drawingml/2006/main">
               <a:ext uri="{FF2B5EF4-FFF2-40B4-BE49-F238E27FC236}">
-                <a16:creationId xmlns:a16="http://schemas.microsoft.com/office/drawing/2014/main" id="{A07AB886-7D13-4146-9404-58AF4E9C4BC3}"/>
+                <a16:creationId xmlns:a16="http://schemas.microsoft.com/office/drawing/2014/main" id="{BD397FB7-EDB2-4820-99A0-FBEBA89B377F}"/>
               </a:ext>
             </a:extLst>
           </p:cNvPr>
@@ -3418,7 +3418,7 @@
           <p:cNvPr id="2" name="">
             <a:extLst xmlns:a="http://schemas.openxmlformats.org/drawingml/2006/main">
               <a:ext uri="{FF2B5EF4-FFF2-40B4-BE49-F238E27FC236}">
-                <a16:creationId xmlns:a16="http://schemas.microsoft.com/office/drawing/2014/main" id="{41D7EDB0-F199-4AF6-BE65-CE247CEA493B}"/>
+                <a16:creationId xmlns:a16="http://schemas.microsoft.com/office/drawing/2014/main" id="{9F124385-2A9D-4FC3-A2D4-3C299138D764}"/>
               </a:ext>
             </a:extLst>
           </p:cNvPr>
@@ -3475,7 +3475,7 @@
           <p:cNvPr id="3" name="">
             <a:extLst xmlns:a="http://schemas.openxmlformats.org/drawingml/2006/main">
               <a:ext uri="{FF2B5EF4-FFF2-40B4-BE49-F238E27FC236}">
-                <a16:creationId xmlns:a16="http://schemas.microsoft.com/office/drawing/2014/main" id="{6BD118B7-1164-4AB6-8E2D-C884F72B1DF4}"/>
+                <a16:creationId xmlns:a16="http://schemas.microsoft.com/office/drawing/2014/main" id="{2EAAA66E-25B0-4C6A-8168-316AB3405BB9}"/>
               </a:ext>
             </a:extLst>
           </p:cNvPr>
@@ -3532,7 +3532,7 @@
           <p:cNvPr id="4" name="">
             <a:extLst xmlns:a="http://schemas.openxmlformats.org/drawingml/2006/main">
               <a:ext uri="{FF2B5EF4-FFF2-40B4-BE49-F238E27FC236}">
-                <a16:creationId xmlns:a16="http://schemas.microsoft.com/office/drawing/2014/main" id="{EA165346-C2F7-4EB5-9E69-04BCF39E523C}"/>
+                <a16:creationId xmlns:a16="http://schemas.microsoft.com/office/drawing/2014/main" id="{6F4F7ADC-2401-42B7-A090-B6F5EED91088}"/>
               </a:ext>
             </a:extLst>
           </p:cNvPr>
@@ -3589,7 +3589,7 @@
           <p:cNvPr id="5" name="">
             <a:extLst xmlns:a="http://schemas.openxmlformats.org/drawingml/2006/main">
               <a:ext uri="{FF2B5EF4-FFF2-40B4-BE49-F238E27FC236}">
-                <a16:creationId xmlns:a16="http://schemas.microsoft.com/office/drawing/2014/main" id="{1944128D-5B92-4E3C-B265-431F0DD8C880}"/>
+                <a16:creationId xmlns:a16="http://schemas.microsoft.com/office/drawing/2014/main" id="{9DA799FD-2AF4-4B1D-A8F2-D29F4CBBDF4E}"/>
               </a:ext>
             </a:extLst>
           </p:cNvPr>
@@ -3646,7 +3646,7 @@
           <p:cNvPr id="6" name="">
             <a:extLst xmlns:a="http://schemas.openxmlformats.org/drawingml/2006/main">
               <a:ext uri="{FF2B5EF4-FFF2-40B4-BE49-F238E27FC236}">
-                <a16:creationId xmlns:a16="http://schemas.microsoft.com/office/drawing/2014/main" id="{6DB58CBC-BA5C-4F54-932A-52155C9FBDE3}"/>
+                <a16:creationId xmlns:a16="http://schemas.microsoft.com/office/drawing/2014/main" id="{D56FB0FB-A3A3-4287-846B-77190F22BA86}"/>
               </a:ext>
             </a:extLst>
           </p:cNvPr>
@@ -3753,7 +3753,7 @@
           <p:cNvPr id="9" name="">
             <a:extLst xmlns:a="http://schemas.openxmlformats.org/drawingml/2006/main">
               <a:ext uri="{FF2B5EF4-FFF2-40B4-BE49-F238E27FC236}">
-                <a16:creationId xmlns:a16="http://schemas.microsoft.com/office/drawing/2014/main" id="{C39433BB-FB79-4E91-BB4F-C7AF06F4E0BC}"/>
+                <a16:creationId xmlns:a16="http://schemas.microsoft.com/office/drawing/2014/main" id="{98E1F8C2-8357-4F42-9DEF-34830270E436}"/>
               </a:ext>
             </a:extLst>
           </p:cNvPr>
@@ -3833,7 +3833,7 @@
           <p:cNvPr id="10" name="">
             <a:extLst xmlns:a="http://schemas.openxmlformats.org/drawingml/2006/main">
               <a:ext uri="{FF2B5EF4-FFF2-40B4-BE49-F238E27FC236}">
-                <a16:creationId xmlns:a16="http://schemas.microsoft.com/office/drawing/2014/main" id="{394D28DC-C853-4CD6-A707-CFB72D9B6E25}"/>
+                <a16:creationId xmlns:a16="http://schemas.microsoft.com/office/drawing/2014/main" id="{EB74A9F1-52BD-4344-B098-F700C05BBC1D}"/>
               </a:ext>
             </a:extLst>
           </p:cNvPr>
@@ -3913,7 +3913,7 @@
           <p:cNvPr id="11" name="">
             <a:extLst xmlns:a="http://schemas.openxmlformats.org/drawingml/2006/main">
               <a:ext uri="{FF2B5EF4-FFF2-40B4-BE49-F238E27FC236}">
-                <a16:creationId xmlns:a16="http://schemas.microsoft.com/office/drawing/2014/main" id="{4A901C36-94C7-4D87-AE11-934E00008A9D}"/>
+                <a16:creationId xmlns:a16="http://schemas.microsoft.com/office/drawing/2014/main" id="{9B27D420-94A6-4FC6-BD06-ED13ED3C7A4B}"/>
               </a:ext>
             </a:extLst>
           </p:cNvPr>
@@ -3993,7 +3993,7 @@
           <p:cNvPr id="12" name="">
             <a:extLst xmlns:a="http://schemas.openxmlformats.org/drawingml/2006/main">
               <a:ext uri="{FF2B5EF4-FFF2-40B4-BE49-F238E27FC236}">
-                <a16:creationId xmlns:a16="http://schemas.microsoft.com/office/drawing/2014/main" id="{74E4E518-DA47-4765-A73A-8BD49CC5221B}"/>
+                <a16:creationId xmlns:a16="http://schemas.microsoft.com/office/drawing/2014/main" id="{60E2FB1D-5B26-42E3-B597-F5A5CA0FC0CA}"/>
               </a:ext>
             </a:extLst>
           </p:cNvPr>
@@ -4048,7 +4048,7 @@
     </p:spTree>
     <p:extLst>
       <p:ext uri="{BB962C8B-B14F-4D97-AF65-F5344CB8AC3E}">
-        <p14:creationId xmlns:p14="http://schemas.microsoft.com/office/powerpoint/2010/main" val="474400926"/>
+        <p14:creationId xmlns:p14="http://schemas.microsoft.com/office/powerpoint/2010/main" val="732918739"/>
       </p:ext>
     </p:extLst>
   </p:cSld>
@@ -4079,7 +4079,7 @@
           <p:cNvPr id="8" name="">
             <a:extLst xmlns:a="http://schemas.openxmlformats.org/drawingml/2006/main">
               <a:ext uri="{FF2B5EF4-FFF2-40B4-BE49-F238E27FC236}">
-                <a16:creationId xmlns:a16="http://schemas.microsoft.com/office/drawing/2014/main" id="{A1FBB9DB-C429-475D-9B44-C28885BDCADD}"/>
+                <a16:creationId xmlns:a16="http://schemas.microsoft.com/office/drawing/2014/main" id="{C4E71D1D-15E0-4D92-A742-C88F4834FE0D}"/>
               </a:ext>
             </a:extLst>
           </p:cNvPr>
@@ -4136,7 +4136,7 @@
           <p:cNvPr id="2" name="">
             <a:extLst xmlns:a="http://schemas.openxmlformats.org/drawingml/2006/main">
               <a:ext uri="{FF2B5EF4-FFF2-40B4-BE49-F238E27FC236}">
-                <a16:creationId xmlns:a16="http://schemas.microsoft.com/office/drawing/2014/main" id="{9E1C6CBE-0FA1-475F-A874-BCC0034F4E58}"/>
+                <a16:creationId xmlns:a16="http://schemas.microsoft.com/office/drawing/2014/main" id="{88AF808E-966C-4F30-A11C-C082E44848D3}"/>
               </a:ext>
             </a:extLst>
           </p:cNvPr>
@@ -4193,7 +4193,7 @@
           <p:cNvPr id="3" name="">
             <a:extLst xmlns:a="http://schemas.openxmlformats.org/drawingml/2006/main">
               <a:ext uri="{FF2B5EF4-FFF2-40B4-BE49-F238E27FC236}">
-                <a16:creationId xmlns:a16="http://schemas.microsoft.com/office/drawing/2014/main" id="{BF8BA3AA-1573-4083-81A6-E36887DA0606}"/>
+                <a16:creationId xmlns:a16="http://schemas.microsoft.com/office/drawing/2014/main" id="{5458842C-3E3C-4617-BCA0-41BD75079084}"/>
               </a:ext>
             </a:extLst>
           </p:cNvPr>
@@ -4250,7 +4250,7 @@
           <p:cNvPr id="4" name="">
             <a:extLst xmlns:a="http://schemas.openxmlformats.org/drawingml/2006/main">
               <a:ext uri="{FF2B5EF4-FFF2-40B4-BE49-F238E27FC236}">
-                <a16:creationId xmlns:a16="http://schemas.microsoft.com/office/drawing/2014/main" id="{2CEB7D61-4513-41F0-87BD-03A6FE593805}"/>
+                <a16:creationId xmlns:a16="http://schemas.microsoft.com/office/drawing/2014/main" id="{871BAC46-1C1C-4938-B47C-D1BA369116DB}"/>
               </a:ext>
             </a:extLst>
           </p:cNvPr>
@@ -4307,7 +4307,7 @@
           <p:cNvPr id="5" name="">
             <a:extLst xmlns:a="http://schemas.openxmlformats.org/drawingml/2006/main">
               <a:ext uri="{FF2B5EF4-FFF2-40B4-BE49-F238E27FC236}">
-                <a16:creationId xmlns:a16="http://schemas.microsoft.com/office/drawing/2014/main" id="{194AB657-180D-43A5-82D3-F3F0441B128D}"/>
+                <a16:creationId xmlns:a16="http://schemas.microsoft.com/office/drawing/2014/main" id="{FBCDFB2E-2589-49D7-9957-6DBA1852842D}"/>
               </a:ext>
             </a:extLst>
           </p:cNvPr>
@@ -4410,7 +4410,7 @@
           <p:cNvPr id="6" name="">
             <a:extLst xmlns:a="http://schemas.openxmlformats.org/drawingml/2006/main">
               <a:ext uri="{FF2B5EF4-FFF2-40B4-BE49-F238E27FC236}">
-                <a16:creationId xmlns:a16="http://schemas.microsoft.com/office/drawing/2014/main" id="{3CDDEFFF-283D-4F2C-9893-D948FE8FB037}"/>
+                <a16:creationId xmlns:a16="http://schemas.microsoft.com/office/drawing/2014/main" id="{B6FE3C5D-F8B7-4092-9184-1C1918659427}"/>
               </a:ext>
             </a:extLst>
           </p:cNvPr>
@@ -4513,7 +4513,7 @@
           <p:cNvPr id="7" name="">
             <a:extLst xmlns:a="http://schemas.openxmlformats.org/drawingml/2006/main">
               <a:ext uri="{FF2B5EF4-FFF2-40B4-BE49-F238E27FC236}">
-                <a16:creationId xmlns:a16="http://schemas.microsoft.com/office/drawing/2014/main" id="{9ADC6AAD-5225-41E5-96A6-0C859BBC33A3}"/>
+                <a16:creationId xmlns:a16="http://schemas.microsoft.com/office/drawing/2014/main" id="{E472C7E3-0465-4169-964E-FAAB950303AF}"/>
               </a:ext>
             </a:extLst>
           </p:cNvPr>
@@ -4568,7 +4568,7 @@
     </p:spTree>
     <p:extLst>
       <p:ext uri="{BB962C8B-B14F-4D97-AF65-F5344CB8AC3E}">
-        <p14:creationId xmlns:p14="http://schemas.microsoft.com/office/powerpoint/2010/main" val="515625176"/>
+        <p14:creationId xmlns:p14="http://schemas.microsoft.com/office/powerpoint/2010/main" val="1140872120"/>
       </p:ext>
     </p:extLst>
   </p:cSld>
@@ -4599,7 +4599,7 @@
           <p:cNvPr id="10" name="">
             <a:extLst xmlns:a="http://schemas.openxmlformats.org/drawingml/2006/main">
               <a:ext uri="{FF2B5EF4-FFF2-40B4-BE49-F238E27FC236}">
-                <a16:creationId xmlns:a16="http://schemas.microsoft.com/office/drawing/2014/main" id="{1552F973-AA57-4B88-A6DA-8D7E04228DE6}"/>
+                <a16:creationId xmlns:a16="http://schemas.microsoft.com/office/drawing/2014/main" id="{9AEAEC41-0929-4FBF-934B-76E0920105CE}"/>
               </a:ext>
             </a:extLst>
           </p:cNvPr>
@@ -4656,7 +4656,7 @@
           <p:cNvPr id="2" name="">
             <a:extLst xmlns:a="http://schemas.openxmlformats.org/drawingml/2006/main">
               <a:ext uri="{FF2B5EF4-FFF2-40B4-BE49-F238E27FC236}">
-                <a16:creationId xmlns:a16="http://schemas.microsoft.com/office/drawing/2014/main" id="{B804E00F-D8B1-4676-B7B8-0D2DA3C74155}"/>
+                <a16:creationId xmlns:a16="http://schemas.microsoft.com/office/drawing/2014/main" id="{7651A644-B080-455C-8FB2-3C1C8753FBE7}"/>
               </a:ext>
             </a:extLst>
           </p:cNvPr>
@@ -4759,7 +4759,7 @@
           <p:cNvPr id="3" name="">
             <a:extLst xmlns:a="http://schemas.openxmlformats.org/drawingml/2006/main">
               <a:ext uri="{FF2B5EF4-FFF2-40B4-BE49-F238E27FC236}">
-                <a16:creationId xmlns:a16="http://schemas.microsoft.com/office/drawing/2014/main" id="{956369B7-7FF5-47EA-BE22-57BF882B82A2}"/>
+                <a16:creationId xmlns:a16="http://schemas.microsoft.com/office/drawing/2014/main" id="{D869BB7E-C1EA-499D-928F-C0B996E13CBE}"/>
               </a:ext>
             </a:extLst>
           </p:cNvPr>
@@ -4816,7 +4816,7 @@
           <p:cNvPr id="4" name="">
             <a:extLst xmlns:a="http://schemas.openxmlformats.org/drawingml/2006/main">
               <a:ext uri="{FF2B5EF4-FFF2-40B4-BE49-F238E27FC236}">
-                <a16:creationId xmlns:a16="http://schemas.microsoft.com/office/drawing/2014/main" id="{B0E84A31-4131-49F0-80F6-1085FE56CAD2}"/>
+                <a16:creationId xmlns:a16="http://schemas.microsoft.com/office/drawing/2014/main" id="{64B02357-D0B2-4FBF-93C3-B91157105B64}"/>
               </a:ext>
             </a:extLst>
           </p:cNvPr>
@@ -4873,7 +4873,7 @@
           <p:cNvPr id="5" name="">
             <a:extLst xmlns:a="http://schemas.openxmlformats.org/drawingml/2006/main">
               <a:ext uri="{FF2B5EF4-FFF2-40B4-BE49-F238E27FC236}">
-                <a16:creationId xmlns:a16="http://schemas.microsoft.com/office/drawing/2014/main" id="{DBC69723-3D4D-4887-9862-1DC6024790F7}"/>
+                <a16:creationId xmlns:a16="http://schemas.microsoft.com/office/drawing/2014/main" id="{13A908F7-5DD3-48D3-8CA2-8AA2A17A9DA8}"/>
               </a:ext>
             </a:extLst>
           </p:cNvPr>
@@ -4955,7 +4955,7 @@
           <p:cNvPr id="7" name="">
             <a:extLst xmlns:a="http://schemas.openxmlformats.org/drawingml/2006/main">
               <a:ext uri="{FF2B5EF4-FFF2-40B4-BE49-F238E27FC236}">
-                <a16:creationId xmlns:a16="http://schemas.microsoft.com/office/drawing/2014/main" id="{4865DB6C-1EB9-4EA3-95A7-F8B61DF03842}"/>
+                <a16:creationId xmlns:a16="http://schemas.microsoft.com/office/drawing/2014/main" id="{DE997B8B-97F6-4FB1-A08F-56D7D35F92CB}"/>
               </a:ext>
             </a:extLst>
           </p:cNvPr>
@@ -5012,7 +5012,7 @@
           <p:cNvPr id="8" name="">
             <a:extLst xmlns:a="http://schemas.openxmlformats.org/drawingml/2006/main">
               <a:ext uri="{FF2B5EF4-FFF2-40B4-BE49-F238E27FC236}">
-                <a16:creationId xmlns:a16="http://schemas.microsoft.com/office/drawing/2014/main" id="{4ABDB5C6-911F-4DDB-9BD5-E54D5BF59BA7}"/>
+                <a16:creationId xmlns:a16="http://schemas.microsoft.com/office/drawing/2014/main" id="{A8788BDA-87A4-4149-B9CC-0F831F0A4724}"/>
               </a:ext>
             </a:extLst>
           </p:cNvPr>
@@ -5115,7 +5115,7 @@
           <p:cNvPr id="9" name="">
             <a:extLst xmlns:a="http://schemas.openxmlformats.org/drawingml/2006/main">
               <a:ext uri="{FF2B5EF4-FFF2-40B4-BE49-F238E27FC236}">
-                <a16:creationId xmlns:a16="http://schemas.microsoft.com/office/drawing/2014/main" id="{F63C5746-0B83-4731-8ED1-A450042222A4}"/>
+                <a16:creationId xmlns:a16="http://schemas.microsoft.com/office/drawing/2014/main" id="{9021A3D2-D42C-4981-947A-D513786E232B}"/>
               </a:ext>
             </a:extLst>
           </p:cNvPr>
@@ -5170,7 +5170,7 @@
     </p:spTree>
     <p:extLst>
       <p:ext uri="{BB962C8B-B14F-4D97-AF65-F5344CB8AC3E}">
-        <p14:creationId xmlns:p14="http://schemas.microsoft.com/office/powerpoint/2010/main" val="677416903"/>
+        <p14:creationId xmlns:p14="http://schemas.microsoft.com/office/powerpoint/2010/main" val="147194026"/>
       </p:ext>
     </p:extLst>
   </p:cSld>
@@ -5201,7 +5201,7 @@
           <p:cNvPr id="12" name="">
             <a:extLst xmlns:a="http://schemas.openxmlformats.org/drawingml/2006/main">
               <a:ext uri="{FF2B5EF4-FFF2-40B4-BE49-F238E27FC236}">
-                <a16:creationId xmlns:a16="http://schemas.microsoft.com/office/drawing/2014/main" id="{8ECBAA3C-52C0-4DF2-AAD6-4243772885B6}"/>
+                <a16:creationId xmlns:a16="http://schemas.microsoft.com/office/drawing/2014/main" id="{0F93B6EC-2044-483F-A510-09D159485F80}"/>
               </a:ext>
             </a:extLst>
           </p:cNvPr>
@@ -5258,7 +5258,7 @@
           <p:cNvPr id="2" name="">
             <a:extLst xmlns:a="http://schemas.openxmlformats.org/drawingml/2006/main">
               <a:ext uri="{FF2B5EF4-FFF2-40B4-BE49-F238E27FC236}">
-                <a16:creationId xmlns:a16="http://schemas.microsoft.com/office/drawing/2014/main" id="{80A7451B-3DFC-4827-860F-44559B4EC8CB}"/>
+                <a16:creationId xmlns:a16="http://schemas.microsoft.com/office/drawing/2014/main" id="{2F19CCFC-F352-4A91-9285-4D2C95F3852A}"/>
               </a:ext>
             </a:extLst>
           </p:cNvPr>
@@ -5315,7 +5315,7 @@
           <p:cNvPr id="3" name="">
             <a:extLst xmlns:a="http://schemas.openxmlformats.org/drawingml/2006/main">
               <a:ext uri="{FF2B5EF4-FFF2-40B4-BE49-F238E27FC236}">
-                <a16:creationId xmlns:a16="http://schemas.microsoft.com/office/drawing/2014/main" id="{178B5A72-2A27-4B14-AA75-CBC05F70FED9}"/>
+                <a16:creationId xmlns:a16="http://schemas.microsoft.com/office/drawing/2014/main" id="{C899FA81-E5AD-436A-A6C6-DFC43152211B}"/>
               </a:ext>
             </a:extLst>
           </p:cNvPr>
@@ -5376,7 +5376,7 @@
           <p:nvPr/>
         </p:nvPicPr>
         <p:blipFill>
-          <a:blip xmlns:r="http://schemas.openxmlformats.org/officeDocument/2006/relationships" xmlns:a="http://schemas.openxmlformats.org/drawingml/2006/main" r:embed="R7e2776c2f2c34d69"/>
+          <a:blip xmlns:r="http://schemas.openxmlformats.org/officeDocument/2006/relationships" xmlns:a="http://schemas.openxmlformats.org/drawingml/2006/main" r:embed="Rd76223ac42c54725"/>
           <a:stretch xmlns:a="http://schemas.openxmlformats.org/drawingml/2006/main"/>
         </p:blipFill>
         <p:spPr>
@@ -5394,7 +5394,7 @@
           <p:cNvPr id="5" name="">
             <a:extLst xmlns:a="http://schemas.openxmlformats.org/drawingml/2006/main">
               <a:ext uri="{FF2B5EF4-FFF2-40B4-BE49-F238E27FC236}">
-                <a16:creationId xmlns:a16="http://schemas.microsoft.com/office/drawing/2014/main" id="{87F41FBE-9854-4A24-B6C8-F7C45DC89A96}"/>
+                <a16:creationId xmlns:a16="http://schemas.microsoft.com/office/drawing/2014/main" id="{6B2A251C-CCBC-4183-9A64-E009BAF53F14}"/>
               </a:ext>
             </a:extLst>
           </p:cNvPr>
@@ -5451,7 +5451,7 @@
           <p:cNvPr id="6" name="">
             <a:extLst xmlns:a="http://schemas.openxmlformats.org/drawingml/2006/main">
               <a:ext uri="{FF2B5EF4-FFF2-40B4-BE49-F238E27FC236}">
-                <a16:creationId xmlns:a16="http://schemas.microsoft.com/office/drawing/2014/main" id="{E9A87290-B3E1-436A-A99D-C82A09C9406E}"/>
+                <a16:creationId xmlns:a16="http://schemas.microsoft.com/office/drawing/2014/main" id="{B6DC324D-86BA-4A85-BE27-CE39904C0183}"/>
               </a:ext>
             </a:extLst>
           </p:cNvPr>
@@ -5508,7 +5508,7 @@
           <p:cNvPr id="7" name="">
             <a:extLst xmlns:a="http://schemas.openxmlformats.org/drawingml/2006/main">
               <a:ext uri="{FF2B5EF4-FFF2-40B4-BE49-F238E27FC236}">
-                <a16:creationId xmlns:a16="http://schemas.microsoft.com/office/drawing/2014/main" id="{88FAB194-9C69-4BF7-B091-5902DEC1E165}"/>
+                <a16:creationId xmlns:a16="http://schemas.microsoft.com/office/drawing/2014/main" id="{F6F944CE-9979-4AEE-85BA-B577B601F82D}"/>
               </a:ext>
             </a:extLst>
           </p:cNvPr>
@@ -5565,7 +5565,7 @@
           <p:cNvPr id="8" name="">
             <a:extLst xmlns:a="http://schemas.openxmlformats.org/drawingml/2006/main">
               <a:ext uri="{FF2B5EF4-FFF2-40B4-BE49-F238E27FC236}">
-                <a16:creationId xmlns:a16="http://schemas.microsoft.com/office/drawing/2014/main" id="{F1FEF392-D66E-4867-99FC-D16C57DE5787}"/>
+                <a16:creationId xmlns:a16="http://schemas.microsoft.com/office/drawing/2014/main" id="{0FEBD3F2-5A6E-458D-ADF4-648922233CF9}"/>
               </a:ext>
             </a:extLst>
           </p:cNvPr>
@@ -5622,7 +5622,7 @@
           <p:cNvPr id="9" name="">
             <a:extLst xmlns:a="http://schemas.openxmlformats.org/drawingml/2006/main">
               <a:ext uri="{FF2B5EF4-FFF2-40B4-BE49-F238E27FC236}">
-                <a16:creationId xmlns:a16="http://schemas.microsoft.com/office/drawing/2014/main" id="{2F108CF1-FF51-4263-A839-4BFA3AE98601}"/>
+                <a16:creationId xmlns:a16="http://schemas.microsoft.com/office/drawing/2014/main" id="{0AAB1F71-467B-4650-8BCB-943F9F99608F}"/>
               </a:ext>
             </a:extLst>
           </p:cNvPr>
@@ -5679,7 +5679,7 @@
           <p:cNvPr id="10" name="">
             <a:extLst xmlns:a="http://schemas.openxmlformats.org/drawingml/2006/main">
               <a:ext uri="{FF2B5EF4-FFF2-40B4-BE49-F238E27FC236}">
-                <a16:creationId xmlns:a16="http://schemas.microsoft.com/office/drawing/2014/main" id="{9EA48DAD-FAF8-4233-864B-0717943F70FC}"/>
+                <a16:creationId xmlns:a16="http://schemas.microsoft.com/office/drawing/2014/main" id="{71C9C747-1435-444C-8062-3D33C992E422}"/>
               </a:ext>
             </a:extLst>
           </p:cNvPr>
@@ -5736,7 +5736,7 @@
           <p:cNvPr id="11" name="">
             <a:extLst xmlns:a="http://schemas.openxmlformats.org/drawingml/2006/main">
               <a:ext uri="{FF2B5EF4-FFF2-40B4-BE49-F238E27FC236}">
-                <a16:creationId xmlns:a16="http://schemas.microsoft.com/office/drawing/2014/main" id="{8C329736-38FE-4E3F-881A-C7404B10FF21}"/>
+                <a16:creationId xmlns:a16="http://schemas.microsoft.com/office/drawing/2014/main" id="{02C81E5A-946F-4C3B-9A9E-F02253FF1F06}"/>
               </a:ext>
             </a:extLst>
           </p:cNvPr>
@@ -5791,7 +5791,7 @@
     </p:spTree>
     <p:extLst>
       <p:ext uri="{BB962C8B-B14F-4D97-AF65-F5344CB8AC3E}">
-        <p14:creationId xmlns:p14="http://schemas.microsoft.com/office/powerpoint/2010/main" val="1653473882"/>
+        <p14:creationId xmlns:p14="http://schemas.microsoft.com/office/powerpoint/2010/main" val="748814572"/>
       </p:ext>
     </p:extLst>
   </p:cSld>
@@ -5822,7 +5822,7 @@
           <p:cNvPr id="8" name="">
             <a:extLst xmlns:a="http://schemas.openxmlformats.org/drawingml/2006/main">
               <a:ext uri="{FF2B5EF4-FFF2-40B4-BE49-F238E27FC236}">
-                <a16:creationId xmlns:a16="http://schemas.microsoft.com/office/drawing/2014/main" id="{8CD0E92F-D186-4D70-A8EA-C412C734D41C}"/>
+                <a16:creationId xmlns:a16="http://schemas.microsoft.com/office/drawing/2014/main" id="{5E09766A-F545-4986-B8A1-B3A0D4771FF2}"/>
               </a:ext>
             </a:extLst>
           </p:cNvPr>
@@ -5879,7 +5879,7 @@
           <p:cNvPr id="2" name="">
             <a:extLst xmlns:a="http://schemas.openxmlformats.org/drawingml/2006/main">
               <a:ext uri="{FF2B5EF4-FFF2-40B4-BE49-F238E27FC236}">
-                <a16:creationId xmlns:a16="http://schemas.microsoft.com/office/drawing/2014/main" id="{C0DA9ED9-537A-4D9C-A04B-7246E0CCE1E1}"/>
+                <a16:creationId xmlns:a16="http://schemas.microsoft.com/office/drawing/2014/main" id="{979E8ADF-B492-4022-B14C-F51F5696BC74}"/>
               </a:ext>
             </a:extLst>
           </p:cNvPr>
@@ -5982,7 +5982,7 @@
           <p:cNvPr id="3" name="">
             <a:extLst xmlns:a="http://schemas.openxmlformats.org/drawingml/2006/main">
               <a:ext uri="{FF2B5EF4-FFF2-40B4-BE49-F238E27FC236}">
-                <a16:creationId xmlns:a16="http://schemas.microsoft.com/office/drawing/2014/main" id="{12CC1887-982F-46E4-B626-8B1DDF9BE794}"/>
+                <a16:creationId xmlns:a16="http://schemas.microsoft.com/office/drawing/2014/main" id="{3AD2F879-5468-42FB-B93D-DCF9B1BBE7A5}"/>
               </a:ext>
             </a:extLst>
           </p:cNvPr>
@@ -6039,7 +6039,7 @@
           <p:cNvPr id="4" name="">
             <a:extLst xmlns:a="http://schemas.openxmlformats.org/drawingml/2006/main">
               <a:ext uri="{FF2B5EF4-FFF2-40B4-BE49-F238E27FC236}">
-                <a16:creationId xmlns:a16="http://schemas.microsoft.com/office/drawing/2014/main" id="{17D38C92-6B19-492E-A41E-94340ECD1944}"/>
+                <a16:creationId xmlns:a16="http://schemas.microsoft.com/office/drawing/2014/main" id="{8B080338-1FC9-4115-B4D7-C67BB675A576}"/>
               </a:ext>
             </a:extLst>
           </p:cNvPr>
@@ -6096,7 +6096,7 @@
           <p:cNvPr id="5" name="">
             <a:extLst xmlns:a="http://schemas.openxmlformats.org/drawingml/2006/main">
               <a:ext uri="{FF2B5EF4-FFF2-40B4-BE49-F238E27FC236}">
-                <a16:creationId xmlns:a16="http://schemas.microsoft.com/office/drawing/2014/main" id="{A96E4E72-6112-4EEF-ACAA-4367B57A68DF}"/>
+                <a16:creationId xmlns:a16="http://schemas.microsoft.com/office/drawing/2014/main" id="{7A91EC0A-5237-4156-84B3-30E218DA4DEB}"/>
               </a:ext>
             </a:extLst>
           </p:cNvPr>
@@ -6153,7 +6153,7 @@
           <p:cNvPr id="6" name="">
             <a:extLst xmlns:a="http://schemas.openxmlformats.org/drawingml/2006/main">
               <a:ext uri="{FF2B5EF4-FFF2-40B4-BE49-F238E27FC236}">
-                <a16:creationId xmlns:a16="http://schemas.microsoft.com/office/drawing/2014/main" id="{4CDC1C76-D072-40FA-9E6D-794F2A238145}"/>
+                <a16:creationId xmlns:a16="http://schemas.microsoft.com/office/drawing/2014/main" id="{1D4346C1-97B1-468F-AE9E-FBF18DECB5F7}"/>
               </a:ext>
             </a:extLst>
           </p:cNvPr>
@@ -6214,13 +6214,13 @@
           <p:nvPr/>
         </p:nvPicPr>
         <p:blipFill>
-          <a:blip xmlns:r="http://schemas.openxmlformats.org/officeDocument/2006/relationships" xmlns:a="http://schemas.openxmlformats.org/drawingml/2006/main" r:embed="R4b124bac01364fdb"/>
+          <a:blip xmlns:r="http://schemas.openxmlformats.org/officeDocument/2006/relationships" xmlns:a="http://schemas.openxmlformats.org/drawingml/2006/main" r:embed="R133051b562b14b91"/>
           <a:stretch xmlns:a="http://schemas.openxmlformats.org/drawingml/2006/main"/>
         </p:blipFill>
         <p:spPr>
           <a:xfrm xmlns:a="http://schemas.openxmlformats.org/drawingml/2006/main">
-            <a:off x="5387248" y="1266825"/>
-            <a:ext cx="6332404" cy="4238625"/>
+            <a:off x="5600700" y="1028700"/>
+            <a:ext cx="5905500" cy="5105400"/>
           </a:xfrm>
           <a:prstGeom xmlns:a="http://schemas.openxmlformats.org/drawingml/2006/main" prst="rect">
             <a:avLst/>
@@ -6230,7 +6230,7 @@
     </p:spTree>
     <p:extLst>
       <p:ext uri="{BB962C8B-B14F-4D97-AF65-F5344CB8AC3E}">
-        <p14:creationId xmlns:p14="http://schemas.microsoft.com/office/powerpoint/2010/main" val="1649432144"/>
+        <p14:creationId xmlns:p14="http://schemas.microsoft.com/office/powerpoint/2010/main" val="470279024"/>
       </p:ext>
     </p:extLst>
   </p:cSld>
@@ -6261,7 +6261,7 @@
           <p:cNvPr id="12" name="">
             <a:extLst xmlns:a="http://schemas.openxmlformats.org/drawingml/2006/main">
               <a:ext uri="{FF2B5EF4-FFF2-40B4-BE49-F238E27FC236}">
-                <a16:creationId xmlns:a16="http://schemas.microsoft.com/office/drawing/2014/main" id="{BD9078AA-65F4-40D5-83DB-B346AE052801}"/>
+                <a16:creationId xmlns:a16="http://schemas.microsoft.com/office/drawing/2014/main" id="{78E73A5A-8573-4AB2-A37C-18A791D52A7D}"/>
               </a:ext>
             </a:extLst>
           </p:cNvPr>
@@ -6318,7 +6318,7 @@
           <p:cNvPr id="2" name="">
             <a:extLst xmlns:a="http://schemas.openxmlformats.org/drawingml/2006/main">
               <a:ext uri="{FF2B5EF4-FFF2-40B4-BE49-F238E27FC236}">
-                <a16:creationId xmlns:a16="http://schemas.microsoft.com/office/drawing/2014/main" id="{DC6A6A22-15B0-40E8-A9E0-9597A6EB7E31}"/>
+                <a16:creationId xmlns:a16="http://schemas.microsoft.com/office/drawing/2014/main" id="{3925739F-A1B6-429E-BD07-0D763E01C3BA}"/>
               </a:ext>
             </a:extLst>
           </p:cNvPr>
@@ -6398,7 +6398,7 @@
           <p:cNvPr id="3" name="">
             <a:extLst xmlns:a="http://schemas.openxmlformats.org/drawingml/2006/main">
               <a:ext uri="{FF2B5EF4-FFF2-40B4-BE49-F238E27FC236}">
-                <a16:creationId xmlns:a16="http://schemas.microsoft.com/office/drawing/2014/main" id="{2E8ED396-F9D7-4C1E-B048-672C3DD750B4}"/>
+                <a16:creationId xmlns:a16="http://schemas.microsoft.com/office/drawing/2014/main" id="{A0DE91F1-6DC1-4660-8276-5216C73FF659}"/>
               </a:ext>
             </a:extLst>
           </p:cNvPr>
@@ -6455,7 +6455,7 @@
           <p:cNvPr id="4" name="">
             <a:extLst xmlns:a="http://schemas.openxmlformats.org/drawingml/2006/main">
               <a:ext uri="{FF2B5EF4-FFF2-40B4-BE49-F238E27FC236}">
-                <a16:creationId xmlns:a16="http://schemas.microsoft.com/office/drawing/2014/main" id="{4B198C70-8098-492F-8CF7-4090834EE7E7}"/>
+                <a16:creationId xmlns:a16="http://schemas.microsoft.com/office/drawing/2014/main" id="{19E83B18-A2F2-4CE1-91A4-DFFC2407D7D4}"/>
               </a:ext>
             </a:extLst>
           </p:cNvPr>
@@ -6512,7 +6512,7 @@
           <p:cNvPr id="5" name="">
             <a:extLst xmlns:a="http://schemas.openxmlformats.org/drawingml/2006/main">
               <a:ext uri="{FF2B5EF4-FFF2-40B4-BE49-F238E27FC236}">
-                <a16:creationId xmlns:a16="http://schemas.microsoft.com/office/drawing/2014/main" id="{C4F3EAC8-45B4-494E-A774-50D1C2B89076}"/>
+                <a16:creationId xmlns:a16="http://schemas.microsoft.com/office/drawing/2014/main" id="{D0EB8CCD-E095-4DB8-86B3-C3864DF09A83}"/>
               </a:ext>
             </a:extLst>
           </p:cNvPr>
@@ -6569,7 +6569,7 @@
           <p:cNvPr id="6" name="">
             <a:extLst xmlns:a="http://schemas.openxmlformats.org/drawingml/2006/main">
               <a:ext uri="{FF2B5EF4-FFF2-40B4-BE49-F238E27FC236}">
-                <a16:creationId xmlns:a16="http://schemas.microsoft.com/office/drawing/2014/main" id="{34E9D5C6-2B20-48AE-972A-806C2FC7CC24}"/>
+                <a16:creationId xmlns:a16="http://schemas.microsoft.com/office/drawing/2014/main" id="{238F7747-68A9-4820-A5F5-7E144A46A371}"/>
               </a:ext>
             </a:extLst>
           </p:cNvPr>
@@ -6626,7 +6626,7 @@
           <p:cNvPr id="7" name="">
             <a:extLst xmlns:a="http://schemas.openxmlformats.org/drawingml/2006/main">
               <a:ext uri="{FF2B5EF4-FFF2-40B4-BE49-F238E27FC236}">
-                <a16:creationId xmlns:a16="http://schemas.microsoft.com/office/drawing/2014/main" id="{957CECE9-E37A-4E6E-82B9-4DC58D2752DD}"/>
+                <a16:creationId xmlns:a16="http://schemas.microsoft.com/office/drawing/2014/main" id="{91CF7208-C1AF-478F-B3D7-6C5109CA7D7C}"/>
               </a:ext>
             </a:extLst>
           </p:cNvPr>
@@ -6683,7 +6683,7 @@
           <p:cNvPr id="8" name="">
             <a:extLst xmlns:a="http://schemas.openxmlformats.org/drawingml/2006/main">
               <a:ext uri="{FF2B5EF4-FFF2-40B4-BE49-F238E27FC236}">
-                <a16:creationId xmlns:a16="http://schemas.microsoft.com/office/drawing/2014/main" id="{30E5414B-0DFD-4716-9210-572FBBE764D7}"/>
+                <a16:creationId xmlns:a16="http://schemas.microsoft.com/office/drawing/2014/main" id="{D0A1D67E-A707-4D5F-825A-88AA2DA3FE66}"/>
               </a:ext>
             </a:extLst>
           </p:cNvPr>
@@ -6740,7 +6740,7 @@
           <p:cNvPr id="9" name="">
             <a:extLst xmlns:a="http://schemas.openxmlformats.org/drawingml/2006/main">
               <a:ext uri="{FF2B5EF4-FFF2-40B4-BE49-F238E27FC236}">
-                <a16:creationId xmlns:a16="http://schemas.microsoft.com/office/drawing/2014/main" id="{CBAE4850-31E8-45CA-B62A-575954D0A02B}"/>
+                <a16:creationId xmlns:a16="http://schemas.microsoft.com/office/drawing/2014/main" id="{A77F05A8-225C-48D9-953B-4AFE6297267F}"/>
               </a:ext>
             </a:extLst>
           </p:cNvPr>
@@ -6801,7 +6801,7 @@
           <p:nvPr/>
         </p:nvPicPr>
         <p:blipFill>
-          <a:blip xmlns:r="http://schemas.openxmlformats.org/officeDocument/2006/relationships" xmlns:a="http://schemas.openxmlformats.org/drawingml/2006/main" r:embed="R8a1d81149ac44c92"/>
+          <a:blip xmlns:r="http://schemas.openxmlformats.org/officeDocument/2006/relationships" xmlns:a="http://schemas.openxmlformats.org/drawingml/2006/main" r:embed="R0652395d9b5b4c91"/>
           <a:stretch xmlns:a="http://schemas.openxmlformats.org/drawingml/2006/main"/>
         </p:blipFill>
         <p:spPr>
@@ -6819,7 +6819,7 @@
           <p:cNvPr id="11" name="">
             <a:extLst xmlns:a="http://schemas.openxmlformats.org/drawingml/2006/main">
               <a:ext uri="{FF2B5EF4-FFF2-40B4-BE49-F238E27FC236}">
-                <a16:creationId xmlns:a16="http://schemas.microsoft.com/office/drawing/2014/main" id="{23B9891E-96E6-4DA4-90AA-439AB684D51D}"/>
+                <a16:creationId xmlns:a16="http://schemas.microsoft.com/office/drawing/2014/main" id="{2292BD01-9397-4177-A944-B31BB89E5B5A}"/>
               </a:ext>
             </a:extLst>
           </p:cNvPr>
@@ -6874,7 +6874,7 @@
     </p:spTree>
     <p:extLst>
       <p:ext uri="{BB962C8B-B14F-4D97-AF65-F5344CB8AC3E}">
-        <p14:creationId xmlns:p14="http://schemas.microsoft.com/office/powerpoint/2010/main" val="1984412140"/>
+        <p14:creationId xmlns:p14="http://schemas.microsoft.com/office/powerpoint/2010/main" val="1791486643"/>
       </p:ext>
     </p:extLst>
   </p:cSld>
@@ -6905,7 +6905,7 @@
           <p:cNvPr id="6" name="">
             <a:extLst xmlns:a="http://schemas.openxmlformats.org/drawingml/2006/main">
               <a:ext uri="{FF2B5EF4-FFF2-40B4-BE49-F238E27FC236}">
-                <a16:creationId xmlns:a16="http://schemas.microsoft.com/office/drawing/2014/main" id="{66AB1DD8-7C63-48C6-8DAC-BC27F972BE4A}"/>
+                <a16:creationId xmlns:a16="http://schemas.microsoft.com/office/drawing/2014/main" id="{5E6433FC-244A-4B66-93C3-BBF626F7F331}"/>
               </a:ext>
             </a:extLst>
           </p:cNvPr>
@@ -6962,7 +6962,7 @@
           <p:cNvPr id="2" name="">
             <a:extLst xmlns:a="http://schemas.openxmlformats.org/drawingml/2006/main">
               <a:ext uri="{FF2B5EF4-FFF2-40B4-BE49-F238E27FC236}">
-                <a16:creationId xmlns:a16="http://schemas.microsoft.com/office/drawing/2014/main" id="{AD0590D1-0A8E-4055-A629-020DF0ED63DC}"/>
+                <a16:creationId xmlns:a16="http://schemas.microsoft.com/office/drawing/2014/main" id="{AFE6CFF2-9AC4-4D6F-B3FC-C7846C355F99}"/>
               </a:ext>
             </a:extLst>
           </p:cNvPr>
@@ -7019,7 +7019,7 @@
           <p:cNvPr id="3" name="">
             <a:extLst xmlns:a="http://schemas.openxmlformats.org/drawingml/2006/main">
               <a:ext uri="{FF2B5EF4-FFF2-40B4-BE49-F238E27FC236}">
-                <a16:creationId xmlns:a16="http://schemas.microsoft.com/office/drawing/2014/main" id="{4792FE17-6CA2-4155-BA90-341E6E7D4886}"/>
+                <a16:creationId xmlns:a16="http://schemas.microsoft.com/office/drawing/2014/main" id="{97EA139C-DB07-4CBD-804D-9BF6EDB721DA}"/>
               </a:ext>
             </a:extLst>
           </p:cNvPr>
@@ -7080,7 +7080,7 @@
           <p:nvPr/>
         </p:nvPicPr>
         <p:blipFill>
-          <a:blip xmlns:r="http://schemas.openxmlformats.org/officeDocument/2006/relationships" xmlns:a="http://schemas.openxmlformats.org/drawingml/2006/main" r:embed="R55514447da8d4219"/>
+          <a:blip xmlns:r="http://schemas.openxmlformats.org/officeDocument/2006/relationships" xmlns:a="http://schemas.openxmlformats.org/drawingml/2006/main" r:embed="R27b688d7a16248d0"/>
           <a:stretch xmlns:a="http://schemas.openxmlformats.org/drawingml/2006/main"/>
         </p:blipFill>
         <p:spPr>
@@ -7098,7 +7098,7 @@
           <p:cNvPr id="5" name="">
             <a:extLst xmlns:a="http://schemas.openxmlformats.org/drawingml/2006/main">
               <a:ext uri="{FF2B5EF4-FFF2-40B4-BE49-F238E27FC236}">
-                <a16:creationId xmlns:a16="http://schemas.microsoft.com/office/drawing/2014/main" id="{0AC3A349-2D06-4927-AFC7-B864FE6CF256}"/>
+                <a16:creationId xmlns:a16="http://schemas.microsoft.com/office/drawing/2014/main" id="{EC22285A-C8DA-4238-9B64-1ABCF2BD7358}"/>
               </a:ext>
             </a:extLst>
           </p:cNvPr>
@@ -7153,7 +7153,7 @@
     </p:spTree>
     <p:extLst>
       <p:ext uri="{BB962C8B-B14F-4D97-AF65-F5344CB8AC3E}">
-        <p14:creationId xmlns:p14="http://schemas.microsoft.com/office/powerpoint/2010/main" val="58616622"/>
+        <p14:creationId xmlns:p14="http://schemas.microsoft.com/office/powerpoint/2010/main" val="1859985455"/>
       </p:ext>
     </p:extLst>
   </p:cSld>
@@ -7184,7 +7184,7 @@
           <p:cNvPr id="8" name="">
             <a:extLst xmlns:a="http://schemas.openxmlformats.org/drawingml/2006/main">
               <a:ext uri="{FF2B5EF4-FFF2-40B4-BE49-F238E27FC236}">
-                <a16:creationId xmlns:a16="http://schemas.microsoft.com/office/drawing/2014/main" id="{5DCA5C45-035E-48F2-B3B4-880ACD1D7D59}"/>
+                <a16:creationId xmlns:a16="http://schemas.microsoft.com/office/drawing/2014/main" id="{B57EB2C8-06A2-4232-9DEE-C8B0E353B481}"/>
               </a:ext>
             </a:extLst>
           </p:cNvPr>
@@ -7241,7 +7241,7 @@
           <p:cNvPr id="2" name="">
             <a:extLst xmlns:a="http://schemas.openxmlformats.org/drawingml/2006/main">
               <a:ext uri="{FF2B5EF4-FFF2-40B4-BE49-F238E27FC236}">
-                <a16:creationId xmlns:a16="http://schemas.microsoft.com/office/drawing/2014/main" id="{7F9DD7DF-DD54-4CD6-9C35-124AFA25BEBF}"/>
+                <a16:creationId xmlns:a16="http://schemas.microsoft.com/office/drawing/2014/main" id="{B15DCD63-8CA7-4B07-AA8C-478EE81C78CB}"/>
               </a:ext>
             </a:extLst>
           </p:cNvPr>
@@ -7298,7 +7298,7 @@
           <p:cNvPr id="3" name="">
             <a:extLst xmlns:a="http://schemas.openxmlformats.org/drawingml/2006/main">
               <a:ext uri="{FF2B5EF4-FFF2-40B4-BE49-F238E27FC236}">
-                <a16:creationId xmlns:a16="http://schemas.microsoft.com/office/drawing/2014/main" id="{C9DDDDCA-5214-4645-84ED-1D84ACFFA1C8}"/>
+                <a16:creationId xmlns:a16="http://schemas.microsoft.com/office/drawing/2014/main" id="{6D186074-1E5C-4250-83B3-6C81E30FFEAB}"/>
               </a:ext>
             </a:extLst>
           </p:cNvPr>
@@ -7355,7 +7355,7 @@
           <p:cNvPr id="4" name="">
             <a:extLst xmlns:a="http://schemas.openxmlformats.org/drawingml/2006/main">
               <a:ext uri="{FF2B5EF4-FFF2-40B4-BE49-F238E27FC236}">
-                <a16:creationId xmlns:a16="http://schemas.microsoft.com/office/drawing/2014/main" id="{569447AA-1CC5-41DA-9E1A-7130D8C820FD}"/>
+                <a16:creationId xmlns:a16="http://schemas.microsoft.com/office/drawing/2014/main" id="{6F295069-763C-4640-AE01-19B4510DF16D}"/>
               </a:ext>
             </a:extLst>
           </p:cNvPr>
@@ -7439,7 +7439,7 @@
           <p:nvPr/>
         </p:nvPicPr>
         <p:blipFill>
-          <a:blip xmlns:r="http://schemas.openxmlformats.org/officeDocument/2006/relationships" xmlns:a="http://schemas.openxmlformats.org/drawingml/2006/main" r:embed="Re3df9365f31446b3"/>
+          <a:blip xmlns:r="http://schemas.openxmlformats.org/officeDocument/2006/relationships" xmlns:a="http://schemas.openxmlformats.org/drawingml/2006/main" r:embed="Rc0258a91507c4da3"/>
           <a:stretch xmlns:a="http://schemas.openxmlformats.org/drawingml/2006/main"/>
         </p:blipFill>
         <p:spPr>
@@ -7457,7 +7457,7 @@
           <p:cNvPr id="6" name="">
             <a:extLst xmlns:a="http://schemas.openxmlformats.org/drawingml/2006/main">
               <a:ext uri="{FF2B5EF4-FFF2-40B4-BE49-F238E27FC236}">
-                <a16:creationId xmlns:a16="http://schemas.microsoft.com/office/drawing/2014/main" id="{FC86677C-9CF2-4117-926B-243932C2EFD8}"/>
+                <a16:creationId xmlns:a16="http://schemas.microsoft.com/office/drawing/2014/main" id="{53D32409-1DA2-4688-A44A-142A9A97EDF6}"/>
               </a:ext>
             </a:extLst>
           </p:cNvPr>
@@ -7514,7 +7514,7 @@
           <p:cNvPr id="7" name="">
             <a:extLst xmlns:a="http://schemas.openxmlformats.org/drawingml/2006/main">
               <a:ext uri="{FF2B5EF4-FFF2-40B4-BE49-F238E27FC236}">
-                <a16:creationId xmlns:a16="http://schemas.microsoft.com/office/drawing/2014/main" id="{E3DF3B0D-4736-4AFD-A922-68D173419207}"/>
+                <a16:creationId xmlns:a16="http://schemas.microsoft.com/office/drawing/2014/main" id="{D22BD1CC-5363-4441-88DB-0BB63BE592A2}"/>
               </a:ext>
             </a:extLst>
           </p:cNvPr>
@@ -7569,7 +7569,7 @@
     </p:spTree>
     <p:extLst>
       <p:ext uri="{BB962C8B-B14F-4D97-AF65-F5344CB8AC3E}">
-        <p14:creationId xmlns:p14="http://schemas.microsoft.com/office/powerpoint/2010/main" val="458191324"/>
+        <p14:creationId xmlns:p14="http://schemas.microsoft.com/office/powerpoint/2010/main" val="1921805292"/>
       </p:ext>
     </p:extLst>
   </p:cSld>
@@ -7600,7 +7600,7 @@
           <p:cNvPr id="10" name="">
             <a:extLst xmlns:a="http://schemas.openxmlformats.org/drawingml/2006/main">
               <a:ext uri="{FF2B5EF4-FFF2-40B4-BE49-F238E27FC236}">
-                <a16:creationId xmlns:a16="http://schemas.microsoft.com/office/drawing/2014/main" id="{32FEABC0-5DB9-42FC-996D-B7654015AB3E}"/>
+                <a16:creationId xmlns:a16="http://schemas.microsoft.com/office/drawing/2014/main" id="{166ACE43-2190-4242-AB81-7DF36791D65E}"/>
               </a:ext>
             </a:extLst>
           </p:cNvPr>
@@ -7657,7 +7657,7 @@
           <p:cNvPr id="2" name="">
             <a:extLst xmlns:a="http://schemas.openxmlformats.org/drawingml/2006/main">
               <a:ext uri="{FF2B5EF4-FFF2-40B4-BE49-F238E27FC236}">
-                <a16:creationId xmlns:a16="http://schemas.microsoft.com/office/drawing/2014/main" id="{25A44D48-B326-41EE-924F-9C802E19252C}"/>
+                <a16:creationId xmlns:a16="http://schemas.microsoft.com/office/drawing/2014/main" id="{9ABADBE7-6F29-4CC7-B398-FE8E99D28AA6}"/>
               </a:ext>
             </a:extLst>
           </p:cNvPr>
@@ -7714,7 +7714,7 @@
           <p:cNvPr id="3" name="">
             <a:extLst xmlns:a="http://schemas.openxmlformats.org/drawingml/2006/main">
               <a:ext uri="{FF2B5EF4-FFF2-40B4-BE49-F238E27FC236}">
-                <a16:creationId xmlns:a16="http://schemas.microsoft.com/office/drawing/2014/main" id="{F0B150FF-1033-486B-9EF9-10910E2E69B4}"/>
+                <a16:creationId xmlns:a16="http://schemas.microsoft.com/office/drawing/2014/main" id="{904C01D8-3F47-47D6-95C5-2615C20BFE1E}"/>
               </a:ext>
             </a:extLst>
           </p:cNvPr>
@@ -7771,7 +7771,7 @@
           <p:cNvPr id="4" name="">
             <a:extLst xmlns:a="http://schemas.openxmlformats.org/drawingml/2006/main">
               <a:ext uri="{FF2B5EF4-FFF2-40B4-BE49-F238E27FC236}">
-                <a16:creationId xmlns:a16="http://schemas.microsoft.com/office/drawing/2014/main" id="{1BFB302E-0029-49FB-9F33-FE02F3F2205A}"/>
+                <a16:creationId xmlns:a16="http://schemas.microsoft.com/office/drawing/2014/main" id="{63BCA784-523F-43B6-B176-82B78391B741}"/>
               </a:ext>
             </a:extLst>
           </p:cNvPr>
@@ -7828,7 +7828,7 @@
           <p:cNvPr id="5" name="">
             <a:extLst xmlns:a="http://schemas.openxmlformats.org/drawingml/2006/main">
               <a:ext uri="{FF2B5EF4-FFF2-40B4-BE49-F238E27FC236}">
-                <a16:creationId xmlns:a16="http://schemas.microsoft.com/office/drawing/2014/main" id="{85064D35-0875-409C-A01E-2055F5A697BF}"/>
+                <a16:creationId xmlns:a16="http://schemas.microsoft.com/office/drawing/2014/main" id="{04A815C2-0907-4915-9189-78630BB96D99}"/>
               </a:ext>
             </a:extLst>
           </p:cNvPr>
@@ -7885,7 +7885,7 @@
           <p:cNvPr id="6" name="">
             <a:extLst xmlns:a="http://schemas.openxmlformats.org/drawingml/2006/main">
               <a:ext uri="{FF2B5EF4-FFF2-40B4-BE49-F238E27FC236}">
-                <a16:creationId xmlns:a16="http://schemas.microsoft.com/office/drawing/2014/main" id="{F117CF6A-5708-446A-A694-DF3F1180BE6B}"/>
+                <a16:creationId xmlns:a16="http://schemas.microsoft.com/office/drawing/2014/main" id="{DD701C8E-A2B2-4DFD-AE30-459974A8A884}"/>
               </a:ext>
             </a:extLst>
           </p:cNvPr>
@@ -7942,7 +7942,7 @@
           <p:cNvPr id="7" name="">
             <a:extLst xmlns:a="http://schemas.openxmlformats.org/drawingml/2006/main">
               <a:ext uri="{FF2B5EF4-FFF2-40B4-BE49-F238E27FC236}">
-                <a16:creationId xmlns:a16="http://schemas.microsoft.com/office/drawing/2014/main" id="{A613C08B-4D3F-4F68-B25F-FE2062D7AD23}"/>
+                <a16:creationId xmlns:a16="http://schemas.microsoft.com/office/drawing/2014/main" id="{041F9176-538A-4080-80E0-8A54981B1E54}"/>
               </a:ext>
             </a:extLst>
           </p:cNvPr>
@@ -8606,7 +8606,7 @@
           <p:cNvPr id="9" name="">
             <a:extLst xmlns:a="http://schemas.openxmlformats.org/drawingml/2006/main">
               <a:ext uri="{FF2B5EF4-FFF2-40B4-BE49-F238E27FC236}">
-                <a16:creationId xmlns:a16="http://schemas.microsoft.com/office/drawing/2014/main" id="{781BD8EB-915B-410E-A160-EA4E7CCED364}"/>
+                <a16:creationId xmlns:a16="http://schemas.microsoft.com/office/drawing/2014/main" id="{BA3AEF7D-62CE-4354-A356-8936AF947350}"/>
               </a:ext>
             </a:extLst>
           </p:cNvPr>
@@ -8661,7 +8661,7 @@
     </p:spTree>
     <p:extLst>
       <p:ext uri="{BB962C8B-B14F-4D97-AF65-F5344CB8AC3E}">
-        <p14:creationId xmlns:p14="http://schemas.microsoft.com/office/powerpoint/2010/main" val="2096116936"/>
+        <p14:creationId xmlns:p14="http://schemas.microsoft.com/office/powerpoint/2010/main" val="202498848"/>
       </p:ext>
     </p:extLst>
   </p:cSld>
@@ -8689,10 +8689,10 @@
       </p:grpSpPr>
       <p:sp>
         <p:nvSpPr>
-          <p:cNvPr id="18" name="">
-            <a:extLst xmlns:a="http://schemas.openxmlformats.org/drawingml/2006/main">
-              <a:ext uri="{FF2B5EF4-FFF2-40B4-BE49-F238E27FC236}">
-                <a16:creationId xmlns:a16="http://schemas.microsoft.com/office/drawing/2014/main" id="{CC2915C0-3722-43B3-9B1B-8E9AC538079C}"/>
+          <p:cNvPr id="20" name="">
+            <a:extLst xmlns:a="http://schemas.openxmlformats.org/drawingml/2006/main">
+              <a:ext uri="{FF2B5EF4-FFF2-40B4-BE49-F238E27FC236}">
+                <a16:creationId xmlns:a16="http://schemas.microsoft.com/office/drawing/2014/main" id="{370C069A-5D48-4EA3-9DDB-69692A396AB4}"/>
               </a:ext>
             </a:extLst>
           </p:cNvPr>
@@ -8749,7 +8749,7 @@
           <p:cNvPr id="2" name="">
             <a:extLst xmlns:a="http://schemas.openxmlformats.org/drawingml/2006/main">
               <a:ext uri="{FF2B5EF4-FFF2-40B4-BE49-F238E27FC236}">
-                <a16:creationId xmlns:a16="http://schemas.microsoft.com/office/drawing/2014/main" id="{01F2CD2C-0A8E-4DA0-BBE9-E4DDA92BEEDF}"/>
+                <a16:creationId xmlns:a16="http://schemas.microsoft.com/office/drawing/2014/main" id="{DFD3FB03-DB43-4EED-AD5D-F1FEC97D21D1}"/>
               </a:ext>
             </a:extLst>
           </p:cNvPr>
@@ -8806,36 +8806,207 @@
           <p:cNvPr id="3" name="">
             <a:extLst xmlns:a="http://schemas.openxmlformats.org/drawingml/2006/main">
               <a:ext uri="{FF2B5EF4-FFF2-40B4-BE49-F238E27FC236}">
-                <a16:creationId xmlns:a16="http://schemas.microsoft.com/office/drawing/2014/main" id="{EB59A59E-0AE4-4164-8293-5D1DBDB167FF}"/>
-              </a:ext>
-            </a:extLst>
-          </p:cNvPr>
-          <p:cNvSpPr>
-            <a:spLocks xmlns:a="http://schemas.openxmlformats.org/drawingml/2006/main" noGrp="1"/>
-          </p:cNvSpPr>
-          <p:nvPr/>
-        </p:nvSpPr>
-        <p:spPr>
-          <a:xfrm xmlns:a="http://schemas.openxmlformats.org/drawingml/2006/main">
-            <a:off x="619125" y="2095500"/>
-            <a:ext cx="1857375" cy="590550"/>
-          </a:xfrm>
-          <a:prstGeom xmlns:a="http://schemas.openxmlformats.org/drawingml/2006/main" prst="rect">
-            <a:avLst/>
-          </a:prstGeom>
-          <a:noFill xmlns:a="http://schemas.openxmlformats.org/drawingml/2006/main"/>
-          <a:ln xmlns:a="http://schemas.openxmlformats.org/drawingml/2006/main" w="0">
-            <a:noFill/>
-          </a:ln>
-        </p:spPr>
-        <p:txBody>
-          <a:bodyPr xmlns:a="http://schemas.openxmlformats.org/drawingml/2006/main">
-            <a:noAutofit/>
-          </a:bodyPr>
-          <a:lstStyle xmlns:a="http://schemas.openxmlformats.org/drawingml/2006/main"/>
-          <a:p xmlns:a="http://schemas.openxmlformats.org/drawingml/2006/main">
-            <a:pPr>
-              <a:defRPr sz="2325" b="1">
+                <a16:creationId xmlns:a16="http://schemas.microsoft.com/office/drawing/2014/main" id="{6132A8C5-8907-43B2-9DD3-150707CE1F40}"/>
+              </a:ext>
+            </a:extLst>
+          </p:cNvPr>
+          <p:cNvSpPr>
+            <a:spLocks xmlns:a="http://schemas.openxmlformats.org/drawingml/2006/main" noGrp="1"/>
+          </p:cNvSpPr>
+          <p:nvPr/>
+        </p:nvSpPr>
+        <p:spPr>
+          <a:xfrm xmlns:a="http://schemas.openxmlformats.org/drawingml/2006/main">
+            <a:off x="619125" y="1914525"/>
+            <a:ext cx="2857500" cy="323850"/>
+          </a:xfrm>
+          <a:prstGeom xmlns:a="http://schemas.openxmlformats.org/drawingml/2006/main" prst="rect">
+            <a:avLst/>
+          </a:prstGeom>
+          <a:noFill xmlns:a="http://schemas.openxmlformats.org/drawingml/2006/main"/>
+          <a:ln xmlns:a="http://schemas.openxmlformats.org/drawingml/2006/main" w="0">
+            <a:noFill/>
+          </a:ln>
+        </p:spPr>
+        <p:txBody>
+          <a:bodyPr xmlns:a="http://schemas.openxmlformats.org/drawingml/2006/main">
+            <a:noAutofit/>
+          </a:bodyPr>
+          <a:lstStyle xmlns:a="http://schemas.openxmlformats.org/drawingml/2006/main"/>
+          <a:p xmlns:a="http://schemas.openxmlformats.org/drawingml/2006/main">
+            <a:pPr>
+              <a:defRPr sz="1350" b="1">
+                <a:solidFill>
+                  <a:srgbClr val="666962"/>
+                </a:solidFill>
+                <a:latin typeface="Manrope"/>
+                <a:ea typeface="Manrope"/>
+                <a:cs typeface="Manrope"/>
+              </a:defRPr>
+            </a:pPr>
+            <a:r>
+              <a:rPr sz="1350" b="1">
+                <a:solidFill>
+                  <a:srgbClr val="666962"/>
+                </a:solidFill>
+                <a:latin typeface="Manrope"/>
+                <a:ea typeface="Manrope"/>
+                <a:cs typeface="Manrope"/>
+              </a:rPr>
+              <a:t>CLIENTS</a:t>
+            </a:r>
+          </a:p>
+        </p:txBody>
+      </p:sp>
+      <p:sp>
+        <p:nvSpPr>
+          <p:cNvPr id="4" name="">
+            <a:extLst xmlns:a="http://schemas.openxmlformats.org/drawingml/2006/main">
+              <a:ext uri="{FF2B5EF4-FFF2-40B4-BE49-F238E27FC236}">
+                <a16:creationId xmlns:a16="http://schemas.microsoft.com/office/drawing/2014/main" id="{53E73545-BB5C-4CA1-A52C-52488E219B84}"/>
+              </a:ext>
+            </a:extLst>
+          </p:cNvPr>
+          <p:cNvSpPr>
+            <a:spLocks xmlns:a="http://schemas.openxmlformats.org/drawingml/2006/main" noGrp="1"/>
+          </p:cNvSpPr>
+          <p:nvPr/>
+        </p:nvSpPr>
+        <p:spPr>
+          <a:xfrm xmlns:a="http://schemas.openxmlformats.org/drawingml/2006/main">
+            <a:off x="4591050" y="1914525"/>
+            <a:ext cx="2857500" cy="323850"/>
+          </a:xfrm>
+          <a:prstGeom xmlns:a="http://schemas.openxmlformats.org/drawingml/2006/main" prst="rect">
+            <a:avLst/>
+          </a:prstGeom>
+          <a:noFill xmlns:a="http://schemas.openxmlformats.org/drawingml/2006/main"/>
+          <a:ln xmlns:a="http://schemas.openxmlformats.org/drawingml/2006/main" w="0">
+            <a:noFill/>
+          </a:ln>
+        </p:spPr>
+        <p:txBody>
+          <a:bodyPr xmlns:a="http://schemas.openxmlformats.org/drawingml/2006/main">
+            <a:noAutofit/>
+          </a:bodyPr>
+          <a:lstStyle xmlns:a="http://schemas.openxmlformats.org/drawingml/2006/main"/>
+          <a:p xmlns:a="http://schemas.openxmlformats.org/drawingml/2006/main">
+            <a:pPr>
+              <a:defRPr sz="1350" b="1">
+                <a:solidFill>
+                  <a:srgbClr val="666962"/>
+                </a:solidFill>
+                <a:latin typeface="Manrope"/>
+                <a:ea typeface="Manrope"/>
+                <a:cs typeface="Manrope"/>
+              </a:defRPr>
+            </a:pPr>
+            <a:r>
+              <a:rPr sz="1350" b="1">
+                <a:solidFill>
+                  <a:srgbClr val="666962"/>
+                </a:solidFill>
+                <a:latin typeface="Manrope"/>
+                <a:ea typeface="Manrope"/>
+                <a:cs typeface="Manrope"/>
+              </a:rPr>
+              <a:t>COMMANDS</a:t>
+            </a:r>
+          </a:p>
+        </p:txBody>
+      </p:sp>
+      <p:sp>
+        <p:nvSpPr>
+          <p:cNvPr id="5" name="">
+            <a:extLst xmlns:a="http://schemas.openxmlformats.org/drawingml/2006/main">
+              <a:ext uri="{FF2B5EF4-FFF2-40B4-BE49-F238E27FC236}">
+                <a16:creationId xmlns:a16="http://schemas.microsoft.com/office/drawing/2014/main" id="{09EC0801-E5D6-4AE2-8615-C9E76C9F6A80}"/>
+              </a:ext>
+            </a:extLst>
+          </p:cNvPr>
+          <p:cNvSpPr>
+            <a:spLocks xmlns:a="http://schemas.openxmlformats.org/drawingml/2006/main" noGrp="1"/>
+          </p:cNvSpPr>
+          <p:nvPr/>
+        </p:nvSpPr>
+        <p:spPr>
+          <a:xfrm xmlns:a="http://schemas.openxmlformats.org/drawingml/2006/main">
+            <a:off x="8753475" y="1914525"/>
+            <a:ext cx="2857500" cy="323850"/>
+          </a:xfrm>
+          <a:prstGeom xmlns:a="http://schemas.openxmlformats.org/drawingml/2006/main" prst="rect">
+            <a:avLst/>
+          </a:prstGeom>
+          <a:noFill xmlns:a="http://schemas.openxmlformats.org/drawingml/2006/main"/>
+          <a:ln xmlns:a="http://schemas.openxmlformats.org/drawingml/2006/main" w="0">
+            <a:noFill/>
+          </a:ln>
+        </p:spPr>
+        <p:txBody>
+          <a:bodyPr xmlns:a="http://schemas.openxmlformats.org/drawingml/2006/main">
+            <a:noAutofit/>
+          </a:bodyPr>
+          <a:lstStyle xmlns:a="http://schemas.openxmlformats.org/drawingml/2006/main"/>
+          <a:p xmlns:a="http://schemas.openxmlformats.org/drawingml/2006/main">
+            <a:pPr>
+              <a:defRPr sz="1350" b="1">
+                <a:solidFill>
+                  <a:srgbClr val="666962"/>
+                </a:solidFill>
+                <a:latin typeface="Manrope"/>
+                <a:ea typeface="Manrope"/>
+                <a:cs typeface="Manrope"/>
+              </a:defRPr>
+            </a:pPr>
+            <a:r>
+              <a:rPr sz="1350" b="1">
+                <a:solidFill>
+                  <a:srgbClr val="666962"/>
+                </a:solidFill>
+                <a:latin typeface="Manrope"/>
+                <a:ea typeface="Manrope"/>
+                <a:cs typeface="Manrope"/>
+              </a:rPr>
+              <a:t>STORAGE</a:t>
+            </a:r>
+          </a:p>
+        </p:txBody>
+      </p:sp>
+      <p:sp>
+        <p:nvSpPr>
+          <p:cNvPr id="6" name="">
+            <a:extLst xmlns:a="http://schemas.openxmlformats.org/drawingml/2006/main">
+              <a:ext uri="{FF2B5EF4-FFF2-40B4-BE49-F238E27FC236}">
+                <a16:creationId xmlns:a16="http://schemas.microsoft.com/office/drawing/2014/main" id="{0C0D4BE9-4718-45A1-873E-F18C8D6F2E37}"/>
+              </a:ext>
+            </a:extLst>
+          </p:cNvPr>
+          <p:cNvSpPr>
+            <a:spLocks xmlns:a="http://schemas.openxmlformats.org/drawingml/2006/main" noGrp="1"/>
+          </p:cNvSpPr>
+          <p:nvPr/>
+        </p:nvSpPr>
+        <p:spPr>
+          <a:xfrm xmlns:a="http://schemas.openxmlformats.org/drawingml/2006/main">
+            <a:off x="619125" y="2457450"/>
+            <a:ext cx="2762250" cy="647700"/>
+          </a:xfrm>
+          <a:prstGeom xmlns:a="http://schemas.openxmlformats.org/drawingml/2006/main" prst="rect">
+            <a:avLst/>
+          </a:prstGeom>
+          <a:noFill xmlns:a="http://schemas.openxmlformats.org/drawingml/2006/main"/>
+          <a:ln xmlns:a="http://schemas.openxmlformats.org/drawingml/2006/main" w="0">
+            <a:noFill/>
+          </a:ln>
+        </p:spPr>
+        <p:txBody>
+          <a:bodyPr xmlns:a="http://schemas.openxmlformats.org/drawingml/2006/main">
+            <a:noAutofit/>
+          </a:bodyPr>
+          <a:lstStyle xmlns:a="http://schemas.openxmlformats.org/drawingml/2006/main"/>
+          <a:p xmlns:a="http://schemas.openxmlformats.org/drawingml/2006/main">
+            <a:pPr>
+              <a:defRPr sz="2475" b="1">
                 <a:solidFill>
                   <a:srgbClr val="242729"/>
                 </a:solidFill>
@@ -8845,7 +9016,7 @@
               </a:defRPr>
             </a:pPr>
             <a:r>
-              <a:rPr sz="2325" b="1">
+              <a:rPr sz="2475" b="1">
                 <a:solidFill>
                   <a:srgbClr val="242729"/>
                 </a:solidFill>
@@ -8853,103 +9024,46 @@
                 <a:ea typeface="Manrope"/>
                 <a:cs typeface="Manrope"/>
               </a:rPr>
-              <a:t>React web</a:t>
-            </a:r>
-          </a:p>
-        </p:txBody>
-      </p:sp>
-      <p:sp>
-        <p:nvSpPr>
-          <p:cNvPr id="4" name="">
-            <a:extLst xmlns:a="http://schemas.openxmlformats.org/drawingml/2006/main">
-              <a:ext uri="{FF2B5EF4-FFF2-40B4-BE49-F238E27FC236}">
-                <a16:creationId xmlns:a16="http://schemas.microsoft.com/office/drawing/2014/main" id="{92D5360A-4B33-4AB7-AA5E-28B67DC4DDA2}"/>
-              </a:ext>
-            </a:extLst>
-          </p:cNvPr>
-          <p:cNvSpPr>
-            <a:spLocks xmlns:a="http://schemas.openxmlformats.org/drawingml/2006/main" noGrp="1"/>
-          </p:cNvSpPr>
-          <p:nvPr/>
-        </p:nvSpPr>
-        <p:spPr>
-          <a:xfrm xmlns:a="http://schemas.openxmlformats.org/drawingml/2006/main">
-            <a:off x="657225" y="2800350"/>
-            <a:ext cx="2724150" cy="457200"/>
-          </a:xfrm>
-          <a:prstGeom xmlns:a="http://schemas.openxmlformats.org/drawingml/2006/main" prst="rect">
-            <a:avLst/>
-          </a:prstGeom>
-          <a:noFill xmlns:a="http://schemas.openxmlformats.org/drawingml/2006/main"/>
-          <a:ln xmlns:a="http://schemas.openxmlformats.org/drawingml/2006/main" w="0">
-            <a:noFill/>
-          </a:ln>
-        </p:spPr>
-        <p:txBody>
-          <a:bodyPr xmlns:a="http://schemas.openxmlformats.org/drawingml/2006/main">
-            <a:noAutofit/>
-          </a:bodyPr>
-          <a:lstStyle xmlns:a="http://schemas.openxmlformats.org/drawingml/2006/main"/>
-          <a:p xmlns:a="http://schemas.openxmlformats.org/drawingml/2006/main">
-            <a:pPr>
-              <a:defRPr sz="1650" b="0">
-                <a:solidFill>
-                  <a:srgbClr val="666962"/>
-                </a:solidFill>
-                <a:latin typeface="Manrope"/>
-                <a:ea typeface="Manrope"/>
-                <a:cs typeface="Manrope"/>
-              </a:defRPr>
-            </a:pPr>
-            <a:r>
-              <a:rPr sz="1650" b="0">
-                <a:solidFill>
-                  <a:srgbClr val="666962"/>
-                </a:solidFill>
-                <a:latin typeface="Manrope"/>
-                <a:ea typeface="Manrope"/>
-                <a:cs typeface="Manrope"/>
-              </a:rPr>
-              <a:t>Dispatcher decisions</a:t>
-            </a:r>
-          </a:p>
-        </p:txBody>
-      </p:sp>
-      <p:sp>
-        <p:nvSpPr>
-          <p:cNvPr id="5" name="">
-            <a:extLst xmlns:a="http://schemas.openxmlformats.org/drawingml/2006/main">
-              <a:ext uri="{FF2B5EF4-FFF2-40B4-BE49-F238E27FC236}">
-                <a16:creationId xmlns:a16="http://schemas.microsoft.com/office/drawing/2014/main" id="{AE1DBA5E-B0B1-45BA-8361-B9F96423ABAA}"/>
-              </a:ext>
-            </a:extLst>
-          </p:cNvPr>
-          <p:cNvSpPr>
-            <a:spLocks xmlns:a="http://schemas.openxmlformats.org/drawingml/2006/main" noGrp="1"/>
-          </p:cNvSpPr>
-          <p:nvPr/>
-        </p:nvSpPr>
-        <p:spPr>
-          <a:xfrm xmlns:a="http://schemas.openxmlformats.org/drawingml/2006/main">
-            <a:off x="619125" y="3733800"/>
-            <a:ext cx="2076450" cy="590550"/>
-          </a:xfrm>
-          <a:prstGeom xmlns:a="http://schemas.openxmlformats.org/drawingml/2006/main" prst="rect">
-            <a:avLst/>
-          </a:prstGeom>
-          <a:noFill xmlns:a="http://schemas.openxmlformats.org/drawingml/2006/main"/>
-          <a:ln xmlns:a="http://schemas.openxmlformats.org/drawingml/2006/main" w="0">
-            <a:noFill/>
-          </a:ln>
-        </p:spPr>
-        <p:txBody>
-          <a:bodyPr xmlns:a="http://schemas.openxmlformats.org/drawingml/2006/main">
-            <a:noAutofit/>
-          </a:bodyPr>
-          <a:lstStyle xmlns:a="http://schemas.openxmlformats.org/drawingml/2006/main"/>
-          <a:p xmlns:a="http://schemas.openxmlformats.org/drawingml/2006/main">
-            <a:pPr>
-              <a:defRPr sz="2325" b="1">
+              <a:t>Web + mobile</a:t>
+            </a:r>
+          </a:p>
+        </p:txBody>
+      </p:sp>
+      <p:sp>
+        <p:nvSpPr>
+          <p:cNvPr id="7" name="">
+            <a:extLst xmlns:a="http://schemas.openxmlformats.org/drawingml/2006/main">
+              <a:ext uri="{FF2B5EF4-FFF2-40B4-BE49-F238E27FC236}">
+                <a16:creationId xmlns:a16="http://schemas.microsoft.com/office/drawing/2014/main" id="{AF4CE4FF-4D5C-441B-A48B-878A4E16FCD3}"/>
+              </a:ext>
+            </a:extLst>
+          </p:cNvPr>
+          <p:cNvSpPr>
+            <a:spLocks xmlns:a="http://schemas.openxmlformats.org/drawingml/2006/main" noGrp="1"/>
+          </p:cNvSpPr>
+          <p:nvPr/>
+        </p:nvSpPr>
+        <p:spPr>
+          <a:xfrm xmlns:a="http://schemas.openxmlformats.org/drawingml/2006/main">
+            <a:off x="4591050" y="2457450"/>
+            <a:ext cx="2676525" cy="647700"/>
+          </a:xfrm>
+          <a:prstGeom xmlns:a="http://schemas.openxmlformats.org/drawingml/2006/main" prst="rect">
+            <a:avLst/>
+          </a:prstGeom>
+          <a:noFill xmlns:a="http://schemas.openxmlformats.org/drawingml/2006/main"/>
+          <a:ln xmlns:a="http://schemas.openxmlformats.org/drawingml/2006/main" w="0">
+            <a:noFill/>
+          </a:ln>
+        </p:spPr>
+        <p:txBody>
+          <a:bodyPr xmlns:a="http://schemas.openxmlformats.org/drawingml/2006/main">
+            <a:noAutofit/>
+          </a:bodyPr>
+          <a:lstStyle xmlns:a="http://schemas.openxmlformats.org/drawingml/2006/main"/>
+          <a:p xmlns:a="http://schemas.openxmlformats.org/drawingml/2006/main">
+            <a:pPr>
+              <a:defRPr sz="2475" b="1">
                 <a:solidFill>
                   <a:srgbClr val="242729"/>
                 </a:solidFill>
@@ -8959,7 +9073,7 @@
               </a:defRPr>
             </a:pPr>
             <a:r>
-              <a:rPr sz="2325" b="1">
+              <a:rPr sz="2475" b="1">
                 <a:solidFill>
                   <a:srgbClr val="242729"/>
                 </a:solidFill>
@@ -8967,190 +9081,46 @@
                 <a:ea typeface="Manrope"/>
                 <a:cs typeface="Manrope"/>
               </a:rPr>
-              <a:t>Expo mobile</a:t>
-            </a:r>
-          </a:p>
-        </p:txBody>
-      </p:sp>
-      <p:sp>
-        <p:nvSpPr>
-          <p:cNvPr id="6" name="">
-            <a:extLst xmlns:a="http://schemas.openxmlformats.org/drawingml/2006/main">
-              <a:ext uri="{FF2B5EF4-FFF2-40B4-BE49-F238E27FC236}">
-                <a16:creationId xmlns:a16="http://schemas.microsoft.com/office/drawing/2014/main" id="{16665786-E21D-417B-956A-35031D30D88D}"/>
-              </a:ext>
-            </a:extLst>
-          </p:cNvPr>
-          <p:cNvSpPr>
-            <a:spLocks xmlns:a="http://schemas.openxmlformats.org/drawingml/2006/main" noGrp="1"/>
-          </p:cNvSpPr>
-          <p:nvPr/>
-        </p:nvSpPr>
-        <p:spPr>
-          <a:xfrm xmlns:a="http://schemas.openxmlformats.org/drawingml/2006/main">
-            <a:off x="657225" y="4438650"/>
-            <a:ext cx="2724150" cy="457200"/>
-          </a:xfrm>
-          <a:prstGeom xmlns:a="http://schemas.openxmlformats.org/drawingml/2006/main" prst="rect">
-            <a:avLst/>
-          </a:prstGeom>
-          <a:noFill xmlns:a="http://schemas.openxmlformats.org/drawingml/2006/main"/>
-          <a:ln xmlns:a="http://schemas.openxmlformats.org/drawingml/2006/main" w="0">
-            <a:noFill/>
-          </a:ln>
-        </p:spPr>
-        <p:txBody>
-          <a:bodyPr xmlns:a="http://schemas.openxmlformats.org/drawingml/2006/main">
-            <a:noAutofit/>
-          </a:bodyPr>
-          <a:lstStyle xmlns:a="http://schemas.openxmlformats.org/drawingml/2006/main"/>
-          <a:p xmlns:a="http://schemas.openxmlformats.org/drawingml/2006/main">
-            <a:pPr>
-              <a:defRPr sz="1650" b="0">
-                <a:solidFill>
-                  <a:srgbClr val="666962"/>
-                </a:solidFill>
-                <a:latin typeface="Manrope"/>
-                <a:ea typeface="Manrope"/>
-                <a:cs typeface="Manrope"/>
-              </a:defRPr>
-            </a:pPr>
-            <a:r>
-              <a:rPr sz="1650" b="0">
-                <a:solidFill>
-                  <a:srgbClr val="666962"/>
-                </a:solidFill>
-                <a:latin typeface="Manrope"/>
-                <a:ea typeface="Manrope"/>
-                <a:cs typeface="Manrope"/>
-              </a:rPr>
-              <a:t>Driver execution</a:t>
-            </a:r>
-          </a:p>
-        </p:txBody>
-      </p:sp>
-      <p:sp>
-        <p:nvSpPr>
-          <p:cNvPr id="7" name="">
-            <a:extLst xmlns:a="http://schemas.openxmlformats.org/drawingml/2006/main">
-              <a:ext uri="{FF2B5EF4-FFF2-40B4-BE49-F238E27FC236}">
-                <a16:creationId xmlns:a16="http://schemas.microsoft.com/office/drawing/2014/main" id="{27FB403F-9235-4073-AA6A-B680D5162972}"/>
-              </a:ext>
-            </a:extLst>
-          </p:cNvPr>
-          <p:cNvSpPr>
-            <a:spLocks xmlns:a="http://schemas.openxmlformats.org/drawingml/2006/main" noGrp="1"/>
-          </p:cNvSpPr>
-          <p:nvPr/>
-        </p:nvSpPr>
-        <p:spPr>
-          <a:xfrm xmlns:a="http://schemas.openxmlformats.org/drawingml/2006/main">
-            <a:off x="3638550" y="3190875"/>
-            <a:ext cx="76200" cy="76200"/>
-          </a:xfrm>
-          <a:prstGeom xmlns:a="http://schemas.openxmlformats.org/drawingml/2006/main" prst="ellipse">
-            <a:avLst/>
-          </a:prstGeom>
-          <a:solidFill xmlns:a="http://schemas.openxmlformats.org/drawingml/2006/main">
-            <a:srgbClr val="666962"/>
-          </a:solidFill>
-          <a:ln xmlns:a="http://schemas.openxmlformats.org/drawingml/2006/main" w="0">
-            <a:noFill/>
-          </a:ln>
-        </p:spPr>
+              <a:t>Fastify API</a:t>
+            </a:r>
+          </a:p>
+        </p:txBody>
       </p:sp>
       <p:sp>
         <p:nvSpPr>
           <p:cNvPr id="8" name="">
             <a:extLst xmlns:a="http://schemas.openxmlformats.org/drawingml/2006/main">
               <a:ext uri="{FF2B5EF4-FFF2-40B4-BE49-F238E27FC236}">
-                <a16:creationId xmlns:a16="http://schemas.microsoft.com/office/drawing/2014/main" id="{114FD072-4BB5-4AF9-871F-3DF3DFE0A8A1}"/>
-              </a:ext>
-            </a:extLst>
-          </p:cNvPr>
-          <p:cNvSpPr>
-            <a:spLocks xmlns:a="http://schemas.openxmlformats.org/drawingml/2006/main" noGrp="1"/>
-          </p:cNvSpPr>
-          <p:nvPr/>
-        </p:nvSpPr>
-        <p:spPr>
-          <a:xfrm xmlns:a="http://schemas.openxmlformats.org/drawingml/2006/main">
-            <a:off x="4514850" y="2924175"/>
-            <a:ext cx="2295525" cy="609600"/>
-          </a:xfrm>
-          <a:prstGeom xmlns:a="http://schemas.openxmlformats.org/drawingml/2006/main" prst="rect">
-            <a:avLst/>
-          </a:prstGeom>
-          <a:noFill xmlns:a="http://schemas.openxmlformats.org/drawingml/2006/main"/>
-          <a:ln xmlns:a="http://schemas.openxmlformats.org/drawingml/2006/main" w="0">
-            <a:noFill/>
-          </a:ln>
-        </p:spPr>
-        <p:txBody>
-          <a:bodyPr xmlns:a="http://schemas.openxmlformats.org/drawingml/2006/main">
-            <a:noAutofit/>
-          </a:bodyPr>
-          <a:lstStyle xmlns:a="http://schemas.openxmlformats.org/drawingml/2006/main"/>
-          <a:p xmlns:a="http://schemas.openxmlformats.org/drawingml/2006/main">
-            <a:pPr>
-              <a:defRPr sz="2625" b="1">
-                <a:solidFill>
-                  <a:srgbClr val="242729"/>
-                </a:solidFill>
-                <a:latin typeface="Manrope"/>
-                <a:ea typeface="Manrope"/>
-                <a:cs typeface="Manrope"/>
-              </a:defRPr>
-            </a:pPr>
-            <a:r>
-              <a:rPr sz="2625" b="1">
-                <a:solidFill>
-                  <a:srgbClr val="242729"/>
-                </a:solidFill>
-                <a:latin typeface="Manrope"/>
-                <a:ea typeface="Manrope"/>
-                <a:cs typeface="Manrope"/>
-              </a:rPr>
-              <a:t>Fastify API</a:t>
-            </a:r>
-          </a:p>
-        </p:txBody>
-      </p:sp>
-      <p:sp>
-        <p:nvSpPr>
-          <p:cNvPr id="9" name="">
-            <a:extLst xmlns:a="http://schemas.openxmlformats.org/drawingml/2006/main">
-              <a:ext uri="{FF2B5EF4-FFF2-40B4-BE49-F238E27FC236}">
-                <a16:creationId xmlns:a16="http://schemas.microsoft.com/office/drawing/2014/main" id="{B0048ED3-C0C0-458D-9380-43CB697D13E0}"/>
-              </a:ext>
-            </a:extLst>
-          </p:cNvPr>
-          <p:cNvSpPr>
-            <a:spLocks xmlns:a="http://schemas.openxmlformats.org/drawingml/2006/main" noGrp="1"/>
-          </p:cNvSpPr>
-          <p:nvPr/>
-        </p:nvSpPr>
-        <p:spPr>
-          <a:xfrm xmlns:a="http://schemas.openxmlformats.org/drawingml/2006/main">
-            <a:off x="8772525" y="2924175"/>
-            <a:ext cx="2800350" cy="609600"/>
-          </a:xfrm>
-          <a:prstGeom xmlns:a="http://schemas.openxmlformats.org/drawingml/2006/main" prst="rect">
-            <a:avLst/>
-          </a:prstGeom>
-          <a:noFill xmlns:a="http://schemas.openxmlformats.org/drawingml/2006/main"/>
-          <a:ln xmlns:a="http://schemas.openxmlformats.org/drawingml/2006/main" w="0">
-            <a:noFill/>
-          </a:ln>
-        </p:spPr>
-        <p:txBody>
-          <a:bodyPr xmlns:a="http://schemas.openxmlformats.org/drawingml/2006/main">
-            <a:noAutofit/>
-          </a:bodyPr>
-          <a:lstStyle xmlns:a="http://schemas.openxmlformats.org/drawingml/2006/main"/>
-          <a:p xmlns:a="http://schemas.openxmlformats.org/drawingml/2006/main">
-            <a:pPr>
-              <a:defRPr sz="2625" b="1">
+                <a16:creationId xmlns:a16="http://schemas.microsoft.com/office/drawing/2014/main" id="{A6E2BE57-627E-40E2-AB78-F2EC7EBA6F52}"/>
+              </a:ext>
+            </a:extLst>
+          </p:cNvPr>
+          <p:cNvSpPr>
+            <a:spLocks xmlns:a="http://schemas.openxmlformats.org/drawingml/2006/main" noGrp="1"/>
+          </p:cNvSpPr>
+          <p:nvPr/>
+        </p:nvSpPr>
+        <p:spPr>
+          <a:xfrm xmlns:a="http://schemas.openxmlformats.org/drawingml/2006/main">
+            <a:off x="8753475" y="2457450"/>
+            <a:ext cx="2809875" cy="647700"/>
+          </a:xfrm>
+          <a:prstGeom xmlns:a="http://schemas.openxmlformats.org/drawingml/2006/main" prst="rect">
+            <a:avLst/>
+          </a:prstGeom>
+          <a:noFill xmlns:a="http://schemas.openxmlformats.org/drawingml/2006/main"/>
+          <a:ln xmlns:a="http://schemas.openxmlformats.org/drawingml/2006/main" w="0">
+            <a:noFill/>
+          </a:ln>
+        </p:spPr>
+        <p:txBody>
+          <a:bodyPr xmlns:a="http://schemas.openxmlformats.org/drawingml/2006/main">
+            <a:noAutofit/>
+          </a:bodyPr>
+          <a:lstStyle xmlns:a="http://schemas.openxmlformats.org/drawingml/2006/main"/>
+          <a:p xmlns:a="http://schemas.openxmlformats.org/drawingml/2006/main">
+            <a:pPr>
+              <a:defRPr sz="2475" b="1">
                 <a:solidFill>
                   <a:srgbClr val="AC3716"/>
                 </a:solidFill>
@@ -9160,7 +9130,7 @@
               </a:defRPr>
             </a:pPr>
             <a:r>
-              <a:rPr sz="2625" b="1">
+              <a:rPr sz="2475" b="1">
                 <a:solidFill>
                   <a:srgbClr val="AC3716"/>
                 </a:solidFill>
@@ -9173,69 +9143,19 @@
           </a:p>
         </p:txBody>
       </p:sp>
-      <p:cxnSp>
-        <p:nvCxnSpPr>
-          <p:cNvPr id="27" name=""/>
-          <p:cNvCxnSpPr>
-            <a:stCxn xmlns:a="http://schemas.openxmlformats.org/drawingml/2006/main" id="3" idx="3"/>
-            <a:endCxn xmlns:a="http://schemas.openxmlformats.org/drawingml/2006/main" id="7" idx="0"/>
-          </p:cNvCxnSpPr>
-          <p:nvPr/>
-        </p:nvCxnSpPr>
-        <p:spPr>
-          <a:xfrm xmlns:a="http://schemas.openxmlformats.org/drawingml/2006/main">
-            <a:off x="2476500" y="2390775"/>
-            <a:ext cx="1200150" cy="800100"/>
-          </a:xfrm>
-          <a:prstGeom xmlns:a="http://schemas.openxmlformats.org/drawingml/2006/main" prst="bentConnector2">
-            <a:avLst/>
-          </a:prstGeom>
-          <a:ln xmlns:a="http://schemas.openxmlformats.org/drawingml/2006/main" w="19050">
-            <a:solidFill>
-              <a:srgbClr val="666962"/>
-            </a:solidFill>
-            <a:prstDash val="solid"/>
-          </a:ln>
-        </p:spPr>
-      </p:cxnSp>
       <p:cxnSp>
         <p:nvCxnSpPr>
           <p:cNvPr id="28" name=""/>
           <p:cNvCxnSpPr>
-            <a:stCxn xmlns:a="http://schemas.openxmlformats.org/drawingml/2006/main" id="5" idx="3"/>
-            <a:endCxn xmlns:a="http://schemas.openxmlformats.org/drawingml/2006/main" id="7" idx="4"/>
+            <a:stCxn xmlns:a="http://schemas.openxmlformats.org/drawingml/2006/main" id="6" idx="3"/>
+            <a:endCxn xmlns:a="http://schemas.openxmlformats.org/drawingml/2006/main" id="7" idx="1"/>
           </p:cNvCxnSpPr>
           <p:nvPr/>
         </p:nvCxnSpPr>
         <p:spPr>
-          <a:xfrm xmlns:a="http://schemas.openxmlformats.org/drawingml/2006/main" flipV="1">
-            <a:off x="2695575" y="3267075"/>
-            <a:ext cx="981075" cy="762000"/>
-          </a:xfrm>
-          <a:prstGeom xmlns:a="http://schemas.openxmlformats.org/drawingml/2006/main" prst="bentConnector2">
-            <a:avLst/>
-          </a:prstGeom>
-          <a:ln xmlns:a="http://schemas.openxmlformats.org/drawingml/2006/main" w="19050">
-            <a:solidFill>
-              <a:srgbClr val="666962"/>
-            </a:solidFill>
-            <a:prstDash val="solid"/>
-          </a:ln>
-        </p:spPr>
-      </p:cxnSp>
-      <p:cxnSp>
-        <p:nvCxnSpPr>
-          <p:cNvPr id="29" name=""/>
-          <p:cNvCxnSpPr>
-            <a:stCxn xmlns:a="http://schemas.openxmlformats.org/drawingml/2006/main" id="7" idx="6"/>
-            <a:endCxn xmlns:a="http://schemas.openxmlformats.org/drawingml/2006/main" id="8" idx="1"/>
-          </p:cNvCxnSpPr>
-          <p:nvPr/>
-        </p:nvCxnSpPr>
-        <p:spPr>
-          <a:xfrm xmlns:a="http://schemas.openxmlformats.org/drawingml/2006/main">
-            <a:off x="3714750" y="3228975"/>
-            <a:ext cx="800100" cy="0"/>
+          <a:xfrm xmlns:a="http://schemas.openxmlformats.org/drawingml/2006/main">
+            <a:off x="3381375" y="2781300"/>
+            <a:ext cx="1209675" cy="0"/>
           </a:xfrm>
           <a:prstGeom xmlns:a="http://schemas.openxmlformats.org/drawingml/2006/main" prst="straightConnector1">
             <a:avLst/>
@@ -9251,17 +9171,17 @@
       </p:cxnSp>
       <p:cxnSp>
         <p:nvCxnSpPr>
-          <p:cNvPr id="30" name=""/>
+          <p:cNvPr id="29" name=""/>
           <p:cNvCxnSpPr>
-            <a:stCxn xmlns:a="http://schemas.openxmlformats.org/drawingml/2006/main" id="8" idx="3"/>
-            <a:endCxn xmlns:a="http://schemas.openxmlformats.org/drawingml/2006/main" id="9" idx="1"/>
+            <a:stCxn xmlns:a="http://schemas.openxmlformats.org/drawingml/2006/main" id="7" idx="3"/>
+            <a:endCxn xmlns:a="http://schemas.openxmlformats.org/drawingml/2006/main" id="8" idx="1"/>
           </p:cNvCxnSpPr>
           <p:nvPr/>
         </p:nvCxnSpPr>
         <p:spPr>
           <a:xfrm xmlns:a="http://schemas.openxmlformats.org/drawingml/2006/main">
-            <a:off x="6810375" y="3228975"/>
-            <a:ext cx="1962150" cy="0"/>
+            <a:off x="7267575" y="2781300"/>
+            <a:ext cx="1485900" cy="0"/>
           </a:xfrm>
           <a:prstGeom xmlns:a="http://schemas.openxmlformats.org/drawingml/2006/main" prst="straightConnector1">
             <a:avLst/>
@@ -9277,39 +9197,355 @@
       </p:cxnSp>
       <p:sp>
         <p:nvSpPr>
+          <p:cNvPr id="11" name="">
+            <a:extLst xmlns:a="http://schemas.openxmlformats.org/drawingml/2006/main">
+              <a:ext uri="{FF2B5EF4-FFF2-40B4-BE49-F238E27FC236}">
+                <a16:creationId xmlns:a16="http://schemas.microsoft.com/office/drawing/2014/main" id="{00AE6069-F79E-4C8B-BA0A-E177BC41DE85}"/>
+              </a:ext>
+            </a:extLst>
+          </p:cNvPr>
+          <p:cNvSpPr>
+            <a:spLocks xmlns:a="http://schemas.openxmlformats.org/drawingml/2006/main" noGrp="1"/>
+          </p:cNvSpPr>
+          <p:nvPr/>
+        </p:nvSpPr>
+        <p:spPr>
+          <a:xfrm xmlns:a="http://schemas.openxmlformats.org/drawingml/2006/main">
+            <a:off x="657225" y="3390900"/>
+            <a:ext cx="3048000" cy="1181100"/>
+          </a:xfrm>
+          <a:prstGeom xmlns:a="http://schemas.openxmlformats.org/drawingml/2006/main" prst="rect">
+            <a:avLst/>
+          </a:prstGeom>
+          <a:noFill xmlns:a="http://schemas.openxmlformats.org/drawingml/2006/main"/>
+          <a:ln xmlns:a="http://schemas.openxmlformats.org/drawingml/2006/main" w="0">
+            <a:noFill/>
+          </a:ln>
+        </p:spPr>
+        <p:txBody>
+          <a:bodyPr xmlns:a="http://schemas.openxmlformats.org/drawingml/2006/main">
+            <a:noAutofit/>
+          </a:bodyPr>
+          <a:lstStyle xmlns:a="http://schemas.openxmlformats.org/drawingml/2006/main"/>
+          <a:p xmlns:a="http://schemas.openxmlformats.org/drawingml/2006/main">
+            <a:pPr>
+              <a:defRPr sz="1875" b="0">
+                <a:solidFill>
+                  <a:srgbClr val="666962"/>
+                </a:solidFill>
+                <a:latin typeface="Manrope"/>
+                <a:ea typeface="Manrope"/>
+                <a:cs typeface="Manrope"/>
+              </a:defRPr>
+            </a:pPr>
+            <a:r>
+              <a:rPr sz="1875" b="0">
+                <a:solidFill>
+                  <a:srgbClr val="666962"/>
+                </a:solidFill>
+                <a:latin typeface="Manrope"/>
+                <a:ea typeface="Manrope"/>
+                <a:cs typeface="Manrope"/>
+              </a:rPr>
+              <a:t>React dispatcher UI</a:t>
+            </a:r>
+          </a:p>
+          <a:p xmlns:a="http://schemas.openxmlformats.org/drawingml/2006/main">
+            <a:pPr>
+              <a:defRPr sz="1875" b="0">
+                <a:solidFill>
+                  <a:srgbClr val="666962"/>
+                </a:solidFill>
+                <a:latin typeface="Manrope"/>
+                <a:ea typeface="Manrope"/>
+                <a:cs typeface="Manrope"/>
+              </a:defRPr>
+            </a:pPr>
+            <a:r>
+              <a:rPr sz="1875" b="0">
+                <a:solidFill>
+                  <a:srgbClr val="666962"/>
+                </a:solidFill>
+                <a:latin typeface="Manrope"/>
+                <a:ea typeface="Manrope"/>
+                <a:cs typeface="Manrope"/>
+              </a:rPr>
+              <a:t>Expo driver execution</a:t>
+            </a:r>
+          </a:p>
+        </p:txBody>
+      </p:sp>
+      <p:sp>
+        <p:nvSpPr>
+          <p:cNvPr id="12" name="">
+            <a:extLst xmlns:a="http://schemas.openxmlformats.org/drawingml/2006/main">
+              <a:ext uri="{FF2B5EF4-FFF2-40B4-BE49-F238E27FC236}">
+                <a16:creationId xmlns:a16="http://schemas.microsoft.com/office/drawing/2014/main" id="{377F30E5-3907-4CE0-BB27-07C70DDC496C}"/>
+              </a:ext>
+            </a:extLst>
+          </p:cNvPr>
+          <p:cNvSpPr>
+            <a:spLocks xmlns:a="http://schemas.openxmlformats.org/drawingml/2006/main" noGrp="1"/>
+          </p:cNvSpPr>
+          <p:nvPr/>
+        </p:nvSpPr>
+        <p:spPr>
+          <a:xfrm xmlns:a="http://schemas.openxmlformats.org/drawingml/2006/main">
+            <a:off x="4629150" y="3390900"/>
+            <a:ext cx="3238500" cy="1181100"/>
+          </a:xfrm>
+          <a:prstGeom xmlns:a="http://schemas.openxmlformats.org/drawingml/2006/main" prst="rect">
+            <a:avLst/>
+          </a:prstGeom>
+          <a:noFill xmlns:a="http://schemas.openxmlformats.org/drawingml/2006/main"/>
+          <a:ln xmlns:a="http://schemas.openxmlformats.org/drawingml/2006/main" w="0">
+            <a:noFill/>
+          </a:ln>
+        </p:spPr>
+        <p:txBody>
+          <a:bodyPr xmlns:a="http://schemas.openxmlformats.org/drawingml/2006/main">
+            <a:noAutofit/>
+          </a:bodyPr>
+          <a:lstStyle xmlns:a="http://schemas.openxmlformats.org/drawingml/2006/main"/>
+          <a:p xmlns:a="http://schemas.openxmlformats.org/drawingml/2006/main">
+            <a:pPr>
+              <a:defRPr sz="1875" b="0">
+                <a:solidFill>
+                  <a:srgbClr val="666962"/>
+                </a:solidFill>
+                <a:latin typeface="Manrope"/>
+                <a:ea typeface="Manrope"/>
+                <a:cs typeface="Manrope"/>
+              </a:defRPr>
+            </a:pPr>
+            <a:r>
+              <a:rPr sz="1875" b="0">
+                <a:solidFill>
+                  <a:srgbClr val="666962"/>
+                </a:solidFill>
+                <a:latin typeface="Manrope"/>
+                <a:ea typeface="Manrope"/>
+                <a:cs typeface="Manrope"/>
+              </a:rPr>
+              <a:t>Firebase identity</a:t>
+            </a:r>
+          </a:p>
+          <a:p xmlns:a="http://schemas.openxmlformats.org/drawingml/2006/main">
+            <a:pPr>
+              <a:defRPr sz="1875" b="0">
+                <a:solidFill>
+                  <a:srgbClr val="666962"/>
+                </a:solidFill>
+                <a:latin typeface="Manrope"/>
+                <a:ea typeface="Manrope"/>
+                <a:cs typeface="Manrope"/>
+              </a:defRPr>
+            </a:pPr>
+            <a:r>
+              <a:rPr sz="1875" b="0">
+                <a:solidFill>
+                  <a:srgbClr val="666962"/>
+                </a:solidFill>
+                <a:latin typeface="Manrope"/>
+                <a:ea typeface="Manrope"/>
+                <a:cs typeface="Manrope"/>
+              </a:rPr>
+              <a:t>Carrier membership</a:t>
+            </a:r>
+          </a:p>
+          <a:p xmlns:a="http://schemas.openxmlformats.org/drawingml/2006/main">
+            <a:pPr>
+              <a:defRPr sz="1875" b="0">
+                <a:solidFill>
+                  <a:srgbClr val="666962"/>
+                </a:solidFill>
+                <a:latin typeface="Manrope"/>
+                <a:ea typeface="Manrope"/>
+                <a:cs typeface="Manrope"/>
+              </a:defRPr>
+            </a:pPr>
+            <a:r>
+              <a:rPr sz="1875" b="0">
+                <a:solidFill>
+                  <a:srgbClr val="666962"/>
+                </a:solidFill>
+                <a:latin typeface="Manrope"/>
+                <a:ea typeface="Manrope"/>
+                <a:cs typeface="Manrope"/>
+              </a:rPr>
+              <a:t>Validated commands</a:t>
+            </a:r>
+          </a:p>
+        </p:txBody>
+      </p:sp>
+      <p:sp>
+        <p:nvSpPr>
+          <p:cNvPr id="13" name="">
+            <a:extLst xmlns:a="http://schemas.openxmlformats.org/drawingml/2006/main">
+              <a:ext uri="{FF2B5EF4-FFF2-40B4-BE49-F238E27FC236}">
+                <a16:creationId xmlns:a16="http://schemas.microsoft.com/office/drawing/2014/main" id="{63F2BFBC-9E23-471D-8A1A-E1F6EEE27BDC}"/>
+              </a:ext>
+            </a:extLst>
+          </p:cNvPr>
+          <p:cNvSpPr>
+            <a:spLocks xmlns:a="http://schemas.openxmlformats.org/drawingml/2006/main" noGrp="1"/>
+          </p:cNvSpPr>
+          <p:nvPr/>
+        </p:nvSpPr>
+        <p:spPr>
+          <a:xfrm xmlns:a="http://schemas.openxmlformats.org/drawingml/2006/main">
+            <a:off x="8791575" y="3390900"/>
+            <a:ext cx="2714625" cy="1181100"/>
+          </a:xfrm>
+          <a:prstGeom xmlns:a="http://schemas.openxmlformats.org/drawingml/2006/main" prst="rect">
+            <a:avLst/>
+          </a:prstGeom>
+          <a:noFill xmlns:a="http://schemas.openxmlformats.org/drawingml/2006/main"/>
+          <a:ln xmlns:a="http://schemas.openxmlformats.org/drawingml/2006/main" w="0">
+            <a:noFill/>
+          </a:ln>
+        </p:spPr>
+        <p:txBody>
+          <a:bodyPr xmlns:a="http://schemas.openxmlformats.org/drawingml/2006/main">
+            <a:noAutofit/>
+          </a:bodyPr>
+          <a:lstStyle xmlns:a="http://schemas.openxmlformats.org/drawingml/2006/main"/>
+          <a:p xmlns:a="http://schemas.openxmlformats.org/drawingml/2006/main">
+            <a:pPr>
+              <a:defRPr sz="1875" b="0">
+                <a:solidFill>
+                  <a:srgbClr val="666962"/>
+                </a:solidFill>
+                <a:latin typeface="Manrope"/>
+                <a:ea typeface="Manrope"/>
+                <a:cs typeface="Manrope"/>
+              </a:defRPr>
+            </a:pPr>
+            <a:r>
+              <a:rPr sz="1875" b="0">
+                <a:solidFill>
+                  <a:srgbClr val="666962"/>
+                </a:solidFill>
+                <a:latin typeface="Manrope"/>
+                <a:ea typeface="Manrope"/>
+                <a:cs typeface="Manrope"/>
+              </a:rPr>
+              <a:t>Versions</a:t>
+            </a:r>
+          </a:p>
+          <a:p xmlns:a="http://schemas.openxmlformats.org/drawingml/2006/main">
+            <a:pPr>
+              <a:defRPr sz="1875" b="0">
+                <a:solidFill>
+                  <a:srgbClr val="666962"/>
+                </a:solidFill>
+                <a:latin typeface="Manrope"/>
+                <a:ea typeface="Manrope"/>
+                <a:cs typeface="Manrope"/>
+              </a:defRPr>
+            </a:pPr>
+            <a:r>
+              <a:rPr sz="1875" b="0">
+                <a:solidFill>
+                  <a:srgbClr val="666962"/>
+                </a:solidFill>
+                <a:latin typeface="Manrope"/>
+                <a:ea typeface="Manrope"/>
+                <a:cs typeface="Manrope"/>
+              </a:rPr>
+              <a:t>Reservations</a:t>
+            </a:r>
+          </a:p>
+          <a:p xmlns:a="http://schemas.openxmlformats.org/drawingml/2006/main">
+            <a:pPr>
+              <a:defRPr sz="1875" b="0">
+                <a:solidFill>
+                  <a:srgbClr val="666962"/>
+                </a:solidFill>
+                <a:latin typeface="Manrope"/>
+                <a:ea typeface="Manrope"/>
+                <a:cs typeface="Manrope"/>
+              </a:defRPr>
+            </a:pPr>
+            <a:r>
+              <a:rPr sz="1875" b="0">
+                <a:solidFill>
+                  <a:srgbClr val="666962"/>
+                </a:solidFill>
+                <a:latin typeface="Manrope"/>
+                <a:ea typeface="Manrope"/>
+                <a:cs typeface="Manrope"/>
+              </a:rPr>
+              <a:t>Evidence</a:t>
+            </a:r>
+          </a:p>
+        </p:txBody>
+      </p:sp>
+      <p:sp>
+        <p:nvSpPr>
           <p:cNvPr id="14" name="">
             <a:extLst xmlns:a="http://schemas.openxmlformats.org/drawingml/2006/main">
               <a:ext uri="{FF2B5EF4-FFF2-40B4-BE49-F238E27FC236}">
-                <a16:creationId xmlns:a16="http://schemas.microsoft.com/office/drawing/2014/main" id="{914B2698-D547-4C94-A44E-C54E86B09C1F}"/>
-              </a:ext>
-            </a:extLst>
-          </p:cNvPr>
-          <p:cNvSpPr>
-            <a:spLocks xmlns:a="http://schemas.openxmlformats.org/drawingml/2006/main" noGrp="1"/>
-          </p:cNvSpPr>
-          <p:nvPr/>
-        </p:nvSpPr>
-        <p:spPr>
-          <a:xfrm xmlns:a="http://schemas.openxmlformats.org/drawingml/2006/main">
-            <a:off x="4581525" y="3943350"/>
-            <a:ext cx="3457575" cy="1257300"/>
-          </a:xfrm>
-          <a:prstGeom xmlns:a="http://schemas.openxmlformats.org/drawingml/2006/main" prst="rect">
-            <a:avLst/>
-          </a:prstGeom>
-          <a:noFill xmlns:a="http://schemas.openxmlformats.org/drawingml/2006/main"/>
-          <a:ln xmlns:a="http://schemas.openxmlformats.org/drawingml/2006/main" w="0">
-            <a:noFill/>
-          </a:ln>
-        </p:spPr>
-        <p:txBody>
-          <a:bodyPr xmlns:a="http://schemas.openxmlformats.org/drawingml/2006/main">
-            <a:noAutofit/>
-          </a:bodyPr>
-          <a:lstStyle xmlns:a="http://schemas.openxmlformats.org/drawingml/2006/main"/>
-          <a:p xmlns:a="http://schemas.openxmlformats.org/drawingml/2006/main">
-            <a:pPr>
-              <a:defRPr sz="1800" b="0">
+                <a16:creationId xmlns:a16="http://schemas.microsoft.com/office/drawing/2014/main" id="{58A8AB9D-E072-462B-AE14-25137AB1DECB}"/>
+              </a:ext>
+            </a:extLst>
+          </p:cNvPr>
+          <p:cNvSpPr>
+            <a:spLocks xmlns:a="http://schemas.openxmlformats.org/drawingml/2006/main" noGrp="1"/>
+          </p:cNvSpPr>
+          <p:nvPr/>
+        </p:nvSpPr>
+        <p:spPr>
+          <a:xfrm xmlns:a="http://schemas.openxmlformats.org/drawingml/2006/main">
+            <a:off x="695325" y="5057775"/>
+            <a:ext cx="10801350" cy="9525"/>
+          </a:xfrm>
+          <a:prstGeom xmlns:a="http://schemas.openxmlformats.org/drawingml/2006/main" prst="rect">
+            <a:avLst/>
+          </a:prstGeom>
+          <a:solidFill xmlns:a="http://schemas.openxmlformats.org/drawingml/2006/main">
+            <a:srgbClr val="DCDDD5"/>
+          </a:solidFill>
+          <a:ln xmlns:a="http://schemas.openxmlformats.org/drawingml/2006/main" w="0">
+            <a:noFill/>
+          </a:ln>
+        </p:spPr>
+      </p:sp>
+      <p:sp>
+        <p:nvSpPr>
+          <p:cNvPr id="15" name="">
+            <a:extLst xmlns:a="http://schemas.openxmlformats.org/drawingml/2006/main">
+              <a:ext uri="{FF2B5EF4-FFF2-40B4-BE49-F238E27FC236}">
+                <a16:creationId xmlns:a16="http://schemas.microsoft.com/office/drawing/2014/main" id="{0CB36440-4196-4B1A-9BC9-F641B52D65EC}"/>
+              </a:ext>
+            </a:extLst>
+          </p:cNvPr>
+          <p:cNvSpPr>
+            <a:spLocks xmlns:a="http://schemas.openxmlformats.org/drawingml/2006/main" noGrp="1"/>
+          </p:cNvSpPr>
+          <p:nvPr/>
+        </p:nvSpPr>
+        <p:spPr>
+          <a:xfrm xmlns:a="http://schemas.openxmlformats.org/drawingml/2006/main">
+            <a:off x="619125" y="5257800"/>
+            <a:ext cx="5334000" cy="304800"/>
+          </a:xfrm>
+          <a:prstGeom xmlns:a="http://schemas.openxmlformats.org/drawingml/2006/main" prst="rect">
+            <a:avLst/>
+          </a:prstGeom>
+          <a:noFill xmlns:a="http://schemas.openxmlformats.org/drawingml/2006/main"/>
+          <a:ln xmlns:a="http://schemas.openxmlformats.org/drawingml/2006/main" w="0">
+            <a:noFill/>
+          </a:ln>
+        </p:spPr>
+        <p:txBody>
+          <a:bodyPr xmlns:a="http://schemas.openxmlformats.org/drawingml/2006/main">
+            <a:noAutofit/>
+          </a:bodyPr>
+          <a:lstStyle xmlns:a="http://schemas.openxmlformats.org/drawingml/2006/main"/>
+          <a:p xmlns:a="http://schemas.openxmlformats.org/drawingml/2006/main">
+            <a:pPr>
+              <a:defRPr sz="1350" b="1">
                 <a:solidFill>
                   <a:srgbClr val="666962"/>
                 </a:solidFill>
@@ -9319,7 +9555,7 @@
               </a:defRPr>
             </a:pPr>
             <a:r>
-              <a:rPr sz="1800" b="0">
+              <a:rPr sz="1350" b="1">
                 <a:solidFill>
                   <a:srgbClr val="666962"/>
                 </a:solidFill>
@@ -9327,12 +9563,46 @@
                 <a:ea typeface="Manrope"/>
                 <a:cs typeface="Manrope"/>
               </a:rPr>
-              <a:t>Firebase identity</a:t>
-            </a:r>
-          </a:p>
-          <a:p xmlns:a="http://schemas.openxmlformats.org/drawingml/2006/main">
-            <a:pPr>
-              <a:defRPr sz="1800" b="0">
+              <a:t>PROPOSALS</a:t>
+            </a:r>
+          </a:p>
+        </p:txBody>
+      </p:sp>
+      <p:sp>
+        <p:nvSpPr>
+          <p:cNvPr id="16" name="">
+            <a:extLst xmlns:a="http://schemas.openxmlformats.org/drawingml/2006/main">
+              <a:ext uri="{FF2B5EF4-FFF2-40B4-BE49-F238E27FC236}">
+                <a16:creationId xmlns:a16="http://schemas.microsoft.com/office/drawing/2014/main" id="{92354771-FC42-48B7-BF96-811EDAB3DE81}"/>
+              </a:ext>
+            </a:extLst>
+          </p:cNvPr>
+          <p:cNvSpPr>
+            <a:spLocks xmlns:a="http://schemas.openxmlformats.org/drawingml/2006/main" noGrp="1"/>
+          </p:cNvSpPr>
+          <p:nvPr/>
+        </p:nvSpPr>
+        <p:spPr>
+          <a:xfrm xmlns:a="http://schemas.openxmlformats.org/drawingml/2006/main">
+            <a:off x="6629400" y="5257800"/>
+            <a:ext cx="4857750" cy="304800"/>
+          </a:xfrm>
+          <a:prstGeom xmlns:a="http://schemas.openxmlformats.org/drawingml/2006/main" prst="rect">
+            <a:avLst/>
+          </a:prstGeom>
+          <a:noFill xmlns:a="http://schemas.openxmlformats.org/drawingml/2006/main"/>
+          <a:ln xmlns:a="http://schemas.openxmlformats.org/drawingml/2006/main" w="0">
+            <a:noFill/>
+          </a:ln>
+        </p:spPr>
+        <p:txBody>
+          <a:bodyPr xmlns:a="http://schemas.openxmlformats.org/drawingml/2006/main">
+            <a:noAutofit/>
+          </a:bodyPr>
+          <a:lstStyle xmlns:a="http://schemas.openxmlformats.org/drawingml/2006/main"/>
+          <a:p xmlns:a="http://schemas.openxmlformats.org/drawingml/2006/main">
+            <a:pPr>
+              <a:defRPr sz="1350" b="1">
                 <a:solidFill>
                   <a:srgbClr val="666962"/>
                 </a:solidFill>
@@ -9342,7 +9612,7 @@
               </a:defRPr>
             </a:pPr>
             <a:r>
-              <a:rPr sz="1800" b="0">
+              <a:rPr sz="1350" b="1">
                 <a:solidFill>
                   <a:srgbClr val="666962"/>
                 </a:solidFill>
@@ -9350,12 +9620,160 @@
                 <a:ea typeface="Manrope"/>
                 <a:cs typeface="Manrope"/>
               </a:rPr>
-              <a:t>Carrier membership</a:t>
-            </a:r>
-          </a:p>
-          <a:p xmlns:a="http://schemas.openxmlformats.org/drawingml/2006/main">
-            <a:pPr>
-              <a:defRPr sz="1800" b="0">
+              <a:t>DOCUMENT FIELDS</a:t>
+            </a:r>
+          </a:p>
+        </p:txBody>
+      </p:sp>
+      <p:sp>
+        <p:nvSpPr>
+          <p:cNvPr id="17" name="">
+            <a:extLst xmlns:a="http://schemas.openxmlformats.org/drawingml/2006/main">
+              <a:ext uri="{FF2B5EF4-FFF2-40B4-BE49-F238E27FC236}">
+                <a16:creationId xmlns:a16="http://schemas.microsoft.com/office/drawing/2014/main" id="{96D4B40D-2275-4266-A02A-CEAEB017D58A}"/>
+              </a:ext>
+            </a:extLst>
+          </p:cNvPr>
+          <p:cNvSpPr>
+            <a:spLocks xmlns:a="http://schemas.openxmlformats.org/drawingml/2006/main" noGrp="1"/>
+          </p:cNvSpPr>
+          <p:nvPr/>
+        </p:nvSpPr>
+        <p:spPr>
+          <a:xfrm xmlns:a="http://schemas.openxmlformats.org/drawingml/2006/main">
+            <a:off x="619125" y="5629275"/>
+            <a:ext cx="5429250" cy="447675"/>
+          </a:xfrm>
+          <a:prstGeom xmlns:a="http://schemas.openxmlformats.org/drawingml/2006/main" prst="rect">
+            <a:avLst/>
+          </a:prstGeom>
+          <a:noFill xmlns:a="http://schemas.openxmlformats.org/drawingml/2006/main"/>
+          <a:ln xmlns:a="http://schemas.openxmlformats.org/drawingml/2006/main" w="0">
+            <a:noFill/>
+          </a:ln>
+        </p:spPr>
+        <p:txBody>
+          <a:bodyPr xmlns:a="http://schemas.openxmlformats.org/drawingml/2006/main">
+            <a:noAutofit/>
+          </a:bodyPr>
+          <a:lstStyle xmlns:a="http://schemas.openxmlformats.org/drawingml/2006/main"/>
+          <a:p xmlns:a="http://schemas.openxmlformats.org/drawingml/2006/main">
+            <a:pPr>
+              <a:defRPr sz="2100" b="0">
+                <a:solidFill>
+                  <a:srgbClr val="242729"/>
+                </a:solidFill>
+                <a:latin typeface="Manrope"/>
+                <a:ea typeface="Manrope"/>
+                <a:cs typeface="Manrope"/>
+              </a:defRPr>
+            </a:pPr>
+            <a:r>
+              <a:rPr sz="2100" b="0">
+                <a:solidFill>
+                  <a:srgbClr val="242729"/>
+                </a:solidFill>
+                <a:latin typeface="Manrope"/>
+                <a:ea typeface="Manrope"/>
+                <a:cs typeface="Manrope"/>
+              </a:rPr>
+              <a:t>OR-Tools + Valhalla</a:t>
+            </a:r>
+          </a:p>
+        </p:txBody>
+      </p:sp>
+      <p:sp>
+        <p:nvSpPr>
+          <p:cNvPr id="18" name="">
+            <a:extLst xmlns:a="http://schemas.openxmlformats.org/drawingml/2006/main">
+              <a:ext uri="{FF2B5EF4-FFF2-40B4-BE49-F238E27FC236}">
+                <a16:creationId xmlns:a16="http://schemas.microsoft.com/office/drawing/2014/main" id="{0D5E5647-939F-4AA6-9FDA-74CCD274C7D3}"/>
+              </a:ext>
+            </a:extLst>
+          </p:cNvPr>
+          <p:cNvSpPr>
+            <a:spLocks xmlns:a="http://schemas.openxmlformats.org/drawingml/2006/main" noGrp="1"/>
+          </p:cNvSpPr>
+          <p:nvPr/>
+        </p:nvSpPr>
+        <p:spPr>
+          <a:xfrm xmlns:a="http://schemas.openxmlformats.org/drawingml/2006/main">
+            <a:off x="6629400" y="5629275"/>
+            <a:ext cx="4857750" cy="447675"/>
+          </a:xfrm>
+          <a:prstGeom xmlns:a="http://schemas.openxmlformats.org/drawingml/2006/main" prst="rect">
+            <a:avLst/>
+          </a:prstGeom>
+          <a:noFill xmlns:a="http://schemas.openxmlformats.org/drawingml/2006/main"/>
+          <a:ln xmlns:a="http://schemas.openxmlformats.org/drawingml/2006/main" w="0">
+            <a:noFill/>
+          </a:ln>
+        </p:spPr>
+        <p:txBody>
+          <a:bodyPr xmlns:a="http://schemas.openxmlformats.org/drawingml/2006/main">
+            <a:noAutofit/>
+          </a:bodyPr>
+          <a:lstStyle xmlns:a="http://schemas.openxmlformats.org/drawingml/2006/main"/>
+          <a:p xmlns:a="http://schemas.openxmlformats.org/drawingml/2006/main">
+            <a:pPr>
+              <a:defRPr sz="2100" b="0">
+                <a:solidFill>
+                  <a:srgbClr val="242729"/>
+                </a:solidFill>
+                <a:latin typeface="Manrope"/>
+                <a:ea typeface="Manrope"/>
+                <a:cs typeface="Manrope"/>
+              </a:defRPr>
+            </a:pPr>
+            <a:r>
+              <a:rPr sz="2100" b="0">
+                <a:solidFill>
+                  <a:srgbClr val="242729"/>
+                </a:solidFill>
+                <a:latin typeface="Manrope"/>
+                <a:ea typeface="Manrope"/>
+                <a:cs typeface="Manrope"/>
+              </a:rPr>
+              <a:t>Gemini extraction</a:t>
+            </a:r>
+          </a:p>
+        </p:txBody>
+      </p:sp>
+      <p:sp>
+        <p:nvSpPr>
+          <p:cNvPr id="19" name="">
+            <a:extLst xmlns:a="http://schemas.openxmlformats.org/drawingml/2006/main">
+              <a:ext uri="{FF2B5EF4-FFF2-40B4-BE49-F238E27FC236}">
+                <a16:creationId xmlns:a16="http://schemas.microsoft.com/office/drawing/2014/main" id="{66A02044-38D2-404D-8EDB-1C15E29CA2A9}"/>
+              </a:ext>
+            </a:extLst>
+          </p:cNvPr>
+          <p:cNvSpPr>
+            <a:spLocks xmlns:a="http://schemas.openxmlformats.org/drawingml/2006/main" noGrp="1"/>
+          </p:cNvSpPr>
+          <p:nvPr/>
+        </p:nvSpPr>
+        <p:spPr>
+          <a:xfrm xmlns:a="http://schemas.openxmlformats.org/drawingml/2006/main">
+            <a:off x="619125" y="6200775"/>
+            <a:ext cx="10477500" cy="361950"/>
+          </a:xfrm>
+          <a:prstGeom xmlns:a="http://schemas.openxmlformats.org/drawingml/2006/main" prst="rect">
+            <a:avLst/>
+          </a:prstGeom>
+          <a:noFill xmlns:a="http://schemas.openxmlformats.org/drawingml/2006/main"/>
+          <a:ln xmlns:a="http://schemas.openxmlformats.org/drawingml/2006/main" w="0">
+            <a:noFill/>
+          </a:ln>
+        </p:spPr>
+        <p:txBody>
+          <a:bodyPr xmlns:a="http://schemas.openxmlformats.org/drawingml/2006/main">
+            <a:noAutofit/>
+          </a:bodyPr>
+          <a:lstStyle xmlns:a="http://schemas.openxmlformats.org/drawingml/2006/main"/>
+          <a:p xmlns:a="http://schemas.openxmlformats.org/drawingml/2006/main">
+            <a:pPr>
+              <a:defRPr sz="1425" b="0">
                 <a:solidFill>
                   <a:srgbClr val="666962"/>
                 </a:solidFill>
@@ -9365,7 +9783,7 @@
               </a:defRPr>
             </a:pPr>
             <a:r>
-              <a:rPr sz="1800" b="0">
+              <a:rPr sz="1425" b="0">
                 <a:solidFill>
                   <a:srgbClr val="666962"/>
                 </a:solidFill>
@@ -9373,224 +9791,7 @@
                 <a:ea typeface="Manrope"/>
                 <a:cs typeface="Manrope"/>
               </a:rPr>
-              <a:t>Validated commands</a:t>
-            </a:r>
-          </a:p>
-        </p:txBody>
-      </p:sp>
-      <p:sp>
-        <p:nvSpPr>
-          <p:cNvPr id="15" name="">
-            <a:extLst xmlns:a="http://schemas.openxmlformats.org/drawingml/2006/main">
-              <a:ext uri="{FF2B5EF4-FFF2-40B4-BE49-F238E27FC236}">
-                <a16:creationId xmlns:a16="http://schemas.microsoft.com/office/drawing/2014/main" id="{E3048863-8951-436A-A8C6-C3E198357748}"/>
-              </a:ext>
-            </a:extLst>
-          </p:cNvPr>
-          <p:cNvSpPr>
-            <a:spLocks xmlns:a="http://schemas.openxmlformats.org/drawingml/2006/main" noGrp="1"/>
-          </p:cNvSpPr>
-          <p:nvPr/>
-        </p:nvSpPr>
-        <p:spPr>
-          <a:xfrm xmlns:a="http://schemas.openxmlformats.org/drawingml/2006/main">
-            <a:off x="8839200" y="3943350"/>
-            <a:ext cx="2638425" cy="1238250"/>
-          </a:xfrm>
-          <a:prstGeom xmlns:a="http://schemas.openxmlformats.org/drawingml/2006/main" prst="rect">
-            <a:avLst/>
-          </a:prstGeom>
-          <a:noFill xmlns:a="http://schemas.openxmlformats.org/drawingml/2006/main"/>
-          <a:ln xmlns:a="http://schemas.openxmlformats.org/drawingml/2006/main" w="0">
-            <a:noFill/>
-          </a:ln>
-        </p:spPr>
-        <p:txBody>
-          <a:bodyPr xmlns:a="http://schemas.openxmlformats.org/drawingml/2006/main">
-            <a:noAutofit/>
-          </a:bodyPr>
-          <a:lstStyle xmlns:a="http://schemas.openxmlformats.org/drawingml/2006/main"/>
-          <a:p xmlns:a="http://schemas.openxmlformats.org/drawingml/2006/main">
-            <a:pPr>
-              <a:defRPr sz="1800" b="0">
-                <a:solidFill>
-                  <a:srgbClr val="666962"/>
-                </a:solidFill>
-                <a:latin typeface="Manrope"/>
-                <a:ea typeface="Manrope"/>
-                <a:cs typeface="Manrope"/>
-              </a:defRPr>
-            </a:pPr>
-            <a:r>
-              <a:rPr sz="1800" b="0">
-                <a:solidFill>
-                  <a:srgbClr val="666962"/>
-                </a:solidFill>
-                <a:latin typeface="Manrope"/>
-                <a:ea typeface="Manrope"/>
-                <a:cs typeface="Manrope"/>
-              </a:rPr>
-              <a:t>Versions</a:t>
-            </a:r>
-          </a:p>
-          <a:p xmlns:a="http://schemas.openxmlformats.org/drawingml/2006/main">
-            <a:pPr>
-              <a:defRPr sz="1800" b="0">
-                <a:solidFill>
-                  <a:srgbClr val="666962"/>
-                </a:solidFill>
-                <a:latin typeface="Manrope"/>
-                <a:ea typeface="Manrope"/>
-                <a:cs typeface="Manrope"/>
-              </a:defRPr>
-            </a:pPr>
-            <a:r>
-              <a:rPr sz="1800" b="0">
-                <a:solidFill>
-                  <a:srgbClr val="666962"/>
-                </a:solidFill>
-                <a:latin typeface="Manrope"/>
-                <a:ea typeface="Manrope"/>
-                <a:cs typeface="Manrope"/>
-              </a:rPr>
-              <a:t>Reservations</a:t>
-            </a:r>
-          </a:p>
-          <a:p xmlns:a="http://schemas.openxmlformats.org/drawingml/2006/main">
-            <a:pPr>
-              <a:defRPr sz="1800" b="0">
-                <a:solidFill>
-                  <a:srgbClr val="666962"/>
-                </a:solidFill>
-                <a:latin typeface="Manrope"/>
-                <a:ea typeface="Manrope"/>
-                <a:cs typeface="Manrope"/>
-              </a:defRPr>
-            </a:pPr>
-            <a:r>
-              <a:rPr sz="1800" b="0">
-                <a:solidFill>
-                  <a:srgbClr val="666962"/>
-                </a:solidFill>
-                <a:latin typeface="Manrope"/>
-                <a:ea typeface="Manrope"/>
-                <a:cs typeface="Manrope"/>
-              </a:rPr>
-              <a:t>Evidence</a:t>
-            </a:r>
-          </a:p>
-        </p:txBody>
-      </p:sp>
-      <p:sp>
-        <p:nvSpPr>
-          <p:cNvPr id="16" name="">
-            <a:extLst xmlns:a="http://schemas.openxmlformats.org/drawingml/2006/main">
-              <a:ext uri="{FF2B5EF4-FFF2-40B4-BE49-F238E27FC236}">
-                <a16:creationId xmlns:a16="http://schemas.microsoft.com/office/drawing/2014/main" id="{886429ED-C853-42AF-8FEC-CF67C7E989A2}"/>
-              </a:ext>
-            </a:extLst>
-          </p:cNvPr>
-          <p:cNvSpPr>
-            <a:spLocks xmlns:a="http://schemas.openxmlformats.org/drawingml/2006/main" noGrp="1"/>
-          </p:cNvSpPr>
-          <p:nvPr/>
-        </p:nvSpPr>
-        <p:spPr>
-          <a:xfrm xmlns:a="http://schemas.openxmlformats.org/drawingml/2006/main">
-            <a:off x="638175" y="5572125"/>
-            <a:ext cx="10477500" cy="466725"/>
-          </a:xfrm>
-          <a:prstGeom xmlns:a="http://schemas.openxmlformats.org/drawingml/2006/main" prst="rect">
-            <a:avLst/>
-          </a:prstGeom>
-          <a:noFill xmlns:a="http://schemas.openxmlformats.org/drawingml/2006/main"/>
-          <a:ln xmlns:a="http://schemas.openxmlformats.org/drawingml/2006/main" w="0">
-            <a:noFill/>
-          </a:ln>
-        </p:spPr>
-        <p:txBody>
-          <a:bodyPr xmlns:a="http://schemas.openxmlformats.org/drawingml/2006/main">
-            <a:noAutofit/>
-          </a:bodyPr>
-          <a:lstStyle xmlns:a="http://schemas.openxmlformats.org/drawingml/2006/main"/>
-          <a:p xmlns:a="http://schemas.openxmlformats.org/drawingml/2006/main">
-            <a:pPr>
-              <a:defRPr sz="1800" b="0">
-                <a:solidFill>
-                  <a:srgbClr val="666962"/>
-                </a:solidFill>
-                <a:latin typeface="Manrope"/>
-                <a:ea typeface="Manrope"/>
-                <a:cs typeface="Manrope"/>
-              </a:defRPr>
-            </a:pPr>
-            <a:r>
-              <a:rPr sz="1800" b="0">
-                <a:solidFill>
-                  <a:srgbClr val="666962"/>
-                </a:solidFill>
-                <a:latin typeface="Manrope"/>
-                <a:ea typeface="Manrope"/>
-                <a:cs typeface="Manrope"/>
-              </a:rPr>
-              <a:t>OR-Tools and Valhalla compute proposals. Gemini extracts fields.</a:t>
-            </a:r>
-          </a:p>
-        </p:txBody>
-      </p:sp>
-      <p:sp>
-        <p:nvSpPr>
-          <p:cNvPr id="17" name="">
-            <a:extLst xmlns:a="http://schemas.openxmlformats.org/drawingml/2006/main">
-              <a:ext uri="{FF2B5EF4-FFF2-40B4-BE49-F238E27FC236}">
-                <a16:creationId xmlns:a16="http://schemas.microsoft.com/office/drawing/2014/main" id="{034600A4-D7E5-4FE4-BA15-3B5F2FA2744B}"/>
-              </a:ext>
-            </a:extLst>
-          </p:cNvPr>
-          <p:cNvSpPr>
-            <a:spLocks xmlns:a="http://schemas.openxmlformats.org/drawingml/2006/main" noGrp="1"/>
-          </p:cNvSpPr>
-          <p:nvPr/>
-        </p:nvSpPr>
-        <p:spPr>
-          <a:xfrm xmlns:a="http://schemas.openxmlformats.org/drawingml/2006/main">
-            <a:off x="638175" y="6143625"/>
-            <a:ext cx="10477500" cy="409575"/>
-          </a:xfrm>
-          <a:prstGeom xmlns:a="http://schemas.openxmlformats.org/drawingml/2006/main" prst="rect">
-            <a:avLst/>
-          </a:prstGeom>
-          <a:noFill xmlns:a="http://schemas.openxmlformats.org/drawingml/2006/main"/>
-          <a:ln xmlns:a="http://schemas.openxmlformats.org/drawingml/2006/main" w="0">
-            <a:noFill/>
-          </a:ln>
-        </p:spPr>
-        <p:txBody>
-          <a:bodyPr xmlns:a="http://schemas.openxmlformats.org/drawingml/2006/main">
-            <a:noAutofit/>
-          </a:bodyPr>
-          <a:lstStyle xmlns:a="http://schemas.openxmlformats.org/drawingml/2006/main"/>
-          <a:p xmlns:a="http://schemas.openxmlformats.org/drawingml/2006/main">
-            <a:pPr>
-              <a:defRPr sz="1425" b="0">
-                <a:solidFill>
-                  <a:srgbClr val="666962"/>
-                </a:solidFill>
-                <a:latin typeface="Manrope"/>
-                <a:ea typeface="Manrope"/>
-                <a:cs typeface="Manrope"/>
-              </a:defRPr>
-            </a:pPr>
-            <a:r>
-              <a:rPr sz="1425" b="0">
-                <a:solidFill>
-                  <a:srgbClr val="666962"/>
-                </a:solidFill>
-                <a:latin typeface="Manrope"/>
-                <a:ea typeface="Manrope"/>
-                <a:cs typeface="Manrope"/>
-              </a:rPr>
-              <a:t>Independent replay keeps its own scenario clock. Approval remains an explicit command.</a:t>
+              <a:t>Independent replay clock · Approval remains an explicit command.</a:t>
             </a:r>
           </a:p>
         </p:txBody>
@@ -9598,7 +9799,7 @@
     </p:spTree>
     <p:extLst>
       <p:ext uri="{BB962C8B-B14F-4D97-AF65-F5344CB8AC3E}">
-        <p14:creationId xmlns:p14="http://schemas.microsoft.com/office/powerpoint/2010/main" val="800071311"/>
+        <p14:creationId xmlns:p14="http://schemas.microsoft.com/office/powerpoint/2010/main" val="1502727757"/>
       </p:ext>
     </p:extLst>
   </p:cSld>

</xml_diff>

<commit_message>
feat: refine recovery presentation and record review gaps
</commit_message>
<xml_diff>
--- a/apps/web/public/demo/roadstar-pitch.pptx
+++ b/apps/web/public/demo/roadstar-pitch.pptx
@@ -2,25 +2,25 @@
 <file path=ppt/presentation.xml><?xml version="1.0" encoding="utf-8"?>
 <p:presentation xmlns:p="http://schemas.openxmlformats.org/presentationml/2006/main">
   <p:sldMasterIdLst>
-    <p:sldMasterId xmlns:r="http://schemas.openxmlformats.org/officeDocument/2006/relationships" id="2147483648" r:id="R90ecf1d36a1d4f46"/>
+    <p:sldMasterId xmlns:r="http://schemas.openxmlformats.org/officeDocument/2006/relationships" id="2147483648" r:id="R702f1ed6a72e44b3"/>
   </p:sldMasterIdLst>
   <p:notesMasterIdLst>
-    <p:notesMasterId xmlns:r="http://schemas.openxmlformats.org/officeDocument/2006/relationships" r:id="R2f4376c42a6d4248"/>
+    <p:notesMasterId xmlns:r="http://schemas.openxmlformats.org/officeDocument/2006/relationships" r:id="Rc7482c2920254ddf"/>
   </p:notesMasterIdLst>
   <p:sldIdLst>
-    <p:sldId xmlns:r="http://schemas.openxmlformats.org/officeDocument/2006/relationships" id="256" r:id="R1e766043f1d54a34"/>
-    <p:sldId xmlns:r="http://schemas.openxmlformats.org/officeDocument/2006/relationships" id="257" r:id="Rc97f4d94be834adb"/>
-    <p:sldId xmlns:r="http://schemas.openxmlformats.org/officeDocument/2006/relationships" id="258" r:id="R479f24bc35c742f2"/>
-    <p:sldId xmlns:r="http://schemas.openxmlformats.org/officeDocument/2006/relationships" id="259" r:id="R64c927bcc5b643ed"/>
-    <p:sldId xmlns:r="http://schemas.openxmlformats.org/officeDocument/2006/relationships" id="260" r:id="R6c2e617993574eca"/>
-    <p:sldId xmlns:r="http://schemas.openxmlformats.org/officeDocument/2006/relationships" id="261" r:id="Rb336c101aff746ce"/>
-    <p:sldId xmlns:r="http://schemas.openxmlformats.org/officeDocument/2006/relationships" id="262" r:id="R8788ab124aec474c"/>
-    <p:sldId xmlns:r="http://schemas.openxmlformats.org/officeDocument/2006/relationships" id="263" r:id="R7cfe72bdc54b474f"/>
-    <p:sldId xmlns:r="http://schemas.openxmlformats.org/officeDocument/2006/relationships" id="264" r:id="Re114ce9dc9d24bd1"/>
-    <p:sldId xmlns:r="http://schemas.openxmlformats.org/officeDocument/2006/relationships" id="265" r:id="R9973bf2d54e24d29"/>
-    <p:sldId xmlns:r="http://schemas.openxmlformats.org/officeDocument/2006/relationships" id="266" r:id="Rcd2f8719bca341a0"/>
-    <p:sldId xmlns:r="http://schemas.openxmlformats.org/officeDocument/2006/relationships" id="267" r:id="R10086aa5c4204556"/>
-    <p:sldId xmlns:r="http://schemas.openxmlformats.org/officeDocument/2006/relationships" id="268" r:id="Rbd327a9df0644536"/>
+    <p:sldId xmlns:r="http://schemas.openxmlformats.org/officeDocument/2006/relationships" id="256" r:id="R3b5ed648c22d45ea"/>
+    <p:sldId xmlns:r="http://schemas.openxmlformats.org/officeDocument/2006/relationships" id="257" r:id="R746fc19ff7bb46cd"/>
+    <p:sldId xmlns:r="http://schemas.openxmlformats.org/officeDocument/2006/relationships" id="258" r:id="Rb2a5f2700eaf4283"/>
+    <p:sldId xmlns:r="http://schemas.openxmlformats.org/officeDocument/2006/relationships" id="259" r:id="R1c16a22f5ad84759"/>
+    <p:sldId xmlns:r="http://schemas.openxmlformats.org/officeDocument/2006/relationships" id="260" r:id="R93316e75399748e2"/>
+    <p:sldId xmlns:r="http://schemas.openxmlformats.org/officeDocument/2006/relationships" id="261" r:id="R565791d54bbd4c8b"/>
+    <p:sldId xmlns:r="http://schemas.openxmlformats.org/officeDocument/2006/relationships" id="262" r:id="Rcff440f29abb46df"/>
+    <p:sldId xmlns:r="http://schemas.openxmlformats.org/officeDocument/2006/relationships" id="263" r:id="R5d808362d649444e"/>
+    <p:sldId xmlns:r="http://schemas.openxmlformats.org/officeDocument/2006/relationships" id="264" r:id="R2610e90ea11c40c8"/>
+    <p:sldId xmlns:r="http://schemas.openxmlformats.org/officeDocument/2006/relationships" id="265" r:id="Rded900b42ad94c79"/>
+    <p:sldId xmlns:r="http://schemas.openxmlformats.org/officeDocument/2006/relationships" id="266" r:id="R6344624bddcf4e17"/>
+    <p:sldId xmlns:r="http://schemas.openxmlformats.org/officeDocument/2006/relationships" id="267" r:id="Rc7644c7e829a47fc"/>
+    <p:sldId xmlns:r="http://schemas.openxmlformats.org/officeDocument/2006/relationships" id="268" r:id="R1f43b7ef0a6647de"/>
   </p:sldIdLst>
   <p:sldSz cx="12192000" cy="6858000"/>
   <p:notesSz cx="6858000" cy="9144000"/>
@@ -934,7 +934,7 @@
           <a:lstStyle xmlns:a="http://schemas.openxmlformats.org/drawingml/2006/main"/>
           <a:p xmlns:a="http://schemas.openxmlformats.org/drawingml/2006/main">
             <a:r>
-              <a:t>80 seconds. Switch to live cloud film-demo or downloaded recording. Record expected departure and inspect the affected next load. Sources: actual RoadStar cloud browser capture, docs/evidence/cloud-auth-smoke.json. Visual: September 10 design-film cloud recording, 01-dock-delay-end.png, exact disruption strip. 12:00 planned departure, 13:30 expected departure, 12:15 next pickup, ET. Final frozen web source: capture-final/delay-impact.png, expanded real delay record in design-final synthetic carrier, September 10 2026. Final v9 source: /tmp/roadstar-polish/final-capture/delay-impact.png, deployment 00017-bj6, design-polish-final carrier. Actual recorded delay; same 12:00 / 13:30 / 12:15 ET scenario.</a:t>
+              <a:t>80 seconds. Switch to live cloud film-demo or downloaded recording. Record expected departure and inspect the affected next load. Sources: actual RoadStar cloud browser capture, docs/evidence/cloud-auth-smoke.json. Visual: September 10 design-film cloud recording, 01-dock-delay-end.png, exact disruption strip. 12:00 planned departure, 13:30 expected departure, 12:15 next pickup, ET. Final frozen web source: capture-final/delay-impact.png, expanded real delay record in design-final synthetic carrier, September 10 2026. Final v9 source: /tmp/roadstar-polish/final-capture/delay-impact.png, deployment 00017-bj6, design-polish-final carrier. Actual recorded delay; same 12:00 / 13:30 / 12:15 ET scenario. Third-pass image: actual expanded delay-impact capture from frozen cloud 00020-8l2, cropped to the delay evidence strip; synthetic rehearsal.</a:t>
             </a:r>
           </a:p>
           <a:p xmlns:a="http://schemas.openxmlformats.org/drawingml/2006/main">
@@ -1014,7 +1014,7 @@
           <a:lstStyle xmlns:a="http://schemas.openxmlformats.org/drawingml/2006/main"/>
           <a:p xmlns:a="http://schemas.openxmlformats.org/drawingml/2006/main">
             <a:r>
-              <a:t>65 seconds. Show current assignment and proposed D02/T102/V102. Approval rechecks versions and availability, then commits reservations and driver offer atomically. Source: tests/postgres.test.ts and actual cloud recovery verification. Visual: exact modal frame at 16 seconds from the new design-film 02-recovery-approval recording. Actual proposal and approval API responses succeeded. Final frozen web source: capture-final/approval-review.png, exact displayed consequential approval dialog in design-final carrier. The capture precedes the explicit confirmation. Final v9 capture: /tmp/roadstar-polish/capture/approval-review.png. Current and proposed drivers and equipment are shown before confirmation. Driver acceptance is separate. Checks and assumptions remain available in the disclosure. Final v9 source supersedes previous frame: /tmp/roadstar-polish/final-capture/approval-review.png, deployment 00017-bj6. Same explicit current-to-proposed dialog before confirmation.</a:t>
+              <a:t>65 seconds. Show current assignment and proposed D02/T102/V102. Approval rechecks versions and availability, then commits reservations and driver offer atomically. Source: tests/postgres.test.ts and actual cloud recovery verification. Visual: exact modal frame at 16 seconds from the new design-film 02-recovery-approval recording. Actual proposal and approval API responses succeeded. Final frozen web source: capture-final/approval-review.png, exact displayed consequential approval dialog in design-final carrier. The capture precedes the explicit confirmation. Final v9 capture: /tmp/roadstar-polish/capture/approval-review.png. Current and proposed drivers and equipment are shown before confirmation. Driver acceptance is separate. Checks and assumptions remain available in the disclosure. Final v9 source supersedes previous frame: /tmp/roadstar-polish/final-capture/approval-review.png, deployment 00017-bj6. Same explicit current-to-proposed dialog before confirmation. Third-pass image: actual approval-review capture from frozen cloud 00020-8l2, cropped to the dialog. Driver acceptance remains a separate command.</a:t>
             </a:r>
           </a:p>
           <a:p xmlns:a="http://schemas.openxmlformats.org/drawingml/2006/main">
@@ -1414,7 +1414,7 @@
           <a:lstStyle xmlns:a="http://schemas.openxmlformats.org/drawingml/2006/main"/>
           <a:p xmlns:a="http://schemas.openxmlformats.org/drawingml/2006/main">
             <a:r>
-              <a:t>50 seconds. Cloud Run Fastify owns state changes. Dedicated PG16/PostGIS owns truth; ORTools/Valhalla compute; Vertex extracts; independent simulator posts synthetic events. API accepts no AI approval. See infra/gcp/README.md and services/api/src/store.ts.</a:t>
+              <a:t>50 seconds. Cloud Run Fastify owns state changes. Dedicated PG16/PostGIS owns truth; ORTools/Valhalla compute; Vertex extracts; independent simulator posts synthetic events. API accepts no AI approval. See infra/gcp/README.md and services/api/src/store.ts. Third-pass architecture clarifies that OR-Tools/Valhalla proposals and Gemini document extraction are supporting capabilities used by the API. The lower section expresses those capabilities without depicting a new transaction flow.</a:t>
             </a:r>
           </a:p>
           <a:p xmlns:a="http://schemas.openxmlformats.org/drawingml/2006/main">
@@ -1492,7 +1492,7 @@
   </p:cSld>
   <p:clrMap bg1="lt1" tx1="dk1" bg2="lt2" tx2="dk2" accent1="accent1" accent2="accent2" accent3="accent3" accent4="accent4" accent5="accent5" accent6="accent6" hlink="hlink" folHlink="folHlink"/>
   <p:sldLayoutIdLst>
-    <p:sldLayoutId xmlns:r="http://schemas.openxmlformats.org/officeDocument/2006/relationships" id="2147483649" r:id="R08382bcaccff487c"/>
+    <p:sldLayoutId xmlns:r="http://schemas.openxmlformats.org/officeDocument/2006/relationships" id="2147483649" r:id="R2a1b26e2931f4a2a"/>
   </p:sldLayoutIdLst>
   <p:txStyles>
     <p:titleStyle>
@@ -2043,7 +2043,7 @@
           <p:cNvPr id="8" name="">
             <a:extLst xmlns:a="http://schemas.openxmlformats.org/drawingml/2006/main">
               <a:ext uri="{FF2B5EF4-FFF2-40B4-BE49-F238E27FC236}">
-                <a16:creationId xmlns:a16="http://schemas.microsoft.com/office/drawing/2014/main" id="{C3ABF97B-8E14-4BE5-9431-DF00D506885C}"/>
+                <a16:creationId xmlns:a16="http://schemas.microsoft.com/office/drawing/2014/main" id="{9A023536-F73A-4B7C-93BD-781348C94BD6}"/>
               </a:ext>
             </a:extLst>
           </p:cNvPr>
@@ -2104,7 +2104,7 @@
           <p:nvPr/>
         </p:nvPicPr>
         <p:blipFill>
-          <a:blip xmlns:r="http://schemas.openxmlformats.org/officeDocument/2006/relationships" xmlns:a="http://schemas.openxmlformats.org/drawingml/2006/main" r:embed="R4a1d33ccf4ae4313"/>
+          <a:blip xmlns:r="http://schemas.openxmlformats.org/officeDocument/2006/relationships" xmlns:a="http://schemas.openxmlformats.org/drawingml/2006/main" r:embed="R34290a2ec56f4f7a"/>
           <a:srcRect xmlns:a="http://schemas.openxmlformats.org/drawingml/2006/main" l="0" t="27" r="0" b="27"/>
           <a:stretch xmlns:a="http://schemas.openxmlformats.org/drawingml/2006/main">
             <a:fillRect l="0" t="0" r="0" b="0"/>
@@ -2129,10 +2129,10 @@
           <p:nvPr/>
         </p:nvPicPr>
         <p:blipFill>
-          <a:blip xmlns:r="http://schemas.openxmlformats.org/officeDocument/2006/relationships" xmlns:a="http://schemas.openxmlformats.org/drawingml/2006/main" r:embed="Rd4eab1898fc84c72">
+          <a:blip xmlns:r="http://schemas.openxmlformats.org/officeDocument/2006/relationships" xmlns:a="http://schemas.openxmlformats.org/drawingml/2006/main" r:embed="R6bb310e4a35b4702">
             <a:extLst>
               <a:ext uri="{96DAC541-7B7A-43D3-8B79-37D633B846F1}">
-                <asvg:svgBlip xmlns:asvg="http://schemas.microsoft.com/office/drawing/2016/SVG/main" r:embed="R010120eeaad54d85"/>
+                <asvg:svgBlip xmlns:asvg="http://schemas.microsoft.com/office/drawing/2016/SVG/main" r:embed="Rc9144068576f4462"/>
               </a:ext>
             </a:extLst>
           </a:blip>
@@ -2153,7 +2153,7 @@
           <p:cNvPr id="4" name="">
             <a:extLst xmlns:a="http://schemas.openxmlformats.org/drawingml/2006/main">
               <a:ext uri="{FF2B5EF4-FFF2-40B4-BE49-F238E27FC236}">
-                <a16:creationId xmlns:a16="http://schemas.microsoft.com/office/drawing/2014/main" id="{76AB2219-6D78-4F45-9FA9-B0C106F8779D}"/>
+                <a16:creationId xmlns:a16="http://schemas.microsoft.com/office/drawing/2014/main" id="{F1B04BE6-D931-4B97-9E5D-AF93FD9A2CF9}"/>
               </a:ext>
             </a:extLst>
           </p:cNvPr>
@@ -2210,7 +2210,7 @@
           <p:cNvPr id="5" name="">
             <a:extLst xmlns:a="http://schemas.openxmlformats.org/drawingml/2006/main">
               <a:ext uri="{FF2B5EF4-FFF2-40B4-BE49-F238E27FC236}">
-                <a16:creationId xmlns:a16="http://schemas.microsoft.com/office/drawing/2014/main" id="{65F9E3ED-5BFD-4EF6-9892-87303D57F00C}"/>
+                <a16:creationId xmlns:a16="http://schemas.microsoft.com/office/drawing/2014/main" id="{2E7D51E9-9BFB-4FE1-856B-5D74F3668F50}"/>
               </a:ext>
             </a:extLst>
           </p:cNvPr>
@@ -2267,7 +2267,7 @@
           <p:cNvPr id="6" name="">
             <a:extLst xmlns:a="http://schemas.openxmlformats.org/drawingml/2006/main">
               <a:ext uri="{FF2B5EF4-FFF2-40B4-BE49-F238E27FC236}">
-                <a16:creationId xmlns:a16="http://schemas.microsoft.com/office/drawing/2014/main" id="{D3C3A533-4D86-4D03-AA96-C907B8C2B051}"/>
+                <a16:creationId xmlns:a16="http://schemas.microsoft.com/office/drawing/2014/main" id="{87F2D0C0-C759-4C87-B7C7-25EC9954D76D}"/>
               </a:ext>
             </a:extLst>
           </p:cNvPr>
@@ -2324,7 +2324,7 @@
           <p:cNvPr id="7" name="">
             <a:extLst xmlns:a="http://schemas.openxmlformats.org/drawingml/2006/main">
               <a:ext uri="{FF2B5EF4-FFF2-40B4-BE49-F238E27FC236}">
-                <a16:creationId xmlns:a16="http://schemas.microsoft.com/office/drawing/2014/main" id="{63A06127-03DF-4C49-A829-B6E8176FDD2E}"/>
+                <a16:creationId xmlns:a16="http://schemas.microsoft.com/office/drawing/2014/main" id="{C26C515F-1F03-46E1-A049-F3C73A7EB6B2}"/>
               </a:ext>
             </a:extLst>
           </p:cNvPr>
@@ -2379,7 +2379,7 @@
     </p:spTree>
     <p:extLst>
       <p:ext uri="{BB962C8B-B14F-4D97-AF65-F5344CB8AC3E}">
-        <p14:creationId xmlns:p14="http://schemas.microsoft.com/office/powerpoint/2010/main" val="1391469382"/>
+        <p14:creationId xmlns:p14="http://schemas.microsoft.com/office/powerpoint/2010/main" val="1521265188"/>
       </p:ext>
     </p:extLst>
   </p:cSld>
@@ -2410,7 +2410,7 @@
           <p:cNvPr id="9" name="">
             <a:extLst xmlns:a="http://schemas.openxmlformats.org/drawingml/2006/main">
               <a:ext uri="{FF2B5EF4-FFF2-40B4-BE49-F238E27FC236}">
-                <a16:creationId xmlns:a16="http://schemas.microsoft.com/office/drawing/2014/main" id="{88F42D03-F424-4AF8-8408-12FDB74EE866}"/>
+                <a16:creationId xmlns:a16="http://schemas.microsoft.com/office/drawing/2014/main" id="{32300A80-82E3-4E8A-8679-79452E864CA1}"/>
               </a:ext>
             </a:extLst>
           </p:cNvPr>
@@ -2467,7 +2467,7 @@
           <p:cNvPr id="2" name="">
             <a:extLst xmlns:a="http://schemas.openxmlformats.org/drawingml/2006/main">
               <a:ext uri="{FF2B5EF4-FFF2-40B4-BE49-F238E27FC236}">
-                <a16:creationId xmlns:a16="http://schemas.microsoft.com/office/drawing/2014/main" id="{2F96C6AC-0058-47EA-899D-C968C71FCA30}"/>
+                <a16:creationId xmlns:a16="http://schemas.microsoft.com/office/drawing/2014/main" id="{8579F888-3A46-4C37-A2FF-A870AD65D88E}"/>
               </a:ext>
             </a:extLst>
           </p:cNvPr>
@@ -2524,7 +2524,7 @@
           <p:cNvPr id="3" name="">
             <a:extLst xmlns:a="http://schemas.openxmlformats.org/drawingml/2006/main">
               <a:ext uri="{FF2B5EF4-FFF2-40B4-BE49-F238E27FC236}">
-                <a16:creationId xmlns:a16="http://schemas.microsoft.com/office/drawing/2014/main" id="{C9365952-645D-4651-9109-09BF7288B03D}"/>
+                <a16:creationId xmlns:a16="http://schemas.microsoft.com/office/drawing/2014/main" id="{CA8ECAC8-39CF-443F-A624-B85D0A550265}"/>
               </a:ext>
             </a:extLst>
           </p:cNvPr>
@@ -2581,7 +2581,7 @@
           <p:cNvPr id="4" name="">
             <a:extLst xmlns:a="http://schemas.openxmlformats.org/drawingml/2006/main">
               <a:ext uri="{FF2B5EF4-FFF2-40B4-BE49-F238E27FC236}">
-                <a16:creationId xmlns:a16="http://schemas.microsoft.com/office/drawing/2014/main" id="{0C5FDD06-9E1C-4212-8270-B78E12CACCC4}"/>
+                <a16:creationId xmlns:a16="http://schemas.microsoft.com/office/drawing/2014/main" id="{EBBFCFA8-7CA9-4961-9891-6B168B668868}"/>
               </a:ext>
             </a:extLst>
           </p:cNvPr>
@@ -2661,7 +2661,7 @@
           <p:cNvPr id="5" name="">
             <a:extLst xmlns:a="http://schemas.openxmlformats.org/drawingml/2006/main">
               <a:ext uri="{FF2B5EF4-FFF2-40B4-BE49-F238E27FC236}">
-                <a16:creationId xmlns:a16="http://schemas.microsoft.com/office/drawing/2014/main" id="{6CE0193B-C4D8-43C4-9DC3-85D8C027E288}"/>
+                <a16:creationId xmlns:a16="http://schemas.microsoft.com/office/drawing/2014/main" id="{C6FD6CFE-026E-44D8-8B60-7EE59D215F4D}"/>
               </a:ext>
             </a:extLst>
           </p:cNvPr>
@@ -2718,7 +2718,7 @@
           <p:cNvPr id="6" name="">
             <a:extLst xmlns:a="http://schemas.openxmlformats.org/drawingml/2006/main">
               <a:ext uri="{FF2B5EF4-FFF2-40B4-BE49-F238E27FC236}">
-                <a16:creationId xmlns:a16="http://schemas.microsoft.com/office/drawing/2014/main" id="{CD03C185-7849-47B6-BEFC-C284798D99F2}"/>
+                <a16:creationId xmlns:a16="http://schemas.microsoft.com/office/drawing/2014/main" id="{3CBEA7E5-801C-494A-8F5C-8538792CB532}"/>
               </a:ext>
             </a:extLst>
           </p:cNvPr>
@@ -2798,7 +2798,7 @@
           <p:cNvPr id="7" name="">
             <a:extLst xmlns:a="http://schemas.openxmlformats.org/drawingml/2006/main">
               <a:ext uri="{FF2B5EF4-FFF2-40B4-BE49-F238E27FC236}">
-                <a16:creationId xmlns:a16="http://schemas.microsoft.com/office/drawing/2014/main" id="{E2C45FF2-B137-4862-BF84-B52D2409B801}"/>
+                <a16:creationId xmlns:a16="http://schemas.microsoft.com/office/drawing/2014/main" id="{3F6111C9-6968-4D90-82F3-81769C441BC9}"/>
               </a:ext>
             </a:extLst>
           </p:cNvPr>
@@ -2901,7 +2901,7 @@
           <p:cNvPr id="8" name="">
             <a:extLst xmlns:a="http://schemas.openxmlformats.org/drawingml/2006/main">
               <a:ext uri="{FF2B5EF4-FFF2-40B4-BE49-F238E27FC236}">
-                <a16:creationId xmlns:a16="http://schemas.microsoft.com/office/drawing/2014/main" id="{41CF3AE4-9A03-4794-98C4-C18D5089A70B}"/>
+                <a16:creationId xmlns:a16="http://schemas.microsoft.com/office/drawing/2014/main" id="{FC28723A-440C-461D-BDC4-C64168D456F3}"/>
               </a:ext>
             </a:extLst>
           </p:cNvPr>
@@ -2979,7 +2979,7 @@
     </p:spTree>
     <p:extLst>
       <p:ext uri="{BB962C8B-B14F-4D97-AF65-F5344CB8AC3E}">
-        <p14:creationId xmlns:p14="http://schemas.microsoft.com/office/powerpoint/2010/main" val="1898114888"/>
+        <p14:creationId xmlns:p14="http://schemas.microsoft.com/office/powerpoint/2010/main" val="312122875"/>
       </p:ext>
     </p:extLst>
   </p:cSld>
@@ -3010,7 +3010,7 @@
           <p:cNvPr id="6" name="">
             <a:extLst xmlns:a="http://schemas.openxmlformats.org/drawingml/2006/main">
               <a:ext uri="{FF2B5EF4-FFF2-40B4-BE49-F238E27FC236}">
-                <a16:creationId xmlns:a16="http://schemas.microsoft.com/office/drawing/2014/main" id="{63AE70DC-F184-4CD5-8C58-E16757A70732}"/>
+                <a16:creationId xmlns:a16="http://schemas.microsoft.com/office/drawing/2014/main" id="{3CCEC802-CB3C-44A6-916D-276767B46F2E}"/>
               </a:ext>
             </a:extLst>
           </p:cNvPr>
@@ -3071,7 +3071,7 @@
           <p:nvPr/>
         </p:nvPicPr>
         <p:blipFill>
-          <a:blip xmlns:r="http://schemas.openxmlformats.org/officeDocument/2006/relationships" xmlns:a="http://schemas.openxmlformats.org/drawingml/2006/main" r:embed="R2d06679150f247ac"/>
+          <a:blip xmlns:r="http://schemas.openxmlformats.org/officeDocument/2006/relationships" xmlns:a="http://schemas.openxmlformats.org/drawingml/2006/main" r:embed="R8cfa346cc0744942"/>
           <a:srcRect xmlns:a="http://schemas.openxmlformats.org/drawingml/2006/main" l="0" t="27" r="0" b="27"/>
           <a:stretch xmlns:a="http://schemas.openxmlformats.org/drawingml/2006/main">
             <a:fillRect l="0" t="0" r="0" b="0"/>
@@ -3092,7 +3092,7 @@
           <p:cNvPr id="3" name="">
             <a:extLst xmlns:a="http://schemas.openxmlformats.org/drawingml/2006/main">
               <a:ext uri="{FF2B5EF4-FFF2-40B4-BE49-F238E27FC236}">
-                <a16:creationId xmlns:a16="http://schemas.microsoft.com/office/drawing/2014/main" id="{58EDE611-F8D4-4FE5-9123-A1CEC2CAF57C}"/>
+                <a16:creationId xmlns:a16="http://schemas.microsoft.com/office/drawing/2014/main" id="{E0001B5A-BCBF-4426-899C-8C926AAECEB7}"/>
               </a:ext>
             </a:extLst>
           </p:cNvPr>
@@ -3172,7 +3172,7 @@
           <p:cNvPr id="4" name="">
             <a:extLst xmlns:a="http://schemas.openxmlformats.org/drawingml/2006/main">
               <a:ext uri="{FF2B5EF4-FFF2-40B4-BE49-F238E27FC236}">
-                <a16:creationId xmlns:a16="http://schemas.microsoft.com/office/drawing/2014/main" id="{1582DF1C-E3B1-4257-9E58-3889E49C43D3}"/>
+                <a16:creationId xmlns:a16="http://schemas.microsoft.com/office/drawing/2014/main" id="{27D53EEA-C0B6-47E0-8645-2B6E4C5BF974}"/>
               </a:ext>
             </a:extLst>
           </p:cNvPr>
@@ -3275,7 +3275,7 @@
           <p:cNvPr id="5" name="">
             <a:extLst xmlns:a="http://schemas.openxmlformats.org/drawingml/2006/main">
               <a:ext uri="{FF2B5EF4-FFF2-40B4-BE49-F238E27FC236}">
-                <a16:creationId xmlns:a16="http://schemas.microsoft.com/office/drawing/2014/main" id="{8634058C-2FFB-4914-A23B-C94F6D3D7A5C}"/>
+                <a16:creationId xmlns:a16="http://schemas.microsoft.com/office/drawing/2014/main" id="{C6857729-5B77-43BB-80D2-ED163B856C75}"/>
               </a:ext>
             </a:extLst>
           </p:cNvPr>
@@ -3330,7 +3330,7 @@
     </p:spTree>
     <p:extLst>
       <p:ext uri="{BB962C8B-B14F-4D97-AF65-F5344CB8AC3E}">
-        <p14:creationId xmlns:p14="http://schemas.microsoft.com/office/powerpoint/2010/main" val="862955831"/>
+        <p14:creationId xmlns:p14="http://schemas.microsoft.com/office/powerpoint/2010/main" val="1215483848"/>
       </p:ext>
     </p:extLst>
   </p:cSld>
@@ -3361,7 +3361,7 @@
           <p:cNvPr id="13" name="">
             <a:extLst xmlns:a="http://schemas.openxmlformats.org/drawingml/2006/main">
               <a:ext uri="{FF2B5EF4-FFF2-40B4-BE49-F238E27FC236}">
-                <a16:creationId xmlns:a16="http://schemas.microsoft.com/office/drawing/2014/main" id="{BD397FB7-EDB2-4820-99A0-FBEBA89B377F}"/>
+                <a16:creationId xmlns:a16="http://schemas.microsoft.com/office/drawing/2014/main" id="{204D8AE8-0905-4A2D-ACFB-41BDA2F7FBF2}"/>
               </a:ext>
             </a:extLst>
           </p:cNvPr>
@@ -3418,7 +3418,7 @@
           <p:cNvPr id="2" name="">
             <a:extLst xmlns:a="http://schemas.openxmlformats.org/drawingml/2006/main">
               <a:ext uri="{FF2B5EF4-FFF2-40B4-BE49-F238E27FC236}">
-                <a16:creationId xmlns:a16="http://schemas.microsoft.com/office/drawing/2014/main" id="{9F124385-2A9D-4FC3-A2D4-3C299138D764}"/>
+                <a16:creationId xmlns:a16="http://schemas.microsoft.com/office/drawing/2014/main" id="{C4992F9E-8C6F-442C-8E8D-DFD5EF10DD3A}"/>
               </a:ext>
             </a:extLst>
           </p:cNvPr>
@@ -3475,7 +3475,7 @@
           <p:cNvPr id="3" name="">
             <a:extLst xmlns:a="http://schemas.openxmlformats.org/drawingml/2006/main">
               <a:ext uri="{FF2B5EF4-FFF2-40B4-BE49-F238E27FC236}">
-                <a16:creationId xmlns:a16="http://schemas.microsoft.com/office/drawing/2014/main" id="{2EAAA66E-25B0-4C6A-8168-316AB3405BB9}"/>
+                <a16:creationId xmlns:a16="http://schemas.microsoft.com/office/drawing/2014/main" id="{7F7E4B0F-614A-4DB9-883D-F9448CC5BA76}"/>
               </a:ext>
             </a:extLst>
           </p:cNvPr>
@@ -3532,7 +3532,7 @@
           <p:cNvPr id="4" name="">
             <a:extLst xmlns:a="http://schemas.openxmlformats.org/drawingml/2006/main">
               <a:ext uri="{FF2B5EF4-FFF2-40B4-BE49-F238E27FC236}">
-                <a16:creationId xmlns:a16="http://schemas.microsoft.com/office/drawing/2014/main" id="{6F4F7ADC-2401-42B7-A090-B6F5EED91088}"/>
+                <a16:creationId xmlns:a16="http://schemas.microsoft.com/office/drawing/2014/main" id="{D66B1AE4-A634-40F3-9170-B859DE568CAD}"/>
               </a:ext>
             </a:extLst>
           </p:cNvPr>
@@ -3589,7 +3589,7 @@
           <p:cNvPr id="5" name="">
             <a:extLst xmlns:a="http://schemas.openxmlformats.org/drawingml/2006/main">
               <a:ext uri="{FF2B5EF4-FFF2-40B4-BE49-F238E27FC236}">
-                <a16:creationId xmlns:a16="http://schemas.microsoft.com/office/drawing/2014/main" id="{9DA799FD-2AF4-4B1D-A8F2-D29F4CBBDF4E}"/>
+                <a16:creationId xmlns:a16="http://schemas.microsoft.com/office/drawing/2014/main" id="{CA843BFA-AB40-4959-8F41-3306837DB91A}"/>
               </a:ext>
             </a:extLst>
           </p:cNvPr>
@@ -3646,7 +3646,7 @@
           <p:cNvPr id="6" name="">
             <a:extLst xmlns:a="http://schemas.openxmlformats.org/drawingml/2006/main">
               <a:ext uri="{FF2B5EF4-FFF2-40B4-BE49-F238E27FC236}">
-                <a16:creationId xmlns:a16="http://schemas.microsoft.com/office/drawing/2014/main" id="{D56FB0FB-A3A3-4287-846B-77190F22BA86}"/>
+                <a16:creationId xmlns:a16="http://schemas.microsoft.com/office/drawing/2014/main" id="{8F501B34-34D1-4E66-927D-45261169C20A}"/>
               </a:ext>
             </a:extLst>
           </p:cNvPr>
@@ -3753,7 +3753,7 @@
           <p:cNvPr id="9" name="">
             <a:extLst xmlns:a="http://schemas.openxmlformats.org/drawingml/2006/main">
               <a:ext uri="{FF2B5EF4-FFF2-40B4-BE49-F238E27FC236}">
-                <a16:creationId xmlns:a16="http://schemas.microsoft.com/office/drawing/2014/main" id="{98E1F8C2-8357-4F42-9DEF-34830270E436}"/>
+                <a16:creationId xmlns:a16="http://schemas.microsoft.com/office/drawing/2014/main" id="{C9EF697B-A841-49E3-A60F-F3F7A3224FB9}"/>
               </a:ext>
             </a:extLst>
           </p:cNvPr>
@@ -3833,7 +3833,7 @@
           <p:cNvPr id="10" name="">
             <a:extLst xmlns:a="http://schemas.openxmlformats.org/drawingml/2006/main">
               <a:ext uri="{FF2B5EF4-FFF2-40B4-BE49-F238E27FC236}">
-                <a16:creationId xmlns:a16="http://schemas.microsoft.com/office/drawing/2014/main" id="{EB74A9F1-52BD-4344-B098-F700C05BBC1D}"/>
+                <a16:creationId xmlns:a16="http://schemas.microsoft.com/office/drawing/2014/main" id="{B213184A-82E9-4AF8-8766-08D700D3AC89}"/>
               </a:ext>
             </a:extLst>
           </p:cNvPr>
@@ -3913,7 +3913,7 @@
           <p:cNvPr id="11" name="">
             <a:extLst xmlns:a="http://schemas.openxmlformats.org/drawingml/2006/main">
               <a:ext uri="{FF2B5EF4-FFF2-40B4-BE49-F238E27FC236}">
-                <a16:creationId xmlns:a16="http://schemas.microsoft.com/office/drawing/2014/main" id="{9B27D420-94A6-4FC6-BD06-ED13ED3C7A4B}"/>
+                <a16:creationId xmlns:a16="http://schemas.microsoft.com/office/drawing/2014/main" id="{A6B4EF68-90C5-45A5-BBCA-FE1718F772E8}"/>
               </a:ext>
             </a:extLst>
           </p:cNvPr>
@@ -3993,7 +3993,7 @@
           <p:cNvPr id="12" name="">
             <a:extLst xmlns:a="http://schemas.openxmlformats.org/drawingml/2006/main">
               <a:ext uri="{FF2B5EF4-FFF2-40B4-BE49-F238E27FC236}">
-                <a16:creationId xmlns:a16="http://schemas.microsoft.com/office/drawing/2014/main" id="{60E2FB1D-5B26-42E3-B597-F5A5CA0FC0CA}"/>
+                <a16:creationId xmlns:a16="http://schemas.microsoft.com/office/drawing/2014/main" id="{A6B132ED-5808-4526-9DC3-70B85927A07B}"/>
               </a:ext>
             </a:extLst>
           </p:cNvPr>
@@ -4048,7 +4048,7 @@
     </p:spTree>
     <p:extLst>
       <p:ext uri="{BB962C8B-B14F-4D97-AF65-F5344CB8AC3E}">
-        <p14:creationId xmlns:p14="http://schemas.microsoft.com/office/powerpoint/2010/main" val="732918739"/>
+        <p14:creationId xmlns:p14="http://schemas.microsoft.com/office/powerpoint/2010/main" val="2127536711"/>
       </p:ext>
     </p:extLst>
   </p:cSld>
@@ -4079,7 +4079,7 @@
           <p:cNvPr id="8" name="">
             <a:extLst xmlns:a="http://schemas.openxmlformats.org/drawingml/2006/main">
               <a:ext uri="{FF2B5EF4-FFF2-40B4-BE49-F238E27FC236}">
-                <a16:creationId xmlns:a16="http://schemas.microsoft.com/office/drawing/2014/main" id="{C4E71D1D-15E0-4D92-A742-C88F4834FE0D}"/>
+                <a16:creationId xmlns:a16="http://schemas.microsoft.com/office/drawing/2014/main" id="{D61937FA-19D6-41E9-96EB-EEE57B4FF498}"/>
               </a:ext>
             </a:extLst>
           </p:cNvPr>
@@ -4136,7 +4136,7 @@
           <p:cNvPr id="2" name="">
             <a:extLst xmlns:a="http://schemas.openxmlformats.org/drawingml/2006/main">
               <a:ext uri="{FF2B5EF4-FFF2-40B4-BE49-F238E27FC236}">
-                <a16:creationId xmlns:a16="http://schemas.microsoft.com/office/drawing/2014/main" id="{88AF808E-966C-4F30-A11C-C082E44848D3}"/>
+                <a16:creationId xmlns:a16="http://schemas.microsoft.com/office/drawing/2014/main" id="{A9B9875D-B1A8-4A97-B22C-7B661F0B74AF}"/>
               </a:ext>
             </a:extLst>
           </p:cNvPr>
@@ -4193,7 +4193,7 @@
           <p:cNvPr id="3" name="">
             <a:extLst xmlns:a="http://schemas.openxmlformats.org/drawingml/2006/main">
               <a:ext uri="{FF2B5EF4-FFF2-40B4-BE49-F238E27FC236}">
-                <a16:creationId xmlns:a16="http://schemas.microsoft.com/office/drawing/2014/main" id="{5458842C-3E3C-4617-BCA0-41BD75079084}"/>
+                <a16:creationId xmlns:a16="http://schemas.microsoft.com/office/drawing/2014/main" id="{02FD4077-66CD-43A4-B0DA-2EF88EB4D064}"/>
               </a:ext>
             </a:extLst>
           </p:cNvPr>
@@ -4250,7 +4250,7 @@
           <p:cNvPr id="4" name="">
             <a:extLst xmlns:a="http://schemas.openxmlformats.org/drawingml/2006/main">
               <a:ext uri="{FF2B5EF4-FFF2-40B4-BE49-F238E27FC236}">
-                <a16:creationId xmlns:a16="http://schemas.microsoft.com/office/drawing/2014/main" id="{871BAC46-1C1C-4938-B47C-D1BA369116DB}"/>
+                <a16:creationId xmlns:a16="http://schemas.microsoft.com/office/drawing/2014/main" id="{EE168782-B04F-461D-851F-10E6A5C622F1}"/>
               </a:ext>
             </a:extLst>
           </p:cNvPr>
@@ -4307,7 +4307,7 @@
           <p:cNvPr id="5" name="">
             <a:extLst xmlns:a="http://schemas.openxmlformats.org/drawingml/2006/main">
               <a:ext uri="{FF2B5EF4-FFF2-40B4-BE49-F238E27FC236}">
-                <a16:creationId xmlns:a16="http://schemas.microsoft.com/office/drawing/2014/main" id="{FBCDFB2E-2589-49D7-9957-6DBA1852842D}"/>
+                <a16:creationId xmlns:a16="http://schemas.microsoft.com/office/drawing/2014/main" id="{26FF2208-EA8D-44A1-9880-B6FF60D0A47B}"/>
               </a:ext>
             </a:extLst>
           </p:cNvPr>
@@ -4410,7 +4410,7 @@
           <p:cNvPr id="6" name="">
             <a:extLst xmlns:a="http://schemas.openxmlformats.org/drawingml/2006/main">
               <a:ext uri="{FF2B5EF4-FFF2-40B4-BE49-F238E27FC236}">
-                <a16:creationId xmlns:a16="http://schemas.microsoft.com/office/drawing/2014/main" id="{B6FE3C5D-F8B7-4092-9184-1C1918659427}"/>
+                <a16:creationId xmlns:a16="http://schemas.microsoft.com/office/drawing/2014/main" id="{748BC6A2-7A22-4A24-B1D8-369B8E555FEB}"/>
               </a:ext>
             </a:extLst>
           </p:cNvPr>
@@ -4513,7 +4513,7 @@
           <p:cNvPr id="7" name="">
             <a:extLst xmlns:a="http://schemas.openxmlformats.org/drawingml/2006/main">
               <a:ext uri="{FF2B5EF4-FFF2-40B4-BE49-F238E27FC236}">
-                <a16:creationId xmlns:a16="http://schemas.microsoft.com/office/drawing/2014/main" id="{E472C7E3-0465-4169-964E-FAAB950303AF}"/>
+                <a16:creationId xmlns:a16="http://schemas.microsoft.com/office/drawing/2014/main" id="{B0452D18-851B-43D3-934A-65DDF5B24DA2}"/>
               </a:ext>
             </a:extLst>
           </p:cNvPr>
@@ -4568,7 +4568,7 @@
     </p:spTree>
     <p:extLst>
       <p:ext uri="{BB962C8B-B14F-4D97-AF65-F5344CB8AC3E}">
-        <p14:creationId xmlns:p14="http://schemas.microsoft.com/office/powerpoint/2010/main" val="1140872120"/>
+        <p14:creationId xmlns:p14="http://schemas.microsoft.com/office/powerpoint/2010/main" val="1157121252"/>
       </p:ext>
     </p:extLst>
   </p:cSld>
@@ -4599,7 +4599,7 @@
           <p:cNvPr id="10" name="">
             <a:extLst xmlns:a="http://schemas.openxmlformats.org/drawingml/2006/main">
               <a:ext uri="{FF2B5EF4-FFF2-40B4-BE49-F238E27FC236}">
-                <a16:creationId xmlns:a16="http://schemas.microsoft.com/office/drawing/2014/main" id="{9AEAEC41-0929-4FBF-934B-76E0920105CE}"/>
+                <a16:creationId xmlns:a16="http://schemas.microsoft.com/office/drawing/2014/main" id="{D6D61344-CD4D-4D90-B4FE-B749943CF198}"/>
               </a:ext>
             </a:extLst>
           </p:cNvPr>
@@ -4656,7 +4656,7 @@
           <p:cNvPr id="2" name="">
             <a:extLst xmlns:a="http://schemas.openxmlformats.org/drawingml/2006/main">
               <a:ext uri="{FF2B5EF4-FFF2-40B4-BE49-F238E27FC236}">
-                <a16:creationId xmlns:a16="http://schemas.microsoft.com/office/drawing/2014/main" id="{7651A644-B080-455C-8FB2-3C1C8753FBE7}"/>
+                <a16:creationId xmlns:a16="http://schemas.microsoft.com/office/drawing/2014/main" id="{7F51A4B5-457C-4A6D-9D84-96E8E5B04391}"/>
               </a:ext>
             </a:extLst>
           </p:cNvPr>
@@ -4759,7 +4759,7 @@
           <p:cNvPr id="3" name="">
             <a:extLst xmlns:a="http://schemas.openxmlformats.org/drawingml/2006/main">
               <a:ext uri="{FF2B5EF4-FFF2-40B4-BE49-F238E27FC236}">
-                <a16:creationId xmlns:a16="http://schemas.microsoft.com/office/drawing/2014/main" id="{D869BB7E-C1EA-499D-928F-C0B996E13CBE}"/>
+                <a16:creationId xmlns:a16="http://schemas.microsoft.com/office/drawing/2014/main" id="{D8242DBD-E0D4-40D2-9D33-716D35159C6E}"/>
               </a:ext>
             </a:extLst>
           </p:cNvPr>
@@ -4816,7 +4816,7 @@
           <p:cNvPr id="4" name="">
             <a:extLst xmlns:a="http://schemas.openxmlformats.org/drawingml/2006/main">
               <a:ext uri="{FF2B5EF4-FFF2-40B4-BE49-F238E27FC236}">
-                <a16:creationId xmlns:a16="http://schemas.microsoft.com/office/drawing/2014/main" id="{64B02357-D0B2-4FBF-93C3-B91157105B64}"/>
+                <a16:creationId xmlns:a16="http://schemas.microsoft.com/office/drawing/2014/main" id="{CE059BDE-43D0-414D-A6C7-1D1C7157A6CB}"/>
               </a:ext>
             </a:extLst>
           </p:cNvPr>
@@ -4873,7 +4873,7 @@
           <p:cNvPr id="5" name="">
             <a:extLst xmlns:a="http://schemas.openxmlformats.org/drawingml/2006/main">
               <a:ext uri="{FF2B5EF4-FFF2-40B4-BE49-F238E27FC236}">
-                <a16:creationId xmlns:a16="http://schemas.microsoft.com/office/drawing/2014/main" id="{13A908F7-5DD3-48D3-8CA2-8AA2A17A9DA8}"/>
+                <a16:creationId xmlns:a16="http://schemas.microsoft.com/office/drawing/2014/main" id="{C2D7E8D6-C947-4E9E-A36F-6B6FC6695C6A}"/>
               </a:ext>
             </a:extLst>
           </p:cNvPr>
@@ -4955,7 +4955,7 @@
           <p:cNvPr id="7" name="">
             <a:extLst xmlns:a="http://schemas.openxmlformats.org/drawingml/2006/main">
               <a:ext uri="{FF2B5EF4-FFF2-40B4-BE49-F238E27FC236}">
-                <a16:creationId xmlns:a16="http://schemas.microsoft.com/office/drawing/2014/main" id="{DE997B8B-97F6-4FB1-A08F-56D7D35F92CB}"/>
+                <a16:creationId xmlns:a16="http://schemas.microsoft.com/office/drawing/2014/main" id="{CA286ACF-CB7E-44BA-A738-C9800C3EE770}"/>
               </a:ext>
             </a:extLst>
           </p:cNvPr>
@@ -5012,7 +5012,7 @@
           <p:cNvPr id="8" name="">
             <a:extLst xmlns:a="http://schemas.openxmlformats.org/drawingml/2006/main">
               <a:ext uri="{FF2B5EF4-FFF2-40B4-BE49-F238E27FC236}">
-                <a16:creationId xmlns:a16="http://schemas.microsoft.com/office/drawing/2014/main" id="{A8788BDA-87A4-4149-B9CC-0F831F0A4724}"/>
+                <a16:creationId xmlns:a16="http://schemas.microsoft.com/office/drawing/2014/main" id="{845E0B6E-6F03-4DA7-B5D9-577A1B3123B3}"/>
               </a:ext>
             </a:extLst>
           </p:cNvPr>
@@ -5115,7 +5115,7 @@
           <p:cNvPr id="9" name="">
             <a:extLst xmlns:a="http://schemas.openxmlformats.org/drawingml/2006/main">
               <a:ext uri="{FF2B5EF4-FFF2-40B4-BE49-F238E27FC236}">
-                <a16:creationId xmlns:a16="http://schemas.microsoft.com/office/drawing/2014/main" id="{9021A3D2-D42C-4981-947A-D513786E232B}"/>
+                <a16:creationId xmlns:a16="http://schemas.microsoft.com/office/drawing/2014/main" id="{54F09C6A-A8D9-408E-AA4F-27FDE5D3EDCF}"/>
               </a:ext>
             </a:extLst>
           </p:cNvPr>
@@ -5170,7 +5170,7 @@
     </p:spTree>
     <p:extLst>
       <p:ext uri="{BB962C8B-B14F-4D97-AF65-F5344CB8AC3E}">
-        <p14:creationId xmlns:p14="http://schemas.microsoft.com/office/powerpoint/2010/main" val="147194026"/>
+        <p14:creationId xmlns:p14="http://schemas.microsoft.com/office/powerpoint/2010/main" val="505526585"/>
       </p:ext>
     </p:extLst>
   </p:cSld>
@@ -5201,7 +5201,7 @@
           <p:cNvPr id="12" name="">
             <a:extLst xmlns:a="http://schemas.openxmlformats.org/drawingml/2006/main">
               <a:ext uri="{FF2B5EF4-FFF2-40B4-BE49-F238E27FC236}">
-                <a16:creationId xmlns:a16="http://schemas.microsoft.com/office/drawing/2014/main" id="{0F93B6EC-2044-483F-A510-09D159485F80}"/>
+                <a16:creationId xmlns:a16="http://schemas.microsoft.com/office/drawing/2014/main" id="{03DCD849-BEF6-4E43-A058-818828C8113C}"/>
               </a:ext>
             </a:extLst>
           </p:cNvPr>
@@ -5258,7 +5258,7 @@
           <p:cNvPr id="2" name="">
             <a:extLst xmlns:a="http://schemas.openxmlformats.org/drawingml/2006/main">
               <a:ext uri="{FF2B5EF4-FFF2-40B4-BE49-F238E27FC236}">
-                <a16:creationId xmlns:a16="http://schemas.microsoft.com/office/drawing/2014/main" id="{2F19CCFC-F352-4A91-9285-4D2C95F3852A}"/>
+                <a16:creationId xmlns:a16="http://schemas.microsoft.com/office/drawing/2014/main" id="{4130EDF0-BB01-4E86-8577-D15A19B1BCC3}"/>
               </a:ext>
             </a:extLst>
           </p:cNvPr>
@@ -5315,7 +5315,7 @@
           <p:cNvPr id="3" name="">
             <a:extLst xmlns:a="http://schemas.openxmlformats.org/drawingml/2006/main">
               <a:ext uri="{FF2B5EF4-FFF2-40B4-BE49-F238E27FC236}">
-                <a16:creationId xmlns:a16="http://schemas.microsoft.com/office/drawing/2014/main" id="{C899FA81-E5AD-436A-A6C6-DFC43152211B}"/>
+                <a16:creationId xmlns:a16="http://schemas.microsoft.com/office/drawing/2014/main" id="{0C73F5FB-7191-4B66-8954-518301D9B2AB}"/>
               </a:ext>
             </a:extLst>
           </p:cNvPr>
@@ -5376,7 +5376,7 @@
           <p:nvPr/>
         </p:nvPicPr>
         <p:blipFill>
-          <a:blip xmlns:r="http://schemas.openxmlformats.org/officeDocument/2006/relationships" xmlns:a="http://schemas.openxmlformats.org/drawingml/2006/main" r:embed="Rd76223ac42c54725"/>
+          <a:blip xmlns:r="http://schemas.openxmlformats.org/officeDocument/2006/relationships" xmlns:a="http://schemas.openxmlformats.org/drawingml/2006/main" r:embed="R98acb477ba7448fd"/>
           <a:stretch xmlns:a="http://schemas.openxmlformats.org/drawingml/2006/main"/>
         </p:blipFill>
         <p:spPr>
@@ -5394,7 +5394,7 @@
           <p:cNvPr id="5" name="">
             <a:extLst xmlns:a="http://schemas.openxmlformats.org/drawingml/2006/main">
               <a:ext uri="{FF2B5EF4-FFF2-40B4-BE49-F238E27FC236}">
-                <a16:creationId xmlns:a16="http://schemas.microsoft.com/office/drawing/2014/main" id="{6B2A251C-CCBC-4183-9A64-E009BAF53F14}"/>
+                <a16:creationId xmlns:a16="http://schemas.microsoft.com/office/drawing/2014/main" id="{58C2F9F9-AD2F-49C8-AA29-207FA0FB58D1}"/>
               </a:ext>
             </a:extLst>
           </p:cNvPr>
@@ -5451,7 +5451,7 @@
           <p:cNvPr id="6" name="">
             <a:extLst xmlns:a="http://schemas.openxmlformats.org/drawingml/2006/main">
               <a:ext uri="{FF2B5EF4-FFF2-40B4-BE49-F238E27FC236}">
-                <a16:creationId xmlns:a16="http://schemas.microsoft.com/office/drawing/2014/main" id="{B6DC324D-86BA-4A85-BE27-CE39904C0183}"/>
+                <a16:creationId xmlns:a16="http://schemas.microsoft.com/office/drawing/2014/main" id="{4BC278E9-39F7-4906-8D93-7255B13BE9DC}"/>
               </a:ext>
             </a:extLst>
           </p:cNvPr>
@@ -5508,7 +5508,7 @@
           <p:cNvPr id="7" name="">
             <a:extLst xmlns:a="http://schemas.openxmlformats.org/drawingml/2006/main">
               <a:ext uri="{FF2B5EF4-FFF2-40B4-BE49-F238E27FC236}">
-                <a16:creationId xmlns:a16="http://schemas.microsoft.com/office/drawing/2014/main" id="{F6F944CE-9979-4AEE-85BA-B577B601F82D}"/>
+                <a16:creationId xmlns:a16="http://schemas.microsoft.com/office/drawing/2014/main" id="{BD5EDF2E-26EE-4AF7-9F80-7AFDDA1A74E6}"/>
               </a:ext>
             </a:extLst>
           </p:cNvPr>
@@ -5565,7 +5565,7 @@
           <p:cNvPr id="8" name="">
             <a:extLst xmlns:a="http://schemas.openxmlformats.org/drawingml/2006/main">
               <a:ext uri="{FF2B5EF4-FFF2-40B4-BE49-F238E27FC236}">
-                <a16:creationId xmlns:a16="http://schemas.microsoft.com/office/drawing/2014/main" id="{0FEBD3F2-5A6E-458D-ADF4-648922233CF9}"/>
+                <a16:creationId xmlns:a16="http://schemas.microsoft.com/office/drawing/2014/main" id="{01F8E2DD-68FF-4268-BD14-1885853313CC}"/>
               </a:ext>
             </a:extLst>
           </p:cNvPr>
@@ -5622,7 +5622,7 @@
           <p:cNvPr id="9" name="">
             <a:extLst xmlns:a="http://schemas.openxmlformats.org/drawingml/2006/main">
               <a:ext uri="{FF2B5EF4-FFF2-40B4-BE49-F238E27FC236}">
-                <a16:creationId xmlns:a16="http://schemas.microsoft.com/office/drawing/2014/main" id="{0AAB1F71-467B-4650-8BCB-943F9F99608F}"/>
+                <a16:creationId xmlns:a16="http://schemas.microsoft.com/office/drawing/2014/main" id="{911456E8-C70A-4C47-8B05-2392C440F125}"/>
               </a:ext>
             </a:extLst>
           </p:cNvPr>
@@ -5679,7 +5679,7 @@
           <p:cNvPr id="10" name="">
             <a:extLst xmlns:a="http://schemas.openxmlformats.org/drawingml/2006/main">
               <a:ext uri="{FF2B5EF4-FFF2-40B4-BE49-F238E27FC236}">
-                <a16:creationId xmlns:a16="http://schemas.microsoft.com/office/drawing/2014/main" id="{71C9C747-1435-444C-8062-3D33C992E422}"/>
+                <a16:creationId xmlns:a16="http://schemas.microsoft.com/office/drawing/2014/main" id="{8FDD5FD5-567B-4BAB-8133-DA26797A6C56}"/>
               </a:ext>
             </a:extLst>
           </p:cNvPr>
@@ -5736,7 +5736,7 @@
           <p:cNvPr id="11" name="">
             <a:extLst xmlns:a="http://schemas.openxmlformats.org/drawingml/2006/main">
               <a:ext uri="{FF2B5EF4-FFF2-40B4-BE49-F238E27FC236}">
-                <a16:creationId xmlns:a16="http://schemas.microsoft.com/office/drawing/2014/main" id="{02C81E5A-946F-4C3B-9A9E-F02253FF1F06}"/>
+                <a16:creationId xmlns:a16="http://schemas.microsoft.com/office/drawing/2014/main" id="{25ED84FF-04FD-4F44-BA91-8C2A28D484C1}"/>
               </a:ext>
             </a:extLst>
           </p:cNvPr>
@@ -5791,7 +5791,7 @@
     </p:spTree>
     <p:extLst>
       <p:ext uri="{BB962C8B-B14F-4D97-AF65-F5344CB8AC3E}">
-        <p14:creationId xmlns:p14="http://schemas.microsoft.com/office/powerpoint/2010/main" val="748814572"/>
+        <p14:creationId xmlns:p14="http://schemas.microsoft.com/office/powerpoint/2010/main" val="2121407861"/>
       </p:ext>
     </p:extLst>
   </p:cSld>
@@ -5822,7 +5822,7 @@
           <p:cNvPr id="8" name="">
             <a:extLst xmlns:a="http://schemas.openxmlformats.org/drawingml/2006/main">
               <a:ext uri="{FF2B5EF4-FFF2-40B4-BE49-F238E27FC236}">
-                <a16:creationId xmlns:a16="http://schemas.microsoft.com/office/drawing/2014/main" id="{5E09766A-F545-4986-B8A1-B3A0D4771FF2}"/>
+                <a16:creationId xmlns:a16="http://schemas.microsoft.com/office/drawing/2014/main" id="{8356142A-F2E5-406E-AD4E-6799D22BE113}"/>
               </a:ext>
             </a:extLst>
           </p:cNvPr>
@@ -5879,7 +5879,7 @@
           <p:cNvPr id="2" name="">
             <a:extLst xmlns:a="http://schemas.openxmlformats.org/drawingml/2006/main">
               <a:ext uri="{FF2B5EF4-FFF2-40B4-BE49-F238E27FC236}">
-                <a16:creationId xmlns:a16="http://schemas.microsoft.com/office/drawing/2014/main" id="{979E8ADF-B492-4022-B14C-F51F5696BC74}"/>
+                <a16:creationId xmlns:a16="http://schemas.microsoft.com/office/drawing/2014/main" id="{654095B5-E227-4228-9591-7DEA019D5839}"/>
               </a:ext>
             </a:extLst>
           </p:cNvPr>
@@ -5982,7 +5982,7 @@
           <p:cNvPr id="3" name="">
             <a:extLst xmlns:a="http://schemas.openxmlformats.org/drawingml/2006/main">
               <a:ext uri="{FF2B5EF4-FFF2-40B4-BE49-F238E27FC236}">
-                <a16:creationId xmlns:a16="http://schemas.microsoft.com/office/drawing/2014/main" id="{3AD2F879-5468-42FB-B93D-DCF9B1BBE7A5}"/>
+                <a16:creationId xmlns:a16="http://schemas.microsoft.com/office/drawing/2014/main" id="{974D1D00-9CC5-419D-B6EF-1A9C7F314EFC}"/>
               </a:ext>
             </a:extLst>
           </p:cNvPr>
@@ -6039,7 +6039,7 @@
           <p:cNvPr id="4" name="">
             <a:extLst xmlns:a="http://schemas.openxmlformats.org/drawingml/2006/main">
               <a:ext uri="{FF2B5EF4-FFF2-40B4-BE49-F238E27FC236}">
-                <a16:creationId xmlns:a16="http://schemas.microsoft.com/office/drawing/2014/main" id="{8B080338-1FC9-4115-B4D7-C67BB675A576}"/>
+                <a16:creationId xmlns:a16="http://schemas.microsoft.com/office/drawing/2014/main" id="{7AB77BDC-5D0E-4998-8BB9-5076697F0C9A}"/>
               </a:ext>
             </a:extLst>
           </p:cNvPr>
@@ -6096,7 +6096,7 @@
           <p:cNvPr id="5" name="">
             <a:extLst xmlns:a="http://schemas.openxmlformats.org/drawingml/2006/main">
               <a:ext uri="{FF2B5EF4-FFF2-40B4-BE49-F238E27FC236}">
-                <a16:creationId xmlns:a16="http://schemas.microsoft.com/office/drawing/2014/main" id="{7A91EC0A-5237-4156-84B3-30E218DA4DEB}"/>
+                <a16:creationId xmlns:a16="http://schemas.microsoft.com/office/drawing/2014/main" id="{DE81B0B6-9E03-40DD-8FD6-1E70FDDB33E0}"/>
               </a:ext>
             </a:extLst>
           </p:cNvPr>
@@ -6153,7 +6153,7 @@
           <p:cNvPr id="6" name="">
             <a:extLst xmlns:a="http://schemas.openxmlformats.org/drawingml/2006/main">
               <a:ext uri="{FF2B5EF4-FFF2-40B4-BE49-F238E27FC236}">
-                <a16:creationId xmlns:a16="http://schemas.microsoft.com/office/drawing/2014/main" id="{1D4346C1-97B1-468F-AE9E-FBF18DECB5F7}"/>
+                <a16:creationId xmlns:a16="http://schemas.microsoft.com/office/drawing/2014/main" id="{7F843B49-41F9-452D-9C67-11F5E180DEBE}"/>
               </a:ext>
             </a:extLst>
           </p:cNvPr>
@@ -6214,7 +6214,7 @@
           <p:nvPr/>
         </p:nvPicPr>
         <p:blipFill>
-          <a:blip xmlns:r="http://schemas.openxmlformats.org/officeDocument/2006/relationships" xmlns:a="http://schemas.openxmlformats.org/drawingml/2006/main" r:embed="R133051b562b14b91"/>
+          <a:blip xmlns:r="http://schemas.openxmlformats.org/officeDocument/2006/relationships" xmlns:a="http://schemas.openxmlformats.org/drawingml/2006/main" r:embed="R76181354c22c45f0"/>
           <a:stretch xmlns:a="http://schemas.openxmlformats.org/drawingml/2006/main"/>
         </p:blipFill>
         <p:spPr>
@@ -6230,7 +6230,7 @@
     </p:spTree>
     <p:extLst>
       <p:ext uri="{BB962C8B-B14F-4D97-AF65-F5344CB8AC3E}">
-        <p14:creationId xmlns:p14="http://schemas.microsoft.com/office/powerpoint/2010/main" val="470279024"/>
+        <p14:creationId xmlns:p14="http://schemas.microsoft.com/office/powerpoint/2010/main" val="532676095"/>
       </p:ext>
     </p:extLst>
   </p:cSld>
@@ -6261,7 +6261,7 @@
           <p:cNvPr id="12" name="">
             <a:extLst xmlns:a="http://schemas.openxmlformats.org/drawingml/2006/main">
               <a:ext uri="{FF2B5EF4-FFF2-40B4-BE49-F238E27FC236}">
-                <a16:creationId xmlns:a16="http://schemas.microsoft.com/office/drawing/2014/main" id="{78E73A5A-8573-4AB2-A37C-18A791D52A7D}"/>
+                <a16:creationId xmlns:a16="http://schemas.microsoft.com/office/drawing/2014/main" id="{C2C2E7EE-0D4E-4E90-B6AB-AF61EE6BA795}"/>
               </a:ext>
             </a:extLst>
           </p:cNvPr>
@@ -6318,7 +6318,7 @@
           <p:cNvPr id="2" name="">
             <a:extLst xmlns:a="http://schemas.openxmlformats.org/drawingml/2006/main">
               <a:ext uri="{FF2B5EF4-FFF2-40B4-BE49-F238E27FC236}">
-                <a16:creationId xmlns:a16="http://schemas.microsoft.com/office/drawing/2014/main" id="{3925739F-A1B6-429E-BD07-0D763E01C3BA}"/>
+                <a16:creationId xmlns:a16="http://schemas.microsoft.com/office/drawing/2014/main" id="{44E94037-ECE6-4D5C-8BDA-EFA5DE83C60C}"/>
               </a:ext>
             </a:extLst>
           </p:cNvPr>
@@ -6398,7 +6398,7 @@
           <p:cNvPr id="3" name="">
             <a:extLst xmlns:a="http://schemas.openxmlformats.org/drawingml/2006/main">
               <a:ext uri="{FF2B5EF4-FFF2-40B4-BE49-F238E27FC236}">
-                <a16:creationId xmlns:a16="http://schemas.microsoft.com/office/drawing/2014/main" id="{A0DE91F1-6DC1-4660-8276-5216C73FF659}"/>
+                <a16:creationId xmlns:a16="http://schemas.microsoft.com/office/drawing/2014/main" id="{2F5D4045-D9DB-4C6E-A3EB-11520BD33286}"/>
               </a:ext>
             </a:extLst>
           </p:cNvPr>
@@ -6455,7 +6455,7 @@
           <p:cNvPr id="4" name="">
             <a:extLst xmlns:a="http://schemas.openxmlformats.org/drawingml/2006/main">
               <a:ext uri="{FF2B5EF4-FFF2-40B4-BE49-F238E27FC236}">
-                <a16:creationId xmlns:a16="http://schemas.microsoft.com/office/drawing/2014/main" id="{19E83B18-A2F2-4CE1-91A4-DFFC2407D7D4}"/>
+                <a16:creationId xmlns:a16="http://schemas.microsoft.com/office/drawing/2014/main" id="{3EBE8614-D01E-46C2-AF7C-3839F513CF51}"/>
               </a:ext>
             </a:extLst>
           </p:cNvPr>
@@ -6512,7 +6512,7 @@
           <p:cNvPr id="5" name="">
             <a:extLst xmlns:a="http://schemas.openxmlformats.org/drawingml/2006/main">
               <a:ext uri="{FF2B5EF4-FFF2-40B4-BE49-F238E27FC236}">
-                <a16:creationId xmlns:a16="http://schemas.microsoft.com/office/drawing/2014/main" id="{D0EB8CCD-E095-4DB8-86B3-C3864DF09A83}"/>
+                <a16:creationId xmlns:a16="http://schemas.microsoft.com/office/drawing/2014/main" id="{F1479328-DDB8-43B5-93BC-26A6CD76479A}"/>
               </a:ext>
             </a:extLst>
           </p:cNvPr>
@@ -6569,7 +6569,7 @@
           <p:cNvPr id="6" name="">
             <a:extLst xmlns:a="http://schemas.openxmlformats.org/drawingml/2006/main">
               <a:ext uri="{FF2B5EF4-FFF2-40B4-BE49-F238E27FC236}">
-                <a16:creationId xmlns:a16="http://schemas.microsoft.com/office/drawing/2014/main" id="{238F7747-68A9-4820-A5F5-7E144A46A371}"/>
+                <a16:creationId xmlns:a16="http://schemas.microsoft.com/office/drawing/2014/main" id="{A32EDDC6-028E-4457-A9F4-8A415F9DF0F5}"/>
               </a:ext>
             </a:extLst>
           </p:cNvPr>
@@ -6626,7 +6626,7 @@
           <p:cNvPr id="7" name="">
             <a:extLst xmlns:a="http://schemas.openxmlformats.org/drawingml/2006/main">
               <a:ext uri="{FF2B5EF4-FFF2-40B4-BE49-F238E27FC236}">
-                <a16:creationId xmlns:a16="http://schemas.microsoft.com/office/drawing/2014/main" id="{91CF7208-C1AF-478F-B3D7-6C5109CA7D7C}"/>
+                <a16:creationId xmlns:a16="http://schemas.microsoft.com/office/drawing/2014/main" id="{DCE8391A-0853-4D51-A30C-DBC6C1624A13}"/>
               </a:ext>
             </a:extLst>
           </p:cNvPr>
@@ -6683,7 +6683,7 @@
           <p:cNvPr id="8" name="">
             <a:extLst xmlns:a="http://schemas.openxmlformats.org/drawingml/2006/main">
               <a:ext uri="{FF2B5EF4-FFF2-40B4-BE49-F238E27FC236}">
-                <a16:creationId xmlns:a16="http://schemas.microsoft.com/office/drawing/2014/main" id="{D0A1D67E-A707-4D5F-825A-88AA2DA3FE66}"/>
+                <a16:creationId xmlns:a16="http://schemas.microsoft.com/office/drawing/2014/main" id="{9270EBDE-0355-473C-BC7B-7375BBA69D58}"/>
               </a:ext>
             </a:extLst>
           </p:cNvPr>
@@ -6740,7 +6740,7 @@
           <p:cNvPr id="9" name="">
             <a:extLst xmlns:a="http://schemas.openxmlformats.org/drawingml/2006/main">
               <a:ext uri="{FF2B5EF4-FFF2-40B4-BE49-F238E27FC236}">
-                <a16:creationId xmlns:a16="http://schemas.microsoft.com/office/drawing/2014/main" id="{A77F05A8-225C-48D9-953B-4AFE6297267F}"/>
+                <a16:creationId xmlns:a16="http://schemas.microsoft.com/office/drawing/2014/main" id="{CAF2F034-26F6-48AF-A9DA-FBDA93608C6E}"/>
               </a:ext>
             </a:extLst>
           </p:cNvPr>
@@ -6801,7 +6801,7 @@
           <p:nvPr/>
         </p:nvPicPr>
         <p:blipFill>
-          <a:blip xmlns:r="http://schemas.openxmlformats.org/officeDocument/2006/relationships" xmlns:a="http://schemas.openxmlformats.org/drawingml/2006/main" r:embed="R0652395d9b5b4c91"/>
+          <a:blip xmlns:r="http://schemas.openxmlformats.org/officeDocument/2006/relationships" xmlns:a="http://schemas.openxmlformats.org/drawingml/2006/main" r:embed="R052746b4bb0b4587"/>
           <a:stretch xmlns:a="http://schemas.openxmlformats.org/drawingml/2006/main"/>
         </p:blipFill>
         <p:spPr>
@@ -6819,7 +6819,7 @@
           <p:cNvPr id="11" name="">
             <a:extLst xmlns:a="http://schemas.openxmlformats.org/drawingml/2006/main">
               <a:ext uri="{FF2B5EF4-FFF2-40B4-BE49-F238E27FC236}">
-                <a16:creationId xmlns:a16="http://schemas.microsoft.com/office/drawing/2014/main" id="{2292BD01-9397-4177-A944-B31BB89E5B5A}"/>
+                <a16:creationId xmlns:a16="http://schemas.microsoft.com/office/drawing/2014/main" id="{3F3C5D53-081A-48E2-A7F1-4F647D24908E}"/>
               </a:ext>
             </a:extLst>
           </p:cNvPr>
@@ -6874,7 +6874,7 @@
     </p:spTree>
     <p:extLst>
       <p:ext uri="{BB962C8B-B14F-4D97-AF65-F5344CB8AC3E}">
-        <p14:creationId xmlns:p14="http://schemas.microsoft.com/office/powerpoint/2010/main" val="1791486643"/>
+        <p14:creationId xmlns:p14="http://schemas.microsoft.com/office/powerpoint/2010/main" val="966987952"/>
       </p:ext>
     </p:extLst>
   </p:cSld>
@@ -6905,7 +6905,7 @@
           <p:cNvPr id="6" name="">
             <a:extLst xmlns:a="http://schemas.openxmlformats.org/drawingml/2006/main">
               <a:ext uri="{FF2B5EF4-FFF2-40B4-BE49-F238E27FC236}">
-                <a16:creationId xmlns:a16="http://schemas.microsoft.com/office/drawing/2014/main" id="{5E6433FC-244A-4B66-93C3-BBF626F7F331}"/>
+                <a16:creationId xmlns:a16="http://schemas.microsoft.com/office/drawing/2014/main" id="{5003FEB2-3BD9-4DFA-87D5-098ABB5D834E}"/>
               </a:ext>
             </a:extLst>
           </p:cNvPr>
@@ -6962,7 +6962,7 @@
           <p:cNvPr id="2" name="">
             <a:extLst xmlns:a="http://schemas.openxmlformats.org/drawingml/2006/main">
               <a:ext uri="{FF2B5EF4-FFF2-40B4-BE49-F238E27FC236}">
-                <a16:creationId xmlns:a16="http://schemas.microsoft.com/office/drawing/2014/main" id="{AFE6CFF2-9AC4-4D6F-B3FC-C7846C355F99}"/>
+                <a16:creationId xmlns:a16="http://schemas.microsoft.com/office/drawing/2014/main" id="{0DA0A915-6680-4083-B9E1-F1F531B47579}"/>
               </a:ext>
             </a:extLst>
           </p:cNvPr>
@@ -7019,7 +7019,7 @@
           <p:cNvPr id="3" name="">
             <a:extLst xmlns:a="http://schemas.openxmlformats.org/drawingml/2006/main">
               <a:ext uri="{FF2B5EF4-FFF2-40B4-BE49-F238E27FC236}">
-                <a16:creationId xmlns:a16="http://schemas.microsoft.com/office/drawing/2014/main" id="{97EA139C-DB07-4CBD-804D-9BF6EDB721DA}"/>
+                <a16:creationId xmlns:a16="http://schemas.microsoft.com/office/drawing/2014/main" id="{9BE26450-EC28-499A-84DF-F88C2763203B}"/>
               </a:ext>
             </a:extLst>
           </p:cNvPr>
@@ -7080,7 +7080,7 @@
           <p:nvPr/>
         </p:nvPicPr>
         <p:blipFill>
-          <a:blip xmlns:r="http://schemas.openxmlformats.org/officeDocument/2006/relationships" xmlns:a="http://schemas.openxmlformats.org/drawingml/2006/main" r:embed="R27b688d7a16248d0"/>
+          <a:blip xmlns:r="http://schemas.openxmlformats.org/officeDocument/2006/relationships" xmlns:a="http://schemas.openxmlformats.org/drawingml/2006/main" r:embed="R52ea27de90794d63"/>
           <a:stretch xmlns:a="http://schemas.openxmlformats.org/drawingml/2006/main"/>
         </p:blipFill>
         <p:spPr>
@@ -7098,7 +7098,7 @@
           <p:cNvPr id="5" name="">
             <a:extLst xmlns:a="http://schemas.openxmlformats.org/drawingml/2006/main">
               <a:ext uri="{FF2B5EF4-FFF2-40B4-BE49-F238E27FC236}">
-                <a16:creationId xmlns:a16="http://schemas.microsoft.com/office/drawing/2014/main" id="{EC22285A-C8DA-4238-9B64-1ABCF2BD7358}"/>
+                <a16:creationId xmlns:a16="http://schemas.microsoft.com/office/drawing/2014/main" id="{F97D9017-0D84-4A4C-8AA6-7281E72774C4}"/>
               </a:ext>
             </a:extLst>
           </p:cNvPr>
@@ -7153,7 +7153,7 @@
     </p:spTree>
     <p:extLst>
       <p:ext uri="{BB962C8B-B14F-4D97-AF65-F5344CB8AC3E}">
-        <p14:creationId xmlns:p14="http://schemas.microsoft.com/office/powerpoint/2010/main" val="1859985455"/>
+        <p14:creationId xmlns:p14="http://schemas.microsoft.com/office/powerpoint/2010/main" val="1207477955"/>
       </p:ext>
     </p:extLst>
   </p:cSld>
@@ -7184,7 +7184,7 @@
           <p:cNvPr id="8" name="">
             <a:extLst xmlns:a="http://schemas.openxmlformats.org/drawingml/2006/main">
               <a:ext uri="{FF2B5EF4-FFF2-40B4-BE49-F238E27FC236}">
-                <a16:creationId xmlns:a16="http://schemas.microsoft.com/office/drawing/2014/main" id="{B57EB2C8-06A2-4232-9DEE-C8B0E353B481}"/>
+                <a16:creationId xmlns:a16="http://schemas.microsoft.com/office/drawing/2014/main" id="{61DA3EA4-FFFD-4440-A8D7-96765A239B6D}"/>
               </a:ext>
             </a:extLst>
           </p:cNvPr>
@@ -7241,7 +7241,7 @@
           <p:cNvPr id="2" name="">
             <a:extLst xmlns:a="http://schemas.openxmlformats.org/drawingml/2006/main">
               <a:ext uri="{FF2B5EF4-FFF2-40B4-BE49-F238E27FC236}">
-                <a16:creationId xmlns:a16="http://schemas.microsoft.com/office/drawing/2014/main" id="{B15DCD63-8CA7-4B07-AA8C-478EE81C78CB}"/>
+                <a16:creationId xmlns:a16="http://schemas.microsoft.com/office/drawing/2014/main" id="{8AE37F60-B6C0-41D3-9802-2A96E7726CA3}"/>
               </a:ext>
             </a:extLst>
           </p:cNvPr>
@@ -7298,7 +7298,7 @@
           <p:cNvPr id="3" name="">
             <a:extLst xmlns:a="http://schemas.openxmlformats.org/drawingml/2006/main">
               <a:ext uri="{FF2B5EF4-FFF2-40B4-BE49-F238E27FC236}">
-                <a16:creationId xmlns:a16="http://schemas.microsoft.com/office/drawing/2014/main" id="{6D186074-1E5C-4250-83B3-6C81E30FFEAB}"/>
+                <a16:creationId xmlns:a16="http://schemas.microsoft.com/office/drawing/2014/main" id="{56A4D40A-64D4-44DD-8312-887D06E18A58}"/>
               </a:ext>
             </a:extLst>
           </p:cNvPr>
@@ -7355,7 +7355,7 @@
           <p:cNvPr id="4" name="">
             <a:extLst xmlns:a="http://schemas.openxmlformats.org/drawingml/2006/main">
               <a:ext uri="{FF2B5EF4-FFF2-40B4-BE49-F238E27FC236}">
-                <a16:creationId xmlns:a16="http://schemas.microsoft.com/office/drawing/2014/main" id="{6F295069-763C-4640-AE01-19B4510DF16D}"/>
+                <a16:creationId xmlns:a16="http://schemas.microsoft.com/office/drawing/2014/main" id="{32CD796F-BF2A-44A0-9FFA-50058600C64B}"/>
               </a:ext>
             </a:extLst>
           </p:cNvPr>
@@ -7439,7 +7439,7 @@
           <p:nvPr/>
         </p:nvPicPr>
         <p:blipFill>
-          <a:blip xmlns:r="http://schemas.openxmlformats.org/officeDocument/2006/relationships" xmlns:a="http://schemas.openxmlformats.org/drawingml/2006/main" r:embed="Rc0258a91507c4da3"/>
+          <a:blip xmlns:r="http://schemas.openxmlformats.org/officeDocument/2006/relationships" xmlns:a="http://schemas.openxmlformats.org/drawingml/2006/main" r:embed="R4fc777bc1a3b4e15"/>
           <a:stretch xmlns:a="http://schemas.openxmlformats.org/drawingml/2006/main"/>
         </p:blipFill>
         <p:spPr>
@@ -7457,7 +7457,7 @@
           <p:cNvPr id="6" name="">
             <a:extLst xmlns:a="http://schemas.openxmlformats.org/drawingml/2006/main">
               <a:ext uri="{FF2B5EF4-FFF2-40B4-BE49-F238E27FC236}">
-                <a16:creationId xmlns:a16="http://schemas.microsoft.com/office/drawing/2014/main" id="{53D32409-1DA2-4688-A44A-142A9A97EDF6}"/>
+                <a16:creationId xmlns:a16="http://schemas.microsoft.com/office/drawing/2014/main" id="{27508CDB-0959-40BB-A204-69305DD0FDB7}"/>
               </a:ext>
             </a:extLst>
           </p:cNvPr>
@@ -7514,7 +7514,7 @@
           <p:cNvPr id="7" name="">
             <a:extLst xmlns:a="http://schemas.openxmlformats.org/drawingml/2006/main">
               <a:ext uri="{FF2B5EF4-FFF2-40B4-BE49-F238E27FC236}">
-                <a16:creationId xmlns:a16="http://schemas.microsoft.com/office/drawing/2014/main" id="{D22BD1CC-5363-4441-88DB-0BB63BE592A2}"/>
+                <a16:creationId xmlns:a16="http://schemas.microsoft.com/office/drawing/2014/main" id="{A5847131-49D5-437F-AF2D-452F6BA6D9FB}"/>
               </a:ext>
             </a:extLst>
           </p:cNvPr>
@@ -7569,7 +7569,7 @@
     </p:spTree>
     <p:extLst>
       <p:ext uri="{BB962C8B-B14F-4D97-AF65-F5344CB8AC3E}">
-        <p14:creationId xmlns:p14="http://schemas.microsoft.com/office/powerpoint/2010/main" val="1921805292"/>
+        <p14:creationId xmlns:p14="http://schemas.microsoft.com/office/powerpoint/2010/main" val="2073327114"/>
       </p:ext>
     </p:extLst>
   </p:cSld>
@@ -7600,7 +7600,7 @@
           <p:cNvPr id="10" name="">
             <a:extLst xmlns:a="http://schemas.openxmlformats.org/drawingml/2006/main">
               <a:ext uri="{FF2B5EF4-FFF2-40B4-BE49-F238E27FC236}">
-                <a16:creationId xmlns:a16="http://schemas.microsoft.com/office/drawing/2014/main" id="{166ACE43-2190-4242-AB81-7DF36791D65E}"/>
+                <a16:creationId xmlns:a16="http://schemas.microsoft.com/office/drawing/2014/main" id="{2AE0EBC9-22B0-4B45-9C49-A56AE3B415B8}"/>
               </a:ext>
             </a:extLst>
           </p:cNvPr>
@@ -7657,7 +7657,7 @@
           <p:cNvPr id="2" name="">
             <a:extLst xmlns:a="http://schemas.openxmlformats.org/drawingml/2006/main">
               <a:ext uri="{FF2B5EF4-FFF2-40B4-BE49-F238E27FC236}">
-                <a16:creationId xmlns:a16="http://schemas.microsoft.com/office/drawing/2014/main" id="{9ABADBE7-6F29-4CC7-B398-FE8E99D28AA6}"/>
+                <a16:creationId xmlns:a16="http://schemas.microsoft.com/office/drawing/2014/main" id="{2B5D05D7-B8D6-486F-AFD0-952CE69ECEE5}"/>
               </a:ext>
             </a:extLst>
           </p:cNvPr>
@@ -7714,7 +7714,7 @@
           <p:cNvPr id="3" name="">
             <a:extLst xmlns:a="http://schemas.openxmlformats.org/drawingml/2006/main">
               <a:ext uri="{FF2B5EF4-FFF2-40B4-BE49-F238E27FC236}">
-                <a16:creationId xmlns:a16="http://schemas.microsoft.com/office/drawing/2014/main" id="{904C01D8-3F47-47D6-95C5-2615C20BFE1E}"/>
+                <a16:creationId xmlns:a16="http://schemas.microsoft.com/office/drawing/2014/main" id="{748DE094-7CA3-4E46-B861-2BD297DA75BA}"/>
               </a:ext>
             </a:extLst>
           </p:cNvPr>
@@ -7771,7 +7771,7 @@
           <p:cNvPr id="4" name="">
             <a:extLst xmlns:a="http://schemas.openxmlformats.org/drawingml/2006/main">
               <a:ext uri="{FF2B5EF4-FFF2-40B4-BE49-F238E27FC236}">
-                <a16:creationId xmlns:a16="http://schemas.microsoft.com/office/drawing/2014/main" id="{63BCA784-523F-43B6-B176-82B78391B741}"/>
+                <a16:creationId xmlns:a16="http://schemas.microsoft.com/office/drawing/2014/main" id="{55D016D9-4C22-446A-93C7-7A8AF6BEF667}"/>
               </a:ext>
             </a:extLst>
           </p:cNvPr>
@@ -7828,7 +7828,7 @@
           <p:cNvPr id="5" name="">
             <a:extLst xmlns:a="http://schemas.openxmlformats.org/drawingml/2006/main">
               <a:ext uri="{FF2B5EF4-FFF2-40B4-BE49-F238E27FC236}">
-                <a16:creationId xmlns:a16="http://schemas.microsoft.com/office/drawing/2014/main" id="{04A815C2-0907-4915-9189-78630BB96D99}"/>
+                <a16:creationId xmlns:a16="http://schemas.microsoft.com/office/drawing/2014/main" id="{23C6A2B0-76F0-4090-965D-C57C86AB0649}"/>
               </a:ext>
             </a:extLst>
           </p:cNvPr>
@@ -7885,7 +7885,7 @@
           <p:cNvPr id="6" name="">
             <a:extLst xmlns:a="http://schemas.openxmlformats.org/drawingml/2006/main">
               <a:ext uri="{FF2B5EF4-FFF2-40B4-BE49-F238E27FC236}">
-                <a16:creationId xmlns:a16="http://schemas.microsoft.com/office/drawing/2014/main" id="{DD701C8E-A2B2-4DFD-AE30-459974A8A884}"/>
+                <a16:creationId xmlns:a16="http://schemas.microsoft.com/office/drawing/2014/main" id="{46001903-C4E1-4B1E-8A49-8B81CC564F14}"/>
               </a:ext>
             </a:extLst>
           </p:cNvPr>
@@ -7942,7 +7942,7 @@
           <p:cNvPr id="7" name="">
             <a:extLst xmlns:a="http://schemas.openxmlformats.org/drawingml/2006/main">
               <a:ext uri="{FF2B5EF4-FFF2-40B4-BE49-F238E27FC236}">
-                <a16:creationId xmlns:a16="http://schemas.microsoft.com/office/drawing/2014/main" id="{041F9176-538A-4080-80E0-8A54981B1E54}"/>
+                <a16:creationId xmlns:a16="http://schemas.microsoft.com/office/drawing/2014/main" id="{C41ECC2F-0AB8-4E5B-9095-EC3967854313}"/>
               </a:ext>
             </a:extLst>
           </p:cNvPr>
@@ -8606,7 +8606,7 @@
           <p:cNvPr id="9" name="">
             <a:extLst xmlns:a="http://schemas.openxmlformats.org/drawingml/2006/main">
               <a:ext uri="{FF2B5EF4-FFF2-40B4-BE49-F238E27FC236}">
-                <a16:creationId xmlns:a16="http://schemas.microsoft.com/office/drawing/2014/main" id="{BA3AEF7D-62CE-4354-A356-8936AF947350}"/>
+                <a16:creationId xmlns:a16="http://schemas.microsoft.com/office/drawing/2014/main" id="{0E7437EF-4485-495F-B094-81258E930194}"/>
               </a:ext>
             </a:extLst>
           </p:cNvPr>
@@ -8661,7 +8661,7 @@
     </p:spTree>
     <p:extLst>
       <p:ext uri="{BB962C8B-B14F-4D97-AF65-F5344CB8AC3E}">
-        <p14:creationId xmlns:p14="http://schemas.microsoft.com/office/powerpoint/2010/main" val="202498848"/>
+        <p14:creationId xmlns:p14="http://schemas.microsoft.com/office/powerpoint/2010/main" val="1378803675"/>
       </p:ext>
     </p:extLst>
   </p:cSld>
@@ -8689,10 +8689,10 @@
       </p:grpSpPr>
       <p:sp>
         <p:nvSpPr>
-          <p:cNvPr id="20" name="">
-            <a:extLst xmlns:a="http://schemas.openxmlformats.org/drawingml/2006/main">
-              <a:ext uri="{FF2B5EF4-FFF2-40B4-BE49-F238E27FC236}">
-                <a16:creationId xmlns:a16="http://schemas.microsoft.com/office/drawing/2014/main" id="{370C069A-5D48-4EA3-9DDB-69692A396AB4}"/>
+          <p:cNvPr id="19" name="">
+            <a:extLst xmlns:a="http://schemas.openxmlformats.org/drawingml/2006/main">
+              <a:ext uri="{FF2B5EF4-FFF2-40B4-BE49-F238E27FC236}">
+                <a16:creationId xmlns:a16="http://schemas.microsoft.com/office/drawing/2014/main" id="{3F633AEA-1E9F-4FA1-BE6C-9E0684DB0C92}"/>
               </a:ext>
             </a:extLst>
           </p:cNvPr>
@@ -8749,7 +8749,7 @@
           <p:cNvPr id="2" name="">
             <a:extLst xmlns:a="http://schemas.openxmlformats.org/drawingml/2006/main">
               <a:ext uri="{FF2B5EF4-FFF2-40B4-BE49-F238E27FC236}">
-                <a16:creationId xmlns:a16="http://schemas.microsoft.com/office/drawing/2014/main" id="{DFD3FB03-DB43-4EED-AD5D-F1FEC97D21D1}"/>
+                <a16:creationId xmlns:a16="http://schemas.microsoft.com/office/drawing/2014/main" id="{083AD82C-7E78-44A6-B977-89A7DE51D605}"/>
               </a:ext>
             </a:extLst>
           </p:cNvPr>
@@ -8806,7 +8806,7 @@
           <p:cNvPr id="3" name="">
             <a:extLst xmlns:a="http://schemas.openxmlformats.org/drawingml/2006/main">
               <a:ext uri="{FF2B5EF4-FFF2-40B4-BE49-F238E27FC236}">
-                <a16:creationId xmlns:a16="http://schemas.microsoft.com/office/drawing/2014/main" id="{6132A8C5-8907-43B2-9DD3-150707CE1F40}"/>
+                <a16:creationId xmlns:a16="http://schemas.microsoft.com/office/drawing/2014/main" id="{90046A8E-0DA5-4133-A593-0451CC4461B6}"/>
               </a:ext>
             </a:extLst>
           </p:cNvPr>
@@ -8863,7 +8863,7 @@
           <p:cNvPr id="4" name="">
             <a:extLst xmlns:a="http://schemas.openxmlformats.org/drawingml/2006/main">
               <a:ext uri="{FF2B5EF4-FFF2-40B4-BE49-F238E27FC236}">
-                <a16:creationId xmlns:a16="http://schemas.microsoft.com/office/drawing/2014/main" id="{53E73545-BB5C-4CA1-A52C-52488E219B84}"/>
+                <a16:creationId xmlns:a16="http://schemas.microsoft.com/office/drawing/2014/main" id="{D169DBFE-C96D-4134-B0F7-5C76715EAF9F}"/>
               </a:ext>
             </a:extLst>
           </p:cNvPr>
@@ -8920,7 +8920,7 @@
           <p:cNvPr id="5" name="">
             <a:extLst xmlns:a="http://schemas.openxmlformats.org/drawingml/2006/main">
               <a:ext uri="{FF2B5EF4-FFF2-40B4-BE49-F238E27FC236}">
-                <a16:creationId xmlns:a16="http://schemas.microsoft.com/office/drawing/2014/main" id="{09EC0801-E5D6-4AE2-8615-C9E76C9F6A80}"/>
+                <a16:creationId xmlns:a16="http://schemas.microsoft.com/office/drawing/2014/main" id="{D3394EAE-656D-4628-97EE-5C67C2E720D2}"/>
               </a:ext>
             </a:extLst>
           </p:cNvPr>
@@ -8977,7 +8977,7 @@
           <p:cNvPr id="6" name="">
             <a:extLst xmlns:a="http://schemas.openxmlformats.org/drawingml/2006/main">
               <a:ext uri="{FF2B5EF4-FFF2-40B4-BE49-F238E27FC236}">
-                <a16:creationId xmlns:a16="http://schemas.microsoft.com/office/drawing/2014/main" id="{0C0D4BE9-4718-45A1-873E-F18C8D6F2E37}"/>
+                <a16:creationId xmlns:a16="http://schemas.microsoft.com/office/drawing/2014/main" id="{526D0CEA-CAC0-4436-B19D-13E10B08F1AB}"/>
               </a:ext>
             </a:extLst>
           </p:cNvPr>
@@ -9034,7 +9034,7 @@
           <p:cNvPr id="7" name="">
             <a:extLst xmlns:a="http://schemas.openxmlformats.org/drawingml/2006/main">
               <a:ext uri="{FF2B5EF4-FFF2-40B4-BE49-F238E27FC236}">
-                <a16:creationId xmlns:a16="http://schemas.microsoft.com/office/drawing/2014/main" id="{AF4CE4FF-4D5C-441B-A48B-878A4E16FCD3}"/>
+                <a16:creationId xmlns:a16="http://schemas.microsoft.com/office/drawing/2014/main" id="{E0F3D4BE-CC9E-4B35-89E4-DEEF81D54289}"/>
               </a:ext>
             </a:extLst>
           </p:cNvPr>
@@ -9091,7 +9091,7 @@
           <p:cNvPr id="8" name="">
             <a:extLst xmlns:a="http://schemas.openxmlformats.org/drawingml/2006/main">
               <a:ext uri="{FF2B5EF4-FFF2-40B4-BE49-F238E27FC236}">
-                <a16:creationId xmlns:a16="http://schemas.microsoft.com/office/drawing/2014/main" id="{A6E2BE57-627E-40E2-AB78-F2EC7EBA6F52}"/>
+                <a16:creationId xmlns:a16="http://schemas.microsoft.com/office/drawing/2014/main" id="{83DF7FD8-51BA-44EE-9F05-6343A004F820}"/>
               </a:ext>
             </a:extLst>
           </p:cNvPr>
@@ -9145,7 +9145,7 @@
       </p:sp>
       <p:cxnSp>
         <p:nvCxnSpPr>
-          <p:cNvPr id="28" name=""/>
+          <p:cNvPr id="27" name=""/>
           <p:cNvCxnSpPr>
             <a:stCxn xmlns:a="http://schemas.openxmlformats.org/drawingml/2006/main" id="6" idx="3"/>
             <a:endCxn xmlns:a="http://schemas.openxmlformats.org/drawingml/2006/main" id="7" idx="1"/>
@@ -9171,7 +9171,7 @@
       </p:cxnSp>
       <p:cxnSp>
         <p:nvCxnSpPr>
-          <p:cNvPr id="29" name=""/>
+          <p:cNvPr id="28" name=""/>
           <p:cNvCxnSpPr>
             <a:stCxn xmlns:a="http://schemas.openxmlformats.org/drawingml/2006/main" id="7" idx="3"/>
             <a:endCxn xmlns:a="http://schemas.openxmlformats.org/drawingml/2006/main" id="8" idx="1"/>
@@ -9200,7 +9200,7 @@
           <p:cNvPr id="11" name="">
             <a:extLst xmlns:a="http://schemas.openxmlformats.org/drawingml/2006/main">
               <a:ext uri="{FF2B5EF4-FFF2-40B4-BE49-F238E27FC236}">
-                <a16:creationId xmlns:a16="http://schemas.microsoft.com/office/drawing/2014/main" id="{00AE6069-F79E-4C8B-BA0A-E177BC41DE85}"/>
+                <a16:creationId xmlns:a16="http://schemas.microsoft.com/office/drawing/2014/main" id="{D2AAD463-4490-4C6F-90D0-71A3EC61B424}"/>
               </a:ext>
             </a:extLst>
           </p:cNvPr>
@@ -9280,7 +9280,7 @@
           <p:cNvPr id="12" name="">
             <a:extLst xmlns:a="http://schemas.openxmlformats.org/drawingml/2006/main">
               <a:ext uri="{FF2B5EF4-FFF2-40B4-BE49-F238E27FC236}">
-                <a16:creationId xmlns:a16="http://schemas.microsoft.com/office/drawing/2014/main" id="{377F30E5-3907-4CE0-BB27-07C70DDC496C}"/>
+                <a16:creationId xmlns:a16="http://schemas.microsoft.com/office/drawing/2014/main" id="{03567057-0C72-4BB0-9BD7-CBB4FFB8B4BE}"/>
               </a:ext>
             </a:extLst>
           </p:cNvPr>
@@ -9383,7 +9383,7 @@
           <p:cNvPr id="13" name="">
             <a:extLst xmlns:a="http://schemas.openxmlformats.org/drawingml/2006/main">
               <a:ext uri="{FF2B5EF4-FFF2-40B4-BE49-F238E27FC236}">
-                <a16:creationId xmlns:a16="http://schemas.microsoft.com/office/drawing/2014/main" id="{63F2BFBC-9E23-471D-8A1A-E1F6EEE27BDC}"/>
+                <a16:creationId xmlns:a16="http://schemas.microsoft.com/office/drawing/2014/main" id="{773F7C88-E316-425B-8F6E-6837932041A8}"/>
               </a:ext>
             </a:extLst>
           </p:cNvPr>
@@ -9486,7 +9486,7 @@
           <p:cNvPr id="14" name="">
             <a:extLst xmlns:a="http://schemas.openxmlformats.org/drawingml/2006/main">
               <a:ext uri="{FF2B5EF4-FFF2-40B4-BE49-F238E27FC236}">
-                <a16:creationId xmlns:a16="http://schemas.microsoft.com/office/drawing/2014/main" id="{58A8AB9D-E072-462B-AE14-25137AB1DECB}"/>
+                <a16:creationId xmlns:a16="http://schemas.microsoft.com/office/drawing/2014/main" id="{D9CF48BC-115E-47AB-AD55-B368F9082CF3}"/>
               </a:ext>
             </a:extLst>
           </p:cNvPr>
@@ -9516,36 +9516,36 @@
           <p:cNvPr id="15" name="">
             <a:extLst xmlns:a="http://schemas.openxmlformats.org/drawingml/2006/main">
               <a:ext uri="{FF2B5EF4-FFF2-40B4-BE49-F238E27FC236}">
-                <a16:creationId xmlns:a16="http://schemas.microsoft.com/office/drawing/2014/main" id="{0CB36440-4196-4B1A-9BC9-F641B52D65EC}"/>
-              </a:ext>
-            </a:extLst>
-          </p:cNvPr>
-          <p:cNvSpPr>
-            <a:spLocks xmlns:a="http://schemas.openxmlformats.org/drawingml/2006/main" noGrp="1"/>
-          </p:cNvSpPr>
-          <p:nvPr/>
-        </p:nvSpPr>
-        <p:spPr>
-          <a:xfrm xmlns:a="http://schemas.openxmlformats.org/drawingml/2006/main">
-            <a:off x="619125" y="5257800"/>
-            <a:ext cx="5334000" cy="304800"/>
-          </a:xfrm>
-          <a:prstGeom xmlns:a="http://schemas.openxmlformats.org/drawingml/2006/main" prst="rect">
-            <a:avLst/>
-          </a:prstGeom>
-          <a:noFill xmlns:a="http://schemas.openxmlformats.org/drawingml/2006/main"/>
-          <a:ln xmlns:a="http://schemas.openxmlformats.org/drawingml/2006/main" w="0">
-            <a:noFill/>
-          </a:ln>
-        </p:spPr>
-        <p:txBody>
-          <a:bodyPr xmlns:a="http://schemas.openxmlformats.org/drawingml/2006/main">
-            <a:noAutofit/>
-          </a:bodyPr>
-          <a:lstStyle xmlns:a="http://schemas.openxmlformats.org/drawingml/2006/main"/>
-          <a:p xmlns:a="http://schemas.openxmlformats.org/drawingml/2006/main">
-            <a:pPr>
-              <a:defRPr sz="1350" b="1">
+                <a16:creationId xmlns:a16="http://schemas.microsoft.com/office/drawing/2014/main" id="{11E10818-6791-4752-801E-1A3EE57E2D7D}"/>
+              </a:ext>
+            </a:extLst>
+          </p:cNvPr>
+          <p:cNvSpPr>
+            <a:spLocks xmlns:a="http://schemas.openxmlformats.org/drawingml/2006/main" noGrp="1"/>
+          </p:cNvSpPr>
+          <p:nvPr/>
+        </p:nvSpPr>
+        <p:spPr>
+          <a:xfrm xmlns:a="http://schemas.openxmlformats.org/drawingml/2006/main">
+            <a:off x="619125" y="5210175"/>
+            <a:ext cx="10668000" cy="400050"/>
+          </a:xfrm>
+          <a:prstGeom xmlns:a="http://schemas.openxmlformats.org/drawingml/2006/main" prst="rect">
+            <a:avLst/>
+          </a:prstGeom>
+          <a:noFill xmlns:a="http://schemas.openxmlformats.org/drawingml/2006/main"/>
+          <a:ln xmlns:a="http://schemas.openxmlformats.org/drawingml/2006/main" w="0">
+            <a:noFill/>
+          </a:ln>
+        </p:spPr>
+        <p:txBody>
+          <a:bodyPr xmlns:a="http://schemas.openxmlformats.org/drawingml/2006/main">
+            <a:noAutofit/>
+          </a:bodyPr>
+          <a:lstStyle xmlns:a="http://schemas.openxmlformats.org/drawingml/2006/main"/>
+          <a:p xmlns:a="http://schemas.openxmlformats.org/drawingml/2006/main">
+            <a:pPr>
+              <a:defRPr sz="1725" b="1">
                 <a:solidFill>
                   <a:srgbClr val="666962"/>
                 </a:solidFill>
@@ -9555,7 +9555,7 @@
               </a:defRPr>
             </a:pPr>
             <a:r>
-              <a:rPr sz="1350" b="1">
+              <a:rPr sz="1725" b="1">
                 <a:solidFill>
                   <a:srgbClr val="666962"/>
                 </a:solidFill>
@@ -9563,7 +9563,7 @@
                 <a:ea typeface="Manrope"/>
                 <a:cs typeface="Manrope"/>
               </a:rPr>
-              <a:t>PROPOSALS</a:t>
+              <a:t>Supporting capabilities used by the API</a:t>
             </a:r>
           </a:p>
         </p:txBody>
@@ -9573,54 +9573,54 @@
           <p:cNvPr id="16" name="">
             <a:extLst xmlns:a="http://schemas.openxmlformats.org/drawingml/2006/main">
               <a:ext uri="{FF2B5EF4-FFF2-40B4-BE49-F238E27FC236}">
-                <a16:creationId xmlns:a16="http://schemas.microsoft.com/office/drawing/2014/main" id="{92354771-FC42-48B7-BF96-811EDAB3DE81}"/>
-              </a:ext>
-            </a:extLst>
-          </p:cNvPr>
-          <p:cNvSpPr>
-            <a:spLocks xmlns:a="http://schemas.openxmlformats.org/drawingml/2006/main" noGrp="1"/>
-          </p:cNvSpPr>
-          <p:nvPr/>
-        </p:nvSpPr>
-        <p:spPr>
-          <a:xfrm xmlns:a="http://schemas.openxmlformats.org/drawingml/2006/main">
-            <a:off x="6629400" y="5257800"/>
-            <a:ext cx="4857750" cy="304800"/>
-          </a:xfrm>
-          <a:prstGeom xmlns:a="http://schemas.openxmlformats.org/drawingml/2006/main" prst="rect">
-            <a:avLst/>
-          </a:prstGeom>
-          <a:noFill xmlns:a="http://schemas.openxmlformats.org/drawingml/2006/main"/>
-          <a:ln xmlns:a="http://schemas.openxmlformats.org/drawingml/2006/main" w="0">
-            <a:noFill/>
-          </a:ln>
-        </p:spPr>
-        <p:txBody>
-          <a:bodyPr xmlns:a="http://schemas.openxmlformats.org/drawingml/2006/main">
-            <a:noAutofit/>
-          </a:bodyPr>
-          <a:lstStyle xmlns:a="http://schemas.openxmlformats.org/drawingml/2006/main"/>
-          <a:p xmlns:a="http://schemas.openxmlformats.org/drawingml/2006/main">
-            <a:pPr>
-              <a:defRPr sz="1350" b="1">
-                <a:solidFill>
-                  <a:srgbClr val="666962"/>
-                </a:solidFill>
-                <a:latin typeface="Manrope"/>
-                <a:ea typeface="Manrope"/>
-                <a:cs typeface="Manrope"/>
-              </a:defRPr>
-            </a:pPr>
-            <a:r>
-              <a:rPr sz="1350" b="1">
-                <a:solidFill>
-                  <a:srgbClr val="666962"/>
-                </a:solidFill>
-                <a:latin typeface="Manrope"/>
-                <a:ea typeface="Manrope"/>
-                <a:cs typeface="Manrope"/>
-              </a:rPr>
-              <a:t>DOCUMENT FIELDS</a:t>
+                <a16:creationId xmlns:a16="http://schemas.microsoft.com/office/drawing/2014/main" id="{E1C16560-D1A6-4599-A967-38855E1B06A8}"/>
+              </a:ext>
+            </a:extLst>
+          </p:cNvPr>
+          <p:cNvSpPr>
+            <a:spLocks xmlns:a="http://schemas.openxmlformats.org/drawingml/2006/main" noGrp="1"/>
+          </p:cNvSpPr>
+          <p:nvPr/>
+        </p:nvSpPr>
+        <p:spPr>
+          <a:xfrm xmlns:a="http://schemas.openxmlformats.org/drawingml/2006/main">
+            <a:off x="619125" y="5667375"/>
+            <a:ext cx="5886450" cy="409575"/>
+          </a:xfrm>
+          <a:prstGeom xmlns:a="http://schemas.openxmlformats.org/drawingml/2006/main" prst="rect">
+            <a:avLst/>
+          </a:prstGeom>
+          <a:noFill xmlns:a="http://schemas.openxmlformats.org/drawingml/2006/main"/>
+          <a:ln xmlns:a="http://schemas.openxmlformats.org/drawingml/2006/main" w="0">
+            <a:noFill/>
+          </a:ln>
+        </p:spPr>
+        <p:txBody>
+          <a:bodyPr xmlns:a="http://schemas.openxmlformats.org/drawingml/2006/main">
+            <a:noAutofit/>
+          </a:bodyPr>
+          <a:lstStyle xmlns:a="http://schemas.openxmlformats.org/drawingml/2006/main"/>
+          <a:p xmlns:a="http://schemas.openxmlformats.org/drawingml/2006/main">
+            <a:pPr>
+              <a:defRPr sz="1875" b="0">
+                <a:solidFill>
+                  <a:srgbClr val="242729"/>
+                </a:solidFill>
+                <a:latin typeface="Manrope"/>
+                <a:ea typeface="Manrope"/>
+                <a:cs typeface="Manrope"/>
+              </a:defRPr>
+            </a:pPr>
+            <a:r>
+              <a:rPr sz="1875" b="0">
+                <a:solidFill>
+                  <a:srgbClr val="242729"/>
+                </a:solidFill>
+                <a:latin typeface="Manrope"/>
+                <a:ea typeface="Manrope"/>
+                <a:cs typeface="Manrope"/>
+              </a:rPr>
+              <a:t>Proposals: OR-Tools + Valhalla</a:t>
             </a:r>
           </a:p>
         </p:txBody>
@@ -9630,36 +9630,36 @@
           <p:cNvPr id="17" name="">
             <a:extLst xmlns:a="http://schemas.openxmlformats.org/drawingml/2006/main">
               <a:ext uri="{FF2B5EF4-FFF2-40B4-BE49-F238E27FC236}">
-                <a16:creationId xmlns:a16="http://schemas.microsoft.com/office/drawing/2014/main" id="{96D4B40D-2275-4266-A02A-CEAEB017D58A}"/>
-              </a:ext>
-            </a:extLst>
-          </p:cNvPr>
-          <p:cNvSpPr>
-            <a:spLocks xmlns:a="http://schemas.openxmlformats.org/drawingml/2006/main" noGrp="1"/>
-          </p:cNvSpPr>
-          <p:nvPr/>
-        </p:nvSpPr>
-        <p:spPr>
-          <a:xfrm xmlns:a="http://schemas.openxmlformats.org/drawingml/2006/main">
-            <a:off x="619125" y="5629275"/>
-            <a:ext cx="5429250" cy="447675"/>
-          </a:xfrm>
-          <a:prstGeom xmlns:a="http://schemas.openxmlformats.org/drawingml/2006/main" prst="rect">
-            <a:avLst/>
-          </a:prstGeom>
-          <a:noFill xmlns:a="http://schemas.openxmlformats.org/drawingml/2006/main"/>
-          <a:ln xmlns:a="http://schemas.openxmlformats.org/drawingml/2006/main" w="0">
-            <a:noFill/>
-          </a:ln>
-        </p:spPr>
-        <p:txBody>
-          <a:bodyPr xmlns:a="http://schemas.openxmlformats.org/drawingml/2006/main">
-            <a:noAutofit/>
-          </a:bodyPr>
-          <a:lstStyle xmlns:a="http://schemas.openxmlformats.org/drawingml/2006/main"/>
-          <a:p xmlns:a="http://schemas.openxmlformats.org/drawingml/2006/main">
-            <a:pPr>
-              <a:defRPr sz="2100" b="0">
+                <a16:creationId xmlns:a16="http://schemas.microsoft.com/office/drawing/2014/main" id="{3559AE18-DCE9-4022-A93B-C1E2204D2332}"/>
+              </a:ext>
+            </a:extLst>
+          </p:cNvPr>
+          <p:cNvSpPr>
+            <a:spLocks xmlns:a="http://schemas.openxmlformats.org/drawingml/2006/main" noGrp="1"/>
+          </p:cNvSpPr>
+          <p:nvPr/>
+        </p:nvSpPr>
+        <p:spPr>
+          <a:xfrm xmlns:a="http://schemas.openxmlformats.org/drawingml/2006/main">
+            <a:off x="6629400" y="5667375"/>
+            <a:ext cx="4857750" cy="409575"/>
+          </a:xfrm>
+          <a:prstGeom xmlns:a="http://schemas.openxmlformats.org/drawingml/2006/main" prst="rect">
+            <a:avLst/>
+          </a:prstGeom>
+          <a:noFill xmlns:a="http://schemas.openxmlformats.org/drawingml/2006/main"/>
+          <a:ln xmlns:a="http://schemas.openxmlformats.org/drawingml/2006/main" w="0">
+            <a:noFill/>
+          </a:ln>
+        </p:spPr>
+        <p:txBody>
+          <a:bodyPr xmlns:a="http://schemas.openxmlformats.org/drawingml/2006/main">
+            <a:noAutofit/>
+          </a:bodyPr>
+          <a:lstStyle xmlns:a="http://schemas.openxmlformats.org/drawingml/2006/main"/>
+          <a:p xmlns:a="http://schemas.openxmlformats.org/drawingml/2006/main">
+            <a:pPr>
+              <a:defRPr sz="1875" b="0">
                 <a:solidFill>
                   <a:srgbClr val="242729"/>
                 </a:solidFill>
@@ -9669,7 +9669,7 @@
               </a:defRPr>
             </a:pPr>
             <a:r>
-              <a:rPr sz="2100" b="0">
+              <a:rPr sz="1875" b="0">
                 <a:solidFill>
                   <a:srgbClr val="242729"/>
                 </a:solidFill>
@@ -9677,7 +9677,7 @@
                 <a:ea typeface="Manrope"/>
                 <a:cs typeface="Manrope"/>
               </a:rPr>
-              <a:t>OR-Tools + Valhalla</a:t>
+              <a:t>Documents: Gemini extraction</a:t>
             </a:r>
           </a:p>
         </p:txBody>
@@ -9687,64 +9687,7 @@
           <p:cNvPr id="18" name="">
             <a:extLst xmlns:a="http://schemas.openxmlformats.org/drawingml/2006/main">
               <a:ext uri="{FF2B5EF4-FFF2-40B4-BE49-F238E27FC236}">
-                <a16:creationId xmlns:a16="http://schemas.microsoft.com/office/drawing/2014/main" id="{0D5E5647-939F-4AA6-9FDA-74CCD274C7D3}"/>
-              </a:ext>
-            </a:extLst>
-          </p:cNvPr>
-          <p:cNvSpPr>
-            <a:spLocks xmlns:a="http://schemas.openxmlformats.org/drawingml/2006/main" noGrp="1"/>
-          </p:cNvSpPr>
-          <p:nvPr/>
-        </p:nvSpPr>
-        <p:spPr>
-          <a:xfrm xmlns:a="http://schemas.openxmlformats.org/drawingml/2006/main">
-            <a:off x="6629400" y="5629275"/>
-            <a:ext cx="4857750" cy="447675"/>
-          </a:xfrm>
-          <a:prstGeom xmlns:a="http://schemas.openxmlformats.org/drawingml/2006/main" prst="rect">
-            <a:avLst/>
-          </a:prstGeom>
-          <a:noFill xmlns:a="http://schemas.openxmlformats.org/drawingml/2006/main"/>
-          <a:ln xmlns:a="http://schemas.openxmlformats.org/drawingml/2006/main" w="0">
-            <a:noFill/>
-          </a:ln>
-        </p:spPr>
-        <p:txBody>
-          <a:bodyPr xmlns:a="http://schemas.openxmlformats.org/drawingml/2006/main">
-            <a:noAutofit/>
-          </a:bodyPr>
-          <a:lstStyle xmlns:a="http://schemas.openxmlformats.org/drawingml/2006/main"/>
-          <a:p xmlns:a="http://schemas.openxmlformats.org/drawingml/2006/main">
-            <a:pPr>
-              <a:defRPr sz="2100" b="0">
-                <a:solidFill>
-                  <a:srgbClr val="242729"/>
-                </a:solidFill>
-                <a:latin typeface="Manrope"/>
-                <a:ea typeface="Manrope"/>
-                <a:cs typeface="Manrope"/>
-              </a:defRPr>
-            </a:pPr>
-            <a:r>
-              <a:rPr sz="2100" b="0">
-                <a:solidFill>
-                  <a:srgbClr val="242729"/>
-                </a:solidFill>
-                <a:latin typeface="Manrope"/>
-                <a:ea typeface="Manrope"/>
-                <a:cs typeface="Manrope"/>
-              </a:rPr>
-              <a:t>Gemini extraction</a:t>
-            </a:r>
-          </a:p>
-        </p:txBody>
-      </p:sp>
-      <p:sp>
-        <p:nvSpPr>
-          <p:cNvPr id="19" name="">
-            <a:extLst xmlns:a="http://schemas.openxmlformats.org/drawingml/2006/main">
-              <a:ext uri="{FF2B5EF4-FFF2-40B4-BE49-F238E27FC236}">
-                <a16:creationId xmlns:a16="http://schemas.microsoft.com/office/drawing/2014/main" id="{66A02044-38D2-404D-8EDB-1C15E29CA2A9}"/>
+                <a16:creationId xmlns:a16="http://schemas.microsoft.com/office/drawing/2014/main" id="{AFCD141A-D0D3-40DE-8F63-3B1A411DAB28}"/>
               </a:ext>
             </a:extLst>
           </p:cNvPr>
@@ -9799,7 +9742,7 @@
     </p:spTree>
     <p:extLst>
       <p:ext uri="{BB962C8B-B14F-4D97-AF65-F5344CB8AC3E}">
-        <p14:creationId xmlns:p14="http://schemas.microsoft.com/office/powerpoint/2010/main" val="1502727757"/>
+        <p14:creationId xmlns:p14="http://schemas.microsoft.com/office/powerpoint/2010/main" val="1052356397"/>
       </p:ext>
     </p:extLst>
   </p:cSld>

</xml_diff>

<commit_message>
feat(deck): add measured workflow evidence
Co-authored-by: Codex <noreply@openai.com>
</commit_message>
<xml_diff>
--- a/apps/web/public/demo/roadstar-pitch.pptx
+++ b/apps/web/public/demo/roadstar-pitch.pptx
@@ -2,25 +2,25 @@
 <file path=ppt/presentation.xml><?xml version="1.0" encoding="utf-8"?>
 <p:presentation xmlns:p="http://schemas.openxmlformats.org/presentationml/2006/main">
   <p:sldMasterIdLst>
-    <p:sldMasterId xmlns:r="http://schemas.openxmlformats.org/officeDocument/2006/relationships" id="2147483648" r:id="R702f1ed6a72e44b3"/>
+    <p:sldMasterId xmlns:r="http://schemas.openxmlformats.org/officeDocument/2006/relationships" id="2147483648" r:id="Rc1bf39df39f34aa5"/>
   </p:sldMasterIdLst>
   <p:notesMasterIdLst>
-    <p:notesMasterId xmlns:r="http://schemas.openxmlformats.org/officeDocument/2006/relationships" r:id="Rc7482c2920254ddf"/>
+    <p:notesMasterId xmlns:r="http://schemas.openxmlformats.org/officeDocument/2006/relationships" r:id="R9cb2d47fe83943b2"/>
   </p:notesMasterIdLst>
   <p:sldIdLst>
-    <p:sldId xmlns:r="http://schemas.openxmlformats.org/officeDocument/2006/relationships" id="256" r:id="R3b5ed648c22d45ea"/>
-    <p:sldId xmlns:r="http://schemas.openxmlformats.org/officeDocument/2006/relationships" id="257" r:id="R746fc19ff7bb46cd"/>
-    <p:sldId xmlns:r="http://schemas.openxmlformats.org/officeDocument/2006/relationships" id="258" r:id="Rb2a5f2700eaf4283"/>
-    <p:sldId xmlns:r="http://schemas.openxmlformats.org/officeDocument/2006/relationships" id="259" r:id="R1c16a22f5ad84759"/>
-    <p:sldId xmlns:r="http://schemas.openxmlformats.org/officeDocument/2006/relationships" id="260" r:id="R93316e75399748e2"/>
-    <p:sldId xmlns:r="http://schemas.openxmlformats.org/officeDocument/2006/relationships" id="261" r:id="R565791d54bbd4c8b"/>
-    <p:sldId xmlns:r="http://schemas.openxmlformats.org/officeDocument/2006/relationships" id="262" r:id="Rcff440f29abb46df"/>
-    <p:sldId xmlns:r="http://schemas.openxmlformats.org/officeDocument/2006/relationships" id="263" r:id="R5d808362d649444e"/>
-    <p:sldId xmlns:r="http://schemas.openxmlformats.org/officeDocument/2006/relationships" id="264" r:id="R2610e90ea11c40c8"/>
-    <p:sldId xmlns:r="http://schemas.openxmlformats.org/officeDocument/2006/relationships" id="265" r:id="Rded900b42ad94c79"/>
-    <p:sldId xmlns:r="http://schemas.openxmlformats.org/officeDocument/2006/relationships" id="266" r:id="R6344624bddcf4e17"/>
-    <p:sldId xmlns:r="http://schemas.openxmlformats.org/officeDocument/2006/relationships" id="267" r:id="Rc7644c7e829a47fc"/>
-    <p:sldId xmlns:r="http://schemas.openxmlformats.org/officeDocument/2006/relationships" id="268" r:id="R1f43b7ef0a6647de"/>
+    <p:sldId xmlns:r="http://schemas.openxmlformats.org/officeDocument/2006/relationships" id="256" r:id="R7b871bc12b7a4fd0"/>
+    <p:sldId xmlns:r="http://schemas.openxmlformats.org/officeDocument/2006/relationships" id="257" r:id="Re42c28c83dc547a1"/>
+    <p:sldId xmlns:r="http://schemas.openxmlformats.org/officeDocument/2006/relationships" id="258" r:id="R59d9f3d2494e4722"/>
+    <p:sldId xmlns:r="http://schemas.openxmlformats.org/officeDocument/2006/relationships" id="259" r:id="R69dc6d1d6ff945ee"/>
+    <p:sldId xmlns:r="http://schemas.openxmlformats.org/officeDocument/2006/relationships" id="260" r:id="R4b52cb99b27b440f"/>
+    <p:sldId xmlns:r="http://schemas.openxmlformats.org/officeDocument/2006/relationships" id="261" r:id="Rb8e8f3c968a24493"/>
+    <p:sldId xmlns:r="http://schemas.openxmlformats.org/officeDocument/2006/relationships" id="262" r:id="Rcc91622eb85f43d1"/>
+    <p:sldId xmlns:r="http://schemas.openxmlformats.org/officeDocument/2006/relationships" id="263" r:id="R69422b8cc5164dee"/>
+    <p:sldId xmlns:r="http://schemas.openxmlformats.org/officeDocument/2006/relationships" id="264" r:id="R1e09ddc458e04213"/>
+    <p:sldId xmlns:r="http://schemas.openxmlformats.org/officeDocument/2006/relationships" id="265" r:id="R5a53b77e7751495f"/>
+    <p:sldId xmlns:r="http://schemas.openxmlformats.org/officeDocument/2006/relationships" id="266" r:id="Rbdeac8d0a86644a5"/>
+    <p:sldId xmlns:r="http://schemas.openxmlformats.org/officeDocument/2006/relationships" id="267" r:id="Ra3e0918bd4174f9e"/>
+    <p:sldId xmlns:r="http://schemas.openxmlformats.org/officeDocument/2006/relationships" id="268" r:id="R6628de4e55bc4054"/>
   </p:sldIdLst>
   <p:sldSz cx="12192000" cy="6858000"/>
   <p:notesSz cx="6858000" cy="9144000"/>
@@ -464,7 +464,7 @@
           </a:p>
           <a:p xmlns:a="http://schemas.openxmlformats.org/drawingml/2006/main">
             <a:r>
-              <a:t>Visual source: actual RoadStar application captures where shown. Generated road sculpture is illustrative brand artwork, not geographic or route evidence. Design system: docs/design/precision-transport.md. Current check counts: 22 backend, 23 native mobile. Core slides 1–11 total 10 minutes. Appendix slides 12–13 total 5 minutes.</a:t>
+              <a:t>Visual source: actual RoadStar application captures where shown. Generated road sculpture is illustrative brand artwork, not geographic or route evidence. Design system: docs/design/precision-transport.md. Current accepted check counts: 106 backend, 50 native mobile. Core slides 1–11 total 10 minutes. Appendix slides 12–13 total 5 minutes.</a:t>
             </a:r>
           </a:p>
         </p:txBody>
@@ -534,7 +534,7 @@
           <a:lstStyle xmlns:a="http://schemas.openxmlformats.org/drawingml/2006/main"/>
           <a:p xmlns:a="http://schemas.openxmlformats.org/drawingml/2006/main">
             <a:r>
-              <a:t>55 seconds. Do not claim complete legal HOS, guaranteed2s latency, realdevice/iOS or productioncapacity. Cloud benchmark524 telemetry+524syncpairs, no failures, ownacktosnapshotp955448ms. Real-road group integration separate enabled test. Source artifacts under docs/evidence.</a:t>
+              <a:t>55 seconds. Cloud benchmark: 524 telemetry and synchronization pairs, no failures, acknowledged-write-to-snapshot p95 5,448 ms. A separate five-pair local browser comparison observed eight scripted activations and two requests for manual resource assembly versus two activations and one request for ranked recovery. Both selected the same feasible resources; ranked recovery retained the rejected HOS reason. These are after-login automation counts and local execution timings, not dispatcher task time, carrier savings or production latency. Sources: docs/evidence/cloud-load-test-131-after-concurrency.json and docs/evidence/workflow-comparison-2026-09-12/verification.json. HOS remains a planning aid rather than a certified ELD; physical Android and native iOS remain unverified.</a:t>
             </a:r>
           </a:p>
           <a:p xmlns:a="http://schemas.openxmlformats.org/drawingml/2006/main">
@@ -544,7 +544,7 @@
           </a:p>
           <a:p xmlns:a="http://schemas.openxmlformats.org/drawingml/2006/main">
             <a:r>
-              <a:t>Visual source: actual RoadStar application captures where shown. Generated road sculpture is illustrative brand artwork, not geographic or route evidence. Design system: docs/design/precision-transport.md. Current check counts: 22 backend, 23 native mobile. Core slides 1–11 total 10 minutes. Appendix slides 12–13 total 5 minutes.</a:t>
+              <a:t>Visual source: actual RoadStar application captures where shown. Generated road sculpture is illustrative brand artwork, not geographic or route evidence. Design system: docs/design/precision-transport.md. Current accepted check counts: 106 backend, 50 native mobile. Core slides 1–11 total 10 minutes. Appendix slides 12–13 total 5 minutes.</a:t>
             </a:r>
           </a:p>
         </p:txBody>
@@ -624,7 +624,7 @@
           </a:p>
           <a:p xmlns:a="http://schemas.openxmlformats.org/drawingml/2006/main">
             <a:r>
-              <a:t>Visual source: actual RoadStar application captures where shown. Generated road sculpture is illustrative brand artwork, not geographic or route evidence. Design system: docs/design/precision-transport.md. Current check counts: 22 backend, 23 native mobile. Core slides 1–11 total 10 minutes. Appendix slides 12–13 total 5 minutes.</a:t>
+              <a:t>Visual source: actual RoadStar application captures where shown. Generated road sculpture is illustrative brand artwork, not geographic or route evidence. Design system: docs/design/precision-transport.md. Current accepted check counts: 106 backend, 50 native mobile. Core slides 1–11 total 10 minutes. Appendix slides 12–13 total 5 minutes.</a:t>
             </a:r>
           </a:p>
         </p:txBody>
@@ -704,7 +704,7 @@
           </a:p>
           <a:p xmlns:a="http://schemas.openxmlformats.org/drawingml/2006/main">
             <a:r>
-              <a:t>Visual source: actual RoadStar application captures where shown. Generated road sculpture is illustrative brand artwork, not geographic or route evidence. Design system: docs/design/precision-transport.md. Current check counts: 22 backend, 23 native mobile. Core slides 1–11 total 10 minutes. Appendix slides 12–13 total 5 minutes.</a:t>
+              <a:t>Visual source: actual RoadStar application captures where shown. Generated road sculpture is illustrative brand artwork, not geographic or route evidence. Design system: docs/design/precision-transport.md. Current accepted check counts: 106 backend, 50 native mobile. Core slides 1–11 total 10 minutes. Appendix slides 12–13 total 5 minutes.</a:t>
             </a:r>
           </a:p>
         </p:txBody>
@@ -784,7 +784,7 @@
           </a:p>
           <a:p xmlns:a="http://schemas.openxmlformats.org/drawingml/2006/main">
             <a:r>
-              <a:t>Visual source: actual RoadStar application captures where shown. Generated road sculpture is illustrative brand artwork, not geographic or route evidence. Design system: docs/design/precision-transport.md. Current check counts: 22 backend, 23 native mobile. Core slides 1–11 total 10 minutes. Appendix slides 12–13 total 5 minutes.</a:t>
+              <a:t>Visual source: actual RoadStar application captures where shown. Generated road sculpture is illustrative brand artwork, not geographic or route evidence. Design system: docs/design/precision-transport.md. Current accepted check counts: 106 backend, 50 native mobile. Core slides 1–11 total 10 minutes. Appendix slides 12–13 total 5 minutes.</a:t>
             </a:r>
           </a:p>
         </p:txBody>
@@ -864,7 +864,7 @@
           </a:p>
           <a:p xmlns:a="http://schemas.openxmlformats.org/drawingml/2006/main">
             <a:r>
-              <a:t>Visual source: actual RoadStar application captures where shown. Generated road sculpture is illustrative brand artwork, not geographic or route evidence. Design system: docs/design/precision-transport.md. Current check counts: 22 backend, 23 native mobile. Core slides 1–11 total 10 minutes. Appendix slides 12–13 total 5 minutes.</a:t>
+              <a:t>Visual source: actual RoadStar application captures where shown. Generated road sculpture is illustrative brand artwork, not geographic or route evidence. Design system: docs/design/precision-transport.md. Current accepted check counts: 106 backend, 50 native mobile. Core slides 1–11 total 10 minutes. Appendix slides 12–13 total 5 minutes.</a:t>
             </a:r>
           </a:p>
         </p:txBody>
@@ -944,7 +944,7 @@
           </a:p>
           <a:p xmlns:a="http://schemas.openxmlformats.org/drawingml/2006/main">
             <a:r>
-              <a:t>Visual source: actual RoadStar application captures where shown. Generated road sculpture is illustrative brand artwork, not geographic or route evidence. Design system: docs/design/precision-transport.md. Current check counts: 22 backend, 23 native mobile. Core slides 1–11 total 10 minutes. Appendix slides 12–13 total 5 minutes.</a:t>
+              <a:t>Visual source: actual RoadStar application captures where shown. Generated road sculpture is illustrative brand artwork, not geographic or route evidence. Design system: docs/design/precision-transport.md. Current accepted check counts: 106 backend, 50 native mobile. Core slides 1–11 total 10 minutes. Appendix slides 12–13 total 5 minutes.</a:t>
             </a:r>
           </a:p>
         </p:txBody>
@@ -1024,7 +1024,7 @@
           </a:p>
           <a:p xmlns:a="http://schemas.openxmlformats.org/drawingml/2006/main">
             <a:r>
-              <a:t>Visual source: actual RoadStar application captures where shown. Generated road sculpture is illustrative brand artwork, not geographic or route evidence. Design system: docs/design/precision-transport.md. Current check counts: 22 backend, 23 native mobile. Core slides 1–11 total 10 minutes. Appendix slides 12–13 total 5 minutes.</a:t>
+              <a:t>Visual source: actual RoadStar application captures where shown. Generated road sculpture is illustrative brand artwork, not geographic or route evidence. Design system: docs/design/precision-transport.md. Current accepted check counts: 106 backend, 50 native mobile. Core slides 1–11 total 10 minutes. Appendix slides 12–13 total 5 minutes.</a:t>
             </a:r>
           </a:p>
         </p:txBody>
@@ -1104,7 +1104,7 @@
           </a:p>
           <a:p xmlns:a="http://schemas.openxmlformats.org/drawingml/2006/main">
             <a:r>
-              <a:t>Visual source: actual RoadStar application captures where shown. Generated road sculpture is illustrative brand artwork, not geographic or route evidence. Design system: docs/design/precision-transport.md. Current check counts: 22 backend, 23 native mobile. Core slides 1–11 total 10 minutes. Appendix slides 12–13 total 5 minutes.</a:t>
+              <a:t>Visual source: actual RoadStar application captures where shown. Generated road sculpture is illustrative brand artwork, not geographic or route evidence. Design system: docs/design/precision-transport.md. Current accepted check counts: 106 backend, 50 native mobile. Core slides 1–11 total 10 minutes. Appendix slides 12–13 total 5 minutes.</a:t>
             </a:r>
           </a:p>
         </p:txBody>
@@ -1184,7 +1184,7 @@
           </a:p>
           <a:p xmlns:a="http://schemas.openxmlformats.org/drawingml/2006/main">
             <a:r>
-              <a:t>Visual source: actual RoadStar application captures where shown. Generated road sculpture is illustrative brand artwork, not geographic or route evidence. Design system: docs/design/precision-transport.md. Current check counts: 22 backend, 23 native mobile. Core slides 1–11 total 10 minutes. Appendix slides 12–13 total 5 minutes.</a:t>
+              <a:t>Visual source: actual RoadStar application captures where shown. Generated road sculpture is illustrative brand artwork, not geographic or route evidence. Design system: docs/design/precision-transport.md. Current accepted check counts: 106 backend, 50 native mobile. Core slides 1–11 total 10 minutes. Appendix slides 12–13 total 5 minutes.</a:t>
             </a:r>
           </a:p>
         </p:txBody>
@@ -1264,7 +1264,7 @@
           </a:p>
           <a:p xmlns:a="http://schemas.openxmlformats.org/drawingml/2006/main">
             <a:r>
-              <a:t>Visual source: actual RoadStar application captures where shown. Generated road sculpture is illustrative brand artwork, not geographic or route evidence. Design system: docs/design/precision-transport.md. Current check counts: 22 backend, 23 native mobile. Core slides 1–11 total 10 minutes. Appendix slides 12–13 total 5 minutes.</a:t>
+              <a:t>Visual source: actual RoadStar application captures where shown. Generated road sculpture is illustrative brand artwork, not geographic or route evidence. Design system: docs/design/precision-transport.md. Current accepted check counts: 106 backend, 50 native mobile. Core slides 1–11 total 10 minutes. Appendix slides 12–13 total 5 minutes.</a:t>
             </a:r>
           </a:p>
         </p:txBody>
@@ -1344,7 +1344,7 @@
           </a:p>
           <a:p xmlns:a="http://schemas.openxmlformats.org/drawingml/2006/main">
             <a:r>
-              <a:t>Visual source: actual RoadStar application captures where shown. Generated road sculpture is illustrative brand artwork, not geographic or route evidence. Design system: docs/design/precision-transport.md. Current check counts: 22 backend, 23 native mobile. Core slides 1–11 total 10 minutes. Appendix slides 12–13 total 5 minutes.</a:t>
+              <a:t>Visual source: actual RoadStar application captures where shown. Generated road sculpture is illustrative brand artwork, not geographic or route evidence. Design system: docs/design/precision-transport.md. Current accepted check counts: 106 backend, 50 native mobile. Core slides 1–11 total 10 minutes. Appendix slides 12–13 total 5 minutes.</a:t>
             </a:r>
           </a:p>
         </p:txBody>
@@ -1424,7 +1424,7 @@
           </a:p>
           <a:p xmlns:a="http://schemas.openxmlformats.org/drawingml/2006/main">
             <a:r>
-              <a:t>Visual source: actual RoadStar application captures where shown. Generated road sculpture is illustrative brand artwork, not geographic or route evidence. Design system: docs/design/precision-transport.md. Current check counts: 22 backend, 23 native mobile. Core slides 1–11 total 10 minutes. Appendix slides 12–13 total 5 minutes.</a:t>
+              <a:t>Visual source: actual RoadStar application captures where shown. Generated road sculpture is illustrative brand artwork, not geographic or route evidence. Design system: docs/design/precision-transport.md. Current accepted check counts: 106 backend, 50 native mobile. Core slides 1–11 total 10 minutes. Appendix slides 12–13 total 5 minutes.</a:t>
             </a:r>
           </a:p>
         </p:txBody>
@@ -1492,7 +1492,7 @@
   </p:cSld>
   <p:clrMap bg1="lt1" tx1="dk1" bg2="lt2" tx2="dk2" accent1="accent1" accent2="accent2" accent3="accent3" accent4="accent4" accent5="accent5" accent6="accent6" hlink="hlink" folHlink="folHlink"/>
   <p:sldLayoutIdLst>
-    <p:sldLayoutId xmlns:r="http://schemas.openxmlformats.org/officeDocument/2006/relationships" id="2147483649" r:id="R2a1b26e2931f4a2a"/>
+    <p:sldLayoutId xmlns:r="http://schemas.openxmlformats.org/officeDocument/2006/relationships" id="2147483649" r:id="R37678398267b4320"/>
   </p:sldLayoutIdLst>
   <p:txStyles>
     <p:titleStyle>
@@ -2043,7 +2043,7 @@
           <p:cNvPr id="8" name="">
             <a:extLst xmlns:a="http://schemas.openxmlformats.org/drawingml/2006/main">
               <a:ext uri="{FF2B5EF4-FFF2-40B4-BE49-F238E27FC236}">
-                <a16:creationId xmlns:a16="http://schemas.microsoft.com/office/drawing/2014/main" id="{9A023536-F73A-4B7C-93BD-781348C94BD6}"/>
+                <a16:creationId xmlns:a16="http://schemas.microsoft.com/office/drawing/2014/main" id="{0BCFF40E-8D53-45FE-A8F9-71BE927E5985}"/>
               </a:ext>
             </a:extLst>
           </p:cNvPr>
@@ -2104,7 +2104,7 @@
           <p:nvPr/>
         </p:nvPicPr>
         <p:blipFill>
-          <a:blip xmlns:r="http://schemas.openxmlformats.org/officeDocument/2006/relationships" xmlns:a="http://schemas.openxmlformats.org/drawingml/2006/main" r:embed="R34290a2ec56f4f7a"/>
+          <a:blip xmlns:r="http://schemas.openxmlformats.org/officeDocument/2006/relationships" xmlns:a="http://schemas.openxmlformats.org/drawingml/2006/main" r:embed="R8717b160fc0241e2"/>
           <a:srcRect xmlns:a="http://schemas.openxmlformats.org/drawingml/2006/main" l="0" t="27" r="0" b="27"/>
           <a:stretch xmlns:a="http://schemas.openxmlformats.org/drawingml/2006/main">
             <a:fillRect l="0" t="0" r="0" b="0"/>
@@ -2129,10 +2129,10 @@
           <p:nvPr/>
         </p:nvPicPr>
         <p:blipFill>
-          <a:blip xmlns:r="http://schemas.openxmlformats.org/officeDocument/2006/relationships" xmlns:a="http://schemas.openxmlformats.org/drawingml/2006/main" r:embed="R6bb310e4a35b4702">
+          <a:blip xmlns:r="http://schemas.openxmlformats.org/officeDocument/2006/relationships" xmlns:a="http://schemas.openxmlformats.org/drawingml/2006/main" r:embed="R9566382691604c12">
             <a:extLst>
               <a:ext uri="{96DAC541-7B7A-43D3-8B79-37D633B846F1}">
-                <asvg:svgBlip xmlns:asvg="http://schemas.microsoft.com/office/drawing/2016/SVG/main" r:embed="Rc9144068576f4462"/>
+                <asvg:svgBlip xmlns:asvg="http://schemas.microsoft.com/office/drawing/2016/SVG/main" r:embed="R5c7d8a758ff542cb"/>
               </a:ext>
             </a:extLst>
           </a:blip>
@@ -2153,7 +2153,7 @@
           <p:cNvPr id="4" name="">
             <a:extLst xmlns:a="http://schemas.openxmlformats.org/drawingml/2006/main">
               <a:ext uri="{FF2B5EF4-FFF2-40B4-BE49-F238E27FC236}">
-                <a16:creationId xmlns:a16="http://schemas.microsoft.com/office/drawing/2014/main" id="{F1B04BE6-D931-4B97-9E5D-AF93FD9A2CF9}"/>
+                <a16:creationId xmlns:a16="http://schemas.microsoft.com/office/drawing/2014/main" id="{85D4323C-DC3B-4342-89FF-030E354979F1}"/>
               </a:ext>
             </a:extLst>
           </p:cNvPr>
@@ -2210,7 +2210,7 @@
           <p:cNvPr id="5" name="">
             <a:extLst xmlns:a="http://schemas.openxmlformats.org/drawingml/2006/main">
               <a:ext uri="{FF2B5EF4-FFF2-40B4-BE49-F238E27FC236}">
-                <a16:creationId xmlns:a16="http://schemas.microsoft.com/office/drawing/2014/main" id="{2E7D51E9-9BFB-4FE1-856B-5D74F3668F50}"/>
+                <a16:creationId xmlns:a16="http://schemas.microsoft.com/office/drawing/2014/main" id="{C955D690-0463-41A7-A3AD-FE6E190FB272}"/>
               </a:ext>
             </a:extLst>
           </p:cNvPr>
@@ -2267,7 +2267,7 @@
           <p:cNvPr id="6" name="">
             <a:extLst xmlns:a="http://schemas.openxmlformats.org/drawingml/2006/main">
               <a:ext uri="{FF2B5EF4-FFF2-40B4-BE49-F238E27FC236}">
-                <a16:creationId xmlns:a16="http://schemas.microsoft.com/office/drawing/2014/main" id="{87F2D0C0-C759-4C87-B7C7-25EC9954D76D}"/>
+                <a16:creationId xmlns:a16="http://schemas.microsoft.com/office/drawing/2014/main" id="{006027BC-06EF-446E-B5AD-B21EAB80AC51}"/>
               </a:ext>
             </a:extLst>
           </p:cNvPr>
@@ -2324,7 +2324,7 @@
           <p:cNvPr id="7" name="">
             <a:extLst xmlns:a="http://schemas.openxmlformats.org/drawingml/2006/main">
               <a:ext uri="{FF2B5EF4-FFF2-40B4-BE49-F238E27FC236}">
-                <a16:creationId xmlns:a16="http://schemas.microsoft.com/office/drawing/2014/main" id="{C26C515F-1F03-46E1-A049-F3C73A7EB6B2}"/>
+                <a16:creationId xmlns:a16="http://schemas.microsoft.com/office/drawing/2014/main" id="{CA76D21C-A0B9-494C-BD57-383B9329C84C}"/>
               </a:ext>
             </a:extLst>
           </p:cNvPr>
@@ -2379,7 +2379,7 @@
     </p:spTree>
     <p:extLst>
       <p:ext uri="{BB962C8B-B14F-4D97-AF65-F5344CB8AC3E}">
-        <p14:creationId xmlns:p14="http://schemas.microsoft.com/office/powerpoint/2010/main" val="1521265188"/>
+        <p14:creationId xmlns:p14="http://schemas.microsoft.com/office/powerpoint/2010/main" val="383641279"/>
       </p:ext>
     </p:extLst>
   </p:cSld>
@@ -2407,10 +2407,10 @@
       </p:grpSpPr>
       <p:sp>
         <p:nvSpPr>
-          <p:cNvPr id="9" name="">
-            <a:extLst xmlns:a="http://schemas.openxmlformats.org/drawingml/2006/main">
-              <a:ext uri="{FF2B5EF4-FFF2-40B4-BE49-F238E27FC236}">
-                <a16:creationId xmlns:a16="http://schemas.microsoft.com/office/drawing/2014/main" id="{32300A80-82E3-4E8A-8679-79452E864CA1}"/>
+          <p:cNvPr id="10" name="">
+            <a:extLst xmlns:a="http://schemas.openxmlformats.org/drawingml/2006/main">
+              <a:ext uri="{FF2B5EF4-FFF2-40B4-BE49-F238E27FC236}">
+                <a16:creationId xmlns:a16="http://schemas.microsoft.com/office/drawing/2014/main" id="{88AB904F-8F56-4D34-A8E0-FC078B6AF26E}"/>
               </a:ext>
             </a:extLst>
           </p:cNvPr>
@@ -2467,7 +2467,7 @@
           <p:cNvPr id="2" name="">
             <a:extLst xmlns:a="http://schemas.openxmlformats.org/drawingml/2006/main">
               <a:ext uri="{FF2B5EF4-FFF2-40B4-BE49-F238E27FC236}">
-                <a16:creationId xmlns:a16="http://schemas.microsoft.com/office/drawing/2014/main" id="{8579F888-3A46-4C37-A2FF-A870AD65D88E}"/>
+                <a16:creationId xmlns:a16="http://schemas.microsoft.com/office/drawing/2014/main" id="{9D93FB8F-5E60-4907-8A69-C07D118ACBF9}"/>
               </a:ext>
             </a:extLst>
           </p:cNvPr>
@@ -2524,7 +2524,7 @@
           <p:cNvPr id="3" name="">
             <a:extLst xmlns:a="http://schemas.openxmlformats.org/drawingml/2006/main">
               <a:ext uri="{FF2B5EF4-FFF2-40B4-BE49-F238E27FC236}">
-                <a16:creationId xmlns:a16="http://schemas.microsoft.com/office/drawing/2014/main" id="{CA8ECAC8-39CF-443F-A624-B85D0A550265}"/>
+                <a16:creationId xmlns:a16="http://schemas.microsoft.com/office/drawing/2014/main" id="{9F752442-AB2E-4653-A836-41FCA1126431}"/>
               </a:ext>
             </a:extLst>
           </p:cNvPr>
@@ -2581,7 +2581,7 @@
           <p:cNvPr id="4" name="">
             <a:extLst xmlns:a="http://schemas.openxmlformats.org/drawingml/2006/main">
               <a:ext uri="{FF2B5EF4-FFF2-40B4-BE49-F238E27FC236}">
-                <a16:creationId xmlns:a16="http://schemas.microsoft.com/office/drawing/2014/main" id="{EBBFCFA8-7CA9-4961-9891-6B168B668868}"/>
+                <a16:creationId xmlns:a16="http://schemas.microsoft.com/office/drawing/2014/main" id="{D3B2303E-4B12-43FC-A75F-F4E125CDC846}"/>
               </a:ext>
             </a:extLst>
           </p:cNvPr>
@@ -2661,7 +2661,7 @@
           <p:cNvPr id="5" name="">
             <a:extLst xmlns:a="http://schemas.openxmlformats.org/drawingml/2006/main">
               <a:ext uri="{FF2B5EF4-FFF2-40B4-BE49-F238E27FC236}">
-                <a16:creationId xmlns:a16="http://schemas.microsoft.com/office/drawing/2014/main" id="{C6FD6CFE-026E-44D8-8B60-7EE59D215F4D}"/>
+                <a16:creationId xmlns:a16="http://schemas.microsoft.com/office/drawing/2014/main" id="{52FA232B-DF6B-4781-8E33-BD7CFE94BAD6}"/>
               </a:ext>
             </a:extLst>
           </p:cNvPr>
@@ -2718,7 +2718,7 @@
           <p:cNvPr id="6" name="">
             <a:extLst xmlns:a="http://schemas.openxmlformats.org/drawingml/2006/main">
               <a:ext uri="{FF2B5EF4-FFF2-40B4-BE49-F238E27FC236}">
-                <a16:creationId xmlns:a16="http://schemas.microsoft.com/office/drawing/2014/main" id="{3CBEA7E5-801C-494A-8F5C-8538792CB532}"/>
+                <a16:creationId xmlns:a16="http://schemas.microsoft.com/office/drawing/2014/main" id="{2E3184BB-1706-4A1E-9668-029F3FAD4D2C}"/>
               </a:ext>
             </a:extLst>
           </p:cNvPr>
@@ -2798,19 +2798,19 @@
           <p:cNvPr id="7" name="">
             <a:extLst xmlns:a="http://schemas.openxmlformats.org/drawingml/2006/main">
               <a:ext uri="{FF2B5EF4-FFF2-40B4-BE49-F238E27FC236}">
-                <a16:creationId xmlns:a16="http://schemas.microsoft.com/office/drawing/2014/main" id="{3F6111C9-6968-4D90-82F3-81769C441BC9}"/>
-              </a:ext>
-            </a:extLst>
-          </p:cNvPr>
-          <p:cNvSpPr>
-            <a:spLocks xmlns:a="http://schemas.openxmlformats.org/drawingml/2006/main" noGrp="1"/>
-          </p:cNvSpPr>
-          <p:nvPr/>
-        </p:nvSpPr>
-        <p:spPr>
-          <a:xfrm xmlns:a="http://schemas.openxmlformats.org/drawingml/2006/main">
-            <a:off x="638175" y="4972050"/>
-            <a:ext cx="6305550" cy="1247775"/>
+                <a16:creationId xmlns:a16="http://schemas.microsoft.com/office/drawing/2014/main" id="{2FDD97AE-D88E-41A5-90DF-276F813C45EE}"/>
+              </a:ext>
+            </a:extLst>
+          </p:cNvPr>
+          <p:cNvSpPr>
+            <a:spLocks xmlns:a="http://schemas.openxmlformats.org/drawingml/2006/main" noGrp="1"/>
+          </p:cNvSpPr>
+          <p:nvPr/>
+        </p:nvSpPr>
+        <p:spPr>
+          <a:xfrm xmlns:a="http://schemas.openxmlformats.org/drawingml/2006/main">
+            <a:off x="638175" y="4762500"/>
+            <a:ext cx="6305550" cy="1219200"/>
           </a:xfrm>
           <a:prstGeom xmlns:a="http://schemas.openxmlformats.org/drawingml/2006/main" prst="rect">
             <a:avLst/>
@@ -2845,7 +2845,7 @@
                 <a:ea typeface="Manrope"/>
                 <a:cs typeface="Manrope"/>
               </a:rPr>
-              <a:t>22 backend checks</a:t>
+              <a:t>Manual 8 / ranked 2 activations</a:t>
             </a:r>
           </a:p>
           <a:p xmlns:a="http://schemas.openxmlformats.org/drawingml/2006/main">
@@ -2868,7 +2868,7 @@
                 <a:ea typeface="Manrope"/>
                 <a:cs typeface="Manrope"/>
               </a:rPr>
-              <a:t>23 mobile checks</a:t>
+              <a:t>Manual 2 / ranked 1 recovery requests</a:t>
             </a:r>
           </a:p>
           <a:p xmlns:a="http://schemas.openxmlformats.org/drawingml/2006/main">
@@ -2891,7 +2891,7 @@
                 <a:ea typeface="Manrope"/>
                 <a:cs typeface="Manrope"/>
               </a:rPr>
-              <a:t>Real-road integration verified separately</a:t>
+              <a:t>Five matched synthetic browser pairs</a:t>
             </a:r>
           </a:p>
         </p:txBody>
@@ -2901,7 +2901,64 @@
           <p:cNvPr id="8" name="">
             <a:extLst xmlns:a="http://schemas.openxmlformats.org/drawingml/2006/main">
               <a:ext uri="{FF2B5EF4-FFF2-40B4-BE49-F238E27FC236}">
-                <a16:creationId xmlns:a16="http://schemas.microsoft.com/office/drawing/2014/main" id="{FC28723A-440C-461D-BDC4-C64168D456F3}"/>
+                <a16:creationId xmlns:a16="http://schemas.microsoft.com/office/drawing/2014/main" id="{FB7E3D7C-4E33-4A46-8596-F486E40CFE12}"/>
+              </a:ext>
+            </a:extLst>
+          </p:cNvPr>
+          <p:cNvSpPr>
+            <a:spLocks xmlns:a="http://schemas.openxmlformats.org/drawingml/2006/main" noGrp="1"/>
+          </p:cNvSpPr>
+          <p:nvPr/>
+        </p:nvSpPr>
+        <p:spPr>
+          <a:xfrm xmlns:a="http://schemas.openxmlformats.org/drawingml/2006/main">
+            <a:off x="638175" y="6076950"/>
+            <a:ext cx="6305550" cy="285750"/>
+          </a:xfrm>
+          <a:prstGeom xmlns:a="http://schemas.openxmlformats.org/drawingml/2006/main" prst="rect">
+            <a:avLst/>
+          </a:prstGeom>
+          <a:noFill xmlns:a="http://schemas.openxmlformats.org/drawingml/2006/main"/>
+          <a:ln xmlns:a="http://schemas.openxmlformats.org/drawingml/2006/main" w="0">
+            <a:noFill/>
+          </a:ln>
+        </p:spPr>
+        <p:txBody>
+          <a:bodyPr xmlns:a="http://schemas.openxmlformats.org/drawingml/2006/main">
+            <a:noAutofit/>
+          </a:bodyPr>
+          <a:lstStyle xmlns:a="http://schemas.openxmlformats.org/drawingml/2006/main"/>
+          <a:p xmlns:a="http://schemas.openxmlformats.org/drawingml/2006/main">
+            <a:pPr>
+              <a:defRPr sz="1275" b="0">
+                <a:solidFill>
+                  <a:srgbClr val="BFC2BA"/>
+                </a:solidFill>
+                <a:latin typeface="Manrope"/>
+                <a:ea typeface="Manrope"/>
+                <a:cs typeface="Manrope"/>
+              </a:defRPr>
+            </a:pPr>
+            <a:r>
+              <a:rPr sz="1275" b="0">
+                <a:solidFill>
+                  <a:srgbClr val="BFC2BA"/>
+                </a:solidFill>
+                <a:latin typeface="Manrope"/>
+                <a:ea typeface="Manrope"/>
+                <a:cs typeface="Manrope"/>
+              </a:rPr>
+              <a:t>After login. Scripted counts, not human task time.</a:t>
+            </a:r>
+          </a:p>
+        </p:txBody>
+      </p:sp>
+      <p:sp>
+        <p:nvSpPr>
+          <p:cNvPr id="9" name="">
+            <a:extLst xmlns:a="http://schemas.openxmlformats.org/drawingml/2006/main">
+              <a:ext uri="{FF2B5EF4-FFF2-40B4-BE49-F238E27FC236}">
+                <a16:creationId xmlns:a16="http://schemas.microsoft.com/office/drawing/2014/main" id="{2E56CCF0-B031-4FC4-B038-D3011B5173C7}"/>
               </a:ext>
             </a:extLst>
           </p:cNvPr>
@@ -2979,7 +3036,7 @@
     </p:spTree>
     <p:extLst>
       <p:ext uri="{BB962C8B-B14F-4D97-AF65-F5344CB8AC3E}">
-        <p14:creationId xmlns:p14="http://schemas.microsoft.com/office/powerpoint/2010/main" val="312122875"/>
+        <p14:creationId xmlns:p14="http://schemas.microsoft.com/office/powerpoint/2010/main" val="1668099478"/>
       </p:ext>
     </p:extLst>
   </p:cSld>
@@ -3010,7 +3067,7 @@
           <p:cNvPr id="6" name="">
             <a:extLst xmlns:a="http://schemas.openxmlformats.org/drawingml/2006/main">
               <a:ext uri="{FF2B5EF4-FFF2-40B4-BE49-F238E27FC236}">
-                <a16:creationId xmlns:a16="http://schemas.microsoft.com/office/drawing/2014/main" id="{3CCEC802-CB3C-44A6-916D-276767B46F2E}"/>
+                <a16:creationId xmlns:a16="http://schemas.microsoft.com/office/drawing/2014/main" id="{1E7DA67A-2611-4EAA-BE41-8DC845A853C7}"/>
               </a:ext>
             </a:extLst>
           </p:cNvPr>
@@ -3071,7 +3128,7 @@
           <p:nvPr/>
         </p:nvPicPr>
         <p:blipFill>
-          <a:blip xmlns:r="http://schemas.openxmlformats.org/officeDocument/2006/relationships" xmlns:a="http://schemas.openxmlformats.org/drawingml/2006/main" r:embed="R8cfa346cc0744942"/>
+          <a:blip xmlns:r="http://schemas.openxmlformats.org/officeDocument/2006/relationships" xmlns:a="http://schemas.openxmlformats.org/drawingml/2006/main" r:embed="R6ab6f1d078e54a00"/>
           <a:srcRect xmlns:a="http://schemas.openxmlformats.org/drawingml/2006/main" l="0" t="27" r="0" b="27"/>
           <a:stretch xmlns:a="http://schemas.openxmlformats.org/drawingml/2006/main">
             <a:fillRect l="0" t="0" r="0" b="0"/>
@@ -3092,7 +3149,7 @@
           <p:cNvPr id="3" name="">
             <a:extLst xmlns:a="http://schemas.openxmlformats.org/drawingml/2006/main">
               <a:ext uri="{FF2B5EF4-FFF2-40B4-BE49-F238E27FC236}">
-                <a16:creationId xmlns:a16="http://schemas.microsoft.com/office/drawing/2014/main" id="{E0001B5A-BCBF-4426-899C-8C926AAECEB7}"/>
+                <a16:creationId xmlns:a16="http://schemas.microsoft.com/office/drawing/2014/main" id="{C2986A70-7017-4238-AB21-0C16074C22E1}"/>
               </a:ext>
             </a:extLst>
           </p:cNvPr>
@@ -3172,7 +3229,7 @@
           <p:cNvPr id="4" name="">
             <a:extLst xmlns:a="http://schemas.openxmlformats.org/drawingml/2006/main">
               <a:ext uri="{FF2B5EF4-FFF2-40B4-BE49-F238E27FC236}">
-                <a16:creationId xmlns:a16="http://schemas.microsoft.com/office/drawing/2014/main" id="{27D53EEA-C0B6-47E0-8645-2B6E4C5BF974}"/>
+                <a16:creationId xmlns:a16="http://schemas.microsoft.com/office/drawing/2014/main" id="{D5A0795E-7E20-407A-B2BC-FBC9DB3F4CC9}"/>
               </a:ext>
             </a:extLst>
           </p:cNvPr>
@@ -3275,7 +3332,7 @@
           <p:cNvPr id="5" name="">
             <a:extLst xmlns:a="http://schemas.openxmlformats.org/drawingml/2006/main">
               <a:ext uri="{FF2B5EF4-FFF2-40B4-BE49-F238E27FC236}">
-                <a16:creationId xmlns:a16="http://schemas.microsoft.com/office/drawing/2014/main" id="{C6857729-5B77-43BB-80D2-ED163B856C75}"/>
+                <a16:creationId xmlns:a16="http://schemas.microsoft.com/office/drawing/2014/main" id="{D860FEED-5ACC-40A9-95E2-42663FFD48DD}"/>
               </a:ext>
             </a:extLst>
           </p:cNvPr>
@@ -3330,7 +3387,7 @@
     </p:spTree>
     <p:extLst>
       <p:ext uri="{BB962C8B-B14F-4D97-AF65-F5344CB8AC3E}">
-        <p14:creationId xmlns:p14="http://schemas.microsoft.com/office/powerpoint/2010/main" val="1215483848"/>
+        <p14:creationId xmlns:p14="http://schemas.microsoft.com/office/powerpoint/2010/main" val="1019090079"/>
       </p:ext>
     </p:extLst>
   </p:cSld>
@@ -3361,7 +3418,7 @@
           <p:cNvPr id="13" name="">
             <a:extLst xmlns:a="http://schemas.openxmlformats.org/drawingml/2006/main">
               <a:ext uri="{FF2B5EF4-FFF2-40B4-BE49-F238E27FC236}">
-                <a16:creationId xmlns:a16="http://schemas.microsoft.com/office/drawing/2014/main" id="{204D8AE8-0905-4A2D-ACFB-41BDA2F7FBF2}"/>
+                <a16:creationId xmlns:a16="http://schemas.microsoft.com/office/drawing/2014/main" id="{0007641B-4262-4754-94B4-F74ACAC81F5D}"/>
               </a:ext>
             </a:extLst>
           </p:cNvPr>
@@ -3418,7 +3475,7 @@
           <p:cNvPr id="2" name="">
             <a:extLst xmlns:a="http://schemas.openxmlformats.org/drawingml/2006/main">
               <a:ext uri="{FF2B5EF4-FFF2-40B4-BE49-F238E27FC236}">
-                <a16:creationId xmlns:a16="http://schemas.microsoft.com/office/drawing/2014/main" id="{C4992F9E-8C6F-442C-8E8D-DFD5EF10DD3A}"/>
+                <a16:creationId xmlns:a16="http://schemas.microsoft.com/office/drawing/2014/main" id="{03A4B246-DB50-4334-A567-30163E3F7502}"/>
               </a:ext>
             </a:extLst>
           </p:cNvPr>
@@ -3475,7 +3532,7 @@
           <p:cNvPr id="3" name="">
             <a:extLst xmlns:a="http://schemas.openxmlformats.org/drawingml/2006/main">
               <a:ext uri="{FF2B5EF4-FFF2-40B4-BE49-F238E27FC236}">
-                <a16:creationId xmlns:a16="http://schemas.microsoft.com/office/drawing/2014/main" id="{7F7E4B0F-614A-4DB9-883D-F9448CC5BA76}"/>
+                <a16:creationId xmlns:a16="http://schemas.microsoft.com/office/drawing/2014/main" id="{C468119B-ABF3-4756-BAE2-D730A8461524}"/>
               </a:ext>
             </a:extLst>
           </p:cNvPr>
@@ -3532,7 +3589,7 @@
           <p:cNvPr id="4" name="">
             <a:extLst xmlns:a="http://schemas.openxmlformats.org/drawingml/2006/main">
               <a:ext uri="{FF2B5EF4-FFF2-40B4-BE49-F238E27FC236}">
-                <a16:creationId xmlns:a16="http://schemas.microsoft.com/office/drawing/2014/main" id="{D66B1AE4-A634-40F3-9170-B859DE568CAD}"/>
+                <a16:creationId xmlns:a16="http://schemas.microsoft.com/office/drawing/2014/main" id="{1D993BD8-AA14-491F-8838-EC922413BE73}"/>
               </a:ext>
             </a:extLst>
           </p:cNvPr>
@@ -3589,7 +3646,7 @@
           <p:cNvPr id="5" name="">
             <a:extLst xmlns:a="http://schemas.openxmlformats.org/drawingml/2006/main">
               <a:ext uri="{FF2B5EF4-FFF2-40B4-BE49-F238E27FC236}">
-                <a16:creationId xmlns:a16="http://schemas.microsoft.com/office/drawing/2014/main" id="{CA843BFA-AB40-4959-8F41-3306837DB91A}"/>
+                <a16:creationId xmlns:a16="http://schemas.microsoft.com/office/drawing/2014/main" id="{908FB52B-B52F-4695-95D7-EBC751DBDB85}"/>
               </a:ext>
             </a:extLst>
           </p:cNvPr>
@@ -3646,7 +3703,7 @@
           <p:cNvPr id="6" name="">
             <a:extLst xmlns:a="http://schemas.openxmlformats.org/drawingml/2006/main">
               <a:ext uri="{FF2B5EF4-FFF2-40B4-BE49-F238E27FC236}">
-                <a16:creationId xmlns:a16="http://schemas.microsoft.com/office/drawing/2014/main" id="{8F501B34-34D1-4E66-927D-45261169C20A}"/>
+                <a16:creationId xmlns:a16="http://schemas.microsoft.com/office/drawing/2014/main" id="{DE145C97-62D6-496F-8ACD-78AEC937F4D1}"/>
               </a:ext>
             </a:extLst>
           </p:cNvPr>
@@ -3753,7 +3810,7 @@
           <p:cNvPr id="9" name="">
             <a:extLst xmlns:a="http://schemas.openxmlformats.org/drawingml/2006/main">
               <a:ext uri="{FF2B5EF4-FFF2-40B4-BE49-F238E27FC236}">
-                <a16:creationId xmlns:a16="http://schemas.microsoft.com/office/drawing/2014/main" id="{C9EF697B-A841-49E3-A60F-F3F7A3224FB9}"/>
+                <a16:creationId xmlns:a16="http://schemas.microsoft.com/office/drawing/2014/main" id="{83078855-9310-4F19-A953-9B670CB5EA57}"/>
               </a:ext>
             </a:extLst>
           </p:cNvPr>
@@ -3833,7 +3890,7 @@
           <p:cNvPr id="10" name="">
             <a:extLst xmlns:a="http://schemas.openxmlformats.org/drawingml/2006/main">
               <a:ext uri="{FF2B5EF4-FFF2-40B4-BE49-F238E27FC236}">
-                <a16:creationId xmlns:a16="http://schemas.microsoft.com/office/drawing/2014/main" id="{B213184A-82E9-4AF8-8766-08D700D3AC89}"/>
+                <a16:creationId xmlns:a16="http://schemas.microsoft.com/office/drawing/2014/main" id="{FCD240DC-8DE8-4A4E-81C4-920154D1B7F7}"/>
               </a:ext>
             </a:extLst>
           </p:cNvPr>
@@ -3913,7 +3970,7 @@
           <p:cNvPr id="11" name="">
             <a:extLst xmlns:a="http://schemas.openxmlformats.org/drawingml/2006/main">
               <a:ext uri="{FF2B5EF4-FFF2-40B4-BE49-F238E27FC236}">
-                <a16:creationId xmlns:a16="http://schemas.microsoft.com/office/drawing/2014/main" id="{A6B4EF68-90C5-45A5-BBCA-FE1718F772E8}"/>
+                <a16:creationId xmlns:a16="http://schemas.microsoft.com/office/drawing/2014/main" id="{BE4D95FB-FE5E-4A81-94DD-B4118D8D6663}"/>
               </a:ext>
             </a:extLst>
           </p:cNvPr>
@@ -3993,7 +4050,7 @@
           <p:cNvPr id="12" name="">
             <a:extLst xmlns:a="http://schemas.openxmlformats.org/drawingml/2006/main">
               <a:ext uri="{FF2B5EF4-FFF2-40B4-BE49-F238E27FC236}">
-                <a16:creationId xmlns:a16="http://schemas.microsoft.com/office/drawing/2014/main" id="{A6B132ED-5808-4526-9DC3-70B85927A07B}"/>
+                <a16:creationId xmlns:a16="http://schemas.microsoft.com/office/drawing/2014/main" id="{E945BBAA-437D-43AF-A07F-006D30959EEB}"/>
               </a:ext>
             </a:extLst>
           </p:cNvPr>
@@ -4048,7 +4105,7 @@
     </p:spTree>
     <p:extLst>
       <p:ext uri="{BB962C8B-B14F-4D97-AF65-F5344CB8AC3E}">
-        <p14:creationId xmlns:p14="http://schemas.microsoft.com/office/powerpoint/2010/main" val="2127536711"/>
+        <p14:creationId xmlns:p14="http://schemas.microsoft.com/office/powerpoint/2010/main" val="514305922"/>
       </p:ext>
     </p:extLst>
   </p:cSld>
@@ -4079,7 +4136,7 @@
           <p:cNvPr id="8" name="">
             <a:extLst xmlns:a="http://schemas.openxmlformats.org/drawingml/2006/main">
               <a:ext uri="{FF2B5EF4-FFF2-40B4-BE49-F238E27FC236}">
-                <a16:creationId xmlns:a16="http://schemas.microsoft.com/office/drawing/2014/main" id="{D61937FA-19D6-41E9-96EB-EEE57B4FF498}"/>
+                <a16:creationId xmlns:a16="http://schemas.microsoft.com/office/drawing/2014/main" id="{6EC85E57-F9B5-45FD-91D6-B94B9D88F258}"/>
               </a:ext>
             </a:extLst>
           </p:cNvPr>
@@ -4136,7 +4193,7 @@
           <p:cNvPr id="2" name="">
             <a:extLst xmlns:a="http://schemas.openxmlformats.org/drawingml/2006/main">
               <a:ext uri="{FF2B5EF4-FFF2-40B4-BE49-F238E27FC236}">
-                <a16:creationId xmlns:a16="http://schemas.microsoft.com/office/drawing/2014/main" id="{A9B9875D-B1A8-4A97-B22C-7B661F0B74AF}"/>
+                <a16:creationId xmlns:a16="http://schemas.microsoft.com/office/drawing/2014/main" id="{43769462-D992-48A3-83FE-96197629717F}"/>
               </a:ext>
             </a:extLst>
           </p:cNvPr>
@@ -4193,7 +4250,7 @@
           <p:cNvPr id="3" name="">
             <a:extLst xmlns:a="http://schemas.openxmlformats.org/drawingml/2006/main">
               <a:ext uri="{FF2B5EF4-FFF2-40B4-BE49-F238E27FC236}">
-                <a16:creationId xmlns:a16="http://schemas.microsoft.com/office/drawing/2014/main" id="{02FD4077-66CD-43A4-B0DA-2EF88EB4D064}"/>
+                <a16:creationId xmlns:a16="http://schemas.microsoft.com/office/drawing/2014/main" id="{AC9131F1-0931-466B-B1A8-F1DF47D9E294}"/>
               </a:ext>
             </a:extLst>
           </p:cNvPr>
@@ -4250,7 +4307,7 @@
           <p:cNvPr id="4" name="">
             <a:extLst xmlns:a="http://schemas.openxmlformats.org/drawingml/2006/main">
               <a:ext uri="{FF2B5EF4-FFF2-40B4-BE49-F238E27FC236}">
-                <a16:creationId xmlns:a16="http://schemas.microsoft.com/office/drawing/2014/main" id="{EE168782-B04F-461D-851F-10E6A5C622F1}"/>
+                <a16:creationId xmlns:a16="http://schemas.microsoft.com/office/drawing/2014/main" id="{897BB7A1-5DF1-46AC-9C01-06E07DE9440A}"/>
               </a:ext>
             </a:extLst>
           </p:cNvPr>
@@ -4307,7 +4364,7 @@
           <p:cNvPr id="5" name="">
             <a:extLst xmlns:a="http://schemas.openxmlformats.org/drawingml/2006/main">
               <a:ext uri="{FF2B5EF4-FFF2-40B4-BE49-F238E27FC236}">
-                <a16:creationId xmlns:a16="http://schemas.microsoft.com/office/drawing/2014/main" id="{26FF2208-EA8D-44A1-9880-B6FF60D0A47B}"/>
+                <a16:creationId xmlns:a16="http://schemas.microsoft.com/office/drawing/2014/main" id="{7760A21E-AAA2-407A-8FD6-BB68ADCD8064}"/>
               </a:ext>
             </a:extLst>
           </p:cNvPr>
@@ -4410,7 +4467,7 @@
           <p:cNvPr id="6" name="">
             <a:extLst xmlns:a="http://schemas.openxmlformats.org/drawingml/2006/main">
               <a:ext uri="{FF2B5EF4-FFF2-40B4-BE49-F238E27FC236}">
-                <a16:creationId xmlns:a16="http://schemas.microsoft.com/office/drawing/2014/main" id="{748BC6A2-7A22-4A24-B1D8-369B8E555FEB}"/>
+                <a16:creationId xmlns:a16="http://schemas.microsoft.com/office/drawing/2014/main" id="{58A428E8-B9E6-4611-88B9-E2702D53C524}"/>
               </a:ext>
             </a:extLst>
           </p:cNvPr>
@@ -4513,7 +4570,7 @@
           <p:cNvPr id="7" name="">
             <a:extLst xmlns:a="http://schemas.openxmlformats.org/drawingml/2006/main">
               <a:ext uri="{FF2B5EF4-FFF2-40B4-BE49-F238E27FC236}">
-                <a16:creationId xmlns:a16="http://schemas.microsoft.com/office/drawing/2014/main" id="{B0452D18-851B-43D3-934A-65DDF5B24DA2}"/>
+                <a16:creationId xmlns:a16="http://schemas.microsoft.com/office/drawing/2014/main" id="{B3E8382B-593D-48E8-8F4D-8F497E0E2C5F}"/>
               </a:ext>
             </a:extLst>
           </p:cNvPr>
@@ -4568,7 +4625,7 @@
     </p:spTree>
     <p:extLst>
       <p:ext uri="{BB962C8B-B14F-4D97-AF65-F5344CB8AC3E}">
-        <p14:creationId xmlns:p14="http://schemas.microsoft.com/office/powerpoint/2010/main" val="1157121252"/>
+        <p14:creationId xmlns:p14="http://schemas.microsoft.com/office/powerpoint/2010/main" val="108231240"/>
       </p:ext>
     </p:extLst>
   </p:cSld>
@@ -4599,7 +4656,7 @@
           <p:cNvPr id="10" name="">
             <a:extLst xmlns:a="http://schemas.openxmlformats.org/drawingml/2006/main">
               <a:ext uri="{FF2B5EF4-FFF2-40B4-BE49-F238E27FC236}">
-                <a16:creationId xmlns:a16="http://schemas.microsoft.com/office/drawing/2014/main" id="{D6D61344-CD4D-4D90-B4FE-B749943CF198}"/>
+                <a16:creationId xmlns:a16="http://schemas.microsoft.com/office/drawing/2014/main" id="{DADB0928-70AA-429E-9058-99B849D418A3}"/>
               </a:ext>
             </a:extLst>
           </p:cNvPr>
@@ -4656,7 +4713,7 @@
           <p:cNvPr id="2" name="">
             <a:extLst xmlns:a="http://schemas.openxmlformats.org/drawingml/2006/main">
               <a:ext uri="{FF2B5EF4-FFF2-40B4-BE49-F238E27FC236}">
-                <a16:creationId xmlns:a16="http://schemas.microsoft.com/office/drawing/2014/main" id="{7F51A4B5-457C-4A6D-9D84-96E8E5B04391}"/>
+                <a16:creationId xmlns:a16="http://schemas.microsoft.com/office/drawing/2014/main" id="{4EFFF1A5-4809-473C-8800-D8371BB5FCBD}"/>
               </a:ext>
             </a:extLst>
           </p:cNvPr>
@@ -4759,7 +4816,7 @@
           <p:cNvPr id="3" name="">
             <a:extLst xmlns:a="http://schemas.openxmlformats.org/drawingml/2006/main">
               <a:ext uri="{FF2B5EF4-FFF2-40B4-BE49-F238E27FC236}">
-                <a16:creationId xmlns:a16="http://schemas.microsoft.com/office/drawing/2014/main" id="{D8242DBD-E0D4-40D2-9D33-716D35159C6E}"/>
+                <a16:creationId xmlns:a16="http://schemas.microsoft.com/office/drawing/2014/main" id="{B37FE533-50DB-4AAD-AEDB-BE42CAAE0631}"/>
               </a:ext>
             </a:extLst>
           </p:cNvPr>
@@ -4816,7 +4873,7 @@
           <p:cNvPr id="4" name="">
             <a:extLst xmlns:a="http://schemas.openxmlformats.org/drawingml/2006/main">
               <a:ext uri="{FF2B5EF4-FFF2-40B4-BE49-F238E27FC236}">
-                <a16:creationId xmlns:a16="http://schemas.microsoft.com/office/drawing/2014/main" id="{CE059BDE-43D0-414D-A6C7-1D1C7157A6CB}"/>
+                <a16:creationId xmlns:a16="http://schemas.microsoft.com/office/drawing/2014/main" id="{B5BA0B99-9BE6-46DF-AF0D-73F4385E672A}"/>
               </a:ext>
             </a:extLst>
           </p:cNvPr>
@@ -4873,7 +4930,7 @@
           <p:cNvPr id="5" name="">
             <a:extLst xmlns:a="http://schemas.openxmlformats.org/drawingml/2006/main">
               <a:ext uri="{FF2B5EF4-FFF2-40B4-BE49-F238E27FC236}">
-                <a16:creationId xmlns:a16="http://schemas.microsoft.com/office/drawing/2014/main" id="{C2D7E8D6-C947-4E9E-A36F-6B6FC6695C6A}"/>
+                <a16:creationId xmlns:a16="http://schemas.microsoft.com/office/drawing/2014/main" id="{5B8DA382-AABB-4BD3-99A4-726C4DB49A69}"/>
               </a:ext>
             </a:extLst>
           </p:cNvPr>
@@ -4955,7 +5012,7 @@
           <p:cNvPr id="7" name="">
             <a:extLst xmlns:a="http://schemas.openxmlformats.org/drawingml/2006/main">
               <a:ext uri="{FF2B5EF4-FFF2-40B4-BE49-F238E27FC236}">
-                <a16:creationId xmlns:a16="http://schemas.microsoft.com/office/drawing/2014/main" id="{CA286ACF-CB7E-44BA-A738-C9800C3EE770}"/>
+                <a16:creationId xmlns:a16="http://schemas.microsoft.com/office/drawing/2014/main" id="{FAFA4924-6E24-45B0-8EB8-451733EE5A46}"/>
               </a:ext>
             </a:extLst>
           </p:cNvPr>
@@ -5012,7 +5069,7 @@
           <p:cNvPr id="8" name="">
             <a:extLst xmlns:a="http://schemas.openxmlformats.org/drawingml/2006/main">
               <a:ext uri="{FF2B5EF4-FFF2-40B4-BE49-F238E27FC236}">
-                <a16:creationId xmlns:a16="http://schemas.microsoft.com/office/drawing/2014/main" id="{845E0B6E-6F03-4DA7-B5D9-577A1B3123B3}"/>
+                <a16:creationId xmlns:a16="http://schemas.microsoft.com/office/drawing/2014/main" id="{019E4D4E-BAFF-43DE-9C8B-E21B3F34139B}"/>
               </a:ext>
             </a:extLst>
           </p:cNvPr>
@@ -5115,7 +5172,7 @@
           <p:cNvPr id="9" name="">
             <a:extLst xmlns:a="http://schemas.openxmlformats.org/drawingml/2006/main">
               <a:ext uri="{FF2B5EF4-FFF2-40B4-BE49-F238E27FC236}">
-                <a16:creationId xmlns:a16="http://schemas.microsoft.com/office/drawing/2014/main" id="{54F09C6A-A8D9-408E-AA4F-27FDE5D3EDCF}"/>
+                <a16:creationId xmlns:a16="http://schemas.microsoft.com/office/drawing/2014/main" id="{E7E0C8B6-E051-4E76-A81F-F2AE12E187CA}"/>
               </a:ext>
             </a:extLst>
           </p:cNvPr>
@@ -5170,7 +5227,7 @@
     </p:spTree>
     <p:extLst>
       <p:ext uri="{BB962C8B-B14F-4D97-AF65-F5344CB8AC3E}">
-        <p14:creationId xmlns:p14="http://schemas.microsoft.com/office/powerpoint/2010/main" val="505526585"/>
+        <p14:creationId xmlns:p14="http://schemas.microsoft.com/office/powerpoint/2010/main" val="1131245190"/>
       </p:ext>
     </p:extLst>
   </p:cSld>
@@ -5201,7 +5258,7 @@
           <p:cNvPr id="12" name="">
             <a:extLst xmlns:a="http://schemas.openxmlformats.org/drawingml/2006/main">
               <a:ext uri="{FF2B5EF4-FFF2-40B4-BE49-F238E27FC236}">
-                <a16:creationId xmlns:a16="http://schemas.microsoft.com/office/drawing/2014/main" id="{03DCD849-BEF6-4E43-A058-818828C8113C}"/>
+                <a16:creationId xmlns:a16="http://schemas.microsoft.com/office/drawing/2014/main" id="{98B8821B-1DFA-4EC5-A030-69AFBE14D18D}"/>
               </a:ext>
             </a:extLst>
           </p:cNvPr>
@@ -5258,7 +5315,7 @@
           <p:cNvPr id="2" name="">
             <a:extLst xmlns:a="http://schemas.openxmlformats.org/drawingml/2006/main">
               <a:ext uri="{FF2B5EF4-FFF2-40B4-BE49-F238E27FC236}">
-                <a16:creationId xmlns:a16="http://schemas.microsoft.com/office/drawing/2014/main" id="{4130EDF0-BB01-4E86-8577-D15A19B1BCC3}"/>
+                <a16:creationId xmlns:a16="http://schemas.microsoft.com/office/drawing/2014/main" id="{BBE6F048-25F6-4325-A175-DDB8061F7AD9}"/>
               </a:ext>
             </a:extLst>
           </p:cNvPr>
@@ -5315,7 +5372,7 @@
           <p:cNvPr id="3" name="">
             <a:extLst xmlns:a="http://schemas.openxmlformats.org/drawingml/2006/main">
               <a:ext uri="{FF2B5EF4-FFF2-40B4-BE49-F238E27FC236}">
-                <a16:creationId xmlns:a16="http://schemas.microsoft.com/office/drawing/2014/main" id="{0C73F5FB-7191-4B66-8954-518301D9B2AB}"/>
+                <a16:creationId xmlns:a16="http://schemas.microsoft.com/office/drawing/2014/main" id="{EFEBA528-46CB-4A33-922C-1F4BAB7496FF}"/>
               </a:ext>
             </a:extLst>
           </p:cNvPr>
@@ -5376,7 +5433,7 @@
           <p:nvPr/>
         </p:nvPicPr>
         <p:blipFill>
-          <a:blip xmlns:r="http://schemas.openxmlformats.org/officeDocument/2006/relationships" xmlns:a="http://schemas.openxmlformats.org/drawingml/2006/main" r:embed="R98acb477ba7448fd"/>
+          <a:blip xmlns:r="http://schemas.openxmlformats.org/officeDocument/2006/relationships" xmlns:a="http://schemas.openxmlformats.org/drawingml/2006/main" r:embed="Rc7e99db364b14357"/>
           <a:stretch xmlns:a="http://schemas.openxmlformats.org/drawingml/2006/main"/>
         </p:blipFill>
         <p:spPr>
@@ -5394,7 +5451,7 @@
           <p:cNvPr id="5" name="">
             <a:extLst xmlns:a="http://schemas.openxmlformats.org/drawingml/2006/main">
               <a:ext uri="{FF2B5EF4-FFF2-40B4-BE49-F238E27FC236}">
-                <a16:creationId xmlns:a16="http://schemas.microsoft.com/office/drawing/2014/main" id="{58C2F9F9-AD2F-49C8-AA29-207FA0FB58D1}"/>
+                <a16:creationId xmlns:a16="http://schemas.microsoft.com/office/drawing/2014/main" id="{F3F05DA3-7004-4716-9F1A-26323CDA15D5}"/>
               </a:ext>
             </a:extLst>
           </p:cNvPr>
@@ -5451,7 +5508,7 @@
           <p:cNvPr id="6" name="">
             <a:extLst xmlns:a="http://schemas.openxmlformats.org/drawingml/2006/main">
               <a:ext uri="{FF2B5EF4-FFF2-40B4-BE49-F238E27FC236}">
-                <a16:creationId xmlns:a16="http://schemas.microsoft.com/office/drawing/2014/main" id="{4BC278E9-39F7-4906-8D93-7255B13BE9DC}"/>
+                <a16:creationId xmlns:a16="http://schemas.microsoft.com/office/drawing/2014/main" id="{6C50AA2C-9F34-4624-AA34-79A9FAE09121}"/>
               </a:ext>
             </a:extLst>
           </p:cNvPr>
@@ -5508,7 +5565,7 @@
           <p:cNvPr id="7" name="">
             <a:extLst xmlns:a="http://schemas.openxmlformats.org/drawingml/2006/main">
               <a:ext uri="{FF2B5EF4-FFF2-40B4-BE49-F238E27FC236}">
-                <a16:creationId xmlns:a16="http://schemas.microsoft.com/office/drawing/2014/main" id="{BD5EDF2E-26EE-4AF7-9F80-7AFDDA1A74E6}"/>
+                <a16:creationId xmlns:a16="http://schemas.microsoft.com/office/drawing/2014/main" id="{912D41E2-0D91-426E-B32F-2074C46E4973}"/>
               </a:ext>
             </a:extLst>
           </p:cNvPr>
@@ -5565,7 +5622,7 @@
           <p:cNvPr id="8" name="">
             <a:extLst xmlns:a="http://schemas.openxmlformats.org/drawingml/2006/main">
               <a:ext uri="{FF2B5EF4-FFF2-40B4-BE49-F238E27FC236}">
-                <a16:creationId xmlns:a16="http://schemas.microsoft.com/office/drawing/2014/main" id="{01F8E2DD-68FF-4268-BD14-1885853313CC}"/>
+                <a16:creationId xmlns:a16="http://schemas.microsoft.com/office/drawing/2014/main" id="{3471593F-D044-400D-B098-57C570914063}"/>
               </a:ext>
             </a:extLst>
           </p:cNvPr>
@@ -5622,7 +5679,7 @@
           <p:cNvPr id="9" name="">
             <a:extLst xmlns:a="http://schemas.openxmlformats.org/drawingml/2006/main">
               <a:ext uri="{FF2B5EF4-FFF2-40B4-BE49-F238E27FC236}">
-                <a16:creationId xmlns:a16="http://schemas.microsoft.com/office/drawing/2014/main" id="{911456E8-C70A-4C47-8B05-2392C440F125}"/>
+                <a16:creationId xmlns:a16="http://schemas.microsoft.com/office/drawing/2014/main" id="{F0BE663C-EF45-4472-8BBF-88B761E38CF7}"/>
               </a:ext>
             </a:extLst>
           </p:cNvPr>
@@ -5679,7 +5736,7 @@
           <p:cNvPr id="10" name="">
             <a:extLst xmlns:a="http://schemas.openxmlformats.org/drawingml/2006/main">
               <a:ext uri="{FF2B5EF4-FFF2-40B4-BE49-F238E27FC236}">
-                <a16:creationId xmlns:a16="http://schemas.microsoft.com/office/drawing/2014/main" id="{8FDD5FD5-567B-4BAB-8133-DA26797A6C56}"/>
+                <a16:creationId xmlns:a16="http://schemas.microsoft.com/office/drawing/2014/main" id="{09AF70AB-0D61-45BF-ACF3-E72430804175}"/>
               </a:ext>
             </a:extLst>
           </p:cNvPr>
@@ -5736,7 +5793,7 @@
           <p:cNvPr id="11" name="">
             <a:extLst xmlns:a="http://schemas.openxmlformats.org/drawingml/2006/main">
               <a:ext uri="{FF2B5EF4-FFF2-40B4-BE49-F238E27FC236}">
-                <a16:creationId xmlns:a16="http://schemas.microsoft.com/office/drawing/2014/main" id="{25ED84FF-04FD-4F44-BA91-8C2A28D484C1}"/>
+                <a16:creationId xmlns:a16="http://schemas.microsoft.com/office/drawing/2014/main" id="{D1684BED-B2DE-495C-8F42-515C2D4BF0EE}"/>
               </a:ext>
             </a:extLst>
           </p:cNvPr>
@@ -5791,7 +5848,7 @@
     </p:spTree>
     <p:extLst>
       <p:ext uri="{BB962C8B-B14F-4D97-AF65-F5344CB8AC3E}">
-        <p14:creationId xmlns:p14="http://schemas.microsoft.com/office/powerpoint/2010/main" val="2121407861"/>
+        <p14:creationId xmlns:p14="http://schemas.microsoft.com/office/powerpoint/2010/main" val="346079617"/>
       </p:ext>
     </p:extLst>
   </p:cSld>
@@ -5822,7 +5879,7 @@
           <p:cNvPr id="8" name="">
             <a:extLst xmlns:a="http://schemas.openxmlformats.org/drawingml/2006/main">
               <a:ext uri="{FF2B5EF4-FFF2-40B4-BE49-F238E27FC236}">
-                <a16:creationId xmlns:a16="http://schemas.microsoft.com/office/drawing/2014/main" id="{8356142A-F2E5-406E-AD4E-6799D22BE113}"/>
+                <a16:creationId xmlns:a16="http://schemas.microsoft.com/office/drawing/2014/main" id="{35382EC3-85F0-44F8-BD56-28A2B8049E91}"/>
               </a:ext>
             </a:extLst>
           </p:cNvPr>
@@ -5879,7 +5936,7 @@
           <p:cNvPr id="2" name="">
             <a:extLst xmlns:a="http://schemas.openxmlformats.org/drawingml/2006/main">
               <a:ext uri="{FF2B5EF4-FFF2-40B4-BE49-F238E27FC236}">
-                <a16:creationId xmlns:a16="http://schemas.microsoft.com/office/drawing/2014/main" id="{654095B5-E227-4228-9591-7DEA019D5839}"/>
+                <a16:creationId xmlns:a16="http://schemas.microsoft.com/office/drawing/2014/main" id="{9A5C3610-4DC8-431C-AFD1-3D16B487EDF0}"/>
               </a:ext>
             </a:extLst>
           </p:cNvPr>
@@ -5982,7 +6039,7 @@
           <p:cNvPr id="3" name="">
             <a:extLst xmlns:a="http://schemas.openxmlformats.org/drawingml/2006/main">
               <a:ext uri="{FF2B5EF4-FFF2-40B4-BE49-F238E27FC236}">
-                <a16:creationId xmlns:a16="http://schemas.microsoft.com/office/drawing/2014/main" id="{974D1D00-9CC5-419D-B6EF-1A9C7F314EFC}"/>
+                <a16:creationId xmlns:a16="http://schemas.microsoft.com/office/drawing/2014/main" id="{68F5D6D3-C558-4FF9-A29E-B0D5B0E170D1}"/>
               </a:ext>
             </a:extLst>
           </p:cNvPr>
@@ -6039,7 +6096,7 @@
           <p:cNvPr id="4" name="">
             <a:extLst xmlns:a="http://schemas.openxmlformats.org/drawingml/2006/main">
               <a:ext uri="{FF2B5EF4-FFF2-40B4-BE49-F238E27FC236}">
-                <a16:creationId xmlns:a16="http://schemas.microsoft.com/office/drawing/2014/main" id="{7AB77BDC-5D0E-4998-8BB9-5076697F0C9A}"/>
+                <a16:creationId xmlns:a16="http://schemas.microsoft.com/office/drawing/2014/main" id="{7A80C728-575A-43FC-BBA7-B8ECC59A2E1F}"/>
               </a:ext>
             </a:extLst>
           </p:cNvPr>
@@ -6096,7 +6153,7 @@
           <p:cNvPr id="5" name="">
             <a:extLst xmlns:a="http://schemas.openxmlformats.org/drawingml/2006/main">
               <a:ext uri="{FF2B5EF4-FFF2-40B4-BE49-F238E27FC236}">
-                <a16:creationId xmlns:a16="http://schemas.microsoft.com/office/drawing/2014/main" id="{DE81B0B6-9E03-40DD-8FD6-1E70FDDB33E0}"/>
+                <a16:creationId xmlns:a16="http://schemas.microsoft.com/office/drawing/2014/main" id="{53C68C40-CBF4-46D3-A7F7-678DD467CCD5}"/>
               </a:ext>
             </a:extLst>
           </p:cNvPr>
@@ -6153,7 +6210,7 @@
           <p:cNvPr id="6" name="">
             <a:extLst xmlns:a="http://schemas.openxmlformats.org/drawingml/2006/main">
               <a:ext uri="{FF2B5EF4-FFF2-40B4-BE49-F238E27FC236}">
-                <a16:creationId xmlns:a16="http://schemas.microsoft.com/office/drawing/2014/main" id="{7F843B49-41F9-452D-9C67-11F5E180DEBE}"/>
+                <a16:creationId xmlns:a16="http://schemas.microsoft.com/office/drawing/2014/main" id="{E2817ECD-F91D-4DED-B3E2-B4D7ADC65178}"/>
               </a:ext>
             </a:extLst>
           </p:cNvPr>
@@ -6214,7 +6271,7 @@
           <p:nvPr/>
         </p:nvPicPr>
         <p:blipFill>
-          <a:blip xmlns:r="http://schemas.openxmlformats.org/officeDocument/2006/relationships" xmlns:a="http://schemas.openxmlformats.org/drawingml/2006/main" r:embed="R76181354c22c45f0"/>
+          <a:blip xmlns:r="http://schemas.openxmlformats.org/officeDocument/2006/relationships" xmlns:a="http://schemas.openxmlformats.org/drawingml/2006/main" r:embed="R9170dc3dd0484067"/>
           <a:stretch xmlns:a="http://schemas.openxmlformats.org/drawingml/2006/main"/>
         </p:blipFill>
         <p:spPr>
@@ -6230,7 +6287,7 @@
     </p:spTree>
     <p:extLst>
       <p:ext uri="{BB962C8B-B14F-4D97-AF65-F5344CB8AC3E}">
-        <p14:creationId xmlns:p14="http://schemas.microsoft.com/office/powerpoint/2010/main" val="532676095"/>
+        <p14:creationId xmlns:p14="http://schemas.microsoft.com/office/powerpoint/2010/main" val="145935294"/>
       </p:ext>
     </p:extLst>
   </p:cSld>
@@ -6261,7 +6318,7 @@
           <p:cNvPr id="12" name="">
             <a:extLst xmlns:a="http://schemas.openxmlformats.org/drawingml/2006/main">
               <a:ext uri="{FF2B5EF4-FFF2-40B4-BE49-F238E27FC236}">
-                <a16:creationId xmlns:a16="http://schemas.microsoft.com/office/drawing/2014/main" id="{C2C2E7EE-0D4E-4E90-B6AB-AF61EE6BA795}"/>
+                <a16:creationId xmlns:a16="http://schemas.microsoft.com/office/drawing/2014/main" id="{7D6B17F8-BF66-4EFA-8544-B152034F1AA3}"/>
               </a:ext>
             </a:extLst>
           </p:cNvPr>
@@ -6318,7 +6375,7 @@
           <p:cNvPr id="2" name="">
             <a:extLst xmlns:a="http://schemas.openxmlformats.org/drawingml/2006/main">
               <a:ext uri="{FF2B5EF4-FFF2-40B4-BE49-F238E27FC236}">
-                <a16:creationId xmlns:a16="http://schemas.microsoft.com/office/drawing/2014/main" id="{44E94037-ECE6-4D5C-8BDA-EFA5DE83C60C}"/>
+                <a16:creationId xmlns:a16="http://schemas.microsoft.com/office/drawing/2014/main" id="{68110953-F6A5-42B6-A54A-9430A34D45E7}"/>
               </a:ext>
             </a:extLst>
           </p:cNvPr>
@@ -6398,7 +6455,7 @@
           <p:cNvPr id="3" name="">
             <a:extLst xmlns:a="http://schemas.openxmlformats.org/drawingml/2006/main">
               <a:ext uri="{FF2B5EF4-FFF2-40B4-BE49-F238E27FC236}">
-                <a16:creationId xmlns:a16="http://schemas.microsoft.com/office/drawing/2014/main" id="{2F5D4045-D9DB-4C6E-A3EB-11520BD33286}"/>
+                <a16:creationId xmlns:a16="http://schemas.microsoft.com/office/drawing/2014/main" id="{82BC108F-D9EE-4EB7-9015-F4B51D8D6F05}"/>
               </a:ext>
             </a:extLst>
           </p:cNvPr>
@@ -6455,7 +6512,7 @@
           <p:cNvPr id="4" name="">
             <a:extLst xmlns:a="http://schemas.openxmlformats.org/drawingml/2006/main">
               <a:ext uri="{FF2B5EF4-FFF2-40B4-BE49-F238E27FC236}">
-                <a16:creationId xmlns:a16="http://schemas.microsoft.com/office/drawing/2014/main" id="{3EBE8614-D01E-46C2-AF7C-3839F513CF51}"/>
+                <a16:creationId xmlns:a16="http://schemas.microsoft.com/office/drawing/2014/main" id="{4455F3D9-B60B-437A-8B37-0A831F464143}"/>
               </a:ext>
             </a:extLst>
           </p:cNvPr>
@@ -6512,7 +6569,7 @@
           <p:cNvPr id="5" name="">
             <a:extLst xmlns:a="http://schemas.openxmlformats.org/drawingml/2006/main">
               <a:ext uri="{FF2B5EF4-FFF2-40B4-BE49-F238E27FC236}">
-                <a16:creationId xmlns:a16="http://schemas.microsoft.com/office/drawing/2014/main" id="{F1479328-DDB8-43B5-93BC-26A6CD76479A}"/>
+                <a16:creationId xmlns:a16="http://schemas.microsoft.com/office/drawing/2014/main" id="{661F36F1-DE25-436A-A7D4-AD11315669D8}"/>
               </a:ext>
             </a:extLst>
           </p:cNvPr>
@@ -6569,7 +6626,7 @@
           <p:cNvPr id="6" name="">
             <a:extLst xmlns:a="http://schemas.openxmlformats.org/drawingml/2006/main">
               <a:ext uri="{FF2B5EF4-FFF2-40B4-BE49-F238E27FC236}">
-                <a16:creationId xmlns:a16="http://schemas.microsoft.com/office/drawing/2014/main" id="{A32EDDC6-028E-4457-A9F4-8A415F9DF0F5}"/>
+                <a16:creationId xmlns:a16="http://schemas.microsoft.com/office/drawing/2014/main" id="{13208FA5-BADB-4F47-A71B-D54C87978165}"/>
               </a:ext>
             </a:extLst>
           </p:cNvPr>
@@ -6626,7 +6683,7 @@
           <p:cNvPr id="7" name="">
             <a:extLst xmlns:a="http://schemas.openxmlformats.org/drawingml/2006/main">
               <a:ext uri="{FF2B5EF4-FFF2-40B4-BE49-F238E27FC236}">
-                <a16:creationId xmlns:a16="http://schemas.microsoft.com/office/drawing/2014/main" id="{DCE8391A-0853-4D51-A30C-DBC6C1624A13}"/>
+                <a16:creationId xmlns:a16="http://schemas.microsoft.com/office/drawing/2014/main" id="{E6F63BB0-D346-4ED7-BC2D-09744DC23839}"/>
               </a:ext>
             </a:extLst>
           </p:cNvPr>
@@ -6683,7 +6740,7 @@
           <p:cNvPr id="8" name="">
             <a:extLst xmlns:a="http://schemas.openxmlformats.org/drawingml/2006/main">
               <a:ext uri="{FF2B5EF4-FFF2-40B4-BE49-F238E27FC236}">
-                <a16:creationId xmlns:a16="http://schemas.microsoft.com/office/drawing/2014/main" id="{9270EBDE-0355-473C-BC7B-7375BBA69D58}"/>
+                <a16:creationId xmlns:a16="http://schemas.microsoft.com/office/drawing/2014/main" id="{4D5A08DE-C676-4C01-9B24-4DD391B51842}"/>
               </a:ext>
             </a:extLst>
           </p:cNvPr>
@@ -6740,7 +6797,7 @@
           <p:cNvPr id="9" name="">
             <a:extLst xmlns:a="http://schemas.openxmlformats.org/drawingml/2006/main">
               <a:ext uri="{FF2B5EF4-FFF2-40B4-BE49-F238E27FC236}">
-                <a16:creationId xmlns:a16="http://schemas.microsoft.com/office/drawing/2014/main" id="{CAF2F034-26F6-48AF-A9DA-FBDA93608C6E}"/>
+                <a16:creationId xmlns:a16="http://schemas.microsoft.com/office/drawing/2014/main" id="{361F03F2-4B6B-43D3-A5A9-59846CEB8370}"/>
               </a:ext>
             </a:extLst>
           </p:cNvPr>
@@ -6801,7 +6858,7 @@
           <p:nvPr/>
         </p:nvPicPr>
         <p:blipFill>
-          <a:blip xmlns:r="http://schemas.openxmlformats.org/officeDocument/2006/relationships" xmlns:a="http://schemas.openxmlformats.org/drawingml/2006/main" r:embed="R052746b4bb0b4587"/>
+          <a:blip xmlns:r="http://schemas.openxmlformats.org/officeDocument/2006/relationships" xmlns:a="http://schemas.openxmlformats.org/drawingml/2006/main" r:embed="R9d322467077143f7"/>
           <a:stretch xmlns:a="http://schemas.openxmlformats.org/drawingml/2006/main"/>
         </p:blipFill>
         <p:spPr>
@@ -6819,7 +6876,7 @@
           <p:cNvPr id="11" name="">
             <a:extLst xmlns:a="http://schemas.openxmlformats.org/drawingml/2006/main">
               <a:ext uri="{FF2B5EF4-FFF2-40B4-BE49-F238E27FC236}">
-                <a16:creationId xmlns:a16="http://schemas.microsoft.com/office/drawing/2014/main" id="{3F3C5D53-081A-48E2-A7F1-4F647D24908E}"/>
+                <a16:creationId xmlns:a16="http://schemas.microsoft.com/office/drawing/2014/main" id="{2F20AC6C-8EF0-45B7-8B45-8B70F2C3BE50}"/>
               </a:ext>
             </a:extLst>
           </p:cNvPr>
@@ -6874,7 +6931,7 @@
     </p:spTree>
     <p:extLst>
       <p:ext uri="{BB962C8B-B14F-4D97-AF65-F5344CB8AC3E}">
-        <p14:creationId xmlns:p14="http://schemas.microsoft.com/office/powerpoint/2010/main" val="966987952"/>
+        <p14:creationId xmlns:p14="http://schemas.microsoft.com/office/powerpoint/2010/main" val="1758657768"/>
       </p:ext>
     </p:extLst>
   </p:cSld>
@@ -6905,7 +6962,7 @@
           <p:cNvPr id="6" name="">
             <a:extLst xmlns:a="http://schemas.openxmlformats.org/drawingml/2006/main">
               <a:ext uri="{FF2B5EF4-FFF2-40B4-BE49-F238E27FC236}">
-                <a16:creationId xmlns:a16="http://schemas.microsoft.com/office/drawing/2014/main" id="{5003FEB2-3BD9-4DFA-87D5-098ABB5D834E}"/>
+                <a16:creationId xmlns:a16="http://schemas.microsoft.com/office/drawing/2014/main" id="{BCEC003F-20FC-4051-AB09-FB42DC1CD5F4}"/>
               </a:ext>
             </a:extLst>
           </p:cNvPr>
@@ -6962,7 +7019,7 @@
           <p:cNvPr id="2" name="">
             <a:extLst xmlns:a="http://schemas.openxmlformats.org/drawingml/2006/main">
               <a:ext uri="{FF2B5EF4-FFF2-40B4-BE49-F238E27FC236}">
-                <a16:creationId xmlns:a16="http://schemas.microsoft.com/office/drawing/2014/main" id="{0DA0A915-6680-4083-B9E1-F1F531B47579}"/>
+                <a16:creationId xmlns:a16="http://schemas.microsoft.com/office/drawing/2014/main" id="{F9E9FA49-33D0-4B5D-9014-432F4E1E9CEA}"/>
               </a:ext>
             </a:extLst>
           </p:cNvPr>
@@ -7019,7 +7076,7 @@
           <p:cNvPr id="3" name="">
             <a:extLst xmlns:a="http://schemas.openxmlformats.org/drawingml/2006/main">
               <a:ext uri="{FF2B5EF4-FFF2-40B4-BE49-F238E27FC236}">
-                <a16:creationId xmlns:a16="http://schemas.microsoft.com/office/drawing/2014/main" id="{9BE26450-EC28-499A-84DF-F88C2763203B}"/>
+                <a16:creationId xmlns:a16="http://schemas.microsoft.com/office/drawing/2014/main" id="{566B8AE1-8E32-4C8B-A6D1-5EB4A670FA4B}"/>
               </a:ext>
             </a:extLst>
           </p:cNvPr>
@@ -7080,7 +7137,7 @@
           <p:nvPr/>
         </p:nvPicPr>
         <p:blipFill>
-          <a:blip xmlns:r="http://schemas.openxmlformats.org/officeDocument/2006/relationships" xmlns:a="http://schemas.openxmlformats.org/drawingml/2006/main" r:embed="R52ea27de90794d63"/>
+          <a:blip xmlns:r="http://schemas.openxmlformats.org/officeDocument/2006/relationships" xmlns:a="http://schemas.openxmlformats.org/drawingml/2006/main" r:embed="Rc6512876d4ae412d"/>
           <a:stretch xmlns:a="http://schemas.openxmlformats.org/drawingml/2006/main"/>
         </p:blipFill>
         <p:spPr>
@@ -7098,7 +7155,7 @@
           <p:cNvPr id="5" name="">
             <a:extLst xmlns:a="http://schemas.openxmlformats.org/drawingml/2006/main">
               <a:ext uri="{FF2B5EF4-FFF2-40B4-BE49-F238E27FC236}">
-                <a16:creationId xmlns:a16="http://schemas.microsoft.com/office/drawing/2014/main" id="{F97D9017-0D84-4A4C-8AA6-7281E72774C4}"/>
+                <a16:creationId xmlns:a16="http://schemas.microsoft.com/office/drawing/2014/main" id="{3BC0BC65-446C-49C1-B79C-6C7A4825370C}"/>
               </a:ext>
             </a:extLst>
           </p:cNvPr>
@@ -7153,7 +7210,7 @@
     </p:spTree>
     <p:extLst>
       <p:ext uri="{BB962C8B-B14F-4D97-AF65-F5344CB8AC3E}">
-        <p14:creationId xmlns:p14="http://schemas.microsoft.com/office/powerpoint/2010/main" val="1207477955"/>
+        <p14:creationId xmlns:p14="http://schemas.microsoft.com/office/powerpoint/2010/main" val="2054713395"/>
       </p:ext>
     </p:extLst>
   </p:cSld>
@@ -7184,7 +7241,7 @@
           <p:cNvPr id="8" name="">
             <a:extLst xmlns:a="http://schemas.openxmlformats.org/drawingml/2006/main">
               <a:ext uri="{FF2B5EF4-FFF2-40B4-BE49-F238E27FC236}">
-                <a16:creationId xmlns:a16="http://schemas.microsoft.com/office/drawing/2014/main" id="{61DA3EA4-FFFD-4440-A8D7-96765A239B6D}"/>
+                <a16:creationId xmlns:a16="http://schemas.microsoft.com/office/drawing/2014/main" id="{14F14BBC-B182-425C-BC0D-A62A5699A45B}"/>
               </a:ext>
             </a:extLst>
           </p:cNvPr>
@@ -7241,7 +7298,7 @@
           <p:cNvPr id="2" name="">
             <a:extLst xmlns:a="http://schemas.openxmlformats.org/drawingml/2006/main">
               <a:ext uri="{FF2B5EF4-FFF2-40B4-BE49-F238E27FC236}">
-                <a16:creationId xmlns:a16="http://schemas.microsoft.com/office/drawing/2014/main" id="{8AE37F60-B6C0-41D3-9802-2A96E7726CA3}"/>
+                <a16:creationId xmlns:a16="http://schemas.microsoft.com/office/drawing/2014/main" id="{C2366428-F290-41E6-BA0C-41D28C572366}"/>
               </a:ext>
             </a:extLst>
           </p:cNvPr>
@@ -7298,7 +7355,7 @@
           <p:cNvPr id="3" name="">
             <a:extLst xmlns:a="http://schemas.openxmlformats.org/drawingml/2006/main">
               <a:ext uri="{FF2B5EF4-FFF2-40B4-BE49-F238E27FC236}">
-                <a16:creationId xmlns:a16="http://schemas.microsoft.com/office/drawing/2014/main" id="{56A4D40A-64D4-44DD-8312-887D06E18A58}"/>
+                <a16:creationId xmlns:a16="http://schemas.microsoft.com/office/drawing/2014/main" id="{4B9A190A-0176-458C-8269-85136232E746}"/>
               </a:ext>
             </a:extLst>
           </p:cNvPr>
@@ -7355,7 +7412,7 @@
           <p:cNvPr id="4" name="">
             <a:extLst xmlns:a="http://schemas.openxmlformats.org/drawingml/2006/main">
               <a:ext uri="{FF2B5EF4-FFF2-40B4-BE49-F238E27FC236}">
-                <a16:creationId xmlns:a16="http://schemas.microsoft.com/office/drawing/2014/main" id="{32CD796F-BF2A-44A0-9FFA-50058600C64B}"/>
+                <a16:creationId xmlns:a16="http://schemas.microsoft.com/office/drawing/2014/main" id="{C50D5AD6-61FB-4FD9-8C31-285E37EAC910}"/>
               </a:ext>
             </a:extLst>
           </p:cNvPr>
@@ -7439,7 +7496,7 @@
           <p:nvPr/>
         </p:nvPicPr>
         <p:blipFill>
-          <a:blip xmlns:r="http://schemas.openxmlformats.org/officeDocument/2006/relationships" xmlns:a="http://schemas.openxmlformats.org/drawingml/2006/main" r:embed="R4fc777bc1a3b4e15"/>
+          <a:blip xmlns:r="http://schemas.openxmlformats.org/officeDocument/2006/relationships" xmlns:a="http://schemas.openxmlformats.org/drawingml/2006/main" r:embed="Rf53a439b9e514ce0"/>
           <a:stretch xmlns:a="http://schemas.openxmlformats.org/drawingml/2006/main"/>
         </p:blipFill>
         <p:spPr>
@@ -7457,7 +7514,7 @@
           <p:cNvPr id="6" name="">
             <a:extLst xmlns:a="http://schemas.openxmlformats.org/drawingml/2006/main">
               <a:ext uri="{FF2B5EF4-FFF2-40B4-BE49-F238E27FC236}">
-                <a16:creationId xmlns:a16="http://schemas.microsoft.com/office/drawing/2014/main" id="{27508CDB-0959-40BB-A204-69305DD0FDB7}"/>
+                <a16:creationId xmlns:a16="http://schemas.microsoft.com/office/drawing/2014/main" id="{A1DD0CF4-6C18-4FA6-BF60-C3ACC9D3892C}"/>
               </a:ext>
             </a:extLst>
           </p:cNvPr>
@@ -7514,7 +7571,7 @@
           <p:cNvPr id="7" name="">
             <a:extLst xmlns:a="http://schemas.openxmlformats.org/drawingml/2006/main">
               <a:ext uri="{FF2B5EF4-FFF2-40B4-BE49-F238E27FC236}">
-                <a16:creationId xmlns:a16="http://schemas.microsoft.com/office/drawing/2014/main" id="{A5847131-49D5-437F-AF2D-452F6BA6D9FB}"/>
+                <a16:creationId xmlns:a16="http://schemas.microsoft.com/office/drawing/2014/main" id="{AFDDE59D-D32B-419C-AEA0-D5177C848580}"/>
               </a:ext>
             </a:extLst>
           </p:cNvPr>
@@ -7569,7 +7626,7 @@
     </p:spTree>
     <p:extLst>
       <p:ext uri="{BB962C8B-B14F-4D97-AF65-F5344CB8AC3E}">
-        <p14:creationId xmlns:p14="http://schemas.microsoft.com/office/powerpoint/2010/main" val="2073327114"/>
+        <p14:creationId xmlns:p14="http://schemas.microsoft.com/office/powerpoint/2010/main" val="1558356379"/>
       </p:ext>
     </p:extLst>
   </p:cSld>
@@ -7600,7 +7657,7 @@
           <p:cNvPr id="10" name="">
             <a:extLst xmlns:a="http://schemas.openxmlformats.org/drawingml/2006/main">
               <a:ext uri="{FF2B5EF4-FFF2-40B4-BE49-F238E27FC236}">
-                <a16:creationId xmlns:a16="http://schemas.microsoft.com/office/drawing/2014/main" id="{2AE0EBC9-22B0-4B45-9C49-A56AE3B415B8}"/>
+                <a16:creationId xmlns:a16="http://schemas.microsoft.com/office/drawing/2014/main" id="{E28F892A-10A2-4B81-BAF0-6D44C36087F1}"/>
               </a:ext>
             </a:extLst>
           </p:cNvPr>
@@ -7657,7 +7714,7 @@
           <p:cNvPr id="2" name="">
             <a:extLst xmlns:a="http://schemas.openxmlformats.org/drawingml/2006/main">
               <a:ext uri="{FF2B5EF4-FFF2-40B4-BE49-F238E27FC236}">
-                <a16:creationId xmlns:a16="http://schemas.microsoft.com/office/drawing/2014/main" id="{2B5D05D7-B8D6-486F-AFD0-952CE69ECEE5}"/>
+                <a16:creationId xmlns:a16="http://schemas.microsoft.com/office/drawing/2014/main" id="{0B70D46B-2C8C-4927-90EE-6FD27455ED17}"/>
               </a:ext>
             </a:extLst>
           </p:cNvPr>
@@ -7714,7 +7771,7 @@
           <p:cNvPr id="3" name="">
             <a:extLst xmlns:a="http://schemas.openxmlformats.org/drawingml/2006/main">
               <a:ext uri="{FF2B5EF4-FFF2-40B4-BE49-F238E27FC236}">
-                <a16:creationId xmlns:a16="http://schemas.microsoft.com/office/drawing/2014/main" id="{748DE094-7CA3-4E46-B861-2BD297DA75BA}"/>
+                <a16:creationId xmlns:a16="http://schemas.microsoft.com/office/drawing/2014/main" id="{06D67936-97FD-4D78-9A0C-7901FF5FA7A2}"/>
               </a:ext>
             </a:extLst>
           </p:cNvPr>
@@ -7771,7 +7828,7 @@
           <p:cNvPr id="4" name="">
             <a:extLst xmlns:a="http://schemas.openxmlformats.org/drawingml/2006/main">
               <a:ext uri="{FF2B5EF4-FFF2-40B4-BE49-F238E27FC236}">
-                <a16:creationId xmlns:a16="http://schemas.microsoft.com/office/drawing/2014/main" id="{55D016D9-4C22-446A-93C7-7A8AF6BEF667}"/>
+                <a16:creationId xmlns:a16="http://schemas.microsoft.com/office/drawing/2014/main" id="{9E315136-750A-405F-A3AD-5E02AA251168}"/>
               </a:ext>
             </a:extLst>
           </p:cNvPr>
@@ -7828,7 +7885,7 @@
           <p:cNvPr id="5" name="">
             <a:extLst xmlns:a="http://schemas.openxmlformats.org/drawingml/2006/main">
               <a:ext uri="{FF2B5EF4-FFF2-40B4-BE49-F238E27FC236}">
-                <a16:creationId xmlns:a16="http://schemas.microsoft.com/office/drawing/2014/main" id="{23C6A2B0-76F0-4090-965D-C57C86AB0649}"/>
+                <a16:creationId xmlns:a16="http://schemas.microsoft.com/office/drawing/2014/main" id="{822E17B4-E0E6-435A-B40B-104AEC175336}"/>
               </a:ext>
             </a:extLst>
           </p:cNvPr>
@@ -7885,7 +7942,7 @@
           <p:cNvPr id="6" name="">
             <a:extLst xmlns:a="http://schemas.openxmlformats.org/drawingml/2006/main">
               <a:ext uri="{FF2B5EF4-FFF2-40B4-BE49-F238E27FC236}">
-                <a16:creationId xmlns:a16="http://schemas.microsoft.com/office/drawing/2014/main" id="{46001903-C4E1-4B1E-8A49-8B81CC564F14}"/>
+                <a16:creationId xmlns:a16="http://schemas.microsoft.com/office/drawing/2014/main" id="{4AD07A71-AEEA-4C17-8618-039D6D5344BC}"/>
               </a:ext>
             </a:extLst>
           </p:cNvPr>
@@ -7942,7 +7999,7 @@
           <p:cNvPr id="7" name="">
             <a:extLst xmlns:a="http://schemas.openxmlformats.org/drawingml/2006/main">
               <a:ext uri="{FF2B5EF4-FFF2-40B4-BE49-F238E27FC236}">
-                <a16:creationId xmlns:a16="http://schemas.microsoft.com/office/drawing/2014/main" id="{C41ECC2F-0AB8-4E5B-9095-EC3967854313}"/>
+                <a16:creationId xmlns:a16="http://schemas.microsoft.com/office/drawing/2014/main" id="{8C0185DE-D999-4105-8B3B-73B789B0665B}"/>
               </a:ext>
             </a:extLst>
           </p:cNvPr>
@@ -8606,7 +8663,7 @@
           <p:cNvPr id="9" name="">
             <a:extLst xmlns:a="http://schemas.openxmlformats.org/drawingml/2006/main">
               <a:ext uri="{FF2B5EF4-FFF2-40B4-BE49-F238E27FC236}">
-                <a16:creationId xmlns:a16="http://schemas.microsoft.com/office/drawing/2014/main" id="{0E7437EF-4485-495F-B094-81258E930194}"/>
+                <a16:creationId xmlns:a16="http://schemas.microsoft.com/office/drawing/2014/main" id="{7CFCB42D-E9E3-423C-A09C-FBD14ECAFDF5}"/>
               </a:ext>
             </a:extLst>
           </p:cNvPr>
@@ -8661,7 +8718,7 @@
     </p:spTree>
     <p:extLst>
       <p:ext uri="{BB962C8B-B14F-4D97-AF65-F5344CB8AC3E}">
-        <p14:creationId xmlns:p14="http://schemas.microsoft.com/office/powerpoint/2010/main" val="1378803675"/>
+        <p14:creationId xmlns:p14="http://schemas.microsoft.com/office/powerpoint/2010/main" val="952310076"/>
       </p:ext>
     </p:extLst>
   </p:cSld>
@@ -8692,7 +8749,7 @@
           <p:cNvPr id="19" name="">
             <a:extLst xmlns:a="http://schemas.openxmlformats.org/drawingml/2006/main">
               <a:ext uri="{FF2B5EF4-FFF2-40B4-BE49-F238E27FC236}">
-                <a16:creationId xmlns:a16="http://schemas.microsoft.com/office/drawing/2014/main" id="{3F633AEA-1E9F-4FA1-BE6C-9E0684DB0C92}"/>
+                <a16:creationId xmlns:a16="http://schemas.microsoft.com/office/drawing/2014/main" id="{7B98EF19-D257-4822-91B1-2052BC6EE397}"/>
               </a:ext>
             </a:extLst>
           </p:cNvPr>
@@ -8749,7 +8806,7 @@
           <p:cNvPr id="2" name="">
             <a:extLst xmlns:a="http://schemas.openxmlformats.org/drawingml/2006/main">
               <a:ext uri="{FF2B5EF4-FFF2-40B4-BE49-F238E27FC236}">
-                <a16:creationId xmlns:a16="http://schemas.microsoft.com/office/drawing/2014/main" id="{083AD82C-7E78-44A6-B977-89A7DE51D605}"/>
+                <a16:creationId xmlns:a16="http://schemas.microsoft.com/office/drawing/2014/main" id="{68FEF267-9039-4704-B728-6091FA365F9A}"/>
               </a:ext>
             </a:extLst>
           </p:cNvPr>
@@ -8806,7 +8863,7 @@
           <p:cNvPr id="3" name="">
             <a:extLst xmlns:a="http://schemas.openxmlformats.org/drawingml/2006/main">
               <a:ext uri="{FF2B5EF4-FFF2-40B4-BE49-F238E27FC236}">
-                <a16:creationId xmlns:a16="http://schemas.microsoft.com/office/drawing/2014/main" id="{90046A8E-0DA5-4133-A593-0451CC4461B6}"/>
+                <a16:creationId xmlns:a16="http://schemas.microsoft.com/office/drawing/2014/main" id="{E4489C85-A92F-4215-AFCD-ABF5D16DBCE5}"/>
               </a:ext>
             </a:extLst>
           </p:cNvPr>
@@ -8863,7 +8920,7 @@
           <p:cNvPr id="4" name="">
             <a:extLst xmlns:a="http://schemas.openxmlformats.org/drawingml/2006/main">
               <a:ext uri="{FF2B5EF4-FFF2-40B4-BE49-F238E27FC236}">
-                <a16:creationId xmlns:a16="http://schemas.microsoft.com/office/drawing/2014/main" id="{D169DBFE-C96D-4134-B0F7-5C76715EAF9F}"/>
+                <a16:creationId xmlns:a16="http://schemas.microsoft.com/office/drawing/2014/main" id="{F10EFF10-AF7C-44EC-8ED3-88437CFE2C68}"/>
               </a:ext>
             </a:extLst>
           </p:cNvPr>
@@ -8920,7 +8977,7 @@
           <p:cNvPr id="5" name="">
             <a:extLst xmlns:a="http://schemas.openxmlformats.org/drawingml/2006/main">
               <a:ext uri="{FF2B5EF4-FFF2-40B4-BE49-F238E27FC236}">
-                <a16:creationId xmlns:a16="http://schemas.microsoft.com/office/drawing/2014/main" id="{D3394EAE-656D-4628-97EE-5C67C2E720D2}"/>
+                <a16:creationId xmlns:a16="http://schemas.microsoft.com/office/drawing/2014/main" id="{78FC7A8C-DBC9-4D0B-88C2-651EF5A73C3C}"/>
               </a:ext>
             </a:extLst>
           </p:cNvPr>
@@ -8977,7 +9034,7 @@
           <p:cNvPr id="6" name="">
             <a:extLst xmlns:a="http://schemas.openxmlformats.org/drawingml/2006/main">
               <a:ext uri="{FF2B5EF4-FFF2-40B4-BE49-F238E27FC236}">
-                <a16:creationId xmlns:a16="http://schemas.microsoft.com/office/drawing/2014/main" id="{526D0CEA-CAC0-4436-B19D-13E10B08F1AB}"/>
+                <a16:creationId xmlns:a16="http://schemas.microsoft.com/office/drawing/2014/main" id="{9126CF03-96C7-40CB-8A16-6F4AE7DBD5F0}"/>
               </a:ext>
             </a:extLst>
           </p:cNvPr>
@@ -9034,7 +9091,7 @@
           <p:cNvPr id="7" name="">
             <a:extLst xmlns:a="http://schemas.openxmlformats.org/drawingml/2006/main">
               <a:ext uri="{FF2B5EF4-FFF2-40B4-BE49-F238E27FC236}">
-                <a16:creationId xmlns:a16="http://schemas.microsoft.com/office/drawing/2014/main" id="{E0F3D4BE-CC9E-4B35-89E4-DEEF81D54289}"/>
+                <a16:creationId xmlns:a16="http://schemas.microsoft.com/office/drawing/2014/main" id="{27EDD7E3-9632-4220-893C-350415E18C94}"/>
               </a:ext>
             </a:extLst>
           </p:cNvPr>
@@ -9091,7 +9148,7 @@
           <p:cNvPr id="8" name="">
             <a:extLst xmlns:a="http://schemas.openxmlformats.org/drawingml/2006/main">
               <a:ext uri="{FF2B5EF4-FFF2-40B4-BE49-F238E27FC236}">
-                <a16:creationId xmlns:a16="http://schemas.microsoft.com/office/drawing/2014/main" id="{83DF7FD8-51BA-44EE-9F05-6343A004F820}"/>
+                <a16:creationId xmlns:a16="http://schemas.microsoft.com/office/drawing/2014/main" id="{164C47C9-EF6B-4C2E-AD64-F2CDF9F573FD}"/>
               </a:ext>
             </a:extLst>
           </p:cNvPr>
@@ -9200,7 +9257,7 @@
           <p:cNvPr id="11" name="">
             <a:extLst xmlns:a="http://schemas.openxmlformats.org/drawingml/2006/main">
               <a:ext uri="{FF2B5EF4-FFF2-40B4-BE49-F238E27FC236}">
-                <a16:creationId xmlns:a16="http://schemas.microsoft.com/office/drawing/2014/main" id="{D2AAD463-4490-4C6F-90D0-71A3EC61B424}"/>
+                <a16:creationId xmlns:a16="http://schemas.microsoft.com/office/drawing/2014/main" id="{674E00C8-67D0-4281-9FE9-1D05FA48C1A9}"/>
               </a:ext>
             </a:extLst>
           </p:cNvPr>
@@ -9280,7 +9337,7 @@
           <p:cNvPr id="12" name="">
             <a:extLst xmlns:a="http://schemas.openxmlformats.org/drawingml/2006/main">
               <a:ext uri="{FF2B5EF4-FFF2-40B4-BE49-F238E27FC236}">
-                <a16:creationId xmlns:a16="http://schemas.microsoft.com/office/drawing/2014/main" id="{03567057-0C72-4BB0-9BD7-CBB4FFB8B4BE}"/>
+                <a16:creationId xmlns:a16="http://schemas.microsoft.com/office/drawing/2014/main" id="{6E3C9A9C-15C2-4BB5-B4C1-C46304170115}"/>
               </a:ext>
             </a:extLst>
           </p:cNvPr>
@@ -9383,7 +9440,7 @@
           <p:cNvPr id="13" name="">
             <a:extLst xmlns:a="http://schemas.openxmlformats.org/drawingml/2006/main">
               <a:ext uri="{FF2B5EF4-FFF2-40B4-BE49-F238E27FC236}">
-                <a16:creationId xmlns:a16="http://schemas.microsoft.com/office/drawing/2014/main" id="{773F7C88-E316-425B-8F6E-6837932041A8}"/>
+                <a16:creationId xmlns:a16="http://schemas.microsoft.com/office/drawing/2014/main" id="{C63ACAF2-33F7-46E4-ACDE-2A62405FEF65}"/>
               </a:ext>
             </a:extLst>
           </p:cNvPr>
@@ -9486,7 +9543,7 @@
           <p:cNvPr id="14" name="">
             <a:extLst xmlns:a="http://schemas.openxmlformats.org/drawingml/2006/main">
               <a:ext uri="{FF2B5EF4-FFF2-40B4-BE49-F238E27FC236}">
-                <a16:creationId xmlns:a16="http://schemas.microsoft.com/office/drawing/2014/main" id="{D9CF48BC-115E-47AB-AD55-B368F9082CF3}"/>
+                <a16:creationId xmlns:a16="http://schemas.microsoft.com/office/drawing/2014/main" id="{E8167E6C-05B9-4152-AE9A-14CCF2B51A09}"/>
               </a:ext>
             </a:extLst>
           </p:cNvPr>
@@ -9516,7 +9573,7 @@
           <p:cNvPr id="15" name="">
             <a:extLst xmlns:a="http://schemas.openxmlformats.org/drawingml/2006/main">
               <a:ext uri="{FF2B5EF4-FFF2-40B4-BE49-F238E27FC236}">
-                <a16:creationId xmlns:a16="http://schemas.microsoft.com/office/drawing/2014/main" id="{11E10818-6791-4752-801E-1A3EE57E2D7D}"/>
+                <a16:creationId xmlns:a16="http://schemas.microsoft.com/office/drawing/2014/main" id="{3CB48BD3-87A1-4B0F-9925-C6A62842AF69}"/>
               </a:ext>
             </a:extLst>
           </p:cNvPr>
@@ -9573,7 +9630,7 @@
           <p:cNvPr id="16" name="">
             <a:extLst xmlns:a="http://schemas.openxmlformats.org/drawingml/2006/main">
               <a:ext uri="{FF2B5EF4-FFF2-40B4-BE49-F238E27FC236}">
-                <a16:creationId xmlns:a16="http://schemas.microsoft.com/office/drawing/2014/main" id="{E1C16560-D1A6-4599-A967-38855E1B06A8}"/>
+                <a16:creationId xmlns:a16="http://schemas.microsoft.com/office/drawing/2014/main" id="{8448F53B-C7D8-4FD8-9D91-F83B67BE1217}"/>
               </a:ext>
             </a:extLst>
           </p:cNvPr>
@@ -9630,7 +9687,7 @@
           <p:cNvPr id="17" name="">
             <a:extLst xmlns:a="http://schemas.openxmlformats.org/drawingml/2006/main">
               <a:ext uri="{FF2B5EF4-FFF2-40B4-BE49-F238E27FC236}">
-                <a16:creationId xmlns:a16="http://schemas.microsoft.com/office/drawing/2014/main" id="{3559AE18-DCE9-4022-A93B-C1E2204D2332}"/>
+                <a16:creationId xmlns:a16="http://schemas.microsoft.com/office/drawing/2014/main" id="{16A8EB9A-7574-469B-8E66-122D01521C65}"/>
               </a:ext>
             </a:extLst>
           </p:cNvPr>
@@ -9687,7 +9744,7 @@
           <p:cNvPr id="18" name="">
             <a:extLst xmlns:a="http://schemas.openxmlformats.org/drawingml/2006/main">
               <a:ext uri="{FF2B5EF4-FFF2-40B4-BE49-F238E27FC236}">
-                <a16:creationId xmlns:a16="http://schemas.microsoft.com/office/drawing/2014/main" id="{AFCD141A-D0D3-40DE-8F63-3B1A411DAB28}"/>
+                <a16:creationId xmlns:a16="http://schemas.microsoft.com/office/drawing/2014/main" id="{2FAE847B-8CBF-46FB-95DE-44A92B895945}"/>
               </a:ext>
             </a:extLst>
           </p:cNvPr>
@@ -9742,7 +9799,7 @@
     </p:spTree>
     <p:extLst>
       <p:ext uri="{BB962C8B-B14F-4D97-AF65-F5344CB8AC3E}">
-        <p14:creationId xmlns:p14="http://schemas.microsoft.com/office/powerpoint/2010/main" val="1052356397"/>
+        <p14:creationId xmlns:p14="http://schemas.microsoft.com/office/powerpoint/2010/main" val="269941224"/>
       </p:ext>
     </p:extLst>
   </p:cSld>

</xml_diff>

<commit_message>
build(deck): promote matched 401 evidence
Co-authored-by: Codex <noreply@openai.com>
</commit_message>
<xml_diff>
--- a/apps/web/public/demo/roadstar-pitch.pptx
+++ b/apps/web/public/demo/roadstar-pitch.pptx
@@ -2,25 +2,25 @@
 <file path=ppt/presentation.xml><?xml version="1.0" encoding="utf-8"?>
 <p:presentation xmlns:p="http://schemas.openxmlformats.org/presentationml/2006/main">
   <p:sldMasterIdLst>
-    <p:sldMasterId xmlns:r="http://schemas.openxmlformats.org/officeDocument/2006/relationships" id="2147483648" r:id="Rc1bf39df39f34aa5"/>
+    <p:sldMasterId xmlns:r="http://schemas.openxmlformats.org/officeDocument/2006/relationships" id="2147483648" r:id="Rcb1999591c7e4c98"/>
   </p:sldMasterIdLst>
   <p:notesMasterIdLst>
-    <p:notesMasterId xmlns:r="http://schemas.openxmlformats.org/officeDocument/2006/relationships" r:id="R9cb2d47fe83943b2"/>
+    <p:notesMasterId xmlns:r="http://schemas.openxmlformats.org/officeDocument/2006/relationships" r:id="R6d2bf2df96e64c4a"/>
   </p:notesMasterIdLst>
   <p:sldIdLst>
-    <p:sldId xmlns:r="http://schemas.openxmlformats.org/officeDocument/2006/relationships" id="256" r:id="R7b871bc12b7a4fd0"/>
-    <p:sldId xmlns:r="http://schemas.openxmlformats.org/officeDocument/2006/relationships" id="257" r:id="Re42c28c83dc547a1"/>
-    <p:sldId xmlns:r="http://schemas.openxmlformats.org/officeDocument/2006/relationships" id="258" r:id="R59d9f3d2494e4722"/>
-    <p:sldId xmlns:r="http://schemas.openxmlformats.org/officeDocument/2006/relationships" id="259" r:id="R69dc6d1d6ff945ee"/>
-    <p:sldId xmlns:r="http://schemas.openxmlformats.org/officeDocument/2006/relationships" id="260" r:id="R4b52cb99b27b440f"/>
-    <p:sldId xmlns:r="http://schemas.openxmlformats.org/officeDocument/2006/relationships" id="261" r:id="Rb8e8f3c968a24493"/>
-    <p:sldId xmlns:r="http://schemas.openxmlformats.org/officeDocument/2006/relationships" id="262" r:id="Rcc91622eb85f43d1"/>
-    <p:sldId xmlns:r="http://schemas.openxmlformats.org/officeDocument/2006/relationships" id="263" r:id="R69422b8cc5164dee"/>
-    <p:sldId xmlns:r="http://schemas.openxmlformats.org/officeDocument/2006/relationships" id="264" r:id="R1e09ddc458e04213"/>
-    <p:sldId xmlns:r="http://schemas.openxmlformats.org/officeDocument/2006/relationships" id="265" r:id="R5a53b77e7751495f"/>
-    <p:sldId xmlns:r="http://schemas.openxmlformats.org/officeDocument/2006/relationships" id="266" r:id="Rbdeac8d0a86644a5"/>
-    <p:sldId xmlns:r="http://schemas.openxmlformats.org/officeDocument/2006/relationships" id="267" r:id="Ra3e0918bd4174f9e"/>
-    <p:sldId xmlns:r="http://schemas.openxmlformats.org/officeDocument/2006/relationships" id="268" r:id="R6628de4e55bc4054"/>
+    <p:sldId xmlns:r="http://schemas.openxmlformats.org/officeDocument/2006/relationships" id="256" r:id="R754f55c66b6f4abc"/>
+    <p:sldId xmlns:r="http://schemas.openxmlformats.org/officeDocument/2006/relationships" id="257" r:id="Re63b5571f5f44cf8"/>
+    <p:sldId xmlns:r="http://schemas.openxmlformats.org/officeDocument/2006/relationships" id="258" r:id="Ra84132f2410441fa"/>
+    <p:sldId xmlns:r="http://schemas.openxmlformats.org/officeDocument/2006/relationships" id="259" r:id="R9dc869e806ce4ade"/>
+    <p:sldId xmlns:r="http://schemas.openxmlformats.org/officeDocument/2006/relationships" id="260" r:id="R79e0796bc1cb4346"/>
+    <p:sldId xmlns:r="http://schemas.openxmlformats.org/officeDocument/2006/relationships" id="261" r:id="Re5a8fa53f9af4209"/>
+    <p:sldId xmlns:r="http://schemas.openxmlformats.org/officeDocument/2006/relationships" id="262" r:id="R66021b07484c4b4a"/>
+    <p:sldId xmlns:r="http://schemas.openxmlformats.org/officeDocument/2006/relationships" id="263" r:id="Rec3a0dd5c4d14d98"/>
+    <p:sldId xmlns:r="http://schemas.openxmlformats.org/officeDocument/2006/relationships" id="264" r:id="R35240479f899446e"/>
+    <p:sldId xmlns:r="http://schemas.openxmlformats.org/officeDocument/2006/relationships" id="265" r:id="R845909ec5c0449ff"/>
+    <p:sldId xmlns:r="http://schemas.openxmlformats.org/officeDocument/2006/relationships" id="266" r:id="R2198d6f5c9a64886"/>
+    <p:sldId xmlns:r="http://schemas.openxmlformats.org/officeDocument/2006/relationships" id="267" r:id="Rcc1b96d506844407"/>
+    <p:sldId xmlns:r="http://schemas.openxmlformats.org/officeDocument/2006/relationships" id="268" r:id="R001b1ba54ddd41e3"/>
   </p:sldIdLst>
   <p:sldSz cx="12192000" cy="6858000"/>
   <p:notesSz cx="6858000" cy="9144000"/>
@@ -774,7 +774,7 @@
           <a:lstStyle xmlns:a="http://schemas.openxmlformats.org/drawingml/2006/main"/>
           <a:p xmlns:a="http://schemas.openxmlformats.org/drawingml/2006/main">
             <a:r>
-              <a:t>180 seconds. Optional3 minutes. Simulator actualroadroute, constantspeed/dockwaitassumptions. Identicalstartingconditionshash; scenario clocks neveroverwriteoperationtime. Duplicate/outoforder retained withoutdoublecount; entireaccuracydisc determinesinside/outside; uncertainboundarynotarrival. Benchmark burstbarrier/warmdataqualifiers.</a:t>
+              <a:t>180 seconds. Optional3 minutes. Show the actual matched RoadStar comparison at shared T+40:00: baseline and 10%-speed Highway401 slowdown branches each retain2,401 acknowledged observations; the displayed progress gap is27.657km and deterministic modeled finish delta is26m46s. Matching binds route, source, clock, seed, speed, dwell and stops while excluding the declared intervention. Exact at-or-before observations are used without interpolation. Synthetic Valhalla route and modeled slowdown; no live-traffic, measured-savings or certified-GPS claim. Sources: docs/3d-slowdown-comparison.md and docs/evidence/3d-slowdown-comparison-2026-09-12/verification.json.</a:t>
             </a:r>
           </a:p>
           <a:p xmlns:a="http://schemas.openxmlformats.org/drawingml/2006/main">
@@ -1492,7 +1492,7 @@
   </p:cSld>
   <p:clrMap bg1="lt1" tx1="dk1" bg2="lt2" tx2="dk2" accent1="accent1" accent2="accent2" accent3="accent3" accent4="accent4" accent5="accent5" accent6="accent6" hlink="hlink" folHlink="folHlink"/>
   <p:sldLayoutIdLst>
-    <p:sldLayoutId xmlns:r="http://schemas.openxmlformats.org/officeDocument/2006/relationships" id="2147483649" r:id="R37678398267b4320"/>
+    <p:sldLayoutId xmlns:r="http://schemas.openxmlformats.org/officeDocument/2006/relationships" id="2147483649" r:id="R5f6f0e98cb944a68"/>
   </p:sldLayoutIdLst>
   <p:txStyles>
     <p:titleStyle>
@@ -2043,7 +2043,7 @@
           <p:cNvPr id="8" name="">
             <a:extLst xmlns:a="http://schemas.openxmlformats.org/drawingml/2006/main">
               <a:ext uri="{FF2B5EF4-FFF2-40B4-BE49-F238E27FC236}">
-                <a16:creationId xmlns:a16="http://schemas.microsoft.com/office/drawing/2014/main" id="{0BCFF40E-8D53-45FE-A8F9-71BE927E5985}"/>
+                <a16:creationId xmlns:a16="http://schemas.microsoft.com/office/drawing/2014/main" id="{7FFF05F2-4964-4C0A-9298-7B81B0FD68C2}"/>
               </a:ext>
             </a:extLst>
           </p:cNvPr>
@@ -2104,7 +2104,7 @@
           <p:nvPr/>
         </p:nvPicPr>
         <p:blipFill>
-          <a:blip xmlns:r="http://schemas.openxmlformats.org/officeDocument/2006/relationships" xmlns:a="http://schemas.openxmlformats.org/drawingml/2006/main" r:embed="R8717b160fc0241e2"/>
+          <a:blip xmlns:r="http://schemas.openxmlformats.org/officeDocument/2006/relationships" xmlns:a="http://schemas.openxmlformats.org/drawingml/2006/main" r:embed="R955bf372e1854aa3"/>
           <a:srcRect xmlns:a="http://schemas.openxmlformats.org/drawingml/2006/main" l="0" t="27" r="0" b="27"/>
           <a:stretch xmlns:a="http://schemas.openxmlformats.org/drawingml/2006/main">
             <a:fillRect l="0" t="0" r="0" b="0"/>
@@ -2129,10 +2129,10 @@
           <p:nvPr/>
         </p:nvPicPr>
         <p:blipFill>
-          <a:blip xmlns:r="http://schemas.openxmlformats.org/officeDocument/2006/relationships" xmlns:a="http://schemas.openxmlformats.org/drawingml/2006/main" r:embed="R9566382691604c12">
+          <a:blip xmlns:r="http://schemas.openxmlformats.org/officeDocument/2006/relationships" xmlns:a="http://schemas.openxmlformats.org/drawingml/2006/main" r:embed="Rb719b6abc6894228">
             <a:extLst>
               <a:ext uri="{96DAC541-7B7A-43D3-8B79-37D633B846F1}">
-                <asvg:svgBlip xmlns:asvg="http://schemas.microsoft.com/office/drawing/2016/SVG/main" r:embed="R5c7d8a758ff542cb"/>
+                <asvg:svgBlip xmlns:asvg="http://schemas.microsoft.com/office/drawing/2016/SVG/main" r:embed="Rf56cc45fb572406f"/>
               </a:ext>
             </a:extLst>
           </a:blip>
@@ -2153,7 +2153,7 @@
           <p:cNvPr id="4" name="">
             <a:extLst xmlns:a="http://schemas.openxmlformats.org/drawingml/2006/main">
               <a:ext uri="{FF2B5EF4-FFF2-40B4-BE49-F238E27FC236}">
-                <a16:creationId xmlns:a16="http://schemas.microsoft.com/office/drawing/2014/main" id="{85D4323C-DC3B-4342-89FF-030E354979F1}"/>
+                <a16:creationId xmlns:a16="http://schemas.microsoft.com/office/drawing/2014/main" id="{CDEA9352-0124-40AA-8F47-9EA5F079DA1D}"/>
               </a:ext>
             </a:extLst>
           </p:cNvPr>
@@ -2210,7 +2210,7 @@
           <p:cNvPr id="5" name="">
             <a:extLst xmlns:a="http://schemas.openxmlformats.org/drawingml/2006/main">
               <a:ext uri="{FF2B5EF4-FFF2-40B4-BE49-F238E27FC236}">
-                <a16:creationId xmlns:a16="http://schemas.microsoft.com/office/drawing/2014/main" id="{C955D690-0463-41A7-A3AD-FE6E190FB272}"/>
+                <a16:creationId xmlns:a16="http://schemas.microsoft.com/office/drawing/2014/main" id="{9A2E6B89-570C-46E0-A996-EF357378CAA7}"/>
               </a:ext>
             </a:extLst>
           </p:cNvPr>
@@ -2267,7 +2267,7 @@
           <p:cNvPr id="6" name="">
             <a:extLst xmlns:a="http://schemas.openxmlformats.org/drawingml/2006/main">
               <a:ext uri="{FF2B5EF4-FFF2-40B4-BE49-F238E27FC236}">
-                <a16:creationId xmlns:a16="http://schemas.microsoft.com/office/drawing/2014/main" id="{006027BC-06EF-446E-B5AD-B21EAB80AC51}"/>
+                <a16:creationId xmlns:a16="http://schemas.microsoft.com/office/drawing/2014/main" id="{98084747-C213-4F54-931F-8D1302095E24}"/>
               </a:ext>
             </a:extLst>
           </p:cNvPr>
@@ -2324,7 +2324,7 @@
           <p:cNvPr id="7" name="">
             <a:extLst xmlns:a="http://schemas.openxmlformats.org/drawingml/2006/main">
               <a:ext uri="{FF2B5EF4-FFF2-40B4-BE49-F238E27FC236}">
-                <a16:creationId xmlns:a16="http://schemas.microsoft.com/office/drawing/2014/main" id="{CA76D21C-A0B9-494C-BD57-383B9329C84C}"/>
+                <a16:creationId xmlns:a16="http://schemas.microsoft.com/office/drawing/2014/main" id="{10E0FF35-DFCA-4BCD-88BA-D45B19317ACE}"/>
               </a:ext>
             </a:extLst>
           </p:cNvPr>
@@ -2379,7 +2379,7 @@
     </p:spTree>
     <p:extLst>
       <p:ext uri="{BB962C8B-B14F-4D97-AF65-F5344CB8AC3E}">
-        <p14:creationId xmlns:p14="http://schemas.microsoft.com/office/powerpoint/2010/main" val="383641279"/>
+        <p14:creationId xmlns:p14="http://schemas.microsoft.com/office/powerpoint/2010/main" val="1634353398"/>
       </p:ext>
     </p:extLst>
   </p:cSld>
@@ -2410,7 +2410,7 @@
           <p:cNvPr id="10" name="">
             <a:extLst xmlns:a="http://schemas.openxmlformats.org/drawingml/2006/main">
               <a:ext uri="{FF2B5EF4-FFF2-40B4-BE49-F238E27FC236}">
-                <a16:creationId xmlns:a16="http://schemas.microsoft.com/office/drawing/2014/main" id="{88AB904F-8F56-4D34-A8E0-FC078B6AF26E}"/>
+                <a16:creationId xmlns:a16="http://schemas.microsoft.com/office/drawing/2014/main" id="{1FB0D8A7-07DD-4F04-92F8-13F64A326A6A}"/>
               </a:ext>
             </a:extLst>
           </p:cNvPr>
@@ -2467,7 +2467,7 @@
           <p:cNvPr id="2" name="">
             <a:extLst xmlns:a="http://schemas.openxmlformats.org/drawingml/2006/main">
               <a:ext uri="{FF2B5EF4-FFF2-40B4-BE49-F238E27FC236}">
-                <a16:creationId xmlns:a16="http://schemas.microsoft.com/office/drawing/2014/main" id="{9D93FB8F-5E60-4907-8A69-C07D118ACBF9}"/>
+                <a16:creationId xmlns:a16="http://schemas.microsoft.com/office/drawing/2014/main" id="{58C23CB0-D734-45B7-9E56-36AA139E34FF}"/>
               </a:ext>
             </a:extLst>
           </p:cNvPr>
@@ -2524,7 +2524,7 @@
           <p:cNvPr id="3" name="">
             <a:extLst xmlns:a="http://schemas.openxmlformats.org/drawingml/2006/main">
               <a:ext uri="{FF2B5EF4-FFF2-40B4-BE49-F238E27FC236}">
-                <a16:creationId xmlns:a16="http://schemas.microsoft.com/office/drawing/2014/main" id="{9F752442-AB2E-4653-A836-41FCA1126431}"/>
+                <a16:creationId xmlns:a16="http://schemas.microsoft.com/office/drawing/2014/main" id="{2BFB89F2-8F10-4AB0-BB13-2E1812A35DE9}"/>
               </a:ext>
             </a:extLst>
           </p:cNvPr>
@@ -2581,7 +2581,7 @@
           <p:cNvPr id="4" name="">
             <a:extLst xmlns:a="http://schemas.openxmlformats.org/drawingml/2006/main">
               <a:ext uri="{FF2B5EF4-FFF2-40B4-BE49-F238E27FC236}">
-                <a16:creationId xmlns:a16="http://schemas.microsoft.com/office/drawing/2014/main" id="{D3B2303E-4B12-43FC-A75F-F4E125CDC846}"/>
+                <a16:creationId xmlns:a16="http://schemas.microsoft.com/office/drawing/2014/main" id="{430F0232-8341-4DAE-AB9C-23E6D0063075}"/>
               </a:ext>
             </a:extLst>
           </p:cNvPr>
@@ -2661,7 +2661,7 @@
           <p:cNvPr id="5" name="">
             <a:extLst xmlns:a="http://schemas.openxmlformats.org/drawingml/2006/main">
               <a:ext uri="{FF2B5EF4-FFF2-40B4-BE49-F238E27FC236}">
-                <a16:creationId xmlns:a16="http://schemas.microsoft.com/office/drawing/2014/main" id="{52FA232B-DF6B-4781-8E33-BD7CFE94BAD6}"/>
+                <a16:creationId xmlns:a16="http://schemas.microsoft.com/office/drawing/2014/main" id="{F075E4E9-1A2F-4FD3-BE00-59B00C39F5B1}"/>
               </a:ext>
             </a:extLst>
           </p:cNvPr>
@@ -2718,7 +2718,7 @@
           <p:cNvPr id="6" name="">
             <a:extLst xmlns:a="http://schemas.openxmlformats.org/drawingml/2006/main">
               <a:ext uri="{FF2B5EF4-FFF2-40B4-BE49-F238E27FC236}">
-                <a16:creationId xmlns:a16="http://schemas.microsoft.com/office/drawing/2014/main" id="{2E3184BB-1706-4A1E-9668-029F3FAD4D2C}"/>
+                <a16:creationId xmlns:a16="http://schemas.microsoft.com/office/drawing/2014/main" id="{9B171C93-A288-449C-8B41-D0ABF47FED93}"/>
               </a:ext>
             </a:extLst>
           </p:cNvPr>
@@ -2798,7 +2798,7 @@
           <p:cNvPr id="7" name="">
             <a:extLst xmlns:a="http://schemas.openxmlformats.org/drawingml/2006/main">
               <a:ext uri="{FF2B5EF4-FFF2-40B4-BE49-F238E27FC236}">
-                <a16:creationId xmlns:a16="http://schemas.microsoft.com/office/drawing/2014/main" id="{2FDD97AE-D88E-41A5-90DF-276F813C45EE}"/>
+                <a16:creationId xmlns:a16="http://schemas.microsoft.com/office/drawing/2014/main" id="{3C4F9906-3A93-4EDA-BD44-92EC654B26C8}"/>
               </a:ext>
             </a:extLst>
           </p:cNvPr>
@@ -2901,7 +2901,7 @@
           <p:cNvPr id="8" name="">
             <a:extLst xmlns:a="http://schemas.openxmlformats.org/drawingml/2006/main">
               <a:ext uri="{FF2B5EF4-FFF2-40B4-BE49-F238E27FC236}">
-                <a16:creationId xmlns:a16="http://schemas.microsoft.com/office/drawing/2014/main" id="{FB7E3D7C-4E33-4A46-8596-F486E40CFE12}"/>
+                <a16:creationId xmlns:a16="http://schemas.microsoft.com/office/drawing/2014/main" id="{C3B7D211-52C1-4289-883D-6F9653921C65}"/>
               </a:ext>
             </a:extLst>
           </p:cNvPr>
@@ -2958,7 +2958,7 @@
           <p:cNvPr id="9" name="">
             <a:extLst xmlns:a="http://schemas.openxmlformats.org/drawingml/2006/main">
               <a:ext uri="{FF2B5EF4-FFF2-40B4-BE49-F238E27FC236}">
-                <a16:creationId xmlns:a16="http://schemas.microsoft.com/office/drawing/2014/main" id="{2E56CCF0-B031-4FC4-B038-D3011B5173C7}"/>
+                <a16:creationId xmlns:a16="http://schemas.microsoft.com/office/drawing/2014/main" id="{E983C6D2-7E94-413F-B3F1-9A2869ED307C}"/>
               </a:ext>
             </a:extLst>
           </p:cNvPr>
@@ -3036,7 +3036,7 @@
     </p:spTree>
     <p:extLst>
       <p:ext uri="{BB962C8B-B14F-4D97-AF65-F5344CB8AC3E}">
-        <p14:creationId xmlns:p14="http://schemas.microsoft.com/office/powerpoint/2010/main" val="1668099478"/>
+        <p14:creationId xmlns:p14="http://schemas.microsoft.com/office/powerpoint/2010/main" val="2134406244"/>
       </p:ext>
     </p:extLst>
   </p:cSld>
@@ -3067,7 +3067,7 @@
           <p:cNvPr id="6" name="">
             <a:extLst xmlns:a="http://schemas.openxmlformats.org/drawingml/2006/main">
               <a:ext uri="{FF2B5EF4-FFF2-40B4-BE49-F238E27FC236}">
-                <a16:creationId xmlns:a16="http://schemas.microsoft.com/office/drawing/2014/main" id="{1E7DA67A-2611-4EAA-BE41-8DC845A853C7}"/>
+                <a16:creationId xmlns:a16="http://schemas.microsoft.com/office/drawing/2014/main" id="{F674D28D-3D6F-4E54-88FF-00A6EE4AD6ED}"/>
               </a:ext>
             </a:extLst>
           </p:cNvPr>
@@ -3128,7 +3128,7 @@
           <p:nvPr/>
         </p:nvPicPr>
         <p:blipFill>
-          <a:blip xmlns:r="http://schemas.openxmlformats.org/officeDocument/2006/relationships" xmlns:a="http://schemas.openxmlformats.org/drawingml/2006/main" r:embed="R6ab6f1d078e54a00"/>
+          <a:blip xmlns:r="http://schemas.openxmlformats.org/officeDocument/2006/relationships" xmlns:a="http://schemas.openxmlformats.org/drawingml/2006/main" r:embed="R305f7ceac94d4a9a"/>
           <a:srcRect xmlns:a="http://schemas.openxmlformats.org/drawingml/2006/main" l="0" t="27" r="0" b="27"/>
           <a:stretch xmlns:a="http://schemas.openxmlformats.org/drawingml/2006/main">
             <a:fillRect l="0" t="0" r="0" b="0"/>
@@ -3149,7 +3149,7 @@
           <p:cNvPr id="3" name="">
             <a:extLst xmlns:a="http://schemas.openxmlformats.org/drawingml/2006/main">
               <a:ext uri="{FF2B5EF4-FFF2-40B4-BE49-F238E27FC236}">
-                <a16:creationId xmlns:a16="http://schemas.microsoft.com/office/drawing/2014/main" id="{C2986A70-7017-4238-AB21-0C16074C22E1}"/>
+                <a16:creationId xmlns:a16="http://schemas.microsoft.com/office/drawing/2014/main" id="{832CC63A-9C5F-4890-8970-40EAB95EB0F0}"/>
               </a:ext>
             </a:extLst>
           </p:cNvPr>
@@ -3229,7 +3229,7 @@
           <p:cNvPr id="4" name="">
             <a:extLst xmlns:a="http://schemas.openxmlformats.org/drawingml/2006/main">
               <a:ext uri="{FF2B5EF4-FFF2-40B4-BE49-F238E27FC236}">
-                <a16:creationId xmlns:a16="http://schemas.microsoft.com/office/drawing/2014/main" id="{D5A0795E-7E20-407A-B2BC-FBC9DB3F4CC9}"/>
+                <a16:creationId xmlns:a16="http://schemas.microsoft.com/office/drawing/2014/main" id="{67245C82-0C16-40B0-9ADD-6F44B80EE5DF}"/>
               </a:ext>
             </a:extLst>
           </p:cNvPr>
@@ -3332,7 +3332,7 @@
           <p:cNvPr id="5" name="">
             <a:extLst xmlns:a="http://schemas.openxmlformats.org/drawingml/2006/main">
               <a:ext uri="{FF2B5EF4-FFF2-40B4-BE49-F238E27FC236}">
-                <a16:creationId xmlns:a16="http://schemas.microsoft.com/office/drawing/2014/main" id="{D860FEED-5ACC-40A9-95E2-42663FFD48DD}"/>
+                <a16:creationId xmlns:a16="http://schemas.microsoft.com/office/drawing/2014/main" id="{D76C71F0-A62D-42A3-9519-7355FC456359}"/>
               </a:ext>
             </a:extLst>
           </p:cNvPr>
@@ -3387,7 +3387,7 @@
     </p:spTree>
     <p:extLst>
       <p:ext uri="{BB962C8B-B14F-4D97-AF65-F5344CB8AC3E}">
-        <p14:creationId xmlns:p14="http://schemas.microsoft.com/office/powerpoint/2010/main" val="1019090079"/>
+        <p14:creationId xmlns:p14="http://schemas.microsoft.com/office/powerpoint/2010/main" val="2033941771"/>
       </p:ext>
     </p:extLst>
   </p:cSld>
@@ -3418,7 +3418,7 @@
           <p:cNvPr id="13" name="">
             <a:extLst xmlns:a="http://schemas.openxmlformats.org/drawingml/2006/main">
               <a:ext uri="{FF2B5EF4-FFF2-40B4-BE49-F238E27FC236}">
-                <a16:creationId xmlns:a16="http://schemas.microsoft.com/office/drawing/2014/main" id="{0007641B-4262-4754-94B4-F74ACAC81F5D}"/>
+                <a16:creationId xmlns:a16="http://schemas.microsoft.com/office/drawing/2014/main" id="{0120E384-A86B-46BB-81C7-961ECF9EF8C3}"/>
               </a:ext>
             </a:extLst>
           </p:cNvPr>
@@ -3475,7 +3475,7 @@
           <p:cNvPr id="2" name="">
             <a:extLst xmlns:a="http://schemas.openxmlformats.org/drawingml/2006/main">
               <a:ext uri="{FF2B5EF4-FFF2-40B4-BE49-F238E27FC236}">
-                <a16:creationId xmlns:a16="http://schemas.microsoft.com/office/drawing/2014/main" id="{03A4B246-DB50-4334-A567-30163E3F7502}"/>
+                <a16:creationId xmlns:a16="http://schemas.microsoft.com/office/drawing/2014/main" id="{DB6D0C97-1033-4C18-8CBE-13CF5608BE52}"/>
               </a:ext>
             </a:extLst>
           </p:cNvPr>
@@ -3532,7 +3532,7 @@
           <p:cNvPr id="3" name="">
             <a:extLst xmlns:a="http://schemas.openxmlformats.org/drawingml/2006/main">
               <a:ext uri="{FF2B5EF4-FFF2-40B4-BE49-F238E27FC236}">
-                <a16:creationId xmlns:a16="http://schemas.microsoft.com/office/drawing/2014/main" id="{C468119B-ABF3-4756-BAE2-D730A8461524}"/>
+                <a16:creationId xmlns:a16="http://schemas.microsoft.com/office/drawing/2014/main" id="{878E5C0E-67B8-42AF-94F1-58E9E683033A}"/>
               </a:ext>
             </a:extLst>
           </p:cNvPr>
@@ -3589,7 +3589,7 @@
           <p:cNvPr id="4" name="">
             <a:extLst xmlns:a="http://schemas.openxmlformats.org/drawingml/2006/main">
               <a:ext uri="{FF2B5EF4-FFF2-40B4-BE49-F238E27FC236}">
-                <a16:creationId xmlns:a16="http://schemas.microsoft.com/office/drawing/2014/main" id="{1D993BD8-AA14-491F-8838-EC922413BE73}"/>
+                <a16:creationId xmlns:a16="http://schemas.microsoft.com/office/drawing/2014/main" id="{0D5DDA4B-5EC3-4E8A-B4D6-95A874402FB4}"/>
               </a:ext>
             </a:extLst>
           </p:cNvPr>
@@ -3646,7 +3646,7 @@
           <p:cNvPr id="5" name="">
             <a:extLst xmlns:a="http://schemas.openxmlformats.org/drawingml/2006/main">
               <a:ext uri="{FF2B5EF4-FFF2-40B4-BE49-F238E27FC236}">
-                <a16:creationId xmlns:a16="http://schemas.microsoft.com/office/drawing/2014/main" id="{908FB52B-B52F-4695-95D7-EBC751DBDB85}"/>
+                <a16:creationId xmlns:a16="http://schemas.microsoft.com/office/drawing/2014/main" id="{28313E63-BBDC-408B-B79A-BEE2F0434A9A}"/>
               </a:ext>
             </a:extLst>
           </p:cNvPr>
@@ -3703,7 +3703,7 @@
           <p:cNvPr id="6" name="">
             <a:extLst xmlns:a="http://schemas.openxmlformats.org/drawingml/2006/main">
               <a:ext uri="{FF2B5EF4-FFF2-40B4-BE49-F238E27FC236}">
-                <a16:creationId xmlns:a16="http://schemas.microsoft.com/office/drawing/2014/main" id="{DE145C97-62D6-496F-8ACD-78AEC937F4D1}"/>
+                <a16:creationId xmlns:a16="http://schemas.microsoft.com/office/drawing/2014/main" id="{304B97A4-314B-4BF3-B24A-AACC032EDBF6}"/>
               </a:ext>
             </a:extLst>
           </p:cNvPr>
@@ -3810,7 +3810,7 @@
           <p:cNvPr id="9" name="">
             <a:extLst xmlns:a="http://schemas.openxmlformats.org/drawingml/2006/main">
               <a:ext uri="{FF2B5EF4-FFF2-40B4-BE49-F238E27FC236}">
-                <a16:creationId xmlns:a16="http://schemas.microsoft.com/office/drawing/2014/main" id="{83078855-9310-4F19-A953-9B670CB5EA57}"/>
+                <a16:creationId xmlns:a16="http://schemas.microsoft.com/office/drawing/2014/main" id="{235848C1-588B-408B-AADB-15ADF32DDFDB}"/>
               </a:ext>
             </a:extLst>
           </p:cNvPr>
@@ -3890,7 +3890,7 @@
           <p:cNvPr id="10" name="">
             <a:extLst xmlns:a="http://schemas.openxmlformats.org/drawingml/2006/main">
               <a:ext uri="{FF2B5EF4-FFF2-40B4-BE49-F238E27FC236}">
-                <a16:creationId xmlns:a16="http://schemas.microsoft.com/office/drawing/2014/main" id="{FCD240DC-8DE8-4A4E-81C4-920154D1B7F7}"/>
+                <a16:creationId xmlns:a16="http://schemas.microsoft.com/office/drawing/2014/main" id="{0D96BA7E-6C76-4C8A-95F0-918A2FF121B0}"/>
               </a:ext>
             </a:extLst>
           </p:cNvPr>
@@ -3970,7 +3970,7 @@
           <p:cNvPr id="11" name="">
             <a:extLst xmlns:a="http://schemas.openxmlformats.org/drawingml/2006/main">
               <a:ext uri="{FF2B5EF4-FFF2-40B4-BE49-F238E27FC236}">
-                <a16:creationId xmlns:a16="http://schemas.microsoft.com/office/drawing/2014/main" id="{BE4D95FB-FE5E-4A81-94DD-B4118D8D6663}"/>
+                <a16:creationId xmlns:a16="http://schemas.microsoft.com/office/drawing/2014/main" id="{C181D6B2-68CD-474B-8AA6-466B33FA6065}"/>
               </a:ext>
             </a:extLst>
           </p:cNvPr>
@@ -4050,7 +4050,7 @@
           <p:cNvPr id="12" name="">
             <a:extLst xmlns:a="http://schemas.openxmlformats.org/drawingml/2006/main">
               <a:ext uri="{FF2B5EF4-FFF2-40B4-BE49-F238E27FC236}">
-                <a16:creationId xmlns:a16="http://schemas.microsoft.com/office/drawing/2014/main" id="{E945BBAA-437D-43AF-A07F-006D30959EEB}"/>
+                <a16:creationId xmlns:a16="http://schemas.microsoft.com/office/drawing/2014/main" id="{CFC3143F-431A-4866-AD57-ABD864BC5E1E}"/>
               </a:ext>
             </a:extLst>
           </p:cNvPr>
@@ -4105,7 +4105,7 @@
     </p:spTree>
     <p:extLst>
       <p:ext uri="{BB962C8B-B14F-4D97-AF65-F5344CB8AC3E}">
-        <p14:creationId xmlns:p14="http://schemas.microsoft.com/office/powerpoint/2010/main" val="514305922"/>
+        <p14:creationId xmlns:p14="http://schemas.microsoft.com/office/powerpoint/2010/main" val="490506806"/>
       </p:ext>
     </p:extLst>
   </p:cSld>
@@ -4133,10 +4133,10 @@
       </p:grpSpPr>
       <p:sp>
         <p:nvSpPr>
-          <p:cNvPr id="8" name="">
-            <a:extLst xmlns:a="http://schemas.openxmlformats.org/drawingml/2006/main">
-              <a:ext uri="{FF2B5EF4-FFF2-40B4-BE49-F238E27FC236}">
-                <a16:creationId xmlns:a16="http://schemas.microsoft.com/office/drawing/2014/main" id="{6EC85E57-F9B5-45FD-91D6-B94B9D88F258}"/>
+          <p:cNvPr id="12" name="">
+            <a:extLst xmlns:a="http://schemas.openxmlformats.org/drawingml/2006/main">
+              <a:ext uri="{FF2B5EF4-FFF2-40B4-BE49-F238E27FC236}">
+                <a16:creationId xmlns:a16="http://schemas.microsoft.com/office/drawing/2014/main" id="{DAB93187-F74C-465D-8B88-BFCC31C404D0}"/>
               </a:ext>
             </a:extLst>
           </p:cNvPr>
@@ -4193,7 +4193,7 @@
           <p:cNvPr id="2" name="">
             <a:extLst xmlns:a="http://schemas.openxmlformats.org/drawingml/2006/main">
               <a:ext uri="{FF2B5EF4-FFF2-40B4-BE49-F238E27FC236}">
-                <a16:creationId xmlns:a16="http://schemas.microsoft.com/office/drawing/2014/main" id="{43769462-D992-48A3-83FE-96197629717F}"/>
+                <a16:creationId xmlns:a16="http://schemas.microsoft.com/office/drawing/2014/main" id="{8A0CB0BD-6720-43D0-9FE5-2BECB64650B4}"/>
               </a:ext>
             </a:extLst>
           </p:cNvPr>
@@ -4240,7 +4240,7 @@
                 <a:ea typeface="Manrope"/>
                 <a:cs typeface="Manrope"/>
               </a:rPr>
-              <a:t>Replay and telemetry evidence</a:t>
+              <a:t>Matched Highway 401 slowdown</a:t>
             </a:r>
           </a:p>
         </p:txBody>
@@ -4250,36 +4250,93 @@
           <p:cNvPr id="3" name="">
             <a:extLst xmlns:a="http://schemas.openxmlformats.org/drawingml/2006/main">
               <a:ext uri="{FF2B5EF4-FFF2-40B4-BE49-F238E27FC236}">
-                <a16:creationId xmlns:a16="http://schemas.microsoft.com/office/drawing/2014/main" id="{AC9131F1-0931-466B-B1A8-F1DF47D9E294}"/>
-              </a:ext>
-            </a:extLst>
-          </p:cNvPr>
-          <p:cNvSpPr>
-            <a:spLocks xmlns:a="http://schemas.openxmlformats.org/drawingml/2006/main" noGrp="1"/>
-          </p:cNvSpPr>
-          <p:nvPr/>
-        </p:nvSpPr>
-        <p:spPr>
-          <a:xfrm xmlns:a="http://schemas.openxmlformats.org/drawingml/2006/main">
-            <a:off x="619125" y="1943100"/>
-            <a:ext cx="5010150" cy="571500"/>
-          </a:xfrm>
-          <a:prstGeom xmlns:a="http://schemas.openxmlformats.org/drawingml/2006/main" prst="rect">
-            <a:avLst/>
-          </a:prstGeom>
-          <a:noFill xmlns:a="http://schemas.openxmlformats.org/drawingml/2006/main"/>
-          <a:ln xmlns:a="http://schemas.openxmlformats.org/drawingml/2006/main" w="0">
-            <a:noFill/>
-          </a:ln>
-        </p:spPr>
-        <p:txBody>
-          <a:bodyPr xmlns:a="http://schemas.openxmlformats.org/drawingml/2006/main">
-            <a:noAutofit/>
-          </a:bodyPr>
-          <a:lstStyle xmlns:a="http://schemas.openxmlformats.org/drawingml/2006/main"/>
-          <a:p xmlns:a="http://schemas.openxmlformats.org/drawingml/2006/main">
-            <a:pPr>
-              <a:defRPr sz="2475" b="1">
+                <a16:creationId xmlns:a16="http://schemas.microsoft.com/office/drawing/2014/main" id="{04F4F9AF-9150-453A-96FC-E4E7F13709A4}"/>
+              </a:ext>
+            </a:extLst>
+          </p:cNvPr>
+          <p:cNvSpPr>
+            <a:spLocks xmlns:a="http://schemas.openxmlformats.org/drawingml/2006/main" noGrp="1"/>
+          </p:cNvSpPr>
+          <p:nvPr/>
+        </p:nvSpPr>
+        <p:spPr>
+          <a:xfrm xmlns:a="http://schemas.openxmlformats.org/drawingml/2006/main">
+            <a:off x="638175" y="1238250"/>
+            <a:ext cx="5191125" cy="638175"/>
+          </a:xfrm>
+          <a:prstGeom xmlns:a="http://schemas.openxmlformats.org/drawingml/2006/main" prst="rect">
+            <a:avLst/>
+          </a:prstGeom>
+          <a:noFill xmlns:a="http://schemas.openxmlformats.org/drawingml/2006/main"/>
+          <a:ln xmlns:a="http://schemas.openxmlformats.org/drawingml/2006/main" w="0">
+            <a:noFill/>
+          </a:ln>
+        </p:spPr>
+        <p:txBody>
+          <a:bodyPr xmlns:a="http://schemas.openxmlformats.org/drawingml/2006/main">
+            <a:noAutofit/>
+          </a:bodyPr>
+          <a:lstStyle xmlns:a="http://schemas.openxmlformats.org/drawingml/2006/main"/>
+          <a:p xmlns:a="http://schemas.openxmlformats.org/drawingml/2006/main">
+            <a:pPr>
+              <a:defRPr sz="1650" b="0">
+                <a:solidFill>
+                  <a:srgbClr val="BFC2BA"/>
+                </a:solidFill>
+                <a:latin typeface="Manrope"/>
+                <a:ea typeface="Manrope"/>
+                <a:cs typeface="Manrope"/>
+              </a:defRPr>
+            </a:pPr>
+            <a:r>
+              <a:rPr sz="1650" b="0">
+                <a:solidFill>
+                  <a:srgbClr val="BFC2BA"/>
+                </a:solidFill>
+                <a:latin typeface="Manrope"/>
+                <a:ea typeface="Manrope"/>
+                <a:cs typeface="Manrope"/>
+              </a:rPr>
+              <a:t>Same route, seed, clock, dwell and source · only the road intervention changes</a:t>
+            </a:r>
+          </a:p>
+        </p:txBody>
+      </p:sp>
+      <p:sp>
+        <p:nvSpPr>
+          <p:cNvPr id="4" name="">
+            <a:extLst xmlns:a="http://schemas.openxmlformats.org/drawingml/2006/main">
+              <a:ext uri="{FF2B5EF4-FFF2-40B4-BE49-F238E27FC236}">
+                <a16:creationId xmlns:a16="http://schemas.microsoft.com/office/drawing/2014/main" id="{51E32E9E-C8A9-43AB-851A-8CABCF872AC7}"/>
+              </a:ext>
+            </a:extLst>
+          </p:cNvPr>
+          <p:cNvSpPr>
+            <a:spLocks xmlns:a="http://schemas.openxmlformats.org/drawingml/2006/main" noGrp="1"/>
+          </p:cNvSpPr>
+          <p:nvPr/>
+        </p:nvSpPr>
+        <p:spPr>
+          <a:xfrm xmlns:a="http://schemas.openxmlformats.org/drawingml/2006/main">
+            <a:off x="619125" y="2028825"/>
+            <a:ext cx="4857750" cy="666750"/>
+          </a:xfrm>
+          <a:prstGeom xmlns:a="http://schemas.openxmlformats.org/drawingml/2006/main" prst="rect">
+            <a:avLst/>
+          </a:prstGeom>
+          <a:noFill xmlns:a="http://schemas.openxmlformats.org/drawingml/2006/main"/>
+          <a:ln xmlns:a="http://schemas.openxmlformats.org/drawingml/2006/main" w="0">
+            <a:noFill/>
+          </a:ln>
+        </p:spPr>
+        <p:txBody>
+          <a:bodyPr xmlns:a="http://schemas.openxmlformats.org/drawingml/2006/main">
+            <a:noAutofit/>
+          </a:bodyPr>
+          <a:lstStyle xmlns:a="http://schemas.openxmlformats.org/drawingml/2006/main"/>
+          <a:p xmlns:a="http://schemas.openxmlformats.org/drawingml/2006/main">
+            <a:pPr>
+              <a:defRPr sz="4050" b="1">
                 <a:solidFill>
                   <a:srgbClr val="F5F3ED"/>
                 </a:solidFill>
@@ -4289,7 +4346,7 @@
               </a:defRPr>
             </a:pPr>
             <a:r>
-              <a:rPr sz="2475" b="1">
+              <a:rPr sz="4050" b="1">
                 <a:solidFill>
                   <a:srgbClr val="F5F3ED"/>
                 </a:solidFill>
@@ -4297,46 +4354,217 @@
                 <a:ea typeface="Manrope"/>
                 <a:cs typeface="Manrope"/>
               </a:rPr>
-              <a:t>Replay conditions</a:t>
-            </a:r>
-          </a:p>
-        </p:txBody>
-      </p:sp>
-      <p:sp>
-        <p:nvSpPr>
-          <p:cNvPr id="4" name="">
-            <a:extLst xmlns:a="http://schemas.openxmlformats.org/drawingml/2006/main">
-              <a:ext uri="{FF2B5EF4-FFF2-40B4-BE49-F238E27FC236}">
-                <a16:creationId xmlns:a16="http://schemas.microsoft.com/office/drawing/2014/main" id="{897BB7A1-5DF1-46AC-9C01-06E07DE9440A}"/>
-              </a:ext>
-            </a:extLst>
-          </p:cNvPr>
-          <p:cNvSpPr>
-            <a:spLocks xmlns:a="http://schemas.openxmlformats.org/drawingml/2006/main" noGrp="1"/>
-          </p:cNvSpPr>
-          <p:nvPr/>
-        </p:nvSpPr>
-        <p:spPr>
-          <a:xfrm xmlns:a="http://schemas.openxmlformats.org/drawingml/2006/main">
-            <a:off x="6677025" y="1943100"/>
-            <a:ext cx="5038725" cy="571500"/>
-          </a:xfrm>
-          <a:prstGeom xmlns:a="http://schemas.openxmlformats.org/drawingml/2006/main" prst="rect">
-            <a:avLst/>
-          </a:prstGeom>
-          <a:noFill xmlns:a="http://schemas.openxmlformats.org/drawingml/2006/main"/>
-          <a:ln xmlns:a="http://schemas.openxmlformats.org/drawingml/2006/main" w="0">
-            <a:noFill/>
-          </a:ln>
-        </p:spPr>
-        <p:txBody>
-          <a:bodyPr xmlns:a="http://schemas.openxmlformats.org/drawingml/2006/main">
-            <a:noAutofit/>
-          </a:bodyPr>
-          <a:lstStyle xmlns:a="http://schemas.openxmlformats.org/drawingml/2006/main"/>
-          <a:p xmlns:a="http://schemas.openxmlformats.org/drawingml/2006/main">
-            <a:pPr>
-              <a:defRPr sz="2475" b="1">
+              <a:t>2,401 × 2</a:t>
+            </a:r>
+          </a:p>
+        </p:txBody>
+      </p:sp>
+      <p:sp>
+        <p:nvSpPr>
+          <p:cNvPr id="5" name="">
+            <a:extLst xmlns:a="http://schemas.openxmlformats.org/drawingml/2006/main">
+              <a:ext uri="{FF2B5EF4-FFF2-40B4-BE49-F238E27FC236}">
+                <a16:creationId xmlns:a16="http://schemas.microsoft.com/office/drawing/2014/main" id="{CE255608-29FC-42F1-A31B-F4EA1A7ECD14}"/>
+              </a:ext>
+            </a:extLst>
+          </p:cNvPr>
+          <p:cNvSpPr>
+            <a:spLocks xmlns:a="http://schemas.openxmlformats.org/drawingml/2006/main" noGrp="1"/>
+          </p:cNvSpPr>
+          <p:nvPr/>
+        </p:nvSpPr>
+        <p:spPr>
+          <a:xfrm xmlns:a="http://schemas.openxmlformats.org/drawingml/2006/main">
+            <a:off x="657225" y="2714625"/>
+            <a:ext cx="4667250" cy="361950"/>
+          </a:xfrm>
+          <a:prstGeom xmlns:a="http://schemas.openxmlformats.org/drawingml/2006/main" prst="rect">
+            <a:avLst/>
+          </a:prstGeom>
+          <a:noFill xmlns:a="http://schemas.openxmlformats.org/drawingml/2006/main"/>
+          <a:ln xmlns:a="http://schemas.openxmlformats.org/drawingml/2006/main" w="0">
+            <a:noFill/>
+          </a:ln>
+        </p:spPr>
+        <p:txBody>
+          <a:bodyPr xmlns:a="http://schemas.openxmlformats.org/drawingml/2006/main">
+            <a:noAutofit/>
+          </a:bodyPr>
+          <a:lstStyle xmlns:a="http://schemas.openxmlformats.org/drawingml/2006/main"/>
+          <a:p xmlns:a="http://schemas.openxmlformats.org/drawingml/2006/main">
+            <a:pPr>
+              <a:defRPr sz="1650" b="0">
+                <a:solidFill>
+                  <a:srgbClr val="BFC2BA"/>
+                </a:solidFill>
+                <a:latin typeface="Manrope"/>
+                <a:ea typeface="Manrope"/>
+                <a:cs typeface="Manrope"/>
+              </a:defRPr>
+            </a:pPr>
+            <a:r>
+              <a:rPr sz="1650" b="0">
+                <a:solidFill>
+                  <a:srgbClr val="BFC2BA"/>
+                </a:solidFill>
+                <a:latin typeface="Manrope"/>
+                <a:ea typeface="Manrope"/>
+                <a:cs typeface="Manrope"/>
+              </a:rPr>
+              <a:t>acknowledged observations</a:t>
+            </a:r>
+          </a:p>
+        </p:txBody>
+      </p:sp>
+      <p:sp>
+        <p:nvSpPr>
+          <p:cNvPr id="6" name="">
+            <a:extLst xmlns:a="http://schemas.openxmlformats.org/drawingml/2006/main">
+              <a:ext uri="{FF2B5EF4-FFF2-40B4-BE49-F238E27FC236}">
+                <a16:creationId xmlns:a16="http://schemas.microsoft.com/office/drawing/2014/main" id="{734D0EE2-8652-4C2C-A0FD-318897BD5239}"/>
+              </a:ext>
+            </a:extLst>
+          </p:cNvPr>
+          <p:cNvSpPr>
+            <a:spLocks xmlns:a="http://schemas.openxmlformats.org/drawingml/2006/main" noGrp="1"/>
+          </p:cNvSpPr>
+          <p:nvPr/>
+        </p:nvSpPr>
+        <p:spPr>
+          <a:xfrm xmlns:a="http://schemas.openxmlformats.org/drawingml/2006/main">
+            <a:off x="619125" y="3381375"/>
+            <a:ext cx="4857750" cy="647700"/>
+          </a:xfrm>
+          <a:prstGeom xmlns:a="http://schemas.openxmlformats.org/drawingml/2006/main" prst="rect">
+            <a:avLst/>
+          </a:prstGeom>
+          <a:noFill xmlns:a="http://schemas.openxmlformats.org/drawingml/2006/main"/>
+          <a:ln xmlns:a="http://schemas.openxmlformats.org/drawingml/2006/main" w="0">
+            <a:noFill/>
+          </a:ln>
+        </p:spPr>
+        <p:txBody>
+          <a:bodyPr xmlns:a="http://schemas.openxmlformats.org/drawingml/2006/main">
+            <a:noAutofit/>
+          </a:bodyPr>
+          <a:lstStyle xmlns:a="http://schemas.openxmlformats.org/drawingml/2006/main"/>
+          <a:p xmlns:a="http://schemas.openxmlformats.org/drawingml/2006/main">
+            <a:pPr>
+              <a:defRPr sz="3600" b="1">
+                <a:solidFill>
+                  <a:srgbClr val="E65C32"/>
+                </a:solidFill>
+                <a:latin typeface="Manrope"/>
+                <a:ea typeface="Manrope"/>
+                <a:cs typeface="Manrope"/>
+              </a:defRPr>
+            </a:pPr>
+            <a:r>
+              <a:rPr sz="3600" b="1">
+                <a:solidFill>
+                  <a:srgbClr val="E65C32"/>
+                </a:solidFill>
+                <a:latin typeface="Manrope"/>
+                <a:ea typeface="Manrope"/>
+                <a:cs typeface="Manrope"/>
+              </a:rPr>
+              <a:t>+27.657 km</a:t>
+            </a:r>
+          </a:p>
+        </p:txBody>
+      </p:sp>
+      <p:sp>
+        <p:nvSpPr>
+          <p:cNvPr id="7" name="">
+            <a:extLst xmlns:a="http://schemas.openxmlformats.org/drawingml/2006/main">
+              <a:ext uri="{FF2B5EF4-FFF2-40B4-BE49-F238E27FC236}">
+                <a16:creationId xmlns:a16="http://schemas.microsoft.com/office/drawing/2014/main" id="{820005A0-64B4-476C-B49E-B2E1D3104BB4}"/>
+              </a:ext>
+            </a:extLst>
+          </p:cNvPr>
+          <p:cNvSpPr>
+            <a:spLocks xmlns:a="http://schemas.openxmlformats.org/drawingml/2006/main" noGrp="1"/>
+          </p:cNvSpPr>
+          <p:nvPr/>
+        </p:nvSpPr>
+        <p:spPr>
+          <a:xfrm xmlns:a="http://schemas.openxmlformats.org/drawingml/2006/main">
+            <a:off x="657225" y="4048125"/>
+            <a:ext cx="4667250" cy="361950"/>
+          </a:xfrm>
+          <a:prstGeom xmlns:a="http://schemas.openxmlformats.org/drawingml/2006/main" prst="rect">
+            <a:avLst/>
+          </a:prstGeom>
+          <a:noFill xmlns:a="http://schemas.openxmlformats.org/drawingml/2006/main"/>
+          <a:ln xmlns:a="http://schemas.openxmlformats.org/drawingml/2006/main" w="0">
+            <a:noFill/>
+          </a:ln>
+        </p:spPr>
+        <p:txBody>
+          <a:bodyPr xmlns:a="http://schemas.openxmlformats.org/drawingml/2006/main">
+            <a:noAutofit/>
+          </a:bodyPr>
+          <a:lstStyle xmlns:a="http://schemas.openxmlformats.org/drawingml/2006/main"/>
+          <a:p xmlns:a="http://schemas.openxmlformats.org/drawingml/2006/main">
+            <a:pPr>
+              <a:defRPr sz="1650" b="0">
+                <a:solidFill>
+                  <a:srgbClr val="BFC2BA"/>
+                </a:solidFill>
+                <a:latin typeface="Manrope"/>
+                <a:ea typeface="Manrope"/>
+                <a:cs typeface="Manrope"/>
+              </a:defRPr>
+            </a:pPr>
+            <a:r>
+              <a:rPr sz="1650" b="0">
+                <a:solidFill>
+                  <a:srgbClr val="BFC2BA"/>
+                </a:solidFill>
+                <a:latin typeface="Manrope"/>
+                <a:ea typeface="Manrope"/>
+                <a:cs typeface="Manrope"/>
+              </a:rPr>
+              <a:t>progress gap at T+40:00</a:t>
+            </a:r>
+          </a:p>
+        </p:txBody>
+      </p:sp>
+      <p:sp>
+        <p:nvSpPr>
+          <p:cNvPr id="8" name="">
+            <a:extLst xmlns:a="http://schemas.openxmlformats.org/drawingml/2006/main">
+              <a:ext uri="{FF2B5EF4-FFF2-40B4-BE49-F238E27FC236}">
+                <a16:creationId xmlns:a16="http://schemas.microsoft.com/office/drawing/2014/main" id="{21336549-12E0-4E68-B586-B409220EAB4E}"/>
+              </a:ext>
+            </a:extLst>
+          </p:cNvPr>
+          <p:cNvSpPr>
+            <a:spLocks xmlns:a="http://schemas.openxmlformats.org/drawingml/2006/main" noGrp="1"/>
+          </p:cNvSpPr>
+          <p:nvPr/>
+        </p:nvSpPr>
+        <p:spPr>
+          <a:xfrm xmlns:a="http://schemas.openxmlformats.org/drawingml/2006/main">
+            <a:off x="619125" y="4695825"/>
+            <a:ext cx="4857750" cy="647700"/>
+          </a:xfrm>
+          <a:prstGeom xmlns:a="http://schemas.openxmlformats.org/drawingml/2006/main" prst="rect">
+            <a:avLst/>
+          </a:prstGeom>
+          <a:noFill xmlns:a="http://schemas.openxmlformats.org/drawingml/2006/main"/>
+          <a:ln xmlns:a="http://schemas.openxmlformats.org/drawingml/2006/main" w="0">
+            <a:noFill/>
+          </a:ln>
+        </p:spPr>
+        <p:txBody>
+          <a:bodyPr xmlns:a="http://schemas.openxmlformats.org/drawingml/2006/main">
+            <a:noAutofit/>
+          </a:bodyPr>
+          <a:lstStyle xmlns:a="http://schemas.openxmlformats.org/drawingml/2006/main"/>
+          <a:p xmlns:a="http://schemas.openxmlformats.org/drawingml/2006/main">
+            <a:pPr>
+              <a:defRPr sz="3600" b="1">
                 <a:solidFill>
                   <a:srgbClr val="F5F3ED"/>
                 </a:solidFill>
@@ -4346,7 +4574,7 @@
               </a:defRPr>
             </a:pPr>
             <a:r>
-              <a:rPr sz="2475" b="1">
+              <a:rPr sz="3600" b="1">
                 <a:solidFill>
                   <a:srgbClr val="F5F3ED"/>
                 </a:solidFill>
@@ -4354,46 +4582,46 @@
                 <a:ea typeface="Manrope"/>
                 <a:cs typeface="Manrope"/>
               </a:rPr>
-              <a:t>Telemetry interpretation</a:t>
-            </a:r>
-          </a:p>
-        </p:txBody>
-      </p:sp>
-      <p:sp>
-        <p:nvSpPr>
-          <p:cNvPr id="5" name="">
-            <a:extLst xmlns:a="http://schemas.openxmlformats.org/drawingml/2006/main">
-              <a:ext uri="{FF2B5EF4-FFF2-40B4-BE49-F238E27FC236}">
-                <a16:creationId xmlns:a16="http://schemas.microsoft.com/office/drawing/2014/main" id="{7760A21E-AAA2-407A-8FD6-BB68ADCD8064}"/>
-              </a:ext>
-            </a:extLst>
-          </p:cNvPr>
-          <p:cNvSpPr>
-            <a:spLocks xmlns:a="http://schemas.openxmlformats.org/drawingml/2006/main" noGrp="1"/>
-          </p:cNvSpPr>
-          <p:nvPr/>
-        </p:nvSpPr>
-        <p:spPr>
-          <a:xfrm xmlns:a="http://schemas.openxmlformats.org/drawingml/2006/main">
-            <a:off x="657225" y="2924175"/>
-            <a:ext cx="4886325" cy="1809750"/>
-          </a:xfrm>
-          <a:prstGeom xmlns:a="http://schemas.openxmlformats.org/drawingml/2006/main" prst="rect">
-            <a:avLst/>
-          </a:prstGeom>
-          <a:noFill xmlns:a="http://schemas.openxmlformats.org/drawingml/2006/main"/>
-          <a:ln xmlns:a="http://schemas.openxmlformats.org/drawingml/2006/main" w="0">
-            <a:noFill/>
-          </a:ln>
-        </p:spPr>
-        <p:txBody>
-          <a:bodyPr xmlns:a="http://schemas.openxmlformats.org/drawingml/2006/main">
-            <a:noAutofit/>
-          </a:bodyPr>
-          <a:lstStyle xmlns:a="http://schemas.openxmlformats.org/drawingml/2006/main"/>
-          <a:p xmlns:a="http://schemas.openxmlformats.org/drawingml/2006/main">
-            <a:pPr>
-              <a:defRPr sz="2100" b="0">
+              <a:t>+26m46s</a:t>
+            </a:r>
+          </a:p>
+        </p:txBody>
+      </p:sp>
+      <p:sp>
+        <p:nvSpPr>
+          <p:cNvPr id="9" name="">
+            <a:extLst xmlns:a="http://schemas.openxmlformats.org/drawingml/2006/main">
+              <a:ext uri="{FF2B5EF4-FFF2-40B4-BE49-F238E27FC236}">
+                <a16:creationId xmlns:a16="http://schemas.microsoft.com/office/drawing/2014/main" id="{E9E4F748-A1E5-4B47-8A82-A6E101332954}"/>
+              </a:ext>
+            </a:extLst>
+          </p:cNvPr>
+          <p:cNvSpPr>
+            <a:spLocks xmlns:a="http://schemas.openxmlformats.org/drawingml/2006/main" noGrp="1"/>
+          </p:cNvSpPr>
+          <p:nvPr/>
+        </p:nvSpPr>
+        <p:spPr>
+          <a:xfrm xmlns:a="http://schemas.openxmlformats.org/drawingml/2006/main">
+            <a:off x="657225" y="5362575"/>
+            <a:ext cx="4667250" cy="361950"/>
+          </a:xfrm>
+          <a:prstGeom xmlns:a="http://schemas.openxmlformats.org/drawingml/2006/main" prst="rect">
+            <a:avLst/>
+          </a:prstGeom>
+          <a:noFill xmlns:a="http://schemas.openxmlformats.org/drawingml/2006/main"/>
+          <a:ln xmlns:a="http://schemas.openxmlformats.org/drawingml/2006/main" w="0">
+            <a:noFill/>
+          </a:ln>
+        </p:spPr>
+        <p:txBody>
+          <a:bodyPr xmlns:a="http://schemas.openxmlformats.org/drawingml/2006/main">
+            <a:noAutofit/>
+          </a:bodyPr>
+          <a:lstStyle xmlns:a="http://schemas.openxmlformats.org/drawingml/2006/main"/>
+          <a:p xmlns:a="http://schemas.openxmlformats.org/drawingml/2006/main">
+            <a:pPr>
+              <a:defRPr sz="1650" b="0">
                 <a:solidFill>
                   <a:srgbClr val="BFC2BA"/>
                 </a:solidFill>
@@ -4403,7 +4631,7 @@
               </a:defRPr>
             </a:pPr>
             <a:r>
-              <a:rPr sz="2100" b="0">
+              <a:rPr sz="1650" b="0">
                 <a:solidFill>
                   <a:srgbClr val="BFC2BA"/>
                 </a:solidFill>
@@ -4411,12 +4639,46 @@
                 <a:ea typeface="Manrope"/>
                 <a:cs typeface="Manrope"/>
               </a:rPr>
-              <a:t>Recorded starting conditions</a:t>
-            </a:r>
-          </a:p>
-          <a:p xmlns:a="http://schemas.openxmlformats.org/drawingml/2006/main">
-            <a:pPr>
-              <a:defRPr sz="2100" b="0">
+              <a:t>modeled finish delta</a:t>
+            </a:r>
+          </a:p>
+        </p:txBody>
+      </p:sp>
+      <p:sp>
+        <p:nvSpPr>
+          <p:cNvPr id="10" name="">
+            <a:extLst xmlns:a="http://schemas.openxmlformats.org/drawingml/2006/main">
+              <a:ext uri="{FF2B5EF4-FFF2-40B4-BE49-F238E27FC236}">
+                <a16:creationId xmlns:a16="http://schemas.microsoft.com/office/drawing/2014/main" id="{9F974C7E-421E-4A07-B412-848DF79E3135}"/>
+              </a:ext>
+            </a:extLst>
+          </p:cNvPr>
+          <p:cNvSpPr>
+            <a:spLocks xmlns:a="http://schemas.openxmlformats.org/drawingml/2006/main" noGrp="1"/>
+          </p:cNvSpPr>
+          <p:nvPr/>
+        </p:nvSpPr>
+        <p:spPr>
+          <a:xfrm xmlns:a="http://schemas.openxmlformats.org/drawingml/2006/main">
+            <a:off x="657225" y="5953125"/>
+            <a:ext cx="4857750" cy="571500"/>
+          </a:xfrm>
+          <a:prstGeom xmlns:a="http://schemas.openxmlformats.org/drawingml/2006/main" prst="rect">
+            <a:avLst/>
+          </a:prstGeom>
+          <a:noFill xmlns:a="http://schemas.openxmlformats.org/drawingml/2006/main"/>
+          <a:ln xmlns:a="http://schemas.openxmlformats.org/drawingml/2006/main" w="0">
+            <a:noFill/>
+          </a:ln>
+        </p:spPr>
+        <p:txBody>
+          <a:bodyPr xmlns:a="http://schemas.openxmlformats.org/drawingml/2006/main">
+            <a:noAutofit/>
+          </a:bodyPr>
+          <a:lstStyle xmlns:a="http://schemas.openxmlformats.org/drawingml/2006/main"/>
+          <a:p xmlns:a="http://schemas.openxmlformats.org/drawingml/2006/main">
+            <a:pPr>
+              <a:defRPr sz="1350" b="0">
                 <a:solidFill>
                   <a:srgbClr val="BFC2BA"/>
                 </a:solidFill>
@@ -4426,7 +4688,7 @@
               </a:defRPr>
             </a:pPr>
             <a:r>
-              <a:rPr sz="2100" b="0">
+              <a:rPr sz="1350" b="0">
                 <a:solidFill>
                   <a:srgbClr val="BFC2BA"/>
                 </a:solidFill>
@@ -4434,12 +4696,12 @@
                 <a:ea typeface="Manrope"/>
                 <a:cs typeface="Manrope"/>
               </a:rPr>
-              <a:t>Disclosed dock wait and road assumptions</a:t>
-            </a:r>
-          </a:p>
-          <a:p xmlns:a="http://schemas.openxmlformats.org/drawingml/2006/main">
-            <a:pPr>
-              <a:defRPr sz="2100" b="0">
+              <a:t>Exact at-or-before samples · no interpolation</a:t>
+            </a:r>
+          </a:p>
+          <a:p xmlns:a="http://schemas.openxmlformats.org/drawingml/2006/main">
+            <a:pPr>
+              <a:defRPr sz="1350" b="0">
                 <a:solidFill>
                   <a:srgbClr val="BFC2BA"/>
                 </a:solidFill>
@@ -4449,7 +4711,7 @@
               </a:defRPr>
             </a:pPr>
             <a:r>
-              <a:rPr sz="2100" b="0">
+              <a:rPr sz="1350" b="0">
                 <a:solidFill>
                   <a:srgbClr val="BFC2BA"/>
                 </a:solidFill>
@@ -4457,175 +4719,37 @@
                 <a:ea typeface="Manrope"/>
                 <a:cs typeface="Manrope"/>
               </a:rPr>
-              <a:t>An independent scenario clock</a:t>
-            </a:r>
-          </a:p>
-        </p:txBody>
-      </p:sp>
-      <p:sp>
-        <p:nvSpPr>
-          <p:cNvPr id="6" name="">
-            <a:extLst xmlns:a="http://schemas.openxmlformats.org/drawingml/2006/main">
-              <a:ext uri="{FF2B5EF4-FFF2-40B4-BE49-F238E27FC236}">
-                <a16:creationId xmlns:a16="http://schemas.microsoft.com/office/drawing/2014/main" id="{58A428E8-B9E6-4611-88B9-E2702D53C524}"/>
-              </a:ext>
-            </a:extLst>
-          </p:cNvPr>
-          <p:cNvSpPr>
-            <a:spLocks xmlns:a="http://schemas.openxmlformats.org/drawingml/2006/main" noGrp="1"/>
-          </p:cNvSpPr>
-          <p:nvPr/>
-        </p:nvSpPr>
-        <p:spPr>
-          <a:xfrm xmlns:a="http://schemas.openxmlformats.org/drawingml/2006/main">
-            <a:off x="6705600" y="2924175"/>
-            <a:ext cx="4924425" cy="1809750"/>
-          </a:xfrm>
-          <a:prstGeom xmlns:a="http://schemas.openxmlformats.org/drawingml/2006/main" prst="rect">
-            <a:avLst/>
-          </a:prstGeom>
-          <a:noFill xmlns:a="http://schemas.openxmlformats.org/drawingml/2006/main"/>
-          <a:ln xmlns:a="http://schemas.openxmlformats.org/drawingml/2006/main" w="0">
-            <a:noFill/>
-          </a:ln>
-        </p:spPr>
-        <p:txBody>
-          <a:bodyPr xmlns:a="http://schemas.openxmlformats.org/drawingml/2006/main">
-            <a:noAutofit/>
-          </a:bodyPr>
-          <a:lstStyle xmlns:a="http://schemas.openxmlformats.org/drawingml/2006/main"/>
-          <a:p xmlns:a="http://schemas.openxmlformats.org/drawingml/2006/main">
-            <a:pPr>
-              <a:defRPr sz="2100" b="0">
-                <a:solidFill>
-                  <a:srgbClr val="BFC2BA"/>
-                </a:solidFill>
-                <a:latin typeface="Manrope"/>
-                <a:ea typeface="Manrope"/>
-                <a:cs typeface="Manrope"/>
-              </a:defRPr>
-            </a:pPr>
-            <a:r>
-              <a:rPr sz="2100" b="0">
-                <a:solidFill>
-                  <a:srgbClr val="BFC2BA"/>
-                </a:solidFill>
-                <a:latin typeface="Manrope"/>
-                <a:ea typeface="Manrope"/>
-                <a:cs typeface="Manrope"/>
-              </a:rPr>
-              <a:t>Duplicate samples do not double-count</a:t>
-            </a:r>
-          </a:p>
-          <a:p xmlns:a="http://schemas.openxmlformats.org/drawingml/2006/main">
-            <a:pPr>
-              <a:defRPr sz="2100" b="0">
-                <a:solidFill>
-                  <a:srgbClr val="BFC2BA"/>
-                </a:solidFill>
-                <a:latin typeface="Manrope"/>
-                <a:ea typeface="Manrope"/>
-                <a:cs typeface="Manrope"/>
-              </a:defRPr>
-            </a:pPr>
-            <a:r>
-              <a:rPr sz="2100" b="0">
-                <a:solidFill>
-                  <a:srgbClr val="BFC2BA"/>
-                </a:solidFill>
-                <a:latin typeface="Manrope"/>
-                <a:ea typeface="Manrope"/>
-                <a:cs typeface="Manrope"/>
-              </a:rPr>
-              <a:t>Out-of-order samples retain history</a:t>
-            </a:r>
-          </a:p>
-          <a:p xmlns:a="http://schemas.openxmlformats.org/drawingml/2006/main">
-            <a:pPr>
-              <a:defRPr sz="2100" b="0">
-                <a:solidFill>
-                  <a:srgbClr val="BFC2BA"/>
-                </a:solidFill>
-                <a:latin typeface="Manrope"/>
-                <a:ea typeface="Manrope"/>
-                <a:cs typeface="Manrope"/>
-              </a:defRPr>
-            </a:pPr>
-            <a:r>
-              <a:rPr sz="2100" b="0">
-                <a:solidFill>
-                  <a:srgbClr val="BFC2BA"/>
-                </a:solidFill>
-                <a:latin typeface="Manrope"/>
-                <a:ea typeface="Manrope"/>
-                <a:cs typeface="Manrope"/>
-              </a:rPr>
-              <a:t>Uncertain boundaries stay uncertain</a:t>
-            </a:r>
-          </a:p>
-        </p:txBody>
-      </p:sp>
-      <p:sp>
-        <p:nvSpPr>
-          <p:cNvPr id="7" name="">
-            <a:extLst xmlns:a="http://schemas.openxmlformats.org/drawingml/2006/main">
-              <a:ext uri="{FF2B5EF4-FFF2-40B4-BE49-F238E27FC236}">
-                <a16:creationId xmlns:a16="http://schemas.microsoft.com/office/drawing/2014/main" id="{B3E8382B-593D-48E8-8F4D-8F497E0E2C5F}"/>
-              </a:ext>
-            </a:extLst>
-          </p:cNvPr>
-          <p:cNvSpPr>
-            <a:spLocks xmlns:a="http://schemas.openxmlformats.org/drawingml/2006/main" noGrp="1"/>
-          </p:cNvSpPr>
-          <p:nvPr/>
-        </p:nvSpPr>
-        <p:spPr>
-          <a:xfrm xmlns:a="http://schemas.openxmlformats.org/drawingml/2006/main">
-            <a:off x="647700" y="5581650"/>
-            <a:ext cx="10477500" cy="571500"/>
-          </a:xfrm>
-          <a:prstGeom xmlns:a="http://schemas.openxmlformats.org/drawingml/2006/main" prst="rect">
-            <a:avLst/>
-          </a:prstGeom>
-          <a:noFill xmlns:a="http://schemas.openxmlformats.org/drawingml/2006/main"/>
-          <a:ln xmlns:a="http://schemas.openxmlformats.org/drawingml/2006/main" w="0">
-            <a:noFill/>
-          </a:ln>
-        </p:spPr>
-        <p:txBody>
-          <a:bodyPr xmlns:a="http://schemas.openxmlformats.org/drawingml/2006/main">
-            <a:noAutofit/>
-          </a:bodyPr>
-          <a:lstStyle xmlns:a="http://schemas.openxmlformats.org/drawingml/2006/main"/>
-          <a:p xmlns:a="http://schemas.openxmlformats.org/drawingml/2006/main">
-            <a:pPr>
-              <a:defRPr sz="2025" b="0">
-                <a:solidFill>
-                  <a:srgbClr val="F5F3ED"/>
-                </a:solidFill>
-                <a:latin typeface="Manrope"/>
-                <a:ea typeface="Manrope"/>
-                <a:cs typeface="Manrope"/>
-              </a:defRPr>
-            </a:pPr>
-            <a:r>
-              <a:rPr sz="2025" b="0">
-                <a:solidFill>
-                  <a:srgbClr val="F5F3ED"/>
-                </a:solidFill>
-                <a:latin typeface="Manrope"/>
-                <a:ea typeface="Manrope"/>
-                <a:cs typeface="Manrope"/>
-              </a:rPr>
-              <a:t>Operational outcomes remain separate from modeled savings.</a:t>
-            </a:r>
-          </a:p>
-        </p:txBody>
-      </p:sp>
+              <a:t>Synthetic route and slowdown; no live-traffic claim.</a:t>
+            </a:r>
+          </a:p>
+        </p:txBody>
+      </p:sp>
+      <p:pic>
+        <p:nvPicPr>
+          <p:cNvPr id="22" name=""/>
+          <p:cNvPicPr>
+            <a:picLocks xmlns:a="http://schemas.openxmlformats.org/drawingml/2006/main" noChangeAspect="1"/>
+          </p:cNvPicPr>
+          <p:nvPr/>
+        </p:nvPicPr>
+        <p:blipFill>
+          <a:blip xmlns:r="http://schemas.openxmlformats.org/officeDocument/2006/relationships" xmlns:a="http://schemas.openxmlformats.org/drawingml/2006/main" r:embed="R226f9879ea8540de"/>
+          <a:stretch xmlns:a="http://schemas.openxmlformats.org/drawingml/2006/main"/>
+        </p:blipFill>
+        <p:spPr>
+          <a:xfrm xmlns:a="http://schemas.openxmlformats.org/drawingml/2006/main">
+            <a:off x="6274662" y="1323975"/>
+            <a:ext cx="4995726" cy="5143500"/>
+          </a:xfrm>
+          <a:prstGeom xmlns:a="http://schemas.openxmlformats.org/drawingml/2006/main" prst="rect">
+            <a:avLst/>
+          </a:prstGeom>
+        </p:spPr>
+      </p:pic>
     </p:spTree>
     <p:extLst>
       <p:ext uri="{BB962C8B-B14F-4D97-AF65-F5344CB8AC3E}">
-        <p14:creationId xmlns:p14="http://schemas.microsoft.com/office/powerpoint/2010/main" val="108231240"/>
+        <p14:creationId xmlns:p14="http://schemas.microsoft.com/office/powerpoint/2010/main" val="730583710"/>
       </p:ext>
     </p:extLst>
   </p:cSld>
@@ -4656,7 +4780,7 @@
           <p:cNvPr id="10" name="">
             <a:extLst xmlns:a="http://schemas.openxmlformats.org/drawingml/2006/main">
               <a:ext uri="{FF2B5EF4-FFF2-40B4-BE49-F238E27FC236}">
-                <a16:creationId xmlns:a16="http://schemas.microsoft.com/office/drawing/2014/main" id="{DADB0928-70AA-429E-9058-99B849D418A3}"/>
+                <a16:creationId xmlns:a16="http://schemas.microsoft.com/office/drawing/2014/main" id="{D6507A53-0827-49CF-B14F-871259BCEB05}"/>
               </a:ext>
             </a:extLst>
           </p:cNvPr>
@@ -4713,7 +4837,7 @@
           <p:cNvPr id="2" name="">
             <a:extLst xmlns:a="http://schemas.openxmlformats.org/drawingml/2006/main">
               <a:ext uri="{FF2B5EF4-FFF2-40B4-BE49-F238E27FC236}">
-                <a16:creationId xmlns:a16="http://schemas.microsoft.com/office/drawing/2014/main" id="{4EFFF1A5-4809-473C-8800-D8371BB5FCBD}"/>
+                <a16:creationId xmlns:a16="http://schemas.microsoft.com/office/drawing/2014/main" id="{4217477B-F2EA-4247-867F-BBE6974A2D51}"/>
               </a:ext>
             </a:extLst>
           </p:cNvPr>
@@ -4816,7 +4940,7 @@
           <p:cNvPr id="3" name="">
             <a:extLst xmlns:a="http://schemas.openxmlformats.org/drawingml/2006/main">
               <a:ext uri="{FF2B5EF4-FFF2-40B4-BE49-F238E27FC236}">
-                <a16:creationId xmlns:a16="http://schemas.microsoft.com/office/drawing/2014/main" id="{B37FE533-50DB-4AAD-AEDB-BE42CAAE0631}"/>
+                <a16:creationId xmlns:a16="http://schemas.microsoft.com/office/drawing/2014/main" id="{D91AB03E-DFCD-42DB-99E6-72E5DC7F37ED}"/>
               </a:ext>
             </a:extLst>
           </p:cNvPr>
@@ -4873,7 +4997,7 @@
           <p:cNvPr id="4" name="">
             <a:extLst xmlns:a="http://schemas.openxmlformats.org/drawingml/2006/main">
               <a:ext uri="{FF2B5EF4-FFF2-40B4-BE49-F238E27FC236}">
-                <a16:creationId xmlns:a16="http://schemas.microsoft.com/office/drawing/2014/main" id="{B5BA0B99-9BE6-46DF-AF0D-73F4385E672A}"/>
+                <a16:creationId xmlns:a16="http://schemas.microsoft.com/office/drawing/2014/main" id="{D059D472-29BE-4D2D-B206-D6B99A516A18}"/>
               </a:ext>
             </a:extLst>
           </p:cNvPr>
@@ -4930,7 +5054,7 @@
           <p:cNvPr id="5" name="">
             <a:extLst xmlns:a="http://schemas.openxmlformats.org/drawingml/2006/main">
               <a:ext uri="{FF2B5EF4-FFF2-40B4-BE49-F238E27FC236}">
-                <a16:creationId xmlns:a16="http://schemas.microsoft.com/office/drawing/2014/main" id="{5B8DA382-AABB-4BD3-99A4-726C4DB49A69}"/>
+                <a16:creationId xmlns:a16="http://schemas.microsoft.com/office/drawing/2014/main" id="{A077D490-2184-4B13-B06D-F00FA8A96F76}"/>
               </a:ext>
             </a:extLst>
           </p:cNvPr>
@@ -5012,7 +5136,7 @@
           <p:cNvPr id="7" name="">
             <a:extLst xmlns:a="http://schemas.openxmlformats.org/drawingml/2006/main">
               <a:ext uri="{FF2B5EF4-FFF2-40B4-BE49-F238E27FC236}">
-                <a16:creationId xmlns:a16="http://schemas.microsoft.com/office/drawing/2014/main" id="{FAFA4924-6E24-45B0-8EB8-451733EE5A46}"/>
+                <a16:creationId xmlns:a16="http://schemas.microsoft.com/office/drawing/2014/main" id="{C8A27245-AA1E-4A34-8AF4-664A4F5A9DF2}"/>
               </a:ext>
             </a:extLst>
           </p:cNvPr>
@@ -5069,7 +5193,7 @@
           <p:cNvPr id="8" name="">
             <a:extLst xmlns:a="http://schemas.openxmlformats.org/drawingml/2006/main">
               <a:ext uri="{FF2B5EF4-FFF2-40B4-BE49-F238E27FC236}">
-                <a16:creationId xmlns:a16="http://schemas.microsoft.com/office/drawing/2014/main" id="{019E4D4E-BAFF-43DE-9C8B-E21B3F34139B}"/>
+                <a16:creationId xmlns:a16="http://schemas.microsoft.com/office/drawing/2014/main" id="{95FA5A36-1FEE-4903-8961-10E3C017B16B}"/>
               </a:ext>
             </a:extLst>
           </p:cNvPr>
@@ -5172,7 +5296,7 @@
           <p:cNvPr id="9" name="">
             <a:extLst xmlns:a="http://schemas.openxmlformats.org/drawingml/2006/main">
               <a:ext uri="{FF2B5EF4-FFF2-40B4-BE49-F238E27FC236}">
-                <a16:creationId xmlns:a16="http://schemas.microsoft.com/office/drawing/2014/main" id="{E7E0C8B6-E051-4E76-A81F-F2AE12E187CA}"/>
+                <a16:creationId xmlns:a16="http://schemas.microsoft.com/office/drawing/2014/main" id="{8C80CB4F-84DC-47C5-886A-2F3CC90883CE}"/>
               </a:ext>
             </a:extLst>
           </p:cNvPr>
@@ -5227,7 +5351,7 @@
     </p:spTree>
     <p:extLst>
       <p:ext uri="{BB962C8B-B14F-4D97-AF65-F5344CB8AC3E}">
-        <p14:creationId xmlns:p14="http://schemas.microsoft.com/office/powerpoint/2010/main" val="1131245190"/>
+        <p14:creationId xmlns:p14="http://schemas.microsoft.com/office/powerpoint/2010/main" val="669349102"/>
       </p:ext>
     </p:extLst>
   </p:cSld>
@@ -5258,7 +5382,7 @@
           <p:cNvPr id="12" name="">
             <a:extLst xmlns:a="http://schemas.openxmlformats.org/drawingml/2006/main">
               <a:ext uri="{FF2B5EF4-FFF2-40B4-BE49-F238E27FC236}">
-                <a16:creationId xmlns:a16="http://schemas.microsoft.com/office/drawing/2014/main" id="{98B8821B-1DFA-4EC5-A030-69AFBE14D18D}"/>
+                <a16:creationId xmlns:a16="http://schemas.microsoft.com/office/drawing/2014/main" id="{86C14EC8-FD0D-428F-9CB6-744F4D03714B}"/>
               </a:ext>
             </a:extLst>
           </p:cNvPr>
@@ -5315,7 +5439,7 @@
           <p:cNvPr id="2" name="">
             <a:extLst xmlns:a="http://schemas.openxmlformats.org/drawingml/2006/main">
               <a:ext uri="{FF2B5EF4-FFF2-40B4-BE49-F238E27FC236}">
-                <a16:creationId xmlns:a16="http://schemas.microsoft.com/office/drawing/2014/main" id="{BBE6F048-25F6-4325-A175-DDB8061F7AD9}"/>
+                <a16:creationId xmlns:a16="http://schemas.microsoft.com/office/drawing/2014/main" id="{E88A7FEA-6019-4CF2-995A-A72F8823847D}"/>
               </a:ext>
             </a:extLst>
           </p:cNvPr>
@@ -5372,7 +5496,7 @@
           <p:cNvPr id="3" name="">
             <a:extLst xmlns:a="http://schemas.openxmlformats.org/drawingml/2006/main">
               <a:ext uri="{FF2B5EF4-FFF2-40B4-BE49-F238E27FC236}">
-                <a16:creationId xmlns:a16="http://schemas.microsoft.com/office/drawing/2014/main" id="{EFEBA528-46CB-4A33-922C-1F4BAB7496FF}"/>
+                <a16:creationId xmlns:a16="http://schemas.microsoft.com/office/drawing/2014/main" id="{08FCDB8B-6630-4F79-9200-89A91E0DA3FD}"/>
               </a:ext>
             </a:extLst>
           </p:cNvPr>
@@ -5433,7 +5557,7 @@
           <p:nvPr/>
         </p:nvPicPr>
         <p:blipFill>
-          <a:blip xmlns:r="http://schemas.openxmlformats.org/officeDocument/2006/relationships" xmlns:a="http://schemas.openxmlformats.org/drawingml/2006/main" r:embed="Rc7e99db364b14357"/>
+          <a:blip xmlns:r="http://schemas.openxmlformats.org/officeDocument/2006/relationships" xmlns:a="http://schemas.openxmlformats.org/drawingml/2006/main" r:embed="R42ddae3450014f0d"/>
           <a:stretch xmlns:a="http://schemas.openxmlformats.org/drawingml/2006/main"/>
         </p:blipFill>
         <p:spPr>
@@ -5451,7 +5575,7 @@
           <p:cNvPr id="5" name="">
             <a:extLst xmlns:a="http://schemas.openxmlformats.org/drawingml/2006/main">
               <a:ext uri="{FF2B5EF4-FFF2-40B4-BE49-F238E27FC236}">
-                <a16:creationId xmlns:a16="http://schemas.microsoft.com/office/drawing/2014/main" id="{F3F05DA3-7004-4716-9F1A-26323CDA15D5}"/>
+                <a16:creationId xmlns:a16="http://schemas.microsoft.com/office/drawing/2014/main" id="{41E69290-2794-4018-9FB8-A9E166B6590F}"/>
               </a:ext>
             </a:extLst>
           </p:cNvPr>
@@ -5508,7 +5632,7 @@
           <p:cNvPr id="6" name="">
             <a:extLst xmlns:a="http://schemas.openxmlformats.org/drawingml/2006/main">
               <a:ext uri="{FF2B5EF4-FFF2-40B4-BE49-F238E27FC236}">
-                <a16:creationId xmlns:a16="http://schemas.microsoft.com/office/drawing/2014/main" id="{6C50AA2C-9F34-4624-AA34-79A9FAE09121}"/>
+                <a16:creationId xmlns:a16="http://schemas.microsoft.com/office/drawing/2014/main" id="{ACC17EAF-5005-4CD5-86C8-1E6B6032157A}"/>
               </a:ext>
             </a:extLst>
           </p:cNvPr>
@@ -5565,7 +5689,7 @@
           <p:cNvPr id="7" name="">
             <a:extLst xmlns:a="http://schemas.openxmlformats.org/drawingml/2006/main">
               <a:ext uri="{FF2B5EF4-FFF2-40B4-BE49-F238E27FC236}">
-                <a16:creationId xmlns:a16="http://schemas.microsoft.com/office/drawing/2014/main" id="{912D41E2-0D91-426E-B32F-2074C46E4973}"/>
+                <a16:creationId xmlns:a16="http://schemas.microsoft.com/office/drawing/2014/main" id="{6D7B33B0-0E13-46B1-855C-93A3A931926A}"/>
               </a:ext>
             </a:extLst>
           </p:cNvPr>
@@ -5622,7 +5746,7 @@
           <p:cNvPr id="8" name="">
             <a:extLst xmlns:a="http://schemas.openxmlformats.org/drawingml/2006/main">
               <a:ext uri="{FF2B5EF4-FFF2-40B4-BE49-F238E27FC236}">
-                <a16:creationId xmlns:a16="http://schemas.microsoft.com/office/drawing/2014/main" id="{3471593F-D044-400D-B098-57C570914063}"/>
+                <a16:creationId xmlns:a16="http://schemas.microsoft.com/office/drawing/2014/main" id="{92276665-614A-4930-8415-6CDE92B43CA3}"/>
               </a:ext>
             </a:extLst>
           </p:cNvPr>
@@ -5679,7 +5803,7 @@
           <p:cNvPr id="9" name="">
             <a:extLst xmlns:a="http://schemas.openxmlformats.org/drawingml/2006/main">
               <a:ext uri="{FF2B5EF4-FFF2-40B4-BE49-F238E27FC236}">
-                <a16:creationId xmlns:a16="http://schemas.microsoft.com/office/drawing/2014/main" id="{F0BE663C-EF45-4472-8BBF-88B761E38CF7}"/>
+                <a16:creationId xmlns:a16="http://schemas.microsoft.com/office/drawing/2014/main" id="{A678D26C-C1E8-446E-9667-9942ED609667}"/>
               </a:ext>
             </a:extLst>
           </p:cNvPr>
@@ -5736,7 +5860,7 @@
           <p:cNvPr id="10" name="">
             <a:extLst xmlns:a="http://schemas.openxmlformats.org/drawingml/2006/main">
               <a:ext uri="{FF2B5EF4-FFF2-40B4-BE49-F238E27FC236}">
-                <a16:creationId xmlns:a16="http://schemas.microsoft.com/office/drawing/2014/main" id="{09AF70AB-0D61-45BF-ACF3-E72430804175}"/>
+                <a16:creationId xmlns:a16="http://schemas.microsoft.com/office/drawing/2014/main" id="{DE0128FF-22FF-4767-99CA-9F038B0BE5A0}"/>
               </a:ext>
             </a:extLst>
           </p:cNvPr>
@@ -5793,7 +5917,7 @@
           <p:cNvPr id="11" name="">
             <a:extLst xmlns:a="http://schemas.openxmlformats.org/drawingml/2006/main">
               <a:ext uri="{FF2B5EF4-FFF2-40B4-BE49-F238E27FC236}">
-                <a16:creationId xmlns:a16="http://schemas.microsoft.com/office/drawing/2014/main" id="{D1684BED-B2DE-495C-8F42-515C2D4BF0EE}"/>
+                <a16:creationId xmlns:a16="http://schemas.microsoft.com/office/drawing/2014/main" id="{6C54BDCC-3716-4A99-8A87-FD8603D0ACD0}"/>
               </a:ext>
             </a:extLst>
           </p:cNvPr>
@@ -5848,7 +5972,7 @@
     </p:spTree>
     <p:extLst>
       <p:ext uri="{BB962C8B-B14F-4D97-AF65-F5344CB8AC3E}">
-        <p14:creationId xmlns:p14="http://schemas.microsoft.com/office/powerpoint/2010/main" val="346079617"/>
+        <p14:creationId xmlns:p14="http://schemas.microsoft.com/office/powerpoint/2010/main" val="1317986575"/>
       </p:ext>
     </p:extLst>
   </p:cSld>
@@ -5879,7 +6003,7 @@
           <p:cNvPr id="8" name="">
             <a:extLst xmlns:a="http://schemas.openxmlformats.org/drawingml/2006/main">
               <a:ext uri="{FF2B5EF4-FFF2-40B4-BE49-F238E27FC236}">
-                <a16:creationId xmlns:a16="http://schemas.microsoft.com/office/drawing/2014/main" id="{35382EC3-85F0-44F8-BD56-28A2B8049E91}"/>
+                <a16:creationId xmlns:a16="http://schemas.microsoft.com/office/drawing/2014/main" id="{5CF67D21-380B-4DA3-92EC-2E22E2B9EAC5}"/>
               </a:ext>
             </a:extLst>
           </p:cNvPr>
@@ -5936,7 +6060,7 @@
           <p:cNvPr id="2" name="">
             <a:extLst xmlns:a="http://schemas.openxmlformats.org/drawingml/2006/main">
               <a:ext uri="{FF2B5EF4-FFF2-40B4-BE49-F238E27FC236}">
-                <a16:creationId xmlns:a16="http://schemas.microsoft.com/office/drawing/2014/main" id="{9A5C3610-4DC8-431C-AFD1-3D16B487EDF0}"/>
+                <a16:creationId xmlns:a16="http://schemas.microsoft.com/office/drawing/2014/main" id="{0C5C7A4D-CAE6-4929-AC93-E6BE1883F26C}"/>
               </a:ext>
             </a:extLst>
           </p:cNvPr>
@@ -6039,7 +6163,7 @@
           <p:cNvPr id="3" name="">
             <a:extLst xmlns:a="http://schemas.openxmlformats.org/drawingml/2006/main">
               <a:ext uri="{FF2B5EF4-FFF2-40B4-BE49-F238E27FC236}">
-                <a16:creationId xmlns:a16="http://schemas.microsoft.com/office/drawing/2014/main" id="{68F5D6D3-C558-4FF9-A29E-B0D5B0E170D1}"/>
+                <a16:creationId xmlns:a16="http://schemas.microsoft.com/office/drawing/2014/main" id="{A8C100A0-9D22-4AD5-9C34-524A05C08E3B}"/>
               </a:ext>
             </a:extLst>
           </p:cNvPr>
@@ -6096,7 +6220,7 @@
           <p:cNvPr id="4" name="">
             <a:extLst xmlns:a="http://schemas.openxmlformats.org/drawingml/2006/main">
               <a:ext uri="{FF2B5EF4-FFF2-40B4-BE49-F238E27FC236}">
-                <a16:creationId xmlns:a16="http://schemas.microsoft.com/office/drawing/2014/main" id="{7A80C728-575A-43FC-BBA7-B8ECC59A2E1F}"/>
+                <a16:creationId xmlns:a16="http://schemas.microsoft.com/office/drawing/2014/main" id="{DA29C9E8-C8BA-48AF-88A3-A2DE5C407C50}"/>
               </a:ext>
             </a:extLst>
           </p:cNvPr>
@@ -6153,7 +6277,7 @@
           <p:cNvPr id="5" name="">
             <a:extLst xmlns:a="http://schemas.openxmlformats.org/drawingml/2006/main">
               <a:ext uri="{FF2B5EF4-FFF2-40B4-BE49-F238E27FC236}">
-                <a16:creationId xmlns:a16="http://schemas.microsoft.com/office/drawing/2014/main" id="{53C68C40-CBF4-46D3-A7F7-678DD467CCD5}"/>
+                <a16:creationId xmlns:a16="http://schemas.microsoft.com/office/drawing/2014/main" id="{C7F661FF-DF28-49E6-B387-7AF8B6999A2E}"/>
               </a:ext>
             </a:extLst>
           </p:cNvPr>
@@ -6210,7 +6334,7 @@
           <p:cNvPr id="6" name="">
             <a:extLst xmlns:a="http://schemas.openxmlformats.org/drawingml/2006/main">
               <a:ext uri="{FF2B5EF4-FFF2-40B4-BE49-F238E27FC236}">
-                <a16:creationId xmlns:a16="http://schemas.microsoft.com/office/drawing/2014/main" id="{E2817ECD-F91D-4DED-B3E2-B4D7ADC65178}"/>
+                <a16:creationId xmlns:a16="http://schemas.microsoft.com/office/drawing/2014/main" id="{CBEAA969-C592-497A-93D5-8371AFFB63CB}"/>
               </a:ext>
             </a:extLst>
           </p:cNvPr>
@@ -6271,7 +6395,7 @@
           <p:nvPr/>
         </p:nvPicPr>
         <p:blipFill>
-          <a:blip xmlns:r="http://schemas.openxmlformats.org/officeDocument/2006/relationships" xmlns:a="http://schemas.openxmlformats.org/drawingml/2006/main" r:embed="R9170dc3dd0484067"/>
+          <a:blip xmlns:r="http://schemas.openxmlformats.org/officeDocument/2006/relationships" xmlns:a="http://schemas.openxmlformats.org/drawingml/2006/main" r:embed="Rba9746b281804dbc"/>
           <a:stretch xmlns:a="http://schemas.openxmlformats.org/drawingml/2006/main"/>
         </p:blipFill>
         <p:spPr>
@@ -6287,7 +6411,7 @@
     </p:spTree>
     <p:extLst>
       <p:ext uri="{BB962C8B-B14F-4D97-AF65-F5344CB8AC3E}">
-        <p14:creationId xmlns:p14="http://schemas.microsoft.com/office/powerpoint/2010/main" val="145935294"/>
+        <p14:creationId xmlns:p14="http://schemas.microsoft.com/office/powerpoint/2010/main" val="733825669"/>
       </p:ext>
     </p:extLst>
   </p:cSld>
@@ -6318,7 +6442,7 @@
           <p:cNvPr id="12" name="">
             <a:extLst xmlns:a="http://schemas.openxmlformats.org/drawingml/2006/main">
               <a:ext uri="{FF2B5EF4-FFF2-40B4-BE49-F238E27FC236}">
-                <a16:creationId xmlns:a16="http://schemas.microsoft.com/office/drawing/2014/main" id="{7D6B17F8-BF66-4EFA-8544-B152034F1AA3}"/>
+                <a16:creationId xmlns:a16="http://schemas.microsoft.com/office/drawing/2014/main" id="{632990BC-E23E-400E-99D9-C75ECE407F1F}"/>
               </a:ext>
             </a:extLst>
           </p:cNvPr>
@@ -6375,7 +6499,7 @@
           <p:cNvPr id="2" name="">
             <a:extLst xmlns:a="http://schemas.openxmlformats.org/drawingml/2006/main">
               <a:ext uri="{FF2B5EF4-FFF2-40B4-BE49-F238E27FC236}">
-                <a16:creationId xmlns:a16="http://schemas.microsoft.com/office/drawing/2014/main" id="{68110953-F6A5-42B6-A54A-9430A34D45E7}"/>
+                <a16:creationId xmlns:a16="http://schemas.microsoft.com/office/drawing/2014/main" id="{354F0EBC-69CA-4E00-8E2B-E48D7DFC4F35}"/>
               </a:ext>
             </a:extLst>
           </p:cNvPr>
@@ -6455,7 +6579,7 @@
           <p:cNvPr id="3" name="">
             <a:extLst xmlns:a="http://schemas.openxmlformats.org/drawingml/2006/main">
               <a:ext uri="{FF2B5EF4-FFF2-40B4-BE49-F238E27FC236}">
-                <a16:creationId xmlns:a16="http://schemas.microsoft.com/office/drawing/2014/main" id="{82BC108F-D9EE-4EB7-9015-F4B51D8D6F05}"/>
+                <a16:creationId xmlns:a16="http://schemas.microsoft.com/office/drawing/2014/main" id="{A55A9C49-7DD6-4DDA-8825-F0EF67E765E9}"/>
               </a:ext>
             </a:extLst>
           </p:cNvPr>
@@ -6512,7 +6636,7 @@
           <p:cNvPr id="4" name="">
             <a:extLst xmlns:a="http://schemas.openxmlformats.org/drawingml/2006/main">
               <a:ext uri="{FF2B5EF4-FFF2-40B4-BE49-F238E27FC236}">
-                <a16:creationId xmlns:a16="http://schemas.microsoft.com/office/drawing/2014/main" id="{4455F3D9-B60B-437A-8B37-0A831F464143}"/>
+                <a16:creationId xmlns:a16="http://schemas.microsoft.com/office/drawing/2014/main" id="{954FC0C8-794D-4722-9639-51F2E2C65B6E}"/>
               </a:ext>
             </a:extLst>
           </p:cNvPr>
@@ -6569,7 +6693,7 @@
           <p:cNvPr id="5" name="">
             <a:extLst xmlns:a="http://schemas.openxmlformats.org/drawingml/2006/main">
               <a:ext uri="{FF2B5EF4-FFF2-40B4-BE49-F238E27FC236}">
-                <a16:creationId xmlns:a16="http://schemas.microsoft.com/office/drawing/2014/main" id="{661F36F1-DE25-436A-A7D4-AD11315669D8}"/>
+                <a16:creationId xmlns:a16="http://schemas.microsoft.com/office/drawing/2014/main" id="{D63A0814-B5C6-433E-A36A-E9726231F9D6}"/>
               </a:ext>
             </a:extLst>
           </p:cNvPr>
@@ -6626,7 +6750,7 @@
           <p:cNvPr id="6" name="">
             <a:extLst xmlns:a="http://schemas.openxmlformats.org/drawingml/2006/main">
               <a:ext uri="{FF2B5EF4-FFF2-40B4-BE49-F238E27FC236}">
-                <a16:creationId xmlns:a16="http://schemas.microsoft.com/office/drawing/2014/main" id="{13208FA5-BADB-4F47-A71B-D54C87978165}"/>
+                <a16:creationId xmlns:a16="http://schemas.microsoft.com/office/drawing/2014/main" id="{D20C4801-289D-4A4E-91F9-D850A6F1E792}"/>
               </a:ext>
             </a:extLst>
           </p:cNvPr>
@@ -6683,7 +6807,7 @@
           <p:cNvPr id="7" name="">
             <a:extLst xmlns:a="http://schemas.openxmlformats.org/drawingml/2006/main">
               <a:ext uri="{FF2B5EF4-FFF2-40B4-BE49-F238E27FC236}">
-                <a16:creationId xmlns:a16="http://schemas.microsoft.com/office/drawing/2014/main" id="{E6F63BB0-D346-4ED7-BC2D-09744DC23839}"/>
+                <a16:creationId xmlns:a16="http://schemas.microsoft.com/office/drawing/2014/main" id="{FFF6AE36-D684-4491-BE80-77E6D54CB2D0}"/>
               </a:ext>
             </a:extLst>
           </p:cNvPr>
@@ -6740,7 +6864,7 @@
           <p:cNvPr id="8" name="">
             <a:extLst xmlns:a="http://schemas.openxmlformats.org/drawingml/2006/main">
               <a:ext uri="{FF2B5EF4-FFF2-40B4-BE49-F238E27FC236}">
-                <a16:creationId xmlns:a16="http://schemas.microsoft.com/office/drawing/2014/main" id="{4D5A08DE-C676-4C01-9B24-4DD391B51842}"/>
+                <a16:creationId xmlns:a16="http://schemas.microsoft.com/office/drawing/2014/main" id="{A213790F-47AD-4A51-84BB-18A8B92A01A3}"/>
               </a:ext>
             </a:extLst>
           </p:cNvPr>
@@ -6797,7 +6921,7 @@
           <p:cNvPr id="9" name="">
             <a:extLst xmlns:a="http://schemas.openxmlformats.org/drawingml/2006/main">
               <a:ext uri="{FF2B5EF4-FFF2-40B4-BE49-F238E27FC236}">
-                <a16:creationId xmlns:a16="http://schemas.microsoft.com/office/drawing/2014/main" id="{361F03F2-4B6B-43D3-A5A9-59846CEB8370}"/>
+                <a16:creationId xmlns:a16="http://schemas.microsoft.com/office/drawing/2014/main" id="{14D5C2B0-EA99-4CFE-AE67-59F2D4108FEE}"/>
               </a:ext>
             </a:extLst>
           </p:cNvPr>
@@ -6858,7 +6982,7 @@
           <p:nvPr/>
         </p:nvPicPr>
         <p:blipFill>
-          <a:blip xmlns:r="http://schemas.openxmlformats.org/officeDocument/2006/relationships" xmlns:a="http://schemas.openxmlformats.org/drawingml/2006/main" r:embed="R9d322467077143f7"/>
+          <a:blip xmlns:r="http://schemas.openxmlformats.org/officeDocument/2006/relationships" xmlns:a="http://schemas.openxmlformats.org/drawingml/2006/main" r:embed="Rc81c477f1e224dd2"/>
           <a:stretch xmlns:a="http://schemas.openxmlformats.org/drawingml/2006/main"/>
         </p:blipFill>
         <p:spPr>
@@ -6876,7 +7000,7 @@
           <p:cNvPr id="11" name="">
             <a:extLst xmlns:a="http://schemas.openxmlformats.org/drawingml/2006/main">
               <a:ext uri="{FF2B5EF4-FFF2-40B4-BE49-F238E27FC236}">
-                <a16:creationId xmlns:a16="http://schemas.microsoft.com/office/drawing/2014/main" id="{2F20AC6C-8EF0-45B7-8B45-8B70F2C3BE50}"/>
+                <a16:creationId xmlns:a16="http://schemas.microsoft.com/office/drawing/2014/main" id="{A55AD11B-6079-4B83-8BFF-ACA4B6671471}"/>
               </a:ext>
             </a:extLst>
           </p:cNvPr>
@@ -6931,7 +7055,7 @@
     </p:spTree>
     <p:extLst>
       <p:ext uri="{BB962C8B-B14F-4D97-AF65-F5344CB8AC3E}">
-        <p14:creationId xmlns:p14="http://schemas.microsoft.com/office/powerpoint/2010/main" val="1758657768"/>
+        <p14:creationId xmlns:p14="http://schemas.microsoft.com/office/powerpoint/2010/main" val="1378053229"/>
       </p:ext>
     </p:extLst>
   </p:cSld>
@@ -6962,7 +7086,7 @@
           <p:cNvPr id="6" name="">
             <a:extLst xmlns:a="http://schemas.openxmlformats.org/drawingml/2006/main">
               <a:ext uri="{FF2B5EF4-FFF2-40B4-BE49-F238E27FC236}">
-                <a16:creationId xmlns:a16="http://schemas.microsoft.com/office/drawing/2014/main" id="{BCEC003F-20FC-4051-AB09-FB42DC1CD5F4}"/>
+                <a16:creationId xmlns:a16="http://schemas.microsoft.com/office/drawing/2014/main" id="{A9EBDB65-180C-4777-B923-30215DDF5E70}"/>
               </a:ext>
             </a:extLst>
           </p:cNvPr>
@@ -7019,7 +7143,7 @@
           <p:cNvPr id="2" name="">
             <a:extLst xmlns:a="http://schemas.openxmlformats.org/drawingml/2006/main">
               <a:ext uri="{FF2B5EF4-FFF2-40B4-BE49-F238E27FC236}">
-                <a16:creationId xmlns:a16="http://schemas.microsoft.com/office/drawing/2014/main" id="{F9E9FA49-33D0-4B5D-9014-432F4E1E9CEA}"/>
+                <a16:creationId xmlns:a16="http://schemas.microsoft.com/office/drawing/2014/main" id="{75837B34-CF77-4F54-AFCA-F1958C59C976}"/>
               </a:ext>
             </a:extLst>
           </p:cNvPr>
@@ -7076,7 +7200,7 @@
           <p:cNvPr id="3" name="">
             <a:extLst xmlns:a="http://schemas.openxmlformats.org/drawingml/2006/main">
               <a:ext uri="{FF2B5EF4-FFF2-40B4-BE49-F238E27FC236}">
-                <a16:creationId xmlns:a16="http://schemas.microsoft.com/office/drawing/2014/main" id="{566B8AE1-8E32-4C8B-A6D1-5EB4A670FA4B}"/>
+                <a16:creationId xmlns:a16="http://schemas.microsoft.com/office/drawing/2014/main" id="{DC0C5E05-63E3-4EFD-A367-283B78AF097D}"/>
               </a:ext>
             </a:extLst>
           </p:cNvPr>
@@ -7137,7 +7261,7 @@
           <p:nvPr/>
         </p:nvPicPr>
         <p:blipFill>
-          <a:blip xmlns:r="http://schemas.openxmlformats.org/officeDocument/2006/relationships" xmlns:a="http://schemas.openxmlformats.org/drawingml/2006/main" r:embed="Rc6512876d4ae412d"/>
+          <a:blip xmlns:r="http://schemas.openxmlformats.org/officeDocument/2006/relationships" xmlns:a="http://schemas.openxmlformats.org/drawingml/2006/main" r:embed="R363c61e258a34b2d"/>
           <a:stretch xmlns:a="http://schemas.openxmlformats.org/drawingml/2006/main"/>
         </p:blipFill>
         <p:spPr>
@@ -7155,7 +7279,7 @@
           <p:cNvPr id="5" name="">
             <a:extLst xmlns:a="http://schemas.openxmlformats.org/drawingml/2006/main">
               <a:ext uri="{FF2B5EF4-FFF2-40B4-BE49-F238E27FC236}">
-                <a16:creationId xmlns:a16="http://schemas.microsoft.com/office/drawing/2014/main" id="{3BC0BC65-446C-49C1-B79C-6C7A4825370C}"/>
+                <a16:creationId xmlns:a16="http://schemas.microsoft.com/office/drawing/2014/main" id="{5D3473BA-EECB-4A76-9447-F3C36D81C468}"/>
               </a:ext>
             </a:extLst>
           </p:cNvPr>
@@ -7210,7 +7334,7 @@
     </p:spTree>
     <p:extLst>
       <p:ext uri="{BB962C8B-B14F-4D97-AF65-F5344CB8AC3E}">
-        <p14:creationId xmlns:p14="http://schemas.microsoft.com/office/powerpoint/2010/main" val="2054713395"/>
+        <p14:creationId xmlns:p14="http://schemas.microsoft.com/office/powerpoint/2010/main" val="2093622537"/>
       </p:ext>
     </p:extLst>
   </p:cSld>
@@ -7241,7 +7365,7 @@
           <p:cNvPr id="8" name="">
             <a:extLst xmlns:a="http://schemas.openxmlformats.org/drawingml/2006/main">
               <a:ext uri="{FF2B5EF4-FFF2-40B4-BE49-F238E27FC236}">
-                <a16:creationId xmlns:a16="http://schemas.microsoft.com/office/drawing/2014/main" id="{14F14BBC-B182-425C-BC0D-A62A5699A45B}"/>
+                <a16:creationId xmlns:a16="http://schemas.microsoft.com/office/drawing/2014/main" id="{AB40F914-F55C-4A77-A18A-B5A70CDB869B}"/>
               </a:ext>
             </a:extLst>
           </p:cNvPr>
@@ -7298,7 +7422,7 @@
           <p:cNvPr id="2" name="">
             <a:extLst xmlns:a="http://schemas.openxmlformats.org/drawingml/2006/main">
               <a:ext uri="{FF2B5EF4-FFF2-40B4-BE49-F238E27FC236}">
-                <a16:creationId xmlns:a16="http://schemas.microsoft.com/office/drawing/2014/main" id="{C2366428-F290-41E6-BA0C-41D28C572366}"/>
+                <a16:creationId xmlns:a16="http://schemas.microsoft.com/office/drawing/2014/main" id="{ED6CB13B-8856-4601-8277-000EA31D846F}"/>
               </a:ext>
             </a:extLst>
           </p:cNvPr>
@@ -7355,7 +7479,7 @@
           <p:cNvPr id="3" name="">
             <a:extLst xmlns:a="http://schemas.openxmlformats.org/drawingml/2006/main">
               <a:ext uri="{FF2B5EF4-FFF2-40B4-BE49-F238E27FC236}">
-                <a16:creationId xmlns:a16="http://schemas.microsoft.com/office/drawing/2014/main" id="{4B9A190A-0176-458C-8269-85136232E746}"/>
+                <a16:creationId xmlns:a16="http://schemas.microsoft.com/office/drawing/2014/main" id="{44CA47BB-7DC0-47F8-A335-1EF949050240}"/>
               </a:ext>
             </a:extLst>
           </p:cNvPr>
@@ -7412,7 +7536,7 @@
           <p:cNvPr id="4" name="">
             <a:extLst xmlns:a="http://schemas.openxmlformats.org/drawingml/2006/main">
               <a:ext uri="{FF2B5EF4-FFF2-40B4-BE49-F238E27FC236}">
-                <a16:creationId xmlns:a16="http://schemas.microsoft.com/office/drawing/2014/main" id="{C50D5AD6-61FB-4FD9-8C31-285E37EAC910}"/>
+                <a16:creationId xmlns:a16="http://schemas.microsoft.com/office/drawing/2014/main" id="{899EF3F3-71BE-4672-8D9D-72D19EC9676E}"/>
               </a:ext>
             </a:extLst>
           </p:cNvPr>
@@ -7496,7 +7620,7 @@
           <p:nvPr/>
         </p:nvPicPr>
         <p:blipFill>
-          <a:blip xmlns:r="http://schemas.openxmlformats.org/officeDocument/2006/relationships" xmlns:a="http://schemas.openxmlformats.org/drawingml/2006/main" r:embed="Rf53a439b9e514ce0"/>
+          <a:blip xmlns:r="http://schemas.openxmlformats.org/officeDocument/2006/relationships" xmlns:a="http://schemas.openxmlformats.org/drawingml/2006/main" r:embed="R6d37102a23f74fbf"/>
           <a:stretch xmlns:a="http://schemas.openxmlformats.org/drawingml/2006/main"/>
         </p:blipFill>
         <p:spPr>
@@ -7514,7 +7638,7 @@
           <p:cNvPr id="6" name="">
             <a:extLst xmlns:a="http://schemas.openxmlformats.org/drawingml/2006/main">
               <a:ext uri="{FF2B5EF4-FFF2-40B4-BE49-F238E27FC236}">
-                <a16:creationId xmlns:a16="http://schemas.microsoft.com/office/drawing/2014/main" id="{A1DD0CF4-6C18-4FA6-BF60-C3ACC9D3892C}"/>
+                <a16:creationId xmlns:a16="http://schemas.microsoft.com/office/drawing/2014/main" id="{0886B187-3488-496E-913D-7E62806B0CAE}"/>
               </a:ext>
             </a:extLst>
           </p:cNvPr>
@@ -7571,7 +7695,7 @@
           <p:cNvPr id="7" name="">
             <a:extLst xmlns:a="http://schemas.openxmlformats.org/drawingml/2006/main">
               <a:ext uri="{FF2B5EF4-FFF2-40B4-BE49-F238E27FC236}">
-                <a16:creationId xmlns:a16="http://schemas.microsoft.com/office/drawing/2014/main" id="{AFDDE59D-D32B-419C-AEA0-D5177C848580}"/>
+                <a16:creationId xmlns:a16="http://schemas.microsoft.com/office/drawing/2014/main" id="{8BD423D3-0D04-44E5-B7F7-7452E9689F56}"/>
               </a:ext>
             </a:extLst>
           </p:cNvPr>
@@ -7626,7 +7750,7 @@
     </p:spTree>
     <p:extLst>
       <p:ext uri="{BB962C8B-B14F-4D97-AF65-F5344CB8AC3E}">
-        <p14:creationId xmlns:p14="http://schemas.microsoft.com/office/powerpoint/2010/main" val="1558356379"/>
+        <p14:creationId xmlns:p14="http://schemas.microsoft.com/office/powerpoint/2010/main" val="843862840"/>
       </p:ext>
     </p:extLst>
   </p:cSld>
@@ -7657,7 +7781,7 @@
           <p:cNvPr id="10" name="">
             <a:extLst xmlns:a="http://schemas.openxmlformats.org/drawingml/2006/main">
               <a:ext uri="{FF2B5EF4-FFF2-40B4-BE49-F238E27FC236}">
-                <a16:creationId xmlns:a16="http://schemas.microsoft.com/office/drawing/2014/main" id="{E28F892A-10A2-4B81-BAF0-6D44C36087F1}"/>
+                <a16:creationId xmlns:a16="http://schemas.microsoft.com/office/drawing/2014/main" id="{8919ACAF-849A-461E-819A-C44F1F2AD739}"/>
               </a:ext>
             </a:extLst>
           </p:cNvPr>
@@ -7714,7 +7838,7 @@
           <p:cNvPr id="2" name="">
             <a:extLst xmlns:a="http://schemas.openxmlformats.org/drawingml/2006/main">
               <a:ext uri="{FF2B5EF4-FFF2-40B4-BE49-F238E27FC236}">
-                <a16:creationId xmlns:a16="http://schemas.microsoft.com/office/drawing/2014/main" id="{0B70D46B-2C8C-4927-90EE-6FD27455ED17}"/>
+                <a16:creationId xmlns:a16="http://schemas.microsoft.com/office/drawing/2014/main" id="{6D7D56C8-0FE7-4510-B4C7-96FB9DCBD5B1}"/>
               </a:ext>
             </a:extLst>
           </p:cNvPr>
@@ -7771,7 +7895,7 @@
           <p:cNvPr id="3" name="">
             <a:extLst xmlns:a="http://schemas.openxmlformats.org/drawingml/2006/main">
               <a:ext uri="{FF2B5EF4-FFF2-40B4-BE49-F238E27FC236}">
-                <a16:creationId xmlns:a16="http://schemas.microsoft.com/office/drawing/2014/main" id="{06D67936-97FD-4D78-9A0C-7901FF5FA7A2}"/>
+                <a16:creationId xmlns:a16="http://schemas.microsoft.com/office/drawing/2014/main" id="{CDC6AD73-C39D-4A38-8CE8-48D75E7E666C}"/>
               </a:ext>
             </a:extLst>
           </p:cNvPr>
@@ -7828,7 +7952,7 @@
           <p:cNvPr id="4" name="">
             <a:extLst xmlns:a="http://schemas.openxmlformats.org/drawingml/2006/main">
               <a:ext uri="{FF2B5EF4-FFF2-40B4-BE49-F238E27FC236}">
-                <a16:creationId xmlns:a16="http://schemas.microsoft.com/office/drawing/2014/main" id="{9E315136-750A-405F-A3AD-5E02AA251168}"/>
+                <a16:creationId xmlns:a16="http://schemas.microsoft.com/office/drawing/2014/main" id="{0BBFB796-705F-4AA5-811F-4BA80997A7F5}"/>
               </a:ext>
             </a:extLst>
           </p:cNvPr>
@@ -7885,7 +8009,7 @@
           <p:cNvPr id="5" name="">
             <a:extLst xmlns:a="http://schemas.openxmlformats.org/drawingml/2006/main">
               <a:ext uri="{FF2B5EF4-FFF2-40B4-BE49-F238E27FC236}">
-                <a16:creationId xmlns:a16="http://schemas.microsoft.com/office/drawing/2014/main" id="{822E17B4-E0E6-435A-B40B-104AEC175336}"/>
+                <a16:creationId xmlns:a16="http://schemas.microsoft.com/office/drawing/2014/main" id="{2768E9D5-8D2C-40F5-A0B4-FF29C92F37A4}"/>
               </a:ext>
             </a:extLst>
           </p:cNvPr>
@@ -7942,7 +8066,7 @@
           <p:cNvPr id="6" name="">
             <a:extLst xmlns:a="http://schemas.openxmlformats.org/drawingml/2006/main">
               <a:ext uri="{FF2B5EF4-FFF2-40B4-BE49-F238E27FC236}">
-                <a16:creationId xmlns:a16="http://schemas.microsoft.com/office/drawing/2014/main" id="{4AD07A71-AEEA-4C17-8618-039D6D5344BC}"/>
+                <a16:creationId xmlns:a16="http://schemas.microsoft.com/office/drawing/2014/main" id="{9E106DE7-2771-4CEF-B4E0-97D1FFCC93D4}"/>
               </a:ext>
             </a:extLst>
           </p:cNvPr>
@@ -7999,7 +8123,7 @@
           <p:cNvPr id="7" name="">
             <a:extLst xmlns:a="http://schemas.openxmlformats.org/drawingml/2006/main">
               <a:ext uri="{FF2B5EF4-FFF2-40B4-BE49-F238E27FC236}">
-                <a16:creationId xmlns:a16="http://schemas.microsoft.com/office/drawing/2014/main" id="{8C0185DE-D999-4105-8B3B-73B789B0665B}"/>
+                <a16:creationId xmlns:a16="http://schemas.microsoft.com/office/drawing/2014/main" id="{924572D6-93DD-4464-971C-EBBB392BE6F7}"/>
               </a:ext>
             </a:extLst>
           </p:cNvPr>
@@ -8663,7 +8787,7 @@
           <p:cNvPr id="9" name="">
             <a:extLst xmlns:a="http://schemas.openxmlformats.org/drawingml/2006/main">
               <a:ext uri="{FF2B5EF4-FFF2-40B4-BE49-F238E27FC236}">
-                <a16:creationId xmlns:a16="http://schemas.microsoft.com/office/drawing/2014/main" id="{7CFCB42D-E9E3-423C-A09C-FBD14ECAFDF5}"/>
+                <a16:creationId xmlns:a16="http://schemas.microsoft.com/office/drawing/2014/main" id="{1DF849B9-09A2-47E9-99F0-860B7A5CBCC7}"/>
               </a:ext>
             </a:extLst>
           </p:cNvPr>
@@ -8718,7 +8842,7 @@
     </p:spTree>
     <p:extLst>
       <p:ext uri="{BB962C8B-B14F-4D97-AF65-F5344CB8AC3E}">
-        <p14:creationId xmlns:p14="http://schemas.microsoft.com/office/powerpoint/2010/main" val="952310076"/>
+        <p14:creationId xmlns:p14="http://schemas.microsoft.com/office/powerpoint/2010/main" val="1316492801"/>
       </p:ext>
     </p:extLst>
   </p:cSld>
@@ -8749,7 +8873,7 @@
           <p:cNvPr id="19" name="">
             <a:extLst xmlns:a="http://schemas.openxmlformats.org/drawingml/2006/main">
               <a:ext uri="{FF2B5EF4-FFF2-40B4-BE49-F238E27FC236}">
-                <a16:creationId xmlns:a16="http://schemas.microsoft.com/office/drawing/2014/main" id="{7B98EF19-D257-4822-91B1-2052BC6EE397}"/>
+                <a16:creationId xmlns:a16="http://schemas.microsoft.com/office/drawing/2014/main" id="{7EBDC0DE-46D9-4A84-895B-423EF3C15EA4}"/>
               </a:ext>
             </a:extLst>
           </p:cNvPr>
@@ -8806,7 +8930,7 @@
           <p:cNvPr id="2" name="">
             <a:extLst xmlns:a="http://schemas.openxmlformats.org/drawingml/2006/main">
               <a:ext uri="{FF2B5EF4-FFF2-40B4-BE49-F238E27FC236}">
-                <a16:creationId xmlns:a16="http://schemas.microsoft.com/office/drawing/2014/main" id="{68FEF267-9039-4704-B728-6091FA365F9A}"/>
+                <a16:creationId xmlns:a16="http://schemas.microsoft.com/office/drawing/2014/main" id="{5B095C47-7720-452B-A755-C247E7444F9E}"/>
               </a:ext>
             </a:extLst>
           </p:cNvPr>
@@ -8863,7 +8987,7 @@
           <p:cNvPr id="3" name="">
             <a:extLst xmlns:a="http://schemas.openxmlformats.org/drawingml/2006/main">
               <a:ext uri="{FF2B5EF4-FFF2-40B4-BE49-F238E27FC236}">
-                <a16:creationId xmlns:a16="http://schemas.microsoft.com/office/drawing/2014/main" id="{E4489C85-A92F-4215-AFCD-ABF5D16DBCE5}"/>
+                <a16:creationId xmlns:a16="http://schemas.microsoft.com/office/drawing/2014/main" id="{5F845918-6CBA-4EB4-B6E9-F6B1394228CF}"/>
               </a:ext>
             </a:extLst>
           </p:cNvPr>
@@ -8920,7 +9044,7 @@
           <p:cNvPr id="4" name="">
             <a:extLst xmlns:a="http://schemas.openxmlformats.org/drawingml/2006/main">
               <a:ext uri="{FF2B5EF4-FFF2-40B4-BE49-F238E27FC236}">
-                <a16:creationId xmlns:a16="http://schemas.microsoft.com/office/drawing/2014/main" id="{F10EFF10-AF7C-44EC-8ED3-88437CFE2C68}"/>
+                <a16:creationId xmlns:a16="http://schemas.microsoft.com/office/drawing/2014/main" id="{7499D560-D9D8-4092-B45D-E000650732A5}"/>
               </a:ext>
             </a:extLst>
           </p:cNvPr>
@@ -8977,7 +9101,7 @@
           <p:cNvPr id="5" name="">
             <a:extLst xmlns:a="http://schemas.openxmlformats.org/drawingml/2006/main">
               <a:ext uri="{FF2B5EF4-FFF2-40B4-BE49-F238E27FC236}">
-                <a16:creationId xmlns:a16="http://schemas.microsoft.com/office/drawing/2014/main" id="{78FC7A8C-DBC9-4D0B-88C2-651EF5A73C3C}"/>
+                <a16:creationId xmlns:a16="http://schemas.microsoft.com/office/drawing/2014/main" id="{820F78C0-382D-47B2-94ED-3F3EAB6FF1B3}"/>
               </a:ext>
             </a:extLst>
           </p:cNvPr>
@@ -9034,7 +9158,7 @@
           <p:cNvPr id="6" name="">
             <a:extLst xmlns:a="http://schemas.openxmlformats.org/drawingml/2006/main">
               <a:ext uri="{FF2B5EF4-FFF2-40B4-BE49-F238E27FC236}">
-                <a16:creationId xmlns:a16="http://schemas.microsoft.com/office/drawing/2014/main" id="{9126CF03-96C7-40CB-8A16-6F4AE7DBD5F0}"/>
+                <a16:creationId xmlns:a16="http://schemas.microsoft.com/office/drawing/2014/main" id="{7781CCB8-E4A0-4BCF-A7F1-B4C3AA3872AB}"/>
               </a:ext>
             </a:extLst>
           </p:cNvPr>
@@ -9091,7 +9215,7 @@
           <p:cNvPr id="7" name="">
             <a:extLst xmlns:a="http://schemas.openxmlformats.org/drawingml/2006/main">
               <a:ext uri="{FF2B5EF4-FFF2-40B4-BE49-F238E27FC236}">
-                <a16:creationId xmlns:a16="http://schemas.microsoft.com/office/drawing/2014/main" id="{27EDD7E3-9632-4220-893C-350415E18C94}"/>
+                <a16:creationId xmlns:a16="http://schemas.microsoft.com/office/drawing/2014/main" id="{65EBD4D8-5AE0-497E-8106-456954633E94}"/>
               </a:ext>
             </a:extLst>
           </p:cNvPr>
@@ -9148,7 +9272,7 @@
           <p:cNvPr id="8" name="">
             <a:extLst xmlns:a="http://schemas.openxmlformats.org/drawingml/2006/main">
               <a:ext uri="{FF2B5EF4-FFF2-40B4-BE49-F238E27FC236}">
-                <a16:creationId xmlns:a16="http://schemas.microsoft.com/office/drawing/2014/main" id="{164C47C9-EF6B-4C2E-AD64-F2CDF9F573FD}"/>
+                <a16:creationId xmlns:a16="http://schemas.microsoft.com/office/drawing/2014/main" id="{5363A3DD-E4C2-4C66-B7E7-F687FDD7842D}"/>
               </a:ext>
             </a:extLst>
           </p:cNvPr>
@@ -9257,7 +9381,7 @@
           <p:cNvPr id="11" name="">
             <a:extLst xmlns:a="http://schemas.openxmlformats.org/drawingml/2006/main">
               <a:ext uri="{FF2B5EF4-FFF2-40B4-BE49-F238E27FC236}">
-                <a16:creationId xmlns:a16="http://schemas.microsoft.com/office/drawing/2014/main" id="{674E00C8-67D0-4281-9FE9-1D05FA48C1A9}"/>
+                <a16:creationId xmlns:a16="http://schemas.microsoft.com/office/drawing/2014/main" id="{A9BF0448-79DF-4243-9FDF-DAF34F2A5B2E}"/>
               </a:ext>
             </a:extLst>
           </p:cNvPr>
@@ -9337,7 +9461,7 @@
           <p:cNvPr id="12" name="">
             <a:extLst xmlns:a="http://schemas.openxmlformats.org/drawingml/2006/main">
               <a:ext uri="{FF2B5EF4-FFF2-40B4-BE49-F238E27FC236}">
-                <a16:creationId xmlns:a16="http://schemas.microsoft.com/office/drawing/2014/main" id="{6E3C9A9C-15C2-4BB5-B4C1-C46304170115}"/>
+                <a16:creationId xmlns:a16="http://schemas.microsoft.com/office/drawing/2014/main" id="{DB389CBD-9B1A-48F9-824C-EB77BB5FD92E}"/>
               </a:ext>
             </a:extLst>
           </p:cNvPr>
@@ -9440,7 +9564,7 @@
           <p:cNvPr id="13" name="">
             <a:extLst xmlns:a="http://schemas.openxmlformats.org/drawingml/2006/main">
               <a:ext uri="{FF2B5EF4-FFF2-40B4-BE49-F238E27FC236}">
-                <a16:creationId xmlns:a16="http://schemas.microsoft.com/office/drawing/2014/main" id="{C63ACAF2-33F7-46E4-ACDE-2A62405FEF65}"/>
+                <a16:creationId xmlns:a16="http://schemas.microsoft.com/office/drawing/2014/main" id="{1CEC2869-551F-4E04-8959-DA9B72D606AB}"/>
               </a:ext>
             </a:extLst>
           </p:cNvPr>
@@ -9543,7 +9667,7 @@
           <p:cNvPr id="14" name="">
             <a:extLst xmlns:a="http://schemas.openxmlformats.org/drawingml/2006/main">
               <a:ext uri="{FF2B5EF4-FFF2-40B4-BE49-F238E27FC236}">
-                <a16:creationId xmlns:a16="http://schemas.microsoft.com/office/drawing/2014/main" id="{E8167E6C-05B9-4152-AE9A-14CCF2B51A09}"/>
+                <a16:creationId xmlns:a16="http://schemas.microsoft.com/office/drawing/2014/main" id="{297F8E73-0692-44CD-9B5B-6BF694DAC37E}"/>
               </a:ext>
             </a:extLst>
           </p:cNvPr>
@@ -9573,7 +9697,7 @@
           <p:cNvPr id="15" name="">
             <a:extLst xmlns:a="http://schemas.openxmlformats.org/drawingml/2006/main">
               <a:ext uri="{FF2B5EF4-FFF2-40B4-BE49-F238E27FC236}">
-                <a16:creationId xmlns:a16="http://schemas.microsoft.com/office/drawing/2014/main" id="{3CB48BD3-87A1-4B0F-9925-C6A62842AF69}"/>
+                <a16:creationId xmlns:a16="http://schemas.microsoft.com/office/drawing/2014/main" id="{C3FE4FE3-0289-410F-9082-2C6CA5C0AFC9}"/>
               </a:ext>
             </a:extLst>
           </p:cNvPr>
@@ -9630,7 +9754,7 @@
           <p:cNvPr id="16" name="">
             <a:extLst xmlns:a="http://schemas.openxmlformats.org/drawingml/2006/main">
               <a:ext uri="{FF2B5EF4-FFF2-40B4-BE49-F238E27FC236}">
-                <a16:creationId xmlns:a16="http://schemas.microsoft.com/office/drawing/2014/main" id="{8448F53B-C7D8-4FD8-9D91-F83B67BE1217}"/>
+                <a16:creationId xmlns:a16="http://schemas.microsoft.com/office/drawing/2014/main" id="{F004F8CA-6859-40A6-83F7-CED57AE00D78}"/>
               </a:ext>
             </a:extLst>
           </p:cNvPr>
@@ -9687,7 +9811,7 @@
           <p:cNvPr id="17" name="">
             <a:extLst xmlns:a="http://schemas.openxmlformats.org/drawingml/2006/main">
               <a:ext uri="{FF2B5EF4-FFF2-40B4-BE49-F238E27FC236}">
-                <a16:creationId xmlns:a16="http://schemas.microsoft.com/office/drawing/2014/main" id="{16A8EB9A-7574-469B-8E66-122D01521C65}"/>
+                <a16:creationId xmlns:a16="http://schemas.microsoft.com/office/drawing/2014/main" id="{59D37463-5930-4A77-B9EC-033846EC0A5E}"/>
               </a:ext>
             </a:extLst>
           </p:cNvPr>
@@ -9744,7 +9868,7 @@
           <p:cNvPr id="18" name="">
             <a:extLst xmlns:a="http://schemas.openxmlformats.org/drawingml/2006/main">
               <a:ext uri="{FF2B5EF4-FFF2-40B4-BE49-F238E27FC236}">
-                <a16:creationId xmlns:a16="http://schemas.microsoft.com/office/drawing/2014/main" id="{2FAE847B-8CBF-46FB-95DE-44A92B895945}"/>
+                <a16:creationId xmlns:a16="http://schemas.microsoft.com/office/drawing/2014/main" id="{AAAA0689-F92C-4A7E-B56D-25DF4F95EA17}"/>
               </a:ext>
             </a:extLst>
           </p:cNvPr>
@@ -9799,7 +9923,7 @@
     </p:spTree>
     <p:extLst>
       <p:ext uri="{BB962C8B-B14F-4D97-AF65-F5344CB8AC3E}">
-        <p14:creationId xmlns:p14="http://schemas.microsoft.com/office/powerpoint/2010/main" val="269941224"/>
+        <p14:creationId xmlns:p14="http://schemas.microsoft.com/office/powerpoint/2010/main" val="66961407"/>
       </p:ext>
     </p:extLst>
   </p:cSld>

</xml_diff>